<commit_message>
update final presentation with manual edits
Co-Authored-By: Claude Opus 4.8 <noreply@anthropic.com>
</commit_message>
<xml_diff>
--- a/research/presentation/China-Strategies-Presentation-FINAL.pptx
+++ b/research/presentation/China-Strategies-Presentation-FINAL.pptx
@@ -4848,7 +4848,7 @@
         <p:spPr>
           <a:xfrm>
             <a:off x="548640" y="3611880"/>
-            <a:ext cx="10607040" cy="640080"/>
+            <a:ext cx="10607040" cy="307777"/>
           </a:xfrm>
           <a:prstGeom prst="rect">
             <a:avLst/>
@@ -4873,7 +4873,7 @@
               </a:spcAft>
             </a:pPr>
             <a:r>
-              <a:rPr sz="1800" b="0" i="1">
+              <a:rPr sz="2000" b="0" i="1" dirty="0">
                 <a:solidFill>
                   <a:srgbClr val="CBD5E1"/>
                 </a:solidFill>
@@ -4937,8 +4937,8 @@
         </p:nvSpPr>
         <p:spPr>
           <a:xfrm>
-            <a:off x="548640" y="4526280"/>
-            <a:ext cx="3383280" cy="420624"/>
+            <a:off x="548640" y="4613482"/>
+            <a:ext cx="3383280" cy="246221"/>
           </a:xfrm>
           <a:prstGeom prst="rect">
             <a:avLst/>
@@ -4963,7 +4963,7 @@
               </a:spcAft>
             </a:pPr>
             <a:r>
-              <a:rPr sz="1250" b="1" i="0">
+              <a:rPr sz="1600" b="1" i="0">
                 <a:solidFill>
                   <a:srgbClr val="FFFFFF"/>
                 </a:solidFill>
@@ -5027,8 +5027,8 @@
         </p:nvSpPr>
         <p:spPr>
           <a:xfrm>
-            <a:off x="4160520" y="4526280"/>
-            <a:ext cx="3383280" cy="420624"/>
+            <a:off x="4160520" y="4613482"/>
+            <a:ext cx="3383280" cy="246221"/>
           </a:xfrm>
           <a:prstGeom prst="rect">
             <a:avLst/>
@@ -5053,7 +5053,7 @@
               </a:spcAft>
             </a:pPr>
             <a:r>
-              <a:rPr sz="1250" b="1" i="0">
+              <a:rPr sz="1600" b="1" i="0">
                 <a:solidFill>
                   <a:srgbClr val="FFFFFF"/>
                 </a:solidFill>
@@ -5117,8 +5117,8 @@
         </p:nvSpPr>
         <p:spPr>
           <a:xfrm>
-            <a:off x="7772400" y="4526280"/>
-            <a:ext cx="3383280" cy="420624"/>
+            <a:off x="7772400" y="4613482"/>
+            <a:ext cx="3383280" cy="246221"/>
           </a:xfrm>
           <a:prstGeom prst="rect">
             <a:avLst/>
@@ -5143,7 +5143,7 @@
               </a:spcAft>
             </a:pPr>
             <a:r>
-              <a:rPr sz="1250" b="1" i="0">
+              <a:rPr sz="1600" b="1" i="0">
                 <a:solidFill>
                   <a:srgbClr val="FFFFFF"/>
                 </a:solidFill>
@@ -5662,7 +5662,7 @@
         <p:spPr>
           <a:xfrm>
             <a:off x="713232" y="2478024"/>
-            <a:ext cx="3264408" cy="2843784"/>
+            <a:ext cx="3264408" cy="2583271"/>
           </a:xfrm>
           <a:prstGeom prst="rect">
             <a:avLst/>
@@ -5688,7 +5688,7 @@
               <a:buNone/>
             </a:pPr>
             <a:r>
-              <a:rPr sz="1200">
+              <a:rPr sz="1450" dirty="0">
                 <a:solidFill>
                   <a:srgbClr val="DC2626"/>
                 </a:solidFill>
@@ -5697,7 +5697,7 @@
               <a:t>–  </a:t>
             </a:r>
             <a:r>
-              <a:rPr sz="1200">
+              <a:rPr sz="1450" dirty="0">
                 <a:solidFill>
                   <a:srgbClr val="0F172A"/>
                 </a:solidFill>
@@ -5720,7 +5720,7 @@
               <a:buNone/>
             </a:pPr>
             <a:r>
-              <a:rPr sz="1200">
+              <a:rPr sz="1450" dirty="0">
                 <a:solidFill>
                   <a:srgbClr val="DC2626"/>
                 </a:solidFill>
@@ -5729,7 +5729,7 @@
               <a:t>–  </a:t>
             </a:r>
             <a:r>
-              <a:rPr sz="1200">
+              <a:rPr sz="1450" dirty="0">
                 <a:solidFill>
                   <a:srgbClr val="0F172A"/>
                 </a:solidFill>
@@ -5752,7 +5752,7 @@
               <a:buNone/>
             </a:pPr>
             <a:r>
-              <a:rPr sz="1200">
+              <a:rPr sz="1450" dirty="0">
                 <a:solidFill>
                   <a:srgbClr val="DC2626"/>
                 </a:solidFill>
@@ -5761,7 +5761,7 @@
               <a:t>–  </a:t>
             </a:r>
             <a:r>
-              <a:rPr sz="1200">
+              <a:rPr sz="1450" dirty="0">
                 <a:solidFill>
                   <a:srgbClr val="0F172A"/>
                 </a:solidFill>
@@ -5784,7 +5784,7 @@
               <a:buNone/>
             </a:pPr>
             <a:r>
-              <a:rPr sz="1200">
+              <a:rPr sz="1450" dirty="0">
                 <a:solidFill>
                   <a:srgbClr val="DC2626"/>
                 </a:solidFill>
@@ -5793,7 +5793,7 @@
               <a:t>–  </a:t>
             </a:r>
             <a:r>
-              <a:rPr sz="1200">
+              <a:rPr sz="1450" dirty="0">
                 <a:solidFill>
                   <a:srgbClr val="0F172A"/>
                 </a:solidFill>
@@ -5816,7 +5816,7 @@
               <a:buNone/>
             </a:pPr>
             <a:r>
-              <a:rPr sz="1200">
+              <a:rPr sz="1450" dirty="0">
                 <a:solidFill>
                   <a:srgbClr val="DC2626"/>
                 </a:solidFill>
@@ -5825,7 +5825,7 @@
               <a:t>–  </a:t>
             </a:r>
             <a:r>
-              <a:rPr sz="1200">
+              <a:rPr sz="1450" dirty="0">
                 <a:solidFill>
                   <a:srgbClr val="0F172A"/>
                 </a:solidFill>
@@ -5982,7 +5982,7 @@
         <p:spPr>
           <a:xfrm>
             <a:off x="4443984" y="2478024"/>
-            <a:ext cx="3264408" cy="2843784"/>
+            <a:ext cx="3264408" cy="2348976"/>
           </a:xfrm>
           <a:prstGeom prst="rect">
             <a:avLst/>
@@ -6008,7 +6008,7 @@
               <a:buNone/>
             </a:pPr>
             <a:r>
-              <a:rPr sz="1200">
+              <a:rPr sz="1450" dirty="0">
                 <a:solidFill>
                   <a:srgbClr val="2563EB"/>
                 </a:solidFill>
@@ -6017,7 +6017,7 @@
               <a:t>–  </a:t>
             </a:r>
             <a:r>
-              <a:rPr sz="1200">
+              <a:rPr sz="1450" dirty="0">
                 <a:solidFill>
                   <a:srgbClr val="0F172A"/>
                 </a:solidFill>
@@ -6040,7 +6040,7 @@
               <a:buNone/>
             </a:pPr>
             <a:r>
-              <a:rPr sz="1200">
+              <a:rPr sz="1450" dirty="0">
                 <a:solidFill>
                   <a:srgbClr val="2563EB"/>
                 </a:solidFill>
@@ -6049,7 +6049,7 @@
               <a:t>–  </a:t>
             </a:r>
             <a:r>
-              <a:rPr sz="1200">
+              <a:rPr sz="1450" dirty="0">
                 <a:solidFill>
                   <a:srgbClr val="0F172A"/>
                 </a:solidFill>
@@ -6072,7 +6072,7 @@
               <a:buNone/>
             </a:pPr>
             <a:r>
-              <a:rPr sz="1200">
+              <a:rPr sz="1450" dirty="0">
                 <a:solidFill>
                   <a:srgbClr val="2563EB"/>
                 </a:solidFill>
@@ -6081,7 +6081,7 @@
               <a:t>–  </a:t>
             </a:r>
             <a:r>
-              <a:rPr sz="1200">
+              <a:rPr sz="1450" dirty="0">
                 <a:solidFill>
                   <a:srgbClr val="0F172A"/>
                 </a:solidFill>
@@ -6104,7 +6104,7 @@
               <a:buNone/>
             </a:pPr>
             <a:r>
-              <a:rPr sz="1200">
+              <a:rPr sz="1450" dirty="0">
                 <a:solidFill>
                   <a:srgbClr val="2563EB"/>
                 </a:solidFill>
@@ -6113,7 +6113,7 @@
               <a:t>–  </a:t>
             </a:r>
             <a:r>
-              <a:rPr sz="1200">
+              <a:rPr sz="1450" dirty="0">
                 <a:solidFill>
                   <a:srgbClr val="0F172A"/>
                 </a:solidFill>
@@ -6136,7 +6136,7 @@
               <a:buNone/>
             </a:pPr>
             <a:r>
-              <a:rPr sz="1200">
+              <a:rPr sz="1450" dirty="0">
                 <a:solidFill>
                   <a:srgbClr val="2563EB"/>
                 </a:solidFill>
@@ -6145,7 +6145,7 @@
               <a:t>–  </a:t>
             </a:r>
             <a:r>
-              <a:rPr sz="1200">
+              <a:rPr sz="1450" dirty="0">
                 <a:solidFill>
                   <a:srgbClr val="0F172A"/>
                 </a:solidFill>
@@ -6302,7 +6302,7 @@
         <p:spPr>
           <a:xfrm>
             <a:off x="8174736" y="2478024"/>
-            <a:ext cx="3264408" cy="2843784"/>
+            <a:ext cx="3264408" cy="2583271"/>
           </a:xfrm>
           <a:prstGeom prst="rect">
             <a:avLst/>
@@ -6328,7 +6328,7 @@
               <a:buNone/>
             </a:pPr>
             <a:r>
-              <a:rPr sz="1200">
+              <a:rPr sz="1450">
                 <a:solidFill>
                   <a:srgbClr val="06B6D4"/>
                 </a:solidFill>
@@ -6337,7 +6337,7 @@
               <a:t>–  </a:t>
             </a:r>
             <a:r>
-              <a:rPr sz="1200">
+              <a:rPr sz="1450">
                 <a:solidFill>
                   <a:srgbClr val="0F172A"/>
                 </a:solidFill>
@@ -6360,7 +6360,7 @@
               <a:buNone/>
             </a:pPr>
             <a:r>
-              <a:rPr sz="1200">
+              <a:rPr sz="1450">
                 <a:solidFill>
                   <a:srgbClr val="06B6D4"/>
                 </a:solidFill>
@@ -6369,7 +6369,7 @@
               <a:t>–  </a:t>
             </a:r>
             <a:r>
-              <a:rPr sz="1200">
+              <a:rPr sz="1450">
                 <a:solidFill>
                   <a:srgbClr val="0F172A"/>
                 </a:solidFill>
@@ -6392,7 +6392,7 @@
               <a:buNone/>
             </a:pPr>
             <a:r>
-              <a:rPr sz="1200">
+              <a:rPr sz="1450">
                 <a:solidFill>
                   <a:srgbClr val="06B6D4"/>
                 </a:solidFill>
@@ -6401,7 +6401,7 @@
               <a:t>–  </a:t>
             </a:r>
             <a:r>
-              <a:rPr sz="1200">
+              <a:rPr sz="1450">
                 <a:solidFill>
                   <a:srgbClr val="0F172A"/>
                 </a:solidFill>
@@ -6424,7 +6424,7 @@
               <a:buNone/>
             </a:pPr>
             <a:r>
-              <a:rPr sz="1200">
+              <a:rPr sz="1450">
                 <a:solidFill>
                   <a:srgbClr val="06B6D4"/>
                 </a:solidFill>
@@ -6433,7 +6433,7 @@
               <a:t>–  </a:t>
             </a:r>
             <a:r>
-              <a:rPr sz="1200">
+              <a:rPr sz="1450">
                 <a:solidFill>
                   <a:srgbClr val="0F172A"/>
                 </a:solidFill>
@@ -6456,7 +6456,7 @@
               <a:buNone/>
             </a:pPr>
             <a:r>
-              <a:rPr sz="1200">
+              <a:rPr sz="1450">
                 <a:solidFill>
                   <a:srgbClr val="06B6D4"/>
                 </a:solidFill>
@@ -6465,7 +6465,7 @@
               <a:t>–  </a:t>
             </a:r>
             <a:r>
-              <a:rPr sz="1200">
+              <a:rPr sz="1450">
                 <a:solidFill>
                   <a:srgbClr val="0F172A"/>
                 </a:solidFill>
@@ -7007,7 +7007,7 @@
         <p:spPr>
           <a:xfrm>
             <a:off x="713232" y="2478024"/>
-            <a:ext cx="3264408" cy="1746504"/>
+            <a:ext cx="3264408" cy="1517851"/>
           </a:xfrm>
           <a:prstGeom prst="rect">
             <a:avLst/>
@@ -7033,7 +7033,7 @@
               <a:buNone/>
             </a:pPr>
             <a:r>
-              <a:rPr sz="1250">
+              <a:rPr sz="1450" dirty="0">
                 <a:solidFill>
                   <a:srgbClr val="DC2626"/>
                 </a:solidFill>
@@ -7042,7 +7042,7 @@
               <a:t>–  </a:t>
             </a:r>
             <a:r>
-              <a:rPr sz="1250">
+              <a:rPr sz="1450" dirty="0">
                 <a:solidFill>
                   <a:srgbClr val="0F172A"/>
                 </a:solidFill>
@@ -7065,7 +7065,7 @@
               <a:buNone/>
             </a:pPr>
             <a:r>
-              <a:rPr sz="1250">
+              <a:rPr sz="1450" dirty="0">
                 <a:solidFill>
                   <a:srgbClr val="DC2626"/>
                 </a:solidFill>
@@ -7074,13 +7074,31 @@
               <a:t>–  </a:t>
             </a:r>
             <a:r>
-              <a:rPr sz="1250">
+              <a:rPr sz="1450" dirty="0">
                 <a:solidFill>
                   <a:srgbClr val="0F172A"/>
                 </a:solidFill>
                 <a:latin typeface="Arial"/>
               </a:rPr>
-              <a:t>But rent cannibalisation suppressed own innovation (Howell, 2018)</a:t>
+              <a:t>But rent </a:t>
+            </a:r>
+            <a:r>
+              <a:rPr sz="1450" dirty="0" err="1">
+                <a:solidFill>
+                  <a:srgbClr val="0F172A"/>
+                </a:solidFill>
+                <a:latin typeface="Arial"/>
+              </a:rPr>
+              <a:t>cannibalisation</a:t>
+            </a:r>
+            <a:r>
+              <a:rPr sz="1450" dirty="0">
+                <a:solidFill>
+                  <a:srgbClr val="0F172A"/>
+                </a:solidFill>
+                <a:latin typeface="Arial"/>
+              </a:rPr>
+              <a:t> suppressed own innovation (Howell, 2018)</a:t>
             </a:r>
           </a:p>
           <a:p>
@@ -7097,7 +7115,7 @@
               <a:buNone/>
             </a:pPr>
             <a:r>
-              <a:rPr sz="1250">
+              <a:rPr sz="1450" dirty="0">
                 <a:solidFill>
                   <a:srgbClr val="DC2626"/>
                 </a:solidFill>
@@ -7106,7 +7124,7 @@
               <a:t>–  </a:t>
             </a:r>
             <a:r>
-              <a:rPr sz="1250">
+              <a:rPr sz="1450" dirty="0">
                 <a:solidFill>
                   <a:srgbClr val="0F172A"/>
                 </a:solidFill>
@@ -7263,7 +7281,7 @@
         <p:spPr>
           <a:xfrm>
             <a:off x="4443984" y="2478024"/>
-            <a:ext cx="3264408" cy="1746504"/>
+            <a:ext cx="3264408" cy="1517851"/>
           </a:xfrm>
           <a:prstGeom prst="rect">
             <a:avLst/>
@@ -7289,7 +7307,7 @@
               <a:buNone/>
             </a:pPr>
             <a:r>
-              <a:rPr sz="1250">
+              <a:rPr sz="1450" dirty="0">
                 <a:solidFill>
                   <a:srgbClr val="06B6D4"/>
                 </a:solidFill>
@@ -7298,7 +7316,7 @@
               <a:t>–  </a:t>
             </a:r>
             <a:r>
-              <a:rPr sz="1250">
+              <a:rPr sz="1450" dirty="0">
                 <a:solidFill>
                   <a:srgbClr val="0F172A"/>
                 </a:solidFill>
@@ -7321,7 +7339,7 @@
               <a:buNone/>
             </a:pPr>
             <a:r>
-              <a:rPr sz="1250">
+              <a:rPr sz="1450" dirty="0">
                 <a:solidFill>
                   <a:srgbClr val="06B6D4"/>
                 </a:solidFill>
@@ -7330,7 +7348,7 @@
               <a:t>–  </a:t>
             </a:r>
             <a:r>
-              <a:rPr sz="1250">
+              <a:rPr sz="1450" dirty="0">
                 <a:solidFill>
                   <a:srgbClr val="0F172A"/>
                 </a:solidFill>
@@ -7353,7 +7371,7 @@
               <a:buNone/>
             </a:pPr>
             <a:r>
-              <a:rPr sz="1250">
+              <a:rPr sz="1450" dirty="0">
                 <a:solidFill>
                   <a:srgbClr val="06B6D4"/>
                 </a:solidFill>
@@ -7362,7 +7380,7 @@
               <a:t>–  </a:t>
             </a:r>
             <a:r>
-              <a:rPr sz="1250">
+              <a:rPr sz="1450" dirty="0">
                 <a:solidFill>
                   <a:srgbClr val="0F172A"/>
                 </a:solidFill>
@@ -7519,7 +7537,7 @@
         <p:spPr>
           <a:xfrm>
             <a:off x="8174736" y="2478024"/>
-            <a:ext cx="3264408" cy="1746504"/>
+            <a:ext cx="3264408" cy="1517851"/>
           </a:xfrm>
           <a:prstGeom prst="rect">
             <a:avLst/>
@@ -7545,7 +7563,7 @@
               <a:buNone/>
             </a:pPr>
             <a:r>
-              <a:rPr sz="1250">
+              <a:rPr sz="1450">
                 <a:solidFill>
                   <a:srgbClr val="2563EB"/>
                 </a:solidFill>
@@ -7554,7 +7572,7 @@
               <a:t>–  </a:t>
             </a:r>
             <a:r>
-              <a:rPr sz="1250">
+              <a:rPr sz="1450">
                 <a:solidFill>
                   <a:srgbClr val="0F172A"/>
                 </a:solidFill>
@@ -7577,7 +7595,7 @@
               <a:buNone/>
             </a:pPr>
             <a:r>
-              <a:rPr sz="1250">
+              <a:rPr sz="1450">
                 <a:solidFill>
                   <a:srgbClr val="2563EB"/>
                 </a:solidFill>
@@ -7586,7 +7604,7 @@
               <a:t>–  </a:t>
             </a:r>
             <a:r>
-              <a:rPr sz="1250">
+              <a:rPr sz="1450">
                 <a:solidFill>
                   <a:srgbClr val="0F172A"/>
                 </a:solidFill>
@@ -7609,7 +7627,7 @@
               <a:buNone/>
             </a:pPr>
             <a:r>
-              <a:rPr sz="1250">
+              <a:rPr sz="1450">
                 <a:solidFill>
                   <a:srgbClr val="2563EB"/>
                 </a:solidFill>
@@ -7618,7 +7636,7 @@
               <a:t>–  </a:t>
             </a:r>
             <a:r>
-              <a:rPr sz="1250">
+              <a:rPr sz="1450">
                 <a:solidFill>
                   <a:srgbClr val="0F172A"/>
                 </a:solidFill>
@@ -8295,7 +8313,7 @@
         <p:spPr>
           <a:xfrm>
             <a:off x="713232" y="2478024"/>
-            <a:ext cx="3264408" cy="2843784"/>
+            <a:ext cx="3264408" cy="2583271"/>
           </a:xfrm>
           <a:prstGeom prst="rect">
             <a:avLst/>
@@ -8321,7 +8339,7 @@
               <a:buNone/>
             </a:pPr>
             <a:r>
-              <a:rPr sz="1200">
+              <a:rPr sz="1450" dirty="0">
                 <a:solidFill>
                   <a:srgbClr val="DC2626"/>
                 </a:solidFill>
@@ -8330,7 +8348,7 @@
               <a:t>–  </a:t>
             </a:r>
             <a:r>
-              <a:rPr sz="1200">
+              <a:rPr sz="1450" dirty="0">
                 <a:solidFill>
                   <a:srgbClr val="0F172A"/>
                 </a:solidFill>
@@ -8353,7 +8371,7 @@
               <a:buNone/>
             </a:pPr>
             <a:r>
-              <a:rPr sz="1200">
+              <a:rPr sz="1450" dirty="0">
                 <a:solidFill>
                   <a:srgbClr val="DC2626"/>
                 </a:solidFill>
@@ -8362,7 +8380,7 @@
               <a:t>–  </a:t>
             </a:r>
             <a:r>
-              <a:rPr sz="1200">
+              <a:rPr sz="1450" dirty="0">
                 <a:solidFill>
                   <a:srgbClr val="0F172A"/>
                 </a:solidFill>
@@ -8385,7 +8403,7 @@
               <a:buNone/>
             </a:pPr>
             <a:r>
-              <a:rPr sz="1200">
+              <a:rPr sz="1450" dirty="0">
                 <a:solidFill>
                   <a:srgbClr val="DC2626"/>
                 </a:solidFill>
@@ -8394,7 +8412,7 @@
               <a:t>–  </a:t>
             </a:r>
             <a:r>
-              <a:rPr sz="1200">
+              <a:rPr sz="1450" dirty="0">
                 <a:solidFill>
                   <a:srgbClr val="0F172A"/>
                 </a:solidFill>
@@ -8417,7 +8435,7 @@
               <a:buNone/>
             </a:pPr>
             <a:r>
-              <a:rPr sz="1200">
+              <a:rPr sz="1450" dirty="0">
                 <a:solidFill>
                   <a:srgbClr val="DC2626"/>
                 </a:solidFill>
@@ -8426,7 +8444,7 @@
               <a:t>–  </a:t>
             </a:r>
             <a:r>
-              <a:rPr sz="1200">
+              <a:rPr sz="1450" dirty="0">
                 <a:solidFill>
                   <a:srgbClr val="0F172A"/>
                 </a:solidFill>
@@ -8449,7 +8467,7 @@
               <a:buNone/>
             </a:pPr>
             <a:r>
-              <a:rPr sz="1200">
+              <a:rPr sz="1450" dirty="0">
                 <a:solidFill>
                   <a:srgbClr val="DC2626"/>
                 </a:solidFill>
@@ -8458,7 +8476,7 @@
               <a:t>–  </a:t>
             </a:r>
             <a:r>
-              <a:rPr sz="1200">
+              <a:rPr sz="1450" dirty="0">
                 <a:solidFill>
                   <a:srgbClr val="0F172A"/>
                 </a:solidFill>
@@ -8615,7 +8633,7 @@
         <p:spPr>
           <a:xfrm>
             <a:off x="4443984" y="2478024"/>
-            <a:ext cx="3264408" cy="2843784"/>
+            <a:ext cx="3264408" cy="2348976"/>
           </a:xfrm>
           <a:prstGeom prst="rect">
             <a:avLst/>
@@ -8641,7 +8659,7 @@
               <a:buNone/>
             </a:pPr>
             <a:r>
-              <a:rPr sz="1200">
+              <a:rPr sz="1450" dirty="0">
                 <a:solidFill>
                   <a:srgbClr val="2563EB"/>
                 </a:solidFill>
@@ -8650,7 +8668,7 @@
               <a:t>–  </a:t>
             </a:r>
             <a:r>
-              <a:rPr sz="1200">
+              <a:rPr sz="1450" dirty="0">
                 <a:solidFill>
                   <a:srgbClr val="0F172A"/>
                 </a:solidFill>
@@ -8673,7 +8691,7 @@
               <a:buNone/>
             </a:pPr>
             <a:r>
-              <a:rPr sz="1200">
+              <a:rPr sz="1450" dirty="0">
                 <a:solidFill>
                   <a:srgbClr val="2563EB"/>
                 </a:solidFill>
@@ -8682,7 +8700,7 @@
               <a:t>–  </a:t>
             </a:r>
             <a:r>
-              <a:rPr sz="1200">
+              <a:rPr sz="1450" dirty="0">
                 <a:solidFill>
                   <a:srgbClr val="0F172A"/>
                 </a:solidFill>
@@ -8705,7 +8723,7 @@
               <a:buNone/>
             </a:pPr>
             <a:r>
-              <a:rPr sz="1200">
+              <a:rPr sz="1450" dirty="0">
                 <a:solidFill>
                   <a:srgbClr val="2563EB"/>
                 </a:solidFill>
@@ -8714,7 +8732,7 @@
               <a:t>–  </a:t>
             </a:r>
             <a:r>
-              <a:rPr sz="1200">
+              <a:rPr sz="1450" dirty="0">
                 <a:solidFill>
                   <a:srgbClr val="0F172A"/>
                 </a:solidFill>
@@ -8737,7 +8755,7 @@
               <a:buNone/>
             </a:pPr>
             <a:r>
-              <a:rPr sz="1200">
+              <a:rPr sz="1450" dirty="0">
                 <a:solidFill>
                   <a:srgbClr val="2563EB"/>
                 </a:solidFill>
@@ -8746,7 +8764,7 @@
               <a:t>–  </a:t>
             </a:r>
             <a:r>
-              <a:rPr sz="1200">
+              <a:rPr sz="1450" dirty="0">
                 <a:solidFill>
                   <a:srgbClr val="0F172A"/>
                 </a:solidFill>
@@ -8769,7 +8787,7 @@
               <a:buNone/>
             </a:pPr>
             <a:r>
-              <a:rPr sz="1200">
+              <a:rPr sz="1450" dirty="0">
                 <a:solidFill>
                   <a:srgbClr val="2563EB"/>
                 </a:solidFill>
@@ -8778,7 +8796,7 @@
               <a:t>–  </a:t>
             </a:r>
             <a:r>
-              <a:rPr sz="1200">
+              <a:rPr sz="1450" dirty="0">
                 <a:solidFill>
                   <a:srgbClr val="0F172A"/>
                 </a:solidFill>
@@ -8935,7 +8953,7 @@
         <p:spPr>
           <a:xfrm>
             <a:off x="8174736" y="2478024"/>
-            <a:ext cx="3264408" cy="2843784"/>
+            <a:ext cx="3264408" cy="2583271"/>
           </a:xfrm>
           <a:prstGeom prst="rect">
             <a:avLst/>
@@ -8961,7 +8979,7 @@
               <a:buNone/>
             </a:pPr>
             <a:r>
-              <a:rPr sz="1200">
+              <a:rPr sz="1450">
                 <a:solidFill>
                   <a:srgbClr val="06B6D4"/>
                 </a:solidFill>
@@ -8970,7 +8988,7 @@
               <a:t>–  </a:t>
             </a:r>
             <a:r>
-              <a:rPr sz="1200">
+              <a:rPr sz="1450">
                 <a:solidFill>
                   <a:srgbClr val="0F172A"/>
                 </a:solidFill>
@@ -8993,7 +9011,7 @@
               <a:buNone/>
             </a:pPr>
             <a:r>
-              <a:rPr sz="1200">
+              <a:rPr sz="1450">
                 <a:solidFill>
                   <a:srgbClr val="06B6D4"/>
                 </a:solidFill>
@@ -9002,7 +9020,7 @@
               <a:t>–  </a:t>
             </a:r>
             <a:r>
-              <a:rPr sz="1200">
+              <a:rPr sz="1450">
                 <a:solidFill>
                   <a:srgbClr val="0F172A"/>
                 </a:solidFill>
@@ -9025,7 +9043,7 @@
               <a:buNone/>
             </a:pPr>
             <a:r>
-              <a:rPr sz="1200">
+              <a:rPr sz="1450">
                 <a:solidFill>
                   <a:srgbClr val="06B6D4"/>
                 </a:solidFill>
@@ -9034,7 +9052,7 @@
               <a:t>–  </a:t>
             </a:r>
             <a:r>
-              <a:rPr sz="1200">
+              <a:rPr sz="1450">
                 <a:solidFill>
                   <a:srgbClr val="0F172A"/>
                 </a:solidFill>
@@ -9057,7 +9075,7 @@
               <a:buNone/>
             </a:pPr>
             <a:r>
-              <a:rPr sz="1200">
+              <a:rPr sz="1450">
                 <a:solidFill>
                   <a:srgbClr val="06B6D4"/>
                 </a:solidFill>
@@ -9066,7 +9084,7 @@
               <a:t>–  </a:t>
             </a:r>
             <a:r>
-              <a:rPr sz="1200">
+              <a:rPr sz="1450">
                 <a:solidFill>
                   <a:srgbClr val="0F172A"/>
                 </a:solidFill>
@@ -9089,7 +9107,7 @@
               <a:buNone/>
             </a:pPr>
             <a:r>
-              <a:rPr sz="1200">
+              <a:rPr sz="1450">
                 <a:solidFill>
                   <a:srgbClr val="06B6D4"/>
                 </a:solidFill>
@@ -9098,7 +9116,7 @@
               <a:t>–  </a:t>
             </a:r>
             <a:r>
-              <a:rPr sz="1200">
+              <a:rPr sz="1450">
                 <a:solidFill>
                   <a:srgbClr val="0F172A"/>
                 </a:solidFill>
@@ -9368,7 +9386,7 @@
         <p:spPr>
           <a:xfrm>
             <a:off x="548640" y="457200"/>
-            <a:ext cx="10972800" cy="274320"/>
+            <a:ext cx="10972800" cy="215444"/>
           </a:xfrm>
           <a:prstGeom prst="rect">
             <a:avLst/>
@@ -9393,14 +9411,20 @@
               </a:spcAft>
             </a:pPr>
             <a:r>
-              <a:rPr sz="1400" b="1" i="0">
+              <a:rPr lang="de-DE" sz="1400" b="1" i="0" dirty="0">
                 <a:solidFill>
                   <a:srgbClr val="06B6D4"/>
                 </a:solidFill>
                 <a:latin typeface="Arial"/>
               </a:rPr>
-              <a:t>VERDICT</a:t>
-            </a:r>
+              <a:t>RESULT</a:t>
+            </a:r>
+            <a:endParaRPr sz="1400" b="1" i="0" dirty="0">
+              <a:solidFill>
+                <a:srgbClr val="06B6D4"/>
+              </a:solidFill>
+              <a:latin typeface="Arial"/>
+            </a:endParaRPr>
           </a:p>
         </p:txBody>
       </p:sp>
@@ -10041,7 +10065,7 @@
         <p:spPr>
           <a:xfrm>
             <a:off x="777240" y="4160520"/>
-            <a:ext cx="10607040" cy="1143000"/>
+            <a:ext cx="10607040" cy="825354"/>
           </a:xfrm>
           <a:prstGeom prst="rect">
             <a:avLst/>
@@ -10066,7 +10090,7 @@
               </a:spcAft>
             </a:pPr>
             <a:r>
-              <a:rPr sz="1450" b="0" i="0">
+              <a:rPr sz="1600" b="0" i="0" dirty="0">
                 <a:solidFill>
                   <a:srgbClr val="FFFFFF"/>
                 </a:solidFill>
@@ -10653,7 +10677,7 @@
         <p:spPr>
           <a:xfrm>
             <a:off x="1828800" y="2350008"/>
-            <a:ext cx="9509760" cy="548640"/>
+            <a:ext cx="9509760" cy="499111"/>
           </a:xfrm>
           <a:prstGeom prst="rect">
             <a:avLst/>
@@ -10678,7 +10702,7 @@
               </a:spcAft>
             </a:pPr>
             <a:r>
-              <a:rPr sz="1300" b="0" i="0">
+              <a:rPr sz="1600" b="0" i="0" dirty="0">
                 <a:solidFill>
                   <a:srgbClr val="0F172A"/>
                 </a:solidFill>
@@ -10880,7 +10904,7 @@
         <p:spPr>
           <a:xfrm>
             <a:off x="1828800" y="3721608"/>
-            <a:ext cx="9509760" cy="548640"/>
+            <a:ext cx="9509760" cy="499111"/>
           </a:xfrm>
           <a:prstGeom prst="rect">
             <a:avLst/>
@@ -10905,7 +10929,7 @@
               </a:spcAft>
             </a:pPr>
             <a:r>
-              <a:rPr sz="1300" b="0" i="0">
+              <a:rPr sz="1600" b="0" i="0" dirty="0">
                 <a:solidFill>
                   <a:srgbClr val="0F172A"/>
                 </a:solidFill>
@@ -11107,7 +11131,7 @@
         <p:spPr>
           <a:xfrm>
             <a:off x="1828800" y="5093208"/>
-            <a:ext cx="9509760" cy="548640"/>
+            <a:ext cx="9509760" cy="499111"/>
           </a:xfrm>
           <a:prstGeom prst="rect">
             <a:avLst/>
@@ -11132,7 +11156,7 @@
               </a:spcAft>
             </a:pPr>
             <a:r>
-              <a:rPr sz="1300" b="0" i="0">
+              <a:rPr sz="1600" b="0" i="0">
                 <a:solidFill>
                   <a:srgbClr val="0F172A"/>
                 </a:solidFill>
@@ -11627,7 +11651,7 @@
         <p:spPr>
           <a:xfrm>
             <a:off x="7589520" y="1920240"/>
-            <a:ext cx="4023360" cy="365760"/>
+            <a:ext cx="4023360" cy="246221"/>
           </a:xfrm>
           <a:prstGeom prst="rect">
             <a:avLst/>
@@ -11652,7 +11676,7 @@
               </a:spcAft>
             </a:pPr>
             <a:r>
-              <a:rPr sz="1400" b="1" i="0">
+              <a:rPr sz="1600" b="1" i="0" dirty="0">
                 <a:solidFill>
                   <a:srgbClr val="06B6D4"/>
                 </a:solidFill>
@@ -11672,7 +11696,7 @@
         <p:spPr>
           <a:xfrm>
             <a:off x="7589520" y="2377440"/>
-            <a:ext cx="4023360" cy="3017520"/>
+            <a:ext cx="4023360" cy="3276410"/>
           </a:xfrm>
           <a:prstGeom prst="rect">
             <a:avLst/>
@@ -11698,7 +11722,7 @@
               <a:buNone/>
             </a:pPr>
             <a:r>
-              <a:rPr sz="1300">
+              <a:rPr sz="1500" dirty="0">
                 <a:solidFill>
                   <a:srgbClr val="06B6D4"/>
                 </a:solidFill>
@@ -11707,7 +11731,7 @@
               <a:t>–  </a:t>
             </a:r>
             <a:r>
-              <a:rPr sz="1300">
+              <a:rPr sz="1500" dirty="0">
                 <a:solidFill>
                   <a:srgbClr val="E2E8F0"/>
                 </a:solidFill>
@@ -11730,7 +11754,7 @@
               <a:buNone/>
             </a:pPr>
             <a:r>
-              <a:rPr sz="1300">
+              <a:rPr sz="1500" dirty="0">
                 <a:solidFill>
                   <a:srgbClr val="06B6D4"/>
                 </a:solidFill>
@@ -11739,7 +11763,7 @@
               <a:t>–  </a:t>
             </a:r>
             <a:r>
-              <a:rPr sz="1300">
+              <a:rPr sz="1500" dirty="0">
                 <a:solidFill>
                   <a:srgbClr val="E2E8F0"/>
                 </a:solidFill>
@@ -11762,7 +11786,7 @@
               <a:buNone/>
             </a:pPr>
             <a:r>
-              <a:rPr sz="1300">
+              <a:rPr sz="1500" dirty="0">
                 <a:solidFill>
                   <a:srgbClr val="06B6D4"/>
                 </a:solidFill>
@@ -11771,13 +11795,31 @@
               <a:t>–  </a:t>
             </a:r>
             <a:r>
-              <a:rPr sz="1300">
+              <a:rPr sz="1500" dirty="0">
                 <a:solidFill>
                   <a:srgbClr val="E2E8F0"/>
                 </a:solidFill>
                 <a:latin typeface="Arial"/>
               </a:rPr>
-              <a:t>SAIC's state model optimises beyond shareholder value: a permanent structural discount.</a:t>
+              <a:t>SAIC's state model </a:t>
+            </a:r>
+            <a:r>
+              <a:rPr sz="1500" dirty="0" err="1">
+                <a:solidFill>
+                  <a:srgbClr val="E2E8F0"/>
+                </a:solidFill>
+                <a:latin typeface="Arial"/>
+              </a:rPr>
+              <a:t>optimises</a:t>
+            </a:r>
+            <a:r>
+              <a:rPr sz="1500" dirty="0">
+                <a:solidFill>
+                  <a:srgbClr val="E2E8F0"/>
+                </a:solidFill>
+                <a:latin typeface="Arial"/>
+              </a:rPr>
+              <a:t> beyond shareholder value: a permanent structural discount.</a:t>
             </a:r>
           </a:p>
           <a:p>
@@ -11794,7 +11836,7 @@
               <a:buNone/>
             </a:pPr>
             <a:r>
-              <a:rPr sz="1300">
+              <a:rPr sz="1500" dirty="0">
                 <a:solidFill>
                   <a:srgbClr val="06B6D4"/>
                 </a:solidFill>
@@ -11803,7 +11845,7 @@
               <a:t>–  </a:t>
             </a:r>
             <a:r>
-              <a:rPr sz="1300">
+              <a:rPr sz="1500" dirty="0">
                 <a:solidFill>
                   <a:srgbClr val="E2E8F0"/>
                 </a:solidFill>
@@ -12299,8 +12341,8 @@
         </p:nvSpPr>
         <p:spPr>
           <a:xfrm>
-            <a:off x="731520" y="2423160"/>
-            <a:ext cx="5074920" cy="1056508"/>
+            <a:off x="731520" y="2372492"/>
+            <a:ext cx="5074920" cy="1183529"/>
           </a:xfrm>
           <a:prstGeom prst="rect">
             <a:avLst/>
@@ -12326,7 +12368,7 @@
               <a:buNone/>
             </a:pPr>
             <a:r>
-              <a:rPr sz="1300" dirty="0">
+              <a:rPr sz="1500" dirty="0">
                 <a:solidFill>
                   <a:srgbClr val="D97706"/>
                 </a:solidFill>
@@ -12335,7 +12377,7 @@
               <a:t>–  </a:t>
             </a:r>
             <a:r>
-              <a:rPr sz="1300" dirty="0">
+              <a:rPr sz="1500" dirty="0">
                 <a:solidFill>
                   <a:srgbClr val="0F172A"/>
                 </a:solidFill>
@@ -12344,7 +12386,7 @@
               <a:t>Three firms, one industry, one country — limited statistical </a:t>
             </a:r>
             <a:r>
-              <a:rPr sz="1300" dirty="0" err="1">
+              <a:rPr sz="1500" dirty="0" err="1">
                 <a:solidFill>
                   <a:srgbClr val="0F172A"/>
                 </a:solidFill>
@@ -12353,7 +12395,7 @@
               <a:t>generalisability</a:t>
             </a:r>
             <a:r>
-              <a:rPr sz="1300" dirty="0">
+              <a:rPr sz="1500" dirty="0">
                 <a:solidFill>
                   <a:srgbClr val="0F172A"/>
                 </a:solidFill>
@@ -12376,7 +12418,7 @@
               <a:buNone/>
             </a:pPr>
             <a:r>
-              <a:rPr sz="1300" dirty="0">
+              <a:rPr sz="1500" dirty="0">
                 <a:solidFill>
                   <a:srgbClr val="D97706"/>
                 </a:solidFill>
@@ -12385,7 +12427,7 @@
               <a:t>–  </a:t>
             </a:r>
             <a:r>
-              <a:rPr sz="1300" dirty="0">
+              <a:rPr sz="1500" dirty="0">
                 <a:solidFill>
                   <a:srgbClr val="0F172A"/>
                 </a:solidFill>
@@ -12407,7 +12449,7 @@
               </a:spcAft>
               <a:buNone/>
             </a:pPr>
-            <a:endParaRPr sz="1300" dirty="0">
+            <a:endParaRPr sz="1500" dirty="0">
               <a:solidFill>
                 <a:srgbClr val="0F172A"/>
               </a:solidFill>
@@ -12561,8 +12603,8 @@
         </p:nvSpPr>
         <p:spPr>
           <a:xfrm>
-            <a:off x="6355080" y="2423160"/>
-            <a:ext cx="5074920" cy="1592039"/>
+            <a:off x="6355080" y="2372492"/>
+            <a:ext cx="5074920" cy="2268442"/>
           </a:xfrm>
           <a:prstGeom prst="rect">
             <a:avLst/>
@@ -12588,7 +12630,7 @@
               <a:buNone/>
             </a:pPr>
             <a:r>
-              <a:rPr sz="1300" dirty="0">
+              <a:rPr sz="1500" dirty="0">
                 <a:solidFill>
                   <a:srgbClr val="2563EB"/>
                 </a:solidFill>
@@ -12597,7 +12639,7 @@
               <a:t>–</a:t>
             </a:r>
             <a:r>
-              <a:rPr lang="de-DE" sz="1300" dirty="0">
+              <a:rPr lang="de-DE" sz="1500" dirty="0">
                 <a:solidFill>
                   <a:srgbClr val="0F172A"/>
                 </a:solidFill>
@@ -12606,7 +12648,7 @@
               <a:t>  F</a:t>
             </a:r>
             <a:r>
-              <a:rPr sz="1300" dirty="0" err="1">
+              <a:rPr sz="1500" dirty="0" err="1">
                 <a:solidFill>
                   <a:srgbClr val="0F172A"/>
                 </a:solidFill>
@@ -12615,7 +12657,7 @@
               <a:t>ourth</a:t>
             </a:r>
             <a:r>
-              <a:rPr sz="1300" dirty="0">
+              <a:rPr sz="1500" dirty="0">
                 <a:solidFill>
                   <a:srgbClr val="0F172A"/>
                 </a:solidFill>
@@ -12638,7 +12680,7 @@
               <a:buNone/>
             </a:pPr>
             <a:r>
-              <a:rPr sz="1300" dirty="0">
+              <a:rPr sz="1500" dirty="0">
                 <a:solidFill>
                   <a:srgbClr val="2563EB"/>
                 </a:solidFill>
@@ -12647,7 +12689,7 @@
               <a:t>–  </a:t>
             </a:r>
             <a:r>
-              <a:rPr sz="1300" dirty="0">
+              <a:rPr sz="1500" dirty="0">
                 <a:solidFill>
                   <a:srgbClr val="0F172A"/>
                 </a:solidFill>
@@ -12670,7 +12712,7 @@
               <a:buNone/>
             </a:pPr>
             <a:r>
-              <a:rPr sz="1300" dirty="0">
+              <a:rPr sz="1500" dirty="0">
                 <a:solidFill>
                   <a:srgbClr val="2563EB"/>
                 </a:solidFill>
@@ -12679,7 +12721,7 @@
               <a:t>–  </a:t>
             </a:r>
             <a:r>
-              <a:rPr sz="1300" dirty="0">
+              <a:rPr sz="1500" dirty="0">
                 <a:solidFill>
                   <a:srgbClr val="0F172A"/>
                 </a:solidFill>
@@ -12702,7 +12744,7 @@
               <a:buNone/>
             </a:pPr>
             <a:r>
-              <a:rPr sz="1300" dirty="0">
+              <a:rPr sz="1500" dirty="0">
                 <a:solidFill>
                   <a:srgbClr val="2563EB"/>
                 </a:solidFill>
@@ -12711,7 +12753,7 @@
               <a:t>–  </a:t>
             </a:r>
             <a:r>
-              <a:rPr sz="1300" dirty="0">
+              <a:rPr sz="1500" dirty="0">
                 <a:solidFill>
                   <a:srgbClr val="0F172A"/>
                 </a:solidFill>
@@ -13208,7 +13250,7 @@
         <p:spPr>
           <a:xfrm>
             <a:off x="731520" y="2130552"/>
-            <a:ext cx="5074920" cy="320040"/>
+            <a:ext cx="5074920" cy="276999"/>
           </a:xfrm>
           <a:prstGeom prst="rect">
             <a:avLst/>
@@ -13233,7 +13275,7 @@
               </a:spcAft>
             </a:pPr>
             <a:r>
-              <a:rPr sz="1400" b="1" i="0">
+              <a:rPr b="1" i="0">
                 <a:solidFill>
                   <a:srgbClr val="0F172A"/>
                 </a:solidFill>
@@ -13253,7 +13295,7 @@
         <p:spPr>
           <a:xfrm>
             <a:off x="731520" y="2468880"/>
-            <a:ext cx="5074920" cy="411480"/>
+            <a:ext cx="5074920" cy="215444"/>
           </a:xfrm>
           <a:prstGeom prst="rect">
             <a:avLst/>
@@ -13278,7 +13320,7 @@
               </a:spcAft>
             </a:pPr>
             <a:r>
-              <a:rPr sz="1250" b="0" i="0">
+              <a:rPr sz="1400" b="0" i="0" dirty="0">
                 <a:solidFill>
                   <a:srgbClr val="0F172A"/>
                 </a:solidFill>
@@ -13390,7 +13432,7 @@
         <p:spPr>
           <a:xfrm>
             <a:off x="6355080" y="2130552"/>
-            <a:ext cx="5074920" cy="320040"/>
+            <a:ext cx="5074920" cy="276999"/>
           </a:xfrm>
           <a:prstGeom prst="rect">
             <a:avLst/>
@@ -13415,7 +13457,7 @@
               </a:spcAft>
             </a:pPr>
             <a:r>
-              <a:rPr sz="1400" b="1" i="0">
+              <a:rPr b="1" i="0">
                 <a:solidFill>
                   <a:srgbClr val="0F172A"/>
                 </a:solidFill>
@@ -13435,7 +13477,7 @@
         <p:spPr>
           <a:xfrm>
             <a:off x="6355080" y="2468880"/>
-            <a:ext cx="5074920" cy="411480"/>
+            <a:ext cx="5074920" cy="215444"/>
           </a:xfrm>
           <a:prstGeom prst="rect">
             <a:avLst/>
@@ -13460,7 +13502,7 @@
               </a:spcAft>
             </a:pPr>
             <a:r>
-              <a:rPr sz="1250" b="0" i="0">
+              <a:rPr sz="1400" b="0" i="0" dirty="0">
                 <a:solidFill>
                   <a:srgbClr val="0F172A"/>
                 </a:solidFill>
@@ -13617,7 +13659,7 @@
         <p:spPr>
           <a:xfrm>
             <a:off x="658368" y="3611880"/>
-            <a:ext cx="1901952" cy="320040"/>
+            <a:ext cx="1901952" cy="246221"/>
           </a:xfrm>
           <a:prstGeom prst="rect">
             <a:avLst/>
@@ -13642,7 +13684,7 @@
               </a:spcAft>
             </a:pPr>
             <a:r>
-              <a:rPr sz="1250" b="1" i="0">
+              <a:rPr sz="1600" b="1" i="0">
                 <a:solidFill>
                   <a:srgbClr val="06B6D4"/>
                 </a:solidFill>
@@ -13662,7 +13704,7 @@
         <p:spPr>
           <a:xfrm>
             <a:off x="658368" y="3977639"/>
-            <a:ext cx="1901952" cy="640080"/>
+            <a:ext cx="1901952" cy="456535"/>
           </a:xfrm>
           <a:prstGeom prst="rect">
             <a:avLst/>
@@ -13687,7 +13729,7 @@
               </a:spcAft>
             </a:pPr>
             <a:r>
-              <a:rPr sz="1150" b="0" i="0">
+              <a:rPr sz="1400" b="0" i="0" dirty="0">
                 <a:solidFill>
                   <a:srgbClr val="0F172A"/>
                 </a:solidFill>
@@ -13709,7 +13751,7 @@
               </a:spcAft>
             </a:pPr>
             <a:r>
-              <a:rPr sz="1150" b="0" i="0">
+              <a:rPr sz="1400" b="0" i="0" dirty="0">
                 <a:solidFill>
                   <a:srgbClr val="0F172A"/>
                 </a:solidFill>
@@ -13821,7 +13863,7 @@
         <p:spPr>
           <a:xfrm>
             <a:off x="2871216" y="3611880"/>
-            <a:ext cx="1901952" cy="320040"/>
+            <a:ext cx="1901952" cy="246221"/>
           </a:xfrm>
           <a:prstGeom prst="rect">
             <a:avLst/>
@@ -13846,7 +13888,7 @@
               </a:spcAft>
             </a:pPr>
             <a:r>
-              <a:rPr sz="1250" b="1" i="0">
+              <a:rPr sz="1600" b="1" i="0">
                 <a:solidFill>
                   <a:srgbClr val="06B6D4"/>
                 </a:solidFill>
@@ -13866,7 +13908,7 @@
         <p:spPr>
           <a:xfrm>
             <a:off x="2871216" y="3977639"/>
-            <a:ext cx="1901952" cy="640080"/>
+            <a:ext cx="1901952" cy="456535"/>
           </a:xfrm>
           <a:prstGeom prst="rect">
             <a:avLst/>
@@ -13891,7 +13933,7 @@
               </a:spcAft>
             </a:pPr>
             <a:r>
-              <a:rPr sz="1150" b="0" i="0">
+              <a:rPr sz="1400" b="0" i="0">
                 <a:solidFill>
                   <a:srgbClr val="0F172A"/>
                 </a:solidFill>
@@ -13913,7 +13955,7 @@
               </a:spcAft>
             </a:pPr>
             <a:r>
-              <a:rPr sz="1150" b="0" i="0">
+              <a:rPr sz="1400" b="0" i="0">
                 <a:solidFill>
                   <a:srgbClr val="0F172A"/>
                 </a:solidFill>
@@ -14025,7 +14067,7 @@
         <p:spPr>
           <a:xfrm>
             <a:off x="5084064" y="3611880"/>
-            <a:ext cx="1901952" cy="320040"/>
+            <a:ext cx="1901952" cy="246221"/>
           </a:xfrm>
           <a:prstGeom prst="rect">
             <a:avLst/>
@@ -14050,7 +14092,7 @@
               </a:spcAft>
             </a:pPr>
             <a:r>
-              <a:rPr sz="1250" b="1" i="0">
+              <a:rPr sz="1600" b="1" i="0">
                 <a:solidFill>
                   <a:srgbClr val="06B6D4"/>
                 </a:solidFill>
@@ -14070,7 +14112,7 @@
         <p:spPr>
           <a:xfrm>
             <a:off x="5084064" y="3977639"/>
-            <a:ext cx="1901952" cy="640080"/>
+            <a:ext cx="1901952" cy="456535"/>
           </a:xfrm>
           <a:prstGeom prst="rect">
             <a:avLst/>
@@ -14095,7 +14137,7 @@
               </a:spcAft>
             </a:pPr>
             <a:r>
-              <a:rPr sz="1150" b="0" i="0">
+              <a:rPr sz="1400" b="0" i="0">
                 <a:solidFill>
                   <a:srgbClr val="0F172A"/>
                 </a:solidFill>
@@ -14117,7 +14159,7 @@
               </a:spcAft>
             </a:pPr>
             <a:r>
-              <a:rPr sz="1150" b="0" i="0">
+              <a:rPr sz="1400" b="0" i="0">
                 <a:solidFill>
                   <a:srgbClr val="0F172A"/>
                 </a:solidFill>
@@ -14229,7 +14271,7 @@
         <p:spPr>
           <a:xfrm>
             <a:off x="7296912" y="3611880"/>
-            <a:ext cx="1901952" cy="320040"/>
+            <a:ext cx="1901952" cy="246221"/>
           </a:xfrm>
           <a:prstGeom prst="rect">
             <a:avLst/>
@@ -14254,7 +14296,7 @@
               </a:spcAft>
             </a:pPr>
             <a:r>
-              <a:rPr sz="1250" b="1" i="0">
+              <a:rPr sz="1600" b="1" i="0">
                 <a:solidFill>
                   <a:srgbClr val="06B6D4"/>
                 </a:solidFill>
@@ -14274,7 +14316,7 @@
         <p:spPr>
           <a:xfrm>
             <a:off x="7296912" y="3977639"/>
-            <a:ext cx="1901952" cy="640080"/>
+            <a:ext cx="1901952" cy="456535"/>
           </a:xfrm>
           <a:prstGeom prst="rect">
             <a:avLst/>
@@ -14299,7 +14341,7 @@
               </a:spcAft>
             </a:pPr>
             <a:r>
-              <a:rPr sz="1150" b="0" i="0">
+              <a:rPr sz="1400" b="0" i="0">
                 <a:solidFill>
                   <a:srgbClr val="0F172A"/>
                 </a:solidFill>
@@ -14321,7 +14363,7 @@
               </a:spcAft>
             </a:pPr>
             <a:r>
-              <a:rPr sz="1150" b="0" i="0">
+              <a:rPr sz="1400" b="0" i="0">
                 <a:solidFill>
                   <a:srgbClr val="0F172A"/>
                 </a:solidFill>
@@ -14433,7 +14475,7 @@
         <p:spPr>
           <a:xfrm>
             <a:off x="9509760" y="3611880"/>
-            <a:ext cx="1901952" cy="320040"/>
+            <a:ext cx="1901952" cy="246221"/>
           </a:xfrm>
           <a:prstGeom prst="rect">
             <a:avLst/>
@@ -14458,7 +14500,7 @@
               </a:spcAft>
             </a:pPr>
             <a:r>
-              <a:rPr sz="1250" b="1" i="0">
+              <a:rPr sz="1600" b="1" i="0">
                 <a:solidFill>
                   <a:srgbClr val="06B6D4"/>
                 </a:solidFill>
@@ -14478,7 +14520,7 @@
         <p:spPr>
           <a:xfrm>
             <a:off x="9509760" y="3977639"/>
-            <a:ext cx="1901952" cy="640080"/>
+            <a:ext cx="1901952" cy="456535"/>
           </a:xfrm>
           <a:prstGeom prst="rect">
             <a:avLst/>
@@ -14503,7 +14545,7 @@
               </a:spcAft>
             </a:pPr>
             <a:r>
-              <a:rPr sz="1150" b="0" i="0">
+              <a:rPr sz="1400" b="0" i="0">
                 <a:solidFill>
                   <a:srgbClr val="0F172A"/>
                 </a:solidFill>
@@ -14525,7 +14567,7 @@
               </a:spcAft>
             </a:pPr>
             <a:r>
-              <a:rPr sz="1150" b="0" i="0">
+              <a:rPr sz="1400" b="0" i="0">
                 <a:solidFill>
                   <a:srgbClr val="0F172A"/>
                 </a:solidFill>
@@ -14545,7 +14587,7 @@
         <p:spPr>
           <a:xfrm>
             <a:off x="548640" y="4983480"/>
-            <a:ext cx="11064240" cy="822960"/>
+            <a:ext cx="11064240" cy="791499"/>
           </a:xfrm>
           <a:prstGeom prst="rect">
             <a:avLst/>
@@ -14570,7 +14612,7 @@
               </a:spcAft>
             </a:pPr>
             <a:r>
-              <a:rPr sz="1300" b="0" i="0">
+              <a:rPr sz="1600" b="0" i="0">
                 <a:solidFill>
                   <a:srgbClr val="0F172A"/>
                 </a:solidFill>
@@ -15022,7 +15064,7 @@
         <p:spPr>
           <a:xfrm>
             <a:off x="713232" y="1874519"/>
-            <a:ext cx="3291840" cy="365760"/>
+            <a:ext cx="3291840" cy="276999"/>
           </a:xfrm>
           <a:prstGeom prst="rect">
             <a:avLst/>
@@ -15047,7 +15089,7 @@
               </a:spcAft>
             </a:pPr>
             <a:r>
-              <a:rPr sz="1400" b="1" i="0">
+              <a:rPr b="1" i="0">
                 <a:solidFill>
                   <a:srgbClr val="16A34A"/>
                 </a:solidFill>
@@ -15067,7 +15109,7 @@
         <p:spPr>
           <a:xfrm>
             <a:off x="713232" y="2286000"/>
-            <a:ext cx="3291840" cy="1097280"/>
+            <a:ext cx="3291840" cy="499111"/>
           </a:xfrm>
           <a:prstGeom prst="rect">
             <a:avLst/>
@@ -15092,7 +15134,7 @@
               </a:spcAft>
             </a:pPr>
             <a:r>
-              <a:rPr sz="1250" b="0" i="0">
+              <a:rPr sz="1600" b="0" i="0">
                 <a:solidFill>
                   <a:srgbClr val="0F172A"/>
                 </a:solidFill>
@@ -15204,7 +15246,7 @@
         <p:spPr>
           <a:xfrm>
             <a:off x="4443984" y="1874519"/>
-            <a:ext cx="3291840" cy="365760"/>
+            <a:ext cx="3291840" cy="276999"/>
           </a:xfrm>
           <a:prstGeom prst="rect">
             <a:avLst/>
@@ -15229,7 +15271,7 @@
               </a:spcAft>
             </a:pPr>
             <a:r>
-              <a:rPr sz="1400" b="1" i="0">
+              <a:rPr b="1" i="0">
                 <a:solidFill>
                   <a:srgbClr val="16A34A"/>
                 </a:solidFill>
@@ -15249,7 +15291,7 @@
         <p:spPr>
           <a:xfrm>
             <a:off x="4443984" y="2286000"/>
-            <a:ext cx="3291840" cy="1097280"/>
+            <a:ext cx="3291840" cy="757643"/>
           </a:xfrm>
           <a:prstGeom prst="rect">
             <a:avLst/>
@@ -15274,7 +15316,7 @@
               </a:spcAft>
             </a:pPr>
             <a:r>
-              <a:rPr sz="1250" b="0" i="0">
+              <a:rPr sz="1600" b="0" i="0">
                 <a:solidFill>
                   <a:srgbClr val="0F172A"/>
                 </a:solidFill>
@@ -15386,7 +15428,7 @@
         <p:spPr>
           <a:xfrm>
             <a:off x="8174736" y="1874519"/>
-            <a:ext cx="3291840" cy="365760"/>
+            <a:ext cx="3291840" cy="276999"/>
           </a:xfrm>
           <a:prstGeom prst="rect">
             <a:avLst/>
@@ -15411,7 +15453,7 @@
               </a:spcAft>
             </a:pPr>
             <a:r>
-              <a:rPr sz="1400" b="1" i="0">
+              <a:rPr b="1" i="0">
                 <a:solidFill>
                   <a:srgbClr val="16A34A"/>
                 </a:solidFill>
@@ -15431,7 +15473,7 @@
         <p:spPr>
           <a:xfrm>
             <a:off x="8174736" y="2286000"/>
-            <a:ext cx="3291840" cy="1097280"/>
+            <a:ext cx="3291840" cy="757643"/>
           </a:xfrm>
           <a:prstGeom prst="rect">
             <a:avLst/>
@@ -15456,7 +15498,7 @@
               </a:spcAft>
             </a:pPr>
             <a:r>
-              <a:rPr sz="1250" b="0" i="0">
+              <a:rPr sz="1600" b="0" i="0">
                 <a:solidFill>
                   <a:srgbClr val="0F172A"/>
                 </a:solidFill>
@@ -15476,7 +15518,7 @@
         <p:spPr>
           <a:xfrm>
             <a:off x="548640" y="3703320"/>
-            <a:ext cx="11064240" cy="274320"/>
+            <a:ext cx="11064240" cy="246221"/>
           </a:xfrm>
           <a:prstGeom prst="rect">
             <a:avLst/>
@@ -15501,7 +15543,7 @@
               </a:spcAft>
             </a:pPr>
             <a:r>
-              <a:rPr sz="1250" b="1" i="0">
+              <a:rPr sz="1600" b="1" i="0" dirty="0">
                 <a:solidFill>
                   <a:srgbClr val="2563EB"/>
                 </a:solidFill>
@@ -15521,7 +15563,7 @@
         <p:spPr>
           <a:xfrm>
             <a:off x="548640" y="4023360"/>
-            <a:ext cx="11064240" cy="1828800"/>
+            <a:ext cx="11064240" cy="1582484"/>
           </a:xfrm>
           <a:prstGeom prst="rect">
             <a:avLst/>
@@ -15547,7 +15589,7 @@
               <a:buNone/>
             </a:pPr>
             <a:r>
-              <a:rPr sz="1300">
+              <a:rPr sz="1600" dirty="0">
                 <a:solidFill>
                   <a:srgbClr val="2563EB"/>
                 </a:solidFill>
@@ -15556,7 +15598,7 @@
               <a:t>–  </a:t>
             </a:r>
             <a:r>
-              <a:rPr sz="1300">
+              <a:rPr sz="1600" dirty="0">
                 <a:solidFill>
                   <a:srgbClr val="0F172A"/>
                 </a:solidFill>
@@ -15579,7 +15621,7 @@
               <a:buNone/>
             </a:pPr>
             <a:r>
-              <a:rPr sz="1300">
+              <a:rPr sz="1600" dirty="0">
                 <a:solidFill>
                   <a:srgbClr val="2563EB"/>
                 </a:solidFill>
@@ -15588,13 +15630,31 @@
               <a:t>–  </a:t>
             </a:r>
             <a:r>
-              <a:rPr sz="1300">
+              <a:rPr sz="1600" dirty="0">
                 <a:solidFill>
                   <a:srgbClr val="0F172A"/>
                 </a:solidFill>
                 <a:latin typeface="Arial"/>
               </a:rPr>
-              <a:t>Best prompt pattern: “review this as a Dozent looking for overclaims, logical gaps and APA errors.”</a:t>
+              <a:t>Best prompt pattern: “review this as a </a:t>
+            </a:r>
+            <a:r>
+              <a:rPr sz="1600" dirty="0" err="1">
+                <a:solidFill>
+                  <a:srgbClr val="0F172A"/>
+                </a:solidFill>
+                <a:latin typeface="Arial"/>
+              </a:rPr>
+              <a:t>Dozent</a:t>
+            </a:r>
+            <a:r>
+              <a:rPr sz="1600" dirty="0">
+                <a:solidFill>
+                  <a:srgbClr val="0F172A"/>
+                </a:solidFill>
+                <a:latin typeface="Arial"/>
+              </a:rPr>
+              <a:t> looking for overclaims, logical gaps and APA errors.”</a:t>
             </a:r>
           </a:p>
           <a:p>
@@ -15611,7 +15671,7 @@
               <a:buNone/>
             </a:pPr>
             <a:r>
-              <a:rPr sz="1300">
+              <a:rPr sz="1600" dirty="0">
                 <a:solidFill>
                   <a:srgbClr val="2563EB"/>
                 </a:solidFill>
@@ -15620,7 +15680,7 @@
               <a:t>–  </a:t>
             </a:r>
             <a:r>
-              <a:rPr sz="1300">
+              <a:rPr sz="1600" dirty="0">
                 <a:solidFill>
                   <a:srgbClr val="0F172A"/>
                 </a:solidFill>
@@ -15643,7 +15703,7 @@
               <a:buNone/>
             </a:pPr>
             <a:r>
-              <a:rPr sz="1300">
+              <a:rPr sz="1600" dirty="0">
                 <a:solidFill>
                   <a:srgbClr val="2563EB"/>
                 </a:solidFill>
@@ -15652,7 +15712,7 @@
               <a:t>–  </a:t>
             </a:r>
             <a:r>
-              <a:rPr sz="1300">
+              <a:rPr sz="1600" dirty="0">
                 <a:solidFill>
                   <a:srgbClr val="0F172A"/>
                 </a:solidFill>
@@ -16194,7 +16254,7 @@
         <p:spPr>
           <a:xfrm>
             <a:off x="731520" y="2423160"/>
-            <a:ext cx="5074920" cy="2468880"/>
+            <a:ext cx="5074920" cy="1642629"/>
           </a:xfrm>
           <a:prstGeom prst="rect">
             <a:avLst/>
@@ -16220,7 +16280,7 @@
               <a:buNone/>
             </a:pPr>
             <a:r>
-              <a:rPr sz="1250">
+              <a:rPr sz="1500" dirty="0">
                 <a:solidFill>
                   <a:srgbClr val="D97706"/>
                 </a:solidFill>
@@ -16229,7 +16289,7 @@
               <a:t>–  </a:t>
             </a:r>
             <a:r>
-              <a:rPr sz="1250">
+              <a:rPr sz="1500" dirty="0">
                 <a:solidFill>
                   <a:srgbClr val="0F172A"/>
                 </a:solidFill>
@@ -16252,7 +16312,7 @@
               <a:buNone/>
             </a:pPr>
             <a:r>
-              <a:rPr sz="1250">
+              <a:rPr sz="1500" dirty="0">
                 <a:solidFill>
                   <a:srgbClr val="D97706"/>
                 </a:solidFill>
@@ -16261,13 +16321,13 @@
               <a:t>–  </a:t>
             </a:r>
             <a:r>
-              <a:rPr sz="1250">
+              <a:rPr sz="1500" dirty="0">
                 <a:solidFill>
                   <a:srgbClr val="0F172A"/>
                 </a:solidFill>
                 <a:latin typeface="Arial"/>
               </a:rPr>
-              <a:t>Geely PDFs were not machine-readable → more manual web research.</a:t>
+              <a:t>Token / context limits hit quickly on the stronger model in long sessions.</a:t>
             </a:r>
           </a:p>
           <a:p>
@@ -16284,7 +16344,7 @@
               <a:buNone/>
             </a:pPr>
             <a:r>
-              <a:rPr sz="1250">
+              <a:rPr sz="1500" dirty="0">
                 <a:solidFill>
                   <a:srgbClr val="D97706"/>
                 </a:solidFill>
@@ -16293,39 +16353,7 @@
               <a:t>–  </a:t>
             </a:r>
             <a:r>
-              <a:rPr sz="1250">
-                <a:solidFill>
-                  <a:srgbClr val="0F172A"/>
-                </a:solidFill>
-                <a:latin typeface="Arial"/>
-              </a:rPr>
-              <a:t>Token / context limits hit quickly on the stronger model in long sessions.</a:t>
-            </a:r>
-          </a:p>
-          <a:p>
-            <a:pPr>
-              <a:lnSpc>
-                <a:spcPct val="105000"/>
-              </a:lnSpc>
-              <a:spcBef>
-                <a:spcPts val="0"/>
-              </a:spcBef>
-              <a:spcAft>
-                <a:spcPts val="800"/>
-              </a:spcAft>
-              <a:buNone/>
-            </a:pPr>
-            <a:r>
-              <a:rPr sz="1250">
-                <a:solidFill>
-                  <a:srgbClr val="D97706"/>
-                </a:solidFill>
-                <a:latin typeface="Arial"/>
-              </a:rPr>
-              <a:t>–  </a:t>
-            </a:r>
-            <a:r>
-              <a:rPr sz="1250">
+              <a:rPr sz="1500" dirty="0">
                 <a:solidFill>
                   <a:srgbClr val="0F172A"/>
                 </a:solidFill>
@@ -16482,7 +16510,7 @@
         <p:spPr>
           <a:xfrm>
             <a:off x="6355080" y="2423160"/>
-            <a:ext cx="5074920" cy="2468880"/>
+            <a:ext cx="5074920" cy="2229969"/>
           </a:xfrm>
           <a:prstGeom prst="rect">
             <a:avLst/>
@@ -16508,7 +16536,7 @@
               <a:buNone/>
             </a:pPr>
             <a:r>
-              <a:rPr sz="1250">
+              <a:rPr sz="1500" dirty="0">
                 <a:solidFill>
                   <a:srgbClr val="2563EB"/>
                 </a:solidFill>
@@ -16517,7 +16545,7 @@
               <a:t>–  </a:t>
             </a:r>
             <a:r>
-              <a:rPr sz="1250">
+              <a:rPr sz="1500" dirty="0">
                 <a:solidFill>
                   <a:srgbClr val="0F172A"/>
                 </a:solidFill>
@@ -16540,7 +16568,7 @@
               <a:buNone/>
             </a:pPr>
             <a:r>
-              <a:rPr sz="1250">
+              <a:rPr sz="1500" dirty="0">
                 <a:solidFill>
                   <a:srgbClr val="2563EB"/>
                 </a:solidFill>
@@ -16549,7 +16577,7 @@
               <a:t>–  </a:t>
             </a:r>
             <a:r>
-              <a:rPr sz="1250">
+              <a:rPr sz="1500" dirty="0">
                 <a:solidFill>
                   <a:srgbClr val="0F172A"/>
                 </a:solidFill>
@@ -16572,7 +16600,7 @@
               <a:buNone/>
             </a:pPr>
             <a:r>
-              <a:rPr sz="1250">
+              <a:rPr sz="1500" dirty="0">
                 <a:solidFill>
                   <a:srgbClr val="2563EB"/>
                 </a:solidFill>
@@ -16581,7 +16609,7 @@
               <a:t>–  </a:t>
             </a:r>
             <a:r>
-              <a:rPr sz="1250">
+              <a:rPr sz="1500" dirty="0">
                 <a:solidFill>
                   <a:srgbClr val="0F172A"/>
                 </a:solidFill>
@@ -16604,7 +16632,7 @@
               <a:buNone/>
             </a:pPr>
             <a:r>
-              <a:rPr sz="1250">
+              <a:rPr sz="1500" dirty="0">
                 <a:solidFill>
                   <a:srgbClr val="2563EB"/>
                 </a:solidFill>
@@ -16613,7 +16641,7 @@
               <a:t>–  </a:t>
             </a:r>
             <a:r>
-              <a:rPr sz="1250">
+              <a:rPr sz="1500" dirty="0">
                 <a:solidFill>
                   <a:srgbClr val="0F172A"/>
                 </a:solidFill>
@@ -16677,8 +16705,8 @@
         </p:nvSpPr>
         <p:spPr>
           <a:xfrm>
-            <a:off x="731520" y="5257800"/>
-            <a:ext cx="10698480" cy="640080"/>
+            <a:off x="731520" y="5331618"/>
+            <a:ext cx="10698480" cy="492443"/>
           </a:xfrm>
           <a:prstGeom prst="rect">
             <a:avLst/>
@@ -16703,7 +16731,7 @@
               </a:spcAft>
             </a:pPr>
             <a:r>
-              <a:rPr sz="1350" b="1" i="0">
+              <a:rPr sz="1600" b="1" i="0" dirty="0">
                 <a:solidFill>
                   <a:srgbClr val="FFFFFF"/>
                 </a:solidFill>
@@ -17200,7 +17228,7 @@
         <p:spPr>
           <a:xfrm>
             <a:off x="658368" y="2880360"/>
-            <a:ext cx="2478024" cy="594360"/>
+            <a:ext cx="2478024" cy="487313"/>
           </a:xfrm>
           <a:prstGeom prst="rect">
             <a:avLst/>
@@ -17225,7 +17253,7 @@
               </a:spcAft>
             </a:pPr>
             <a:r>
-              <a:rPr sz="1200" b="0" i="0">
+              <a:rPr sz="1500" b="0" i="0" dirty="0">
                 <a:solidFill>
                   <a:srgbClr val="0F172A"/>
                 </a:solidFill>
@@ -17247,7 +17275,7 @@
               </a:spcAft>
             </a:pPr>
             <a:r>
-              <a:rPr sz="1200" b="0" i="0">
+              <a:rPr sz="1500" b="0" i="0" dirty="0">
                 <a:solidFill>
                   <a:srgbClr val="0F172A"/>
                 </a:solidFill>
@@ -17404,7 +17432,7 @@
         <p:spPr>
           <a:xfrm>
             <a:off x="3447288" y="2880360"/>
-            <a:ext cx="2478024" cy="594360"/>
+            <a:ext cx="2478024" cy="487313"/>
           </a:xfrm>
           <a:prstGeom prst="rect">
             <a:avLst/>
@@ -17429,7 +17457,7 @@
               </a:spcAft>
             </a:pPr>
             <a:r>
-              <a:rPr sz="1200" b="0" i="0">
+              <a:rPr sz="1500" b="0" i="0" dirty="0">
                 <a:solidFill>
                   <a:srgbClr val="0F172A"/>
                 </a:solidFill>
@@ -17451,7 +17479,7 @@
               </a:spcAft>
             </a:pPr>
             <a:r>
-              <a:rPr sz="1200" b="0" i="0">
+              <a:rPr sz="1500" b="0" i="0" dirty="0">
                 <a:solidFill>
                   <a:srgbClr val="0F172A"/>
                 </a:solidFill>
@@ -17608,7 +17636,7 @@
         <p:spPr>
           <a:xfrm>
             <a:off x="6236208" y="2880360"/>
-            <a:ext cx="2478024" cy="594360"/>
+            <a:ext cx="2478024" cy="487313"/>
           </a:xfrm>
           <a:prstGeom prst="rect">
             <a:avLst/>
@@ -17622,18 +17650,12 @@
           <a:lstStyle/>
           <a:p>
             <a:pPr algn="ctr">
-              <a:lnSpc>
-                <a:spcPct val="100000"/>
-              </a:lnSpc>
-              <a:spcBef>
-                <a:spcPts val="0"/>
-              </a:spcBef>
               <a:spcAft>
                 <a:spcPts val="200"/>
               </a:spcAft>
             </a:pPr>
             <a:r>
-              <a:rPr sz="1200" b="0" i="0">
+              <a:rPr sz="1500" dirty="0">
                 <a:solidFill>
                   <a:srgbClr val="0F172A"/>
                 </a:solidFill>
@@ -17644,18 +17666,12 @@
           </a:p>
           <a:p>
             <a:pPr algn="ctr">
-              <a:lnSpc>
-                <a:spcPct val="100000"/>
-              </a:lnSpc>
-              <a:spcBef>
-                <a:spcPts val="0"/>
-              </a:spcBef>
               <a:spcAft>
                 <a:spcPts val="200"/>
               </a:spcAft>
             </a:pPr>
             <a:r>
-              <a:rPr sz="1200" b="0" i="0">
+              <a:rPr sz="1500" dirty="0">
                 <a:solidFill>
                   <a:srgbClr val="0F172A"/>
                 </a:solidFill>
@@ -17812,7 +17828,7 @@
         <p:spPr>
           <a:xfrm>
             <a:off x="9025128" y="2880360"/>
-            <a:ext cx="2478024" cy="594360"/>
+            <a:ext cx="2478024" cy="487313"/>
           </a:xfrm>
           <a:prstGeom prst="rect">
             <a:avLst/>
@@ -17837,7 +17853,7 @@
               </a:spcAft>
             </a:pPr>
             <a:r>
-              <a:rPr sz="1200" b="0" i="0">
+              <a:rPr sz="1500" dirty="0">
                 <a:solidFill>
                   <a:srgbClr val="0F172A"/>
                 </a:solidFill>
@@ -17859,7 +17875,7 @@
               </a:spcAft>
             </a:pPr>
             <a:r>
-              <a:rPr sz="1200" b="0" i="0">
+              <a:rPr sz="1500" dirty="0">
                 <a:solidFill>
                   <a:srgbClr val="0F172A"/>
                 </a:solidFill>
@@ -17905,7 +17921,7 @@
               <a:buNone/>
             </a:pPr>
             <a:r>
-              <a:rPr sz="1500">
+              <a:rPr sz="1500" dirty="0">
                 <a:solidFill>
                   <a:srgbClr val="2563EB"/>
                 </a:solidFill>
@@ -17914,7 +17930,7 @@
               <a:t>–  </a:t>
             </a:r>
             <a:r>
-              <a:rPr sz="1500">
+              <a:rPr sz="1500" dirty="0">
                 <a:solidFill>
                   <a:srgbClr val="0F172A"/>
                 </a:solidFill>
@@ -17937,7 +17953,7 @@
               <a:buNone/>
             </a:pPr>
             <a:r>
-              <a:rPr sz="1500">
+              <a:rPr sz="1500" dirty="0">
                 <a:solidFill>
                   <a:srgbClr val="2563EB"/>
                 </a:solidFill>
@@ -17946,7 +17962,7 @@
               <a:t>–  </a:t>
             </a:r>
             <a:r>
-              <a:rPr sz="1500">
+              <a:rPr sz="1500" dirty="0">
                 <a:solidFill>
                   <a:srgbClr val="0F172A"/>
                 </a:solidFill>
@@ -17969,7 +17985,7 @@
               <a:buNone/>
             </a:pPr>
             <a:r>
-              <a:rPr sz="1500">
+              <a:rPr sz="1500" dirty="0">
                 <a:solidFill>
                   <a:srgbClr val="2563EB"/>
                 </a:solidFill>
@@ -17978,7 +17994,7 @@
               <a:t>–  </a:t>
             </a:r>
             <a:r>
-              <a:rPr sz="1500">
+              <a:rPr sz="1500" dirty="0">
                 <a:solidFill>
                   <a:srgbClr val="0F172A"/>
                 </a:solidFill>
@@ -18248,7 +18264,7 @@
         <p:spPr>
           <a:xfrm>
             <a:off x="548640" y="658368"/>
-            <a:ext cx="11064240" cy="914400"/>
+            <a:ext cx="11064240" cy="323165"/>
           </a:xfrm>
           <a:prstGeom prst="rect">
             <a:avLst/>
@@ -18273,13 +18289,13 @@
               </a:spcAft>
             </a:pPr>
             <a:r>
-              <a:rPr sz="2100" b="1" i="0">
+              <a:rPr sz="2100" b="1" i="0" dirty="0">
                 <a:solidFill>
                   <a:srgbClr val="0F172A"/>
                 </a:solidFill>
                 <a:latin typeface="Arial"/>
               </a:rPr>
-              <a:t>Key sources (APA 7)</a:t>
+              <a:t>Key sources</a:t>
             </a:r>
           </a:p>
         </p:txBody>
@@ -19253,7 +19269,7 @@
               </a:spcAft>
             </a:pPr>
             <a:r>
-              <a:rPr sz="1600" b="1" i="1">
+              <a:rPr sz="1600" b="1" i="1" dirty="0">
                 <a:solidFill>
                   <a:srgbClr val="FFFFFF"/>
                 </a:solidFill>
@@ -19410,7 +19426,7 @@
         <p:spPr>
           <a:xfrm>
             <a:off x="713232" y="3273552"/>
-            <a:ext cx="3291840" cy="640080"/>
+            <a:ext cx="3291840" cy="493597"/>
           </a:xfrm>
           <a:prstGeom prst="rect">
             <a:avLst/>
@@ -19435,7 +19451,7 @@
               </a:spcAft>
             </a:pPr>
             <a:r>
-              <a:rPr sz="1300" b="0" i="0">
+              <a:rPr sz="1500" b="0" i="0" dirty="0">
                 <a:solidFill>
                   <a:srgbClr val="0F172A"/>
                 </a:solidFill>
@@ -19457,7 +19473,7 @@
               </a:spcAft>
             </a:pPr>
             <a:r>
-              <a:rPr sz="1300" b="0" i="0">
+              <a:rPr sz="1500" b="0" i="0" dirty="0">
                 <a:solidFill>
                   <a:srgbClr val="0F172A"/>
                 </a:solidFill>
@@ -19594,7 +19610,7 @@
               </a:spcAft>
             </a:pPr>
             <a:r>
-              <a:rPr sz="1600" b="1" i="0">
+              <a:rPr sz="1600" b="1" i="0" dirty="0">
                 <a:solidFill>
                   <a:srgbClr val="2563EB"/>
                 </a:solidFill>
@@ -19614,7 +19630,7 @@
         <p:spPr>
           <a:xfrm>
             <a:off x="4443984" y="3273552"/>
-            <a:ext cx="3291840" cy="640080"/>
+            <a:ext cx="3291840" cy="493597"/>
           </a:xfrm>
           <a:prstGeom prst="rect">
             <a:avLst/>
@@ -19639,7 +19655,7 @@
               </a:spcAft>
             </a:pPr>
             <a:r>
-              <a:rPr sz="1300" b="0" i="0">
+              <a:rPr sz="1500" b="0" i="0" dirty="0">
                 <a:solidFill>
                   <a:srgbClr val="0F172A"/>
                 </a:solidFill>
@@ -19661,7 +19677,7 @@
               </a:spcAft>
             </a:pPr>
             <a:r>
-              <a:rPr sz="1300" b="0" i="0">
+              <a:rPr sz="1500" b="0" i="0" dirty="0">
                 <a:solidFill>
                   <a:srgbClr val="0F172A"/>
                 </a:solidFill>
@@ -19818,7 +19834,7 @@
         <p:spPr>
           <a:xfrm>
             <a:off x="8174736" y="3273552"/>
-            <a:ext cx="3291840" cy="640080"/>
+            <a:ext cx="3291840" cy="493597"/>
           </a:xfrm>
           <a:prstGeom prst="rect">
             <a:avLst/>
@@ -19843,7 +19859,7 @@
               </a:spcAft>
             </a:pPr>
             <a:r>
-              <a:rPr sz="1300" b="0" i="0">
+              <a:rPr sz="1500" b="0" i="0" dirty="0">
                 <a:solidFill>
                   <a:srgbClr val="0F172A"/>
                 </a:solidFill>
@@ -19865,7 +19881,7 @@
               </a:spcAft>
             </a:pPr>
             <a:r>
-              <a:rPr sz="1300" b="0" i="0">
+              <a:rPr sz="1500" b="0" i="0" dirty="0">
                 <a:solidFill>
                   <a:srgbClr val="0F172A"/>
                 </a:solidFill>
@@ -19885,7 +19901,7 @@
         <p:spPr>
           <a:xfrm>
             <a:off x="548640" y="4206240"/>
-            <a:ext cx="11064240" cy="274320"/>
+            <a:ext cx="11064240" cy="230832"/>
           </a:xfrm>
           <a:prstGeom prst="rect">
             <a:avLst/>
@@ -19910,7 +19926,7 @@
               </a:spcAft>
             </a:pPr>
             <a:r>
-              <a:rPr sz="1250" b="1" i="0">
+              <a:rPr sz="1500" b="1" i="0" dirty="0">
                 <a:solidFill>
                   <a:srgbClr val="2563EB"/>
                 </a:solidFill>
@@ -19974,8 +19990,8 @@
         </p:nvSpPr>
         <p:spPr>
           <a:xfrm>
-            <a:off x="548640" y="4572000"/>
-            <a:ext cx="2560320" cy="640080"/>
+            <a:off x="548640" y="4776624"/>
+            <a:ext cx="2560320" cy="230832"/>
           </a:xfrm>
           <a:prstGeom prst="rect">
             <a:avLst/>
@@ -20000,14 +20016,29 @@
               </a:spcAft>
             </a:pPr>
             <a:r>
-              <a:rPr sz="1350" b="1" i="0">
+              <a:rPr lang="de-DE" sz="1500" b="1" i="0" dirty="0">
                 <a:solidFill>
                   <a:srgbClr val="FFFFFF"/>
                 </a:solidFill>
                 <a:latin typeface="Arial"/>
               </a:rPr>
-              <a:t>1  Governance</a:t>
-            </a:r>
+              <a:t>1  </a:t>
+            </a:r>
+            <a:r>
+              <a:rPr lang="de-DE" sz="1500" b="1" i="0" dirty="0" err="1">
+                <a:solidFill>
+                  <a:srgbClr val="FFFFFF"/>
+                </a:solidFill>
+                <a:latin typeface="Arial"/>
+              </a:rPr>
+              <a:t>Governance</a:t>
+            </a:r>
+            <a:endParaRPr sz="1500" b="1" i="0" dirty="0">
+              <a:solidFill>
+                <a:srgbClr val="FFFFFF"/>
+              </a:solidFill>
+              <a:latin typeface="Arial"/>
+            </a:endParaRPr>
           </a:p>
         </p:txBody>
       </p:sp>
@@ -20109,8 +20140,8 @@
         </p:nvSpPr>
         <p:spPr>
           <a:xfrm>
-            <a:off x="3291840" y="4572000"/>
-            <a:ext cx="2560320" cy="640080"/>
+            <a:off x="3291840" y="4776624"/>
+            <a:ext cx="2560320" cy="230832"/>
           </a:xfrm>
           <a:prstGeom prst="rect">
             <a:avLst/>
@@ -20135,7 +20166,7 @@
               </a:spcAft>
             </a:pPr>
             <a:r>
-              <a:rPr sz="1350" b="1" i="0">
+              <a:rPr sz="1500" b="1" i="0" dirty="0">
                 <a:solidFill>
                   <a:srgbClr val="FFFFFF"/>
                 </a:solidFill>
@@ -20244,8 +20275,8 @@
         </p:nvSpPr>
         <p:spPr>
           <a:xfrm>
-            <a:off x="6035040" y="4572000"/>
-            <a:ext cx="2560320" cy="640080"/>
+            <a:off x="6035040" y="4776624"/>
+            <a:ext cx="2560320" cy="230832"/>
           </a:xfrm>
           <a:prstGeom prst="rect">
             <a:avLst/>
@@ -20270,7 +20301,7 @@
               </a:spcAft>
             </a:pPr>
             <a:r>
-              <a:rPr sz="1350" b="1" i="0">
+              <a:rPr sz="1500" b="1" i="0" dirty="0">
                 <a:solidFill>
                   <a:srgbClr val="FFFFFF"/>
                 </a:solidFill>
@@ -20379,8 +20410,8 @@
         </p:nvSpPr>
         <p:spPr>
           <a:xfrm>
-            <a:off x="8778240" y="4572000"/>
-            <a:ext cx="2560320" cy="640080"/>
+            <a:off x="8778240" y="4776624"/>
+            <a:ext cx="2560320" cy="230832"/>
           </a:xfrm>
           <a:prstGeom prst="rect">
             <a:avLst/>
@@ -20405,7 +20436,7 @@
               </a:spcAft>
             </a:pPr>
             <a:r>
-              <a:rPr sz="1350" b="1" i="0">
+              <a:rPr sz="1500" b="1" i="0" dirty="0">
                 <a:solidFill>
                   <a:srgbClr val="FFFFFF"/>
                 </a:solidFill>
@@ -20425,7 +20456,7 @@
         <p:spPr>
           <a:xfrm>
             <a:off x="548640" y="5532120"/>
-            <a:ext cx="11064240" cy="548640"/>
+            <a:ext cx="11064240" cy="225575"/>
           </a:xfrm>
           <a:prstGeom prst="rect">
             <a:avLst/>
@@ -20450,7 +20481,7 @@
               </a:spcAft>
             </a:pPr>
             <a:r>
-              <a:rPr sz="1400" b="1" i="0">
+              <a:rPr sz="1500" b="1" i="0" dirty="0">
                 <a:solidFill>
                   <a:srgbClr val="0F172A"/>
                 </a:solidFill>
@@ -20902,7 +20933,7 @@
         <p:spPr>
           <a:xfrm>
             <a:off x="749808" y="1883664"/>
-            <a:ext cx="3264408" cy="457200"/>
+            <a:ext cx="3264408" cy="233910"/>
           </a:xfrm>
           <a:prstGeom prst="rect">
             <a:avLst/>
@@ -20927,7 +20958,7 @@
               </a:spcAft>
             </a:pPr>
             <a:r>
-              <a:rPr sz="1450" b="1" i="0">
+              <a:rPr sz="1600" b="1" i="0" dirty="0">
                 <a:solidFill>
                   <a:srgbClr val="0F172A"/>
                 </a:solidFill>
@@ -20947,7 +20978,7 @@
         <p:spPr>
           <a:xfrm>
             <a:off x="749808" y="2450592"/>
-            <a:ext cx="3264408" cy="274320"/>
+            <a:ext cx="3264408" cy="230832"/>
           </a:xfrm>
           <a:prstGeom prst="rect">
             <a:avLst/>
@@ -20972,7 +21003,7 @@
               </a:spcAft>
             </a:pPr>
             <a:r>
-              <a:rPr sz="1150" b="1" i="1">
+              <a:rPr sz="1500" b="1" i="1">
                 <a:solidFill>
                   <a:srgbClr val="DC2626"/>
                 </a:solidFill>
@@ -20992,7 +21023,7 @@
         <p:spPr>
           <a:xfrm>
             <a:off x="749808" y="2761488"/>
-            <a:ext cx="3264408" cy="777240"/>
+            <a:ext cx="3264408" cy="461665"/>
           </a:xfrm>
           <a:prstGeom prst="rect">
             <a:avLst/>
@@ -21017,7 +21048,7 @@
               </a:spcAft>
             </a:pPr>
             <a:r>
-              <a:rPr sz="1250" b="0" i="0">
+              <a:rPr sz="1500" b="0" i="0" dirty="0">
                 <a:solidFill>
                   <a:srgbClr val="0F172A"/>
                 </a:solidFill>
@@ -21129,7 +21160,7 @@
         <p:spPr>
           <a:xfrm>
             <a:off x="4494276" y="1883664"/>
-            <a:ext cx="3264408" cy="457200"/>
+            <a:ext cx="3264408" cy="233910"/>
           </a:xfrm>
           <a:prstGeom prst="rect">
             <a:avLst/>
@@ -21154,7 +21185,7 @@
               </a:spcAft>
             </a:pPr>
             <a:r>
-              <a:rPr sz="1450" b="1" i="0">
+              <a:rPr sz="1600" b="1" i="0">
                 <a:solidFill>
                   <a:srgbClr val="0F172A"/>
                 </a:solidFill>
@@ -21174,7 +21205,7 @@
         <p:spPr>
           <a:xfrm>
             <a:off x="4494276" y="2450592"/>
-            <a:ext cx="3264408" cy="274320"/>
+            <a:ext cx="3264408" cy="230832"/>
           </a:xfrm>
           <a:prstGeom prst="rect">
             <a:avLst/>
@@ -21199,7 +21230,7 @@
               </a:spcAft>
             </a:pPr>
             <a:r>
-              <a:rPr sz="1150" b="1" i="1">
+              <a:rPr sz="1500" b="1" i="1">
                 <a:solidFill>
                   <a:srgbClr val="DC2626"/>
                 </a:solidFill>
@@ -21219,7 +21250,7 @@
         <p:spPr>
           <a:xfrm>
             <a:off x="4494276" y="2761488"/>
-            <a:ext cx="3264408" cy="777240"/>
+            <a:ext cx="3264408" cy="461665"/>
           </a:xfrm>
           <a:prstGeom prst="rect">
             <a:avLst/>
@@ -21244,7 +21275,7 @@
               </a:spcAft>
             </a:pPr>
             <a:r>
-              <a:rPr sz="1250" b="0" i="0">
+              <a:rPr sz="1500" b="0" i="0">
                 <a:solidFill>
                   <a:srgbClr val="0F172A"/>
                 </a:solidFill>
@@ -21356,7 +21387,7 @@
         <p:spPr>
           <a:xfrm>
             <a:off x="8238744" y="1883664"/>
-            <a:ext cx="3264408" cy="457200"/>
+            <a:ext cx="3264408" cy="233910"/>
           </a:xfrm>
           <a:prstGeom prst="rect">
             <a:avLst/>
@@ -21381,7 +21412,7 @@
               </a:spcAft>
             </a:pPr>
             <a:r>
-              <a:rPr sz="1450" b="1" i="0">
+              <a:rPr sz="1600" b="1" i="0">
                 <a:solidFill>
                   <a:srgbClr val="0F172A"/>
                 </a:solidFill>
@@ -21401,7 +21432,7 @@
         <p:spPr>
           <a:xfrm>
             <a:off x="8238744" y="2450592"/>
-            <a:ext cx="3264408" cy="274320"/>
+            <a:ext cx="3264408" cy="230832"/>
           </a:xfrm>
           <a:prstGeom prst="rect">
             <a:avLst/>
@@ -21426,7 +21457,7 @@
               </a:spcAft>
             </a:pPr>
             <a:r>
-              <a:rPr sz="1150" b="1" i="1">
+              <a:rPr sz="1500" b="1" i="1">
                 <a:solidFill>
                   <a:srgbClr val="2563EB"/>
                 </a:solidFill>
@@ -21446,7 +21477,7 @@
         <p:spPr>
           <a:xfrm>
             <a:off x="8238744" y="2761488"/>
-            <a:ext cx="3264408" cy="777240"/>
+            <a:ext cx="3264408" cy="461665"/>
           </a:xfrm>
           <a:prstGeom prst="rect">
             <a:avLst/>
@@ -21471,7 +21502,7 @@
               </a:spcAft>
             </a:pPr>
             <a:r>
-              <a:rPr sz="1250" b="0" i="0">
+              <a:rPr sz="1500" b="0" i="0">
                 <a:solidFill>
                   <a:srgbClr val="0F172A"/>
                 </a:solidFill>
@@ -21583,7 +21614,7 @@
         <p:spPr>
           <a:xfrm>
             <a:off x="749808" y="3941063"/>
-            <a:ext cx="3264408" cy="457200"/>
+            <a:ext cx="3264408" cy="233910"/>
           </a:xfrm>
           <a:prstGeom prst="rect">
             <a:avLst/>
@@ -21608,7 +21639,7 @@
               </a:spcAft>
             </a:pPr>
             <a:r>
-              <a:rPr sz="1450" b="1" i="0">
+              <a:rPr sz="1600" b="1" i="0" dirty="0">
                 <a:solidFill>
                   <a:srgbClr val="0F172A"/>
                 </a:solidFill>
@@ -21627,8 +21658,8 @@
         </p:nvSpPr>
         <p:spPr>
           <a:xfrm>
-            <a:off x="749808" y="4507991"/>
-            <a:ext cx="3264408" cy="274320"/>
+            <a:off x="749808" y="4277158"/>
+            <a:ext cx="3264408" cy="461665"/>
           </a:xfrm>
           <a:prstGeom prst="rect">
             <a:avLst/>
@@ -21653,7 +21684,7 @@
               </a:spcAft>
             </a:pPr>
             <a:r>
-              <a:rPr sz="1150" b="1" i="1">
+              <a:rPr sz="1500" b="1" i="1" dirty="0">
                 <a:solidFill>
                   <a:srgbClr val="DC2626"/>
                 </a:solidFill>
@@ -21673,7 +21704,7 @@
         <p:spPr>
           <a:xfrm>
             <a:off x="749808" y="4818887"/>
-            <a:ext cx="3264408" cy="777240"/>
+            <a:ext cx="3264408" cy="461665"/>
           </a:xfrm>
           <a:prstGeom prst="rect">
             <a:avLst/>
@@ -21698,7 +21729,7 @@
               </a:spcAft>
             </a:pPr>
             <a:r>
-              <a:rPr sz="1250" b="0" i="0">
+              <a:rPr sz="1500" b="0" i="0">
                 <a:solidFill>
                   <a:srgbClr val="0F172A"/>
                 </a:solidFill>
@@ -21810,7 +21841,7 @@
         <p:spPr>
           <a:xfrm>
             <a:off x="4494276" y="3941063"/>
-            <a:ext cx="3264408" cy="457200"/>
+            <a:ext cx="3264408" cy="233910"/>
           </a:xfrm>
           <a:prstGeom prst="rect">
             <a:avLst/>
@@ -21835,7 +21866,7 @@
               </a:spcAft>
             </a:pPr>
             <a:r>
-              <a:rPr sz="1450" b="1" i="0">
+              <a:rPr sz="1600" b="1" i="0">
                 <a:solidFill>
                   <a:srgbClr val="0F172A"/>
                 </a:solidFill>
@@ -21855,7 +21886,7 @@
         <p:spPr>
           <a:xfrm>
             <a:off x="4494276" y="4507991"/>
-            <a:ext cx="3264408" cy="274320"/>
+            <a:ext cx="3264408" cy="230832"/>
           </a:xfrm>
           <a:prstGeom prst="rect">
             <a:avLst/>
@@ -21880,7 +21911,7 @@
               </a:spcAft>
             </a:pPr>
             <a:r>
-              <a:rPr sz="1150" b="1" i="1">
+              <a:rPr sz="1500" b="1" i="1">
                 <a:solidFill>
                   <a:srgbClr val="06B6D4"/>
                 </a:solidFill>
@@ -21900,7 +21931,7 @@
         <p:spPr>
           <a:xfrm>
             <a:off x="4494276" y="4818887"/>
-            <a:ext cx="3264408" cy="777240"/>
+            <a:ext cx="3264408" cy="461665"/>
           </a:xfrm>
           <a:prstGeom prst="rect">
             <a:avLst/>
@@ -21925,7 +21956,7 @@
               </a:spcAft>
             </a:pPr>
             <a:r>
-              <a:rPr sz="1250" b="0" i="0">
+              <a:rPr sz="1500" b="0" i="0">
                 <a:solidFill>
                   <a:srgbClr val="0F172A"/>
                 </a:solidFill>
@@ -22037,7 +22068,7 @@
         <p:spPr>
           <a:xfrm>
             <a:off x="8238744" y="3941063"/>
-            <a:ext cx="3264408" cy="457200"/>
+            <a:ext cx="3264408" cy="233910"/>
           </a:xfrm>
           <a:prstGeom prst="rect">
             <a:avLst/>
@@ -22062,7 +22093,7 @@
               </a:spcAft>
             </a:pPr>
             <a:r>
-              <a:rPr sz="1450" b="1" i="0">
+              <a:rPr sz="1600" b="1" i="0">
                 <a:solidFill>
                   <a:srgbClr val="0F172A"/>
                 </a:solidFill>
@@ -22082,7 +22113,7 @@
         <p:spPr>
           <a:xfrm>
             <a:off x="8238744" y="4507991"/>
-            <a:ext cx="3264408" cy="274320"/>
+            <a:ext cx="3264408" cy="230832"/>
           </a:xfrm>
           <a:prstGeom prst="rect">
             <a:avLst/>
@@ -22107,7 +22138,7 @@
               </a:spcAft>
             </a:pPr>
             <a:r>
-              <a:rPr sz="1150" b="1" i="1">
+              <a:rPr sz="1500" b="1" i="1" dirty="0">
                 <a:solidFill>
                   <a:srgbClr val="2563EB"/>
                 </a:solidFill>
@@ -22127,7 +22158,7 @@
         <p:spPr>
           <a:xfrm>
             <a:off x="8238744" y="4818887"/>
-            <a:ext cx="3264408" cy="777240"/>
+            <a:ext cx="3264408" cy="461665"/>
           </a:xfrm>
           <a:prstGeom prst="rect">
             <a:avLst/>
@@ -22152,7 +22183,7 @@
               </a:spcAft>
             </a:pPr>
             <a:r>
-              <a:rPr sz="1250" b="0" i="0">
+              <a:rPr sz="1500" b="0" i="0" dirty="0">
                 <a:solidFill>
                   <a:srgbClr val="0F172A"/>
                 </a:solidFill>
@@ -22638,8 +22669,8 @@
         </p:nvSpPr>
         <p:spPr>
           <a:xfrm>
-            <a:off x="2176272" y="1783080"/>
-            <a:ext cx="2459736" cy="841248"/>
+            <a:off x="2176272" y="2086749"/>
+            <a:ext cx="2459736" cy="233910"/>
           </a:xfrm>
           <a:prstGeom prst="rect">
             <a:avLst/>
@@ -22664,7 +22695,7 @@
               </a:spcAft>
             </a:pPr>
             <a:r>
-              <a:rPr sz="1350" b="1" i="0">
+              <a:rPr sz="1600" b="1" i="0">
                 <a:solidFill>
                   <a:srgbClr val="FFFFFF"/>
                 </a:solidFill>
@@ -22728,8 +22759,8 @@
         </p:nvSpPr>
         <p:spPr>
           <a:xfrm>
-            <a:off x="4782312" y="1783080"/>
-            <a:ext cx="2185416" cy="841248"/>
+            <a:off x="4782312" y="2086749"/>
+            <a:ext cx="2185416" cy="233910"/>
           </a:xfrm>
           <a:prstGeom prst="rect">
             <a:avLst/>
@@ -22754,7 +22785,7 @@
               </a:spcAft>
             </a:pPr>
             <a:r>
-              <a:rPr sz="1350" b="1" i="0">
+              <a:rPr sz="1600" b="1" i="0">
                 <a:solidFill>
                   <a:srgbClr val="FFFFFF"/>
                 </a:solidFill>
@@ -22818,8 +22849,8 @@
         </p:nvSpPr>
         <p:spPr>
           <a:xfrm>
-            <a:off x="7114032" y="1783080"/>
-            <a:ext cx="2185416" cy="841248"/>
+            <a:off x="7114032" y="2086749"/>
+            <a:ext cx="2185416" cy="233910"/>
           </a:xfrm>
           <a:prstGeom prst="rect">
             <a:avLst/>
@@ -22844,7 +22875,7 @@
               </a:spcAft>
             </a:pPr>
             <a:r>
-              <a:rPr sz="1350" b="1" i="0">
+              <a:rPr sz="1600" b="1" i="0">
                 <a:solidFill>
                   <a:srgbClr val="FFFFFF"/>
                 </a:solidFill>
@@ -22908,8 +22939,8 @@
         </p:nvSpPr>
         <p:spPr>
           <a:xfrm>
-            <a:off x="9445752" y="1783080"/>
-            <a:ext cx="2093976" cy="841248"/>
+            <a:off x="9445752" y="2086749"/>
+            <a:ext cx="2093976" cy="233910"/>
           </a:xfrm>
           <a:prstGeom prst="rect">
             <a:avLst/>
@@ -22934,7 +22965,7 @@
               </a:spcAft>
             </a:pPr>
             <a:r>
-              <a:rPr sz="1350" b="1" i="0">
+              <a:rPr sz="1600" b="1" i="0">
                 <a:solidFill>
                   <a:srgbClr val="FFFFFF"/>
                 </a:solidFill>
@@ -23084,8 +23115,8 @@
         </p:nvSpPr>
         <p:spPr>
           <a:xfrm>
-            <a:off x="2176272" y="2624328"/>
-            <a:ext cx="2459736" cy="841248"/>
+            <a:off x="2176272" y="2927997"/>
+            <a:ext cx="2459736" cy="233910"/>
           </a:xfrm>
           <a:prstGeom prst="rect">
             <a:avLst/>
@@ -23110,7 +23141,7 @@
               </a:spcAft>
             </a:pPr>
             <a:r>
-              <a:rPr sz="1350" b="0" i="0">
+              <a:rPr sz="1600" b="0" i="0" dirty="0">
                 <a:solidFill>
                   <a:srgbClr val="0F172A"/>
                 </a:solidFill>
@@ -23176,8 +23207,8 @@
         </p:nvSpPr>
         <p:spPr>
           <a:xfrm>
-            <a:off x="4782312" y="2624328"/>
-            <a:ext cx="2185416" cy="841248"/>
+            <a:off x="4782312" y="2798218"/>
+            <a:ext cx="2185416" cy="493468"/>
           </a:xfrm>
           <a:prstGeom prst="rect">
             <a:avLst/>
@@ -23202,7 +23233,7 @@
               </a:spcAft>
             </a:pPr>
             <a:r>
-              <a:rPr sz="1350" b="0" i="0">
+              <a:rPr sz="1600" b="0" i="0">
                 <a:solidFill>
                   <a:srgbClr val="0F172A"/>
                 </a:solidFill>
@@ -23224,7 +23255,7 @@
               </a:spcAft>
             </a:pPr>
             <a:r>
-              <a:rPr sz="1350" b="0" i="0">
+              <a:rPr sz="1600" b="0" i="0">
                 <a:solidFill>
                   <a:srgbClr val="0F172A"/>
                 </a:solidFill>
@@ -23290,8 +23321,8 @@
         </p:nvSpPr>
         <p:spPr>
           <a:xfrm>
-            <a:off x="7114032" y="2624328"/>
-            <a:ext cx="2185416" cy="841248"/>
+            <a:off x="7114032" y="2927997"/>
+            <a:ext cx="2185416" cy="233910"/>
           </a:xfrm>
           <a:prstGeom prst="rect">
             <a:avLst/>
@@ -23316,7 +23347,7 @@
               </a:spcAft>
             </a:pPr>
             <a:r>
-              <a:rPr sz="1350" b="0" i="0">
+              <a:rPr sz="1600" b="0" i="0">
                 <a:solidFill>
                   <a:srgbClr val="0F172A"/>
                 </a:solidFill>
@@ -23382,8 +23413,8 @@
         </p:nvSpPr>
         <p:spPr>
           <a:xfrm>
-            <a:off x="9445752" y="2624328"/>
-            <a:ext cx="2093976" cy="841248"/>
+            <a:off x="9445752" y="2927997"/>
+            <a:ext cx="2093976" cy="233910"/>
           </a:xfrm>
           <a:prstGeom prst="rect">
             <a:avLst/>
@@ -23408,7 +23439,7 @@
               </a:spcAft>
             </a:pPr>
             <a:r>
-              <a:rPr sz="1350" b="0" i="0">
+              <a:rPr sz="1600" b="0" i="0">
                 <a:solidFill>
                   <a:srgbClr val="0F172A"/>
                 </a:solidFill>
@@ -23558,8 +23589,8 @@
         </p:nvSpPr>
         <p:spPr>
           <a:xfrm>
-            <a:off x="2176272" y="3465576"/>
-            <a:ext cx="2459736" cy="841248"/>
+            <a:off x="2176272" y="3639466"/>
+            <a:ext cx="2459736" cy="493468"/>
           </a:xfrm>
           <a:prstGeom prst="rect">
             <a:avLst/>
@@ -23584,7 +23615,7 @@
               </a:spcAft>
             </a:pPr>
             <a:r>
-              <a:rPr sz="1350" b="0" i="0">
+              <a:rPr sz="1600" b="0" i="0">
                 <a:solidFill>
                   <a:srgbClr val="0F172A"/>
                 </a:solidFill>
@@ -23606,7 +23637,7 @@
               </a:spcAft>
             </a:pPr>
             <a:r>
-              <a:rPr sz="1350" b="0" i="0">
+              <a:rPr sz="1600" b="0" i="0">
                 <a:solidFill>
                   <a:srgbClr val="0F172A"/>
                 </a:solidFill>
@@ -23672,8 +23703,8 @@
         </p:nvSpPr>
         <p:spPr>
           <a:xfrm>
-            <a:off x="4782312" y="3465576"/>
-            <a:ext cx="2185416" cy="841248"/>
+            <a:off x="4782312" y="3639466"/>
+            <a:ext cx="2185416" cy="493468"/>
           </a:xfrm>
           <a:prstGeom prst="rect">
             <a:avLst/>
@@ -23698,7 +23729,7 @@
               </a:spcAft>
             </a:pPr>
             <a:r>
-              <a:rPr sz="1350" b="0" i="0">
+              <a:rPr sz="1600" b="0" i="0">
                 <a:solidFill>
                   <a:srgbClr val="0F172A"/>
                 </a:solidFill>
@@ -23720,7 +23751,7 @@
               </a:spcAft>
             </a:pPr>
             <a:r>
-              <a:rPr sz="1350" b="0" i="0">
+              <a:rPr sz="1600" b="0" i="0">
                 <a:solidFill>
                   <a:srgbClr val="0F172A"/>
                 </a:solidFill>
@@ -23786,8 +23817,8 @@
         </p:nvSpPr>
         <p:spPr>
           <a:xfrm>
-            <a:off x="7114032" y="3465576"/>
-            <a:ext cx="2185416" cy="841248"/>
+            <a:off x="7114032" y="3769245"/>
+            <a:ext cx="2185416" cy="233910"/>
           </a:xfrm>
           <a:prstGeom prst="rect">
             <a:avLst/>
@@ -23812,7 +23843,7 @@
               </a:spcAft>
             </a:pPr>
             <a:r>
-              <a:rPr sz="1350" b="0" i="0">
+              <a:rPr sz="1600" b="0" i="0">
                 <a:solidFill>
                   <a:srgbClr val="0F172A"/>
                 </a:solidFill>
@@ -23878,8 +23909,8 @@
         </p:nvSpPr>
         <p:spPr>
           <a:xfrm>
-            <a:off x="9445752" y="3465576"/>
-            <a:ext cx="2093976" cy="841248"/>
+            <a:off x="9445752" y="3769245"/>
+            <a:ext cx="2093976" cy="233910"/>
           </a:xfrm>
           <a:prstGeom prst="rect">
             <a:avLst/>
@@ -23904,7 +23935,7 @@
               </a:spcAft>
             </a:pPr>
             <a:r>
-              <a:rPr sz="1350" b="0" i="0">
+              <a:rPr sz="1600" b="0" i="0">
                 <a:solidFill>
                   <a:srgbClr val="0F172A"/>
                 </a:solidFill>
@@ -24054,8 +24085,8 @@
         </p:nvSpPr>
         <p:spPr>
           <a:xfrm>
-            <a:off x="2176272" y="4306824"/>
-            <a:ext cx="2459736" cy="841248"/>
+            <a:off x="2176272" y="4480714"/>
+            <a:ext cx="2459736" cy="493468"/>
           </a:xfrm>
           <a:prstGeom prst="rect">
             <a:avLst/>
@@ -24080,7 +24111,7 @@
               </a:spcAft>
             </a:pPr>
             <a:r>
-              <a:rPr sz="1350" b="0" i="0">
+              <a:rPr sz="1600" b="0" i="0">
                 <a:solidFill>
                   <a:srgbClr val="0F172A"/>
                 </a:solidFill>
@@ -24102,7 +24133,7 @@
               </a:spcAft>
             </a:pPr>
             <a:r>
-              <a:rPr sz="1350" b="0" i="0">
+              <a:rPr sz="1600" b="0" i="0">
                 <a:solidFill>
                   <a:srgbClr val="0F172A"/>
                 </a:solidFill>
@@ -24168,8 +24199,8 @@
         </p:nvSpPr>
         <p:spPr>
           <a:xfrm>
-            <a:off x="4782312" y="4306824"/>
-            <a:ext cx="2185416" cy="841248"/>
+            <a:off x="4782312" y="4610493"/>
+            <a:ext cx="2185416" cy="233910"/>
           </a:xfrm>
           <a:prstGeom prst="rect">
             <a:avLst/>
@@ -24194,7 +24225,7 @@
               </a:spcAft>
             </a:pPr>
             <a:r>
-              <a:rPr sz="1350" b="0" i="0">
+              <a:rPr sz="1600" b="0" i="0">
                 <a:solidFill>
                   <a:srgbClr val="0F172A"/>
                 </a:solidFill>
@@ -24260,8 +24291,8 @@
         </p:nvSpPr>
         <p:spPr>
           <a:xfrm>
-            <a:off x="7114032" y="4306824"/>
-            <a:ext cx="2185416" cy="841248"/>
+            <a:off x="7114032" y="4610493"/>
+            <a:ext cx="2185416" cy="233910"/>
           </a:xfrm>
           <a:prstGeom prst="rect">
             <a:avLst/>
@@ -24286,7 +24317,7 @@
               </a:spcAft>
             </a:pPr>
             <a:r>
-              <a:rPr sz="1350" b="0" i="0">
+              <a:rPr sz="1600" b="0" i="0">
                 <a:solidFill>
                   <a:srgbClr val="0F172A"/>
                 </a:solidFill>
@@ -24352,8 +24383,8 @@
         </p:nvSpPr>
         <p:spPr>
           <a:xfrm>
-            <a:off x="9445752" y="4306824"/>
-            <a:ext cx="2093976" cy="841248"/>
+            <a:off x="9445752" y="4610493"/>
+            <a:ext cx="2093976" cy="233910"/>
           </a:xfrm>
           <a:prstGeom prst="rect">
             <a:avLst/>
@@ -24378,7 +24409,7 @@
               </a:spcAft>
             </a:pPr>
             <a:r>
-              <a:rPr sz="1350" b="0" i="0">
+              <a:rPr sz="1600" b="0" i="0">
                 <a:solidFill>
                   <a:srgbClr val="0F172A"/>
                 </a:solidFill>
@@ -24397,8 +24428,8 @@
         </p:nvSpPr>
         <p:spPr>
           <a:xfrm>
-            <a:off x="548640" y="2624328"/>
-            <a:ext cx="1554480" cy="841248"/>
+            <a:off x="548640" y="2921841"/>
+            <a:ext cx="1554480" cy="246221"/>
           </a:xfrm>
           <a:prstGeom prst="rect">
             <a:avLst/>
@@ -24423,7 +24454,7 @@
               </a:spcAft>
             </a:pPr>
             <a:r>
-              <a:rPr sz="1400" b="1" i="0">
+              <a:rPr sz="1600" b="1" i="0">
                 <a:solidFill>
                   <a:srgbClr val="FFFFFF"/>
                 </a:solidFill>
@@ -24442,8 +24473,8 @@
         </p:nvSpPr>
         <p:spPr>
           <a:xfrm>
-            <a:off x="548640" y="3465576"/>
-            <a:ext cx="1554480" cy="841248"/>
+            <a:off x="548640" y="3763089"/>
+            <a:ext cx="1554480" cy="246221"/>
           </a:xfrm>
           <a:prstGeom prst="rect">
             <a:avLst/>
@@ -24468,7 +24499,7 @@
               </a:spcAft>
             </a:pPr>
             <a:r>
-              <a:rPr sz="1400" b="1" i="0">
+              <a:rPr sz="1600" b="1" i="0">
                 <a:solidFill>
                   <a:srgbClr val="FFFFFF"/>
                 </a:solidFill>
@@ -24487,8 +24518,8 @@
         </p:nvSpPr>
         <p:spPr>
           <a:xfrm>
-            <a:off x="548640" y="4306824"/>
-            <a:ext cx="1554480" cy="841248"/>
+            <a:off x="548640" y="4604337"/>
+            <a:ext cx="1554480" cy="246221"/>
           </a:xfrm>
           <a:prstGeom prst="rect">
             <a:avLst/>
@@ -24513,7 +24544,7 @@
               </a:spcAft>
             </a:pPr>
             <a:r>
-              <a:rPr sz="1400" b="1" i="0">
+              <a:rPr sz="1600" b="1" i="0">
                 <a:solidFill>
                   <a:srgbClr val="FFFFFF"/>
                 </a:solidFill>
@@ -24533,7 +24564,7 @@
         <p:spPr>
           <a:xfrm>
             <a:off x="548640" y="5440680"/>
-            <a:ext cx="11064240" cy="548640"/>
+            <a:ext cx="11064240" cy="225575"/>
           </a:xfrm>
           <a:prstGeom prst="rect">
             <a:avLst/>
@@ -24558,13 +24589,13 @@
               </a:spcAft>
             </a:pPr>
             <a:r>
-              <a:rPr sz="1400" b="1" i="0">
+              <a:rPr sz="1500" b="1" i="0" dirty="0">
                 <a:solidFill>
                   <a:srgbClr val="0F172A"/>
                 </a:solidFill>
                 <a:latin typeface="Arial"/>
               </a:rPr>
-              <a:t>Reading the matrix: the firm that is least adaptable in governance is also the most exposed in viability — the columns are linked, not independent.</a:t>
+              <a:t>Reading the matrix: the firm that is least adaptable in governance is also the most exposed in viability</a:t>
             </a:r>
           </a:p>
         </p:txBody>
@@ -24578,7 +24609,7 @@
         <p:spPr>
           <a:xfrm>
             <a:off x="548640" y="6199632"/>
-            <a:ext cx="11064240" cy="274320"/>
+            <a:ext cx="11064240" cy="169277"/>
           </a:xfrm>
           <a:prstGeom prst="rect">
             <a:avLst/>
@@ -24603,13 +24634,31 @@
               </a:spcAft>
             </a:pPr>
             <a:r>
-              <a:rPr sz="1100" b="0" i="1">
+              <a:rPr sz="1100" b="0" i="1" dirty="0">
                 <a:solidFill>
                   <a:srgbClr val="64748B"/>
                 </a:solidFill>
                 <a:latin typeface="Arial"/>
               </a:rPr>
-              <a:t>Anchors: Shleifer &amp; Vishny (1994) · Megginson &amp; Netter (2001) · Teece et al. (1997) · Luo &amp; Tung (2007) · Fan et al. (2007)</a:t>
+              <a:t>Shleifer &amp; </a:t>
+            </a:r>
+            <a:r>
+              <a:rPr sz="1100" b="0" i="1" dirty="0" err="1">
+                <a:solidFill>
+                  <a:srgbClr val="64748B"/>
+                </a:solidFill>
+                <a:latin typeface="Arial"/>
+              </a:rPr>
+              <a:t>Vishny</a:t>
+            </a:r>
+            <a:r>
+              <a:rPr sz="1100" b="0" i="1" dirty="0">
+                <a:solidFill>
+                  <a:srgbClr val="64748B"/>
+                </a:solidFill>
+                <a:latin typeface="Arial"/>
+              </a:rPr>
+              <a:t> (1994) · Megginson &amp; Netter (2001) · Teece et al. (1997) · Luo &amp; Tung (2007) · Fan et al. (2007)</a:t>
             </a:r>
           </a:p>
         </p:txBody>
@@ -25099,8 +25148,8 @@
         </p:nvSpPr>
         <p:spPr>
           <a:xfrm>
-            <a:off x="713232" y="2478024"/>
-            <a:ext cx="3264408" cy="2843784"/>
+            <a:off x="713232" y="2441448"/>
+            <a:ext cx="3264408" cy="2663421"/>
           </a:xfrm>
           <a:prstGeom prst="rect">
             <a:avLst/>
@@ -25126,7 +25175,7 @@
               <a:buNone/>
             </a:pPr>
             <a:r>
-              <a:rPr sz="1250">
+              <a:rPr sz="1500" dirty="0">
                 <a:solidFill>
                   <a:srgbClr val="DC2626"/>
                 </a:solidFill>
@@ -25135,7 +25184,7 @@
               <a:t>–  </a:t>
             </a:r>
             <a:r>
-              <a:rPr sz="1250">
+              <a:rPr sz="1500" dirty="0">
                 <a:solidFill>
                   <a:srgbClr val="0F172A"/>
                 </a:solidFill>
@@ -25158,7 +25207,7 @@
               <a:buNone/>
             </a:pPr>
             <a:r>
-              <a:rPr sz="1250">
+              <a:rPr sz="1500" dirty="0">
                 <a:solidFill>
                   <a:srgbClr val="DC2626"/>
                 </a:solidFill>
@@ -25167,13 +25216,22 @@
               <a:t>–  </a:t>
             </a:r>
             <a:r>
-              <a:rPr sz="1250">
+              <a:rPr sz="1500" dirty="0" err="1">
                 <a:solidFill>
                   <a:srgbClr val="0F172A"/>
                 </a:solidFill>
                 <a:latin typeface="Arial"/>
               </a:rPr>
-              <a:t>Optimises beyond shareholder value: jobs, policy, prestige</a:t>
+              <a:t>Optimises</a:t>
+            </a:r>
+            <a:r>
+              <a:rPr sz="1500" dirty="0">
+                <a:solidFill>
+                  <a:srgbClr val="0F172A"/>
+                </a:solidFill>
+                <a:latin typeface="Arial"/>
+              </a:rPr>
+              <a:t> beyond shareholder value: jobs, policy, prestige</a:t>
             </a:r>
           </a:p>
           <a:p>
@@ -25190,7 +25248,7 @@
               <a:buNone/>
             </a:pPr>
             <a:r>
-              <a:rPr sz="1250">
+              <a:rPr sz="1500" dirty="0">
                 <a:solidFill>
                   <a:srgbClr val="DC2626"/>
                 </a:solidFill>
@@ -25199,7 +25257,7 @@
               <a:t>–  </a:t>
             </a:r>
             <a:r>
-              <a:rPr sz="1250">
+              <a:rPr sz="1500" dirty="0">
                 <a:solidFill>
                   <a:srgbClr val="0F172A"/>
                 </a:solidFill>
@@ -25222,7 +25280,7 @@
               <a:buNone/>
             </a:pPr>
             <a:r>
-              <a:rPr sz="1250">
+              <a:rPr sz="1500" dirty="0">
                 <a:solidFill>
                   <a:srgbClr val="DC2626"/>
                 </a:solidFill>
@@ -25231,7 +25289,7 @@
               <a:t>–  </a:t>
             </a:r>
             <a:r>
-              <a:rPr sz="1250">
+              <a:rPr sz="1500" dirty="0">
                 <a:solidFill>
                   <a:srgbClr val="0F172A"/>
                 </a:solidFill>
@@ -25254,7 +25312,7 @@
               <a:buNone/>
             </a:pPr>
             <a:r>
-              <a:rPr sz="1250">
+              <a:rPr sz="1500" dirty="0">
                 <a:solidFill>
                   <a:srgbClr val="DC2626"/>
                 </a:solidFill>
@@ -25263,7 +25321,7 @@
               <a:t>–  </a:t>
             </a:r>
             <a:r>
-              <a:rPr sz="1250">
+              <a:rPr sz="1500" dirty="0">
                 <a:solidFill>
                   <a:srgbClr val="0F172A"/>
                 </a:solidFill>
@@ -25419,8 +25477,8 @@
         </p:nvSpPr>
         <p:spPr>
           <a:xfrm>
-            <a:off x="4443984" y="2478024"/>
-            <a:ext cx="3264408" cy="2843784"/>
+            <a:off x="4443984" y="2441448"/>
+            <a:ext cx="3264408" cy="2421047"/>
           </a:xfrm>
           <a:prstGeom prst="rect">
             <a:avLst/>
@@ -25446,7 +25504,7 @@
               <a:buNone/>
             </a:pPr>
             <a:r>
-              <a:rPr sz="1250">
+              <a:rPr sz="1500" dirty="0">
                 <a:solidFill>
                   <a:srgbClr val="2563EB"/>
                 </a:solidFill>
@@ -25455,13 +25513,31 @@
               <a:t>–  </a:t>
             </a:r>
             <a:r>
-              <a:rPr sz="1250">
+              <a:rPr sz="1500" dirty="0">
                 <a:solidFill>
                   <a:srgbClr val="0F172A"/>
                 </a:solidFill>
                 <a:latin typeface="Arial"/>
               </a:rPr>
-              <a:t>Wang Chuanfu ~17%; founding team &gt; 1/3 of votes</a:t>
+              <a:t>Wang </a:t>
+            </a:r>
+            <a:r>
+              <a:rPr sz="1500" dirty="0" err="1">
+                <a:solidFill>
+                  <a:srgbClr val="0F172A"/>
+                </a:solidFill>
+                <a:latin typeface="Arial"/>
+              </a:rPr>
+              <a:t>Chuanfu</a:t>
+            </a:r>
+            <a:r>
+              <a:rPr sz="1500" dirty="0">
+                <a:solidFill>
+                  <a:srgbClr val="0F172A"/>
+                </a:solidFill>
+                <a:latin typeface="Arial"/>
+              </a:rPr>
+              <a:t> ~17%; founding team &gt; 1/3 of votes</a:t>
             </a:r>
           </a:p>
           <a:p>
@@ -25478,7 +25554,7 @@
               <a:buNone/>
             </a:pPr>
             <a:r>
-              <a:rPr sz="1250">
+              <a:rPr sz="1500" dirty="0">
                 <a:solidFill>
                   <a:srgbClr val="2563EB"/>
                 </a:solidFill>
@@ -25487,7 +25563,7 @@
               <a:t>–  </a:t>
             </a:r>
             <a:r>
-              <a:rPr sz="1250">
+              <a:rPr sz="1500" dirty="0">
                 <a:solidFill>
                   <a:srgbClr val="0F172A"/>
                 </a:solidFill>
@@ -25510,7 +25586,7 @@
               <a:buNone/>
             </a:pPr>
             <a:r>
-              <a:rPr sz="1250">
+              <a:rPr sz="1500" dirty="0">
                 <a:solidFill>
                   <a:srgbClr val="2563EB"/>
                 </a:solidFill>
@@ -25519,7 +25595,7 @@
               <a:t>–  </a:t>
             </a:r>
             <a:r>
-              <a:rPr sz="1250">
+              <a:rPr sz="1500" dirty="0">
                 <a:solidFill>
                   <a:srgbClr val="0F172A"/>
                 </a:solidFill>
@@ -25542,7 +25618,7 @@
               <a:buNone/>
             </a:pPr>
             <a:r>
-              <a:rPr sz="1250">
+              <a:rPr sz="1500" dirty="0">
                 <a:solidFill>
                   <a:srgbClr val="2563EB"/>
                 </a:solidFill>
@@ -25551,7 +25627,7 @@
               <a:t>–  </a:t>
             </a:r>
             <a:r>
-              <a:rPr sz="1250">
+              <a:rPr sz="1500" dirty="0">
                 <a:solidFill>
                   <a:srgbClr val="0F172A"/>
                 </a:solidFill>
@@ -25574,7 +25650,7 @@
               <a:buNone/>
             </a:pPr>
             <a:r>
-              <a:rPr sz="1250">
+              <a:rPr sz="1500" dirty="0">
                 <a:solidFill>
                   <a:srgbClr val="2563EB"/>
                 </a:solidFill>
@@ -25583,7 +25659,7 @@
               <a:t>–  </a:t>
             </a:r>
             <a:r>
-              <a:rPr sz="1250">
+              <a:rPr sz="1500" dirty="0">
                 <a:solidFill>
                   <a:srgbClr val="0F172A"/>
                 </a:solidFill>
@@ -25739,8 +25815,8 @@
         </p:nvSpPr>
         <p:spPr>
           <a:xfrm>
-            <a:off x="8174736" y="2478024"/>
-            <a:ext cx="3264408" cy="2843784"/>
+            <a:off x="8174736" y="2441448"/>
+            <a:ext cx="3264408" cy="2663421"/>
           </a:xfrm>
           <a:prstGeom prst="rect">
             <a:avLst/>
@@ -25766,7 +25842,7 @@
               <a:buNone/>
             </a:pPr>
             <a:r>
-              <a:rPr sz="1250">
+              <a:rPr sz="1500">
                 <a:solidFill>
                   <a:srgbClr val="06B6D4"/>
                 </a:solidFill>
@@ -25775,7 +25851,7 @@
               <a:t>–  </a:t>
             </a:r>
             <a:r>
-              <a:rPr sz="1250">
+              <a:rPr sz="1500">
                 <a:solidFill>
                   <a:srgbClr val="0F172A"/>
                 </a:solidFill>
@@ -25798,7 +25874,7 @@
               <a:buNone/>
             </a:pPr>
             <a:r>
-              <a:rPr sz="1250">
+              <a:rPr sz="1500">
                 <a:solidFill>
                   <a:srgbClr val="06B6D4"/>
                 </a:solidFill>
@@ -25807,7 +25883,7 @@
               <a:t>–  </a:t>
             </a:r>
             <a:r>
-              <a:rPr sz="1250">
+              <a:rPr sz="1500">
                 <a:solidFill>
                   <a:srgbClr val="0F172A"/>
                 </a:solidFill>
@@ -25830,7 +25906,7 @@
               <a:buNone/>
             </a:pPr>
             <a:r>
-              <a:rPr sz="1250">
+              <a:rPr sz="1500">
                 <a:solidFill>
                   <a:srgbClr val="06B6D4"/>
                 </a:solidFill>
@@ -25839,7 +25915,7 @@
               <a:t>–  </a:t>
             </a:r>
             <a:r>
-              <a:rPr sz="1250">
+              <a:rPr sz="1500">
                 <a:solidFill>
                   <a:srgbClr val="0F172A"/>
                 </a:solidFill>
@@ -25862,7 +25938,7 @@
               <a:buNone/>
             </a:pPr>
             <a:r>
-              <a:rPr sz="1250">
+              <a:rPr sz="1500">
                 <a:solidFill>
                   <a:srgbClr val="06B6D4"/>
                 </a:solidFill>
@@ -25871,7 +25947,7 @@
               <a:t>–  </a:t>
             </a:r>
             <a:r>
-              <a:rPr sz="1250">
+              <a:rPr sz="1500">
                 <a:solidFill>
                   <a:srgbClr val="0F172A"/>
                 </a:solidFill>
@@ -25894,7 +25970,7 @@
               <a:buNone/>
             </a:pPr>
             <a:r>
-              <a:rPr sz="1250">
+              <a:rPr sz="1500">
                 <a:solidFill>
                   <a:srgbClr val="06B6D4"/>
                 </a:solidFill>
@@ -25903,7 +25979,7 @@
               <a:t>–  </a:t>
             </a:r>
             <a:r>
-              <a:rPr sz="1250">
+              <a:rPr sz="1500">
                 <a:solidFill>
                   <a:srgbClr val="0F172A"/>
                 </a:solidFill>
@@ -25923,7 +25999,7 @@
         <p:spPr>
           <a:xfrm>
             <a:off x="548640" y="6199632"/>
-            <a:ext cx="11064240" cy="274320"/>
+            <a:ext cx="11064240" cy="169277"/>
           </a:xfrm>
           <a:prstGeom prst="rect">
             <a:avLst/>
@@ -25948,13 +26024,31 @@
               </a:spcAft>
             </a:pPr>
             <a:r>
-              <a:rPr sz="1100" b="0" i="1">
+              <a:rPr sz="1100" b="0" i="1" dirty="0">
                 <a:solidFill>
                   <a:srgbClr val="64748B"/>
                 </a:solidFill>
                 <a:latin typeface="Arial"/>
               </a:rPr>
-              <a:t>Theory: Shleifer &amp; Vishny (1994) · Fan et al. (2007) · Jensen &amp; Meckling (1976) · Megginson &amp; Netter (2001)</a:t>
+              <a:t>Shleifer &amp; </a:t>
+            </a:r>
+            <a:r>
+              <a:rPr sz="1100" b="0" i="1" dirty="0" err="1">
+                <a:solidFill>
+                  <a:srgbClr val="64748B"/>
+                </a:solidFill>
+                <a:latin typeface="Arial"/>
+              </a:rPr>
+              <a:t>Vishny</a:t>
+            </a:r>
+            <a:r>
+              <a:rPr sz="1100" b="0" i="1" dirty="0">
+                <a:solidFill>
+                  <a:srgbClr val="64748B"/>
+                </a:solidFill>
+                <a:latin typeface="Arial"/>
+              </a:rPr>
+              <a:t> (1994) · Fan et al. (2007) · Jensen &amp; Meckling (1976) · Megginson &amp; Netter (2001)</a:t>
             </a:r>
           </a:p>
         </p:txBody>
@@ -26490,7 +26584,7 @@
         <p:spPr>
           <a:xfrm>
             <a:off x="978408" y="3154680"/>
-            <a:ext cx="3072384" cy="502920"/>
+            <a:ext cx="3072384" cy="456535"/>
           </a:xfrm>
           <a:prstGeom prst="rect">
             <a:avLst/>
@@ -26515,7 +26609,7 @@
               </a:spcAft>
             </a:pPr>
             <a:r>
-              <a:rPr sz="1200" b="0" i="1">
+              <a:rPr sz="1400" b="0" i="1" dirty="0">
                 <a:solidFill>
                   <a:srgbClr val="64748B"/>
                 </a:solidFill>
@@ -26537,7 +26631,7 @@
               </a:spcAft>
             </a:pPr>
             <a:r>
-              <a:rPr sz="1200" b="0" i="1">
+              <a:rPr sz="1400" b="0" i="1" dirty="0">
                 <a:solidFill>
                   <a:srgbClr val="64748B"/>
                 </a:solidFill>
@@ -26739,7 +26833,7 @@
         <p:spPr>
           <a:xfrm>
             <a:off x="4498848" y="3154680"/>
-            <a:ext cx="3072384" cy="502920"/>
+            <a:ext cx="3072384" cy="456535"/>
           </a:xfrm>
           <a:prstGeom prst="rect">
             <a:avLst/>
@@ -26764,7 +26858,7 @@
               </a:spcAft>
             </a:pPr>
             <a:r>
-              <a:rPr sz="1200" b="0" i="1">
+              <a:rPr sz="1400" b="0" i="1" dirty="0">
                 <a:solidFill>
                   <a:srgbClr val="64748B"/>
                 </a:solidFill>
@@ -26786,7 +26880,7 @@
               </a:spcAft>
             </a:pPr>
             <a:r>
-              <a:rPr sz="1200" b="0" i="1">
+              <a:rPr sz="1400" b="0" i="1" dirty="0">
                 <a:solidFill>
                   <a:srgbClr val="64748B"/>
                 </a:solidFill>
@@ -26988,7 +27082,7 @@
         <p:spPr>
           <a:xfrm>
             <a:off x="8019288" y="3154680"/>
-            <a:ext cx="3072384" cy="502920"/>
+            <a:ext cx="3072384" cy="456535"/>
           </a:xfrm>
           <a:prstGeom prst="rect">
             <a:avLst/>
@@ -27013,7 +27107,7 @@
               </a:spcAft>
             </a:pPr>
             <a:r>
-              <a:rPr sz="1200" b="0" i="1">
+              <a:rPr sz="1400" b="0" i="1" dirty="0">
                 <a:solidFill>
                   <a:srgbClr val="64748B"/>
                 </a:solidFill>
@@ -27035,7 +27129,7 @@
               </a:spcAft>
             </a:pPr>
             <a:r>
-              <a:rPr sz="1200" b="0" i="1">
+              <a:rPr sz="1400" b="0" i="1" dirty="0">
                 <a:solidFill>
                   <a:srgbClr val="64748B"/>
                 </a:solidFill>
@@ -27055,7 +27149,7 @@
         <p:spPr>
           <a:xfrm>
             <a:off x="548640" y="4069080"/>
-            <a:ext cx="11064240" cy="1737360"/>
+            <a:ext cx="11064240" cy="1541319"/>
           </a:xfrm>
           <a:prstGeom prst="rect">
             <a:avLst/>
@@ -27081,7 +27175,7 @@
               <a:buNone/>
             </a:pPr>
             <a:r>
-              <a:rPr sz="1500">
+              <a:rPr sz="1500" dirty="0">
                 <a:solidFill>
                   <a:srgbClr val="2563EB"/>
                 </a:solidFill>
@@ -27090,7 +27184,7 @@
               <a:t>–  </a:t>
             </a:r>
             <a:r>
-              <a:rPr sz="1500">
+              <a:rPr sz="1500" dirty="0">
                 <a:solidFill>
                   <a:srgbClr val="0F172A"/>
                 </a:solidFill>
@@ -27113,7 +27207,7 @@
               <a:buNone/>
             </a:pPr>
             <a:r>
-              <a:rPr sz="1500">
+              <a:rPr sz="1500" dirty="0">
                 <a:solidFill>
                   <a:srgbClr val="2563EB"/>
                 </a:solidFill>
@@ -27122,7 +27216,7 @@
               <a:t>–  </a:t>
             </a:r>
             <a:r>
-              <a:rPr sz="1500">
+              <a:rPr sz="1500" dirty="0">
                 <a:solidFill>
                   <a:srgbClr val="0F172A"/>
                 </a:solidFill>
@@ -27130,6 +27224,12 @@
               </a:rPr>
               <a:t>Adaptability rises as control concentrates: JV boards (bilateral consent) → state oversight → founder control.</a:t>
             </a:r>
+            <a:endParaRPr lang="de-DE" sz="1500" dirty="0">
+              <a:solidFill>
+                <a:srgbClr val="0F172A"/>
+              </a:solidFill>
+              <a:latin typeface="Arial"/>
+            </a:endParaRPr>
           </a:p>
           <a:p>
             <a:pPr>
@@ -27144,17 +27244,36 @@
               </a:spcAft>
               <a:buNone/>
             </a:pPr>
-            <a:r>
-              <a:rPr sz="1500">
-                <a:solidFill>
-                  <a:srgbClr val="2563EB"/>
-                </a:solidFill>
-                <a:latin typeface="Arial"/>
-              </a:rPr>
-              <a:t>–  </a:t>
-            </a:r>
-            <a:r>
-              <a:rPr sz="1500">
+            <a:endParaRPr sz="1500" dirty="0">
+              <a:solidFill>
+                <a:srgbClr val="0F172A"/>
+              </a:solidFill>
+              <a:latin typeface="Arial"/>
+            </a:endParaRPr>
+          </a:p>
+          <a:p>
+            <a:pPr algn="ctr">
+              <a:lnSpc>
+                <a:spcPct val="105000"/>
+              </a:lnSpc>
+              <a:spcBef>
+                <a:spcPts val="0"/>
+              </a:spcBef>
+              <a:spcAft>
+                <a:spcPts val="900"/>
+              </a:spcAft>
+            </a:pPr>
+            <a:r>
+              <a:rPr lang="de-DE" sz="1500" b="1" dirty="0">
+                <a:solidFill>
+                  <a:srgbClr val="0F172A"/>
+                </a:solidFill>
+                <a:latin typeface="Arial"/>
+              </a:rPr>
+              <a:t>   </a:t>
+            </a:r>
+            <a:r>
+              <a:rPr sz="1500" b="1" dirty="0">
                 <a:solidFill>
                   <a:srgbClr val="0F172A"/>
                 </a:solidFill>
@@ -27696,7 +27815,7 @@
         <p:spPr>
           <a:xfrm>
             <a:off x="713232" y="2478024"/>
-            <a:ext cx="3264408" cy="2432304"/>
+            <a:ext cx="3264408" cy="2663421"/>
           </a:xfrm>
           <a:prstGeom prst="rect">
             <a:avLst/>
@@ -27722,7 +27841,7 @@
               <a:buNone/>
             </a:pPr>
             <a:r>
-              <a:rPr sz="1250">
+              <a:rPr sz="1450" dirty="0">
                 <a:solidFill>
                   <a:srgbClr val="DC2626"/>
                 </a:solidFill>
@@ -27731,13 +27850,31 @@
               <a:t>–  </a:t>
             </a:r>
             <a:r>
-              <a:rPr sz="1250">
+              <a:rPr sz="1450" dirty="0">
                 <a:solidFill>
                   <a:srgbClr val="0F172A"/>
                 </a:solidFill>
                 <a:latin typeface="Arial"/>
               </a:rPr>
-              <a:t>Risk externalised to 50/50 JV partners</a:t>
+              <a:t>Risk </a:t>
+            </a:r>
+            <a:r>
+              <a:rPr sz="1450" dirty="0" err="1">
+                <a:solidFill>
+                  <a:srgbClr val="0F172A"/>
+                </a:solidFill>
+                <a:latin typeface="Arial"/>
+              </a:rPr>
+              <a:t>externalised</a:t>
+            </a:r>
+            <a:r>
+              <a:rPr sz="1450" dirty="0">
+                <a:solidFill>
+                  <a:srgbClr val="0F172A"/>
+                </a:solidFill>
+                <a:latin typeface="Arial"/>
+              </a:rPr>
+              <a:t> to 50/50 JV partners</a:t>
             </a:r>
           </a:p>
           <a:p>
@@ -27754,7 +27891,7 @@
               <a:buNone/>
             </a:pPr>
             <a:r>
-              <a:rPr sz="1250">
+              <a:rPr sz="1450" dirty="0">
                 <a:solidFill>
                   <a:srgbClr val="DC2626"/>
                 </a:solidFill>
@@ -27763,7 +27900,7 @@
               <a:t>–  </a:t>
             </a:r>
             <a:r>
-              <a:rPr sz="1250">
+              <a:rPr sz="1450" dirty="0">
                 <a:solidFill>
                   <a:srgbClr val="0F172A"/>
                 </a:solidFill>
@@ -27786,7 +27923,7 @@
               <a:buNone/>
             </a:pPr>
             <a:r>
-              <a:rPr sz="1250">
+              <a:rPr sz="1450" dirty="0">
                 <a:solidFill>
                   <a:srgbClr val="DC2626"/>
                 </a:solidFill>
@@ -27795,7 +27932,7 @@
               <a:t>–  </a:t>
             </a:r>
             <a:r>
-              <a:rPr sz="1250">
+              <a:rPr sz="1450" dirty="0">
                 <a:solidFill>
                   <a:srgbClr val="0F172A"/>
                 </a:solidFill>
@@ -27818,7 +27955,7 @@
               <a:buNone/>
             </a:pPr>
             <a:r>
-              <a:rPr sz="1250">
+              <a:rPr sz="1450" dirty="0">
                 <a:solidFill>
                   <a:srgbClr val="DC2626"/>
                 </a:solidFill>
@@ -27827,7 +27964,7 @@
               <a:t>–  </a:t>
             </a:r>
             <a:r>
-              <a:rPr sz="1250">
+              <a:rPr sz="1450" dirty="0">
                 <a:solidFill>
                   <a:srgbClr val="0F172A"/>
                 </a:solidFill>
@@ -27850,16 +27987,16 @@
               <a:buNone/>
             </a:pPr>
             <a:r>
-              <a:rPr sz="1250">
+              <a:rPr sz="1450" b="1" dirty="0">
                 <a:solidFill>
                   <a:srgbClr val="DC2626"/>
                 </a:solidFill>
                 <a:latin typeface="Arial"/>
               </a:rPr>
-              <a:t>–  </a:t>
-            </a:r>
-            <a:r>
-              <a:rPr sz="1250">
+              <a:t> </a:t>
+            </a:r>
+            <a:r>
+              <a:rPr sz="1450" b="1" dirty="0">
                 <a:solidFill>
                   <a:srgbClr val="0F172A"/>
                 </a:solidFill>
@@ -28016,7 +28153,7 @@
         <p:spPr>
           <a:xfrm>
             <a:off x="4443984" y="2478024"/>
-            <a:ext cx="3264408" cy="2432304"/>
+            <a:ext cx="3264408" cy="2663421"/>
           </a:xfrm>
           <a:prstGeom prst="rect">
             <a:avLst/>
@@ -28042,7 +28179,7 @@
               <a:buNone/>
             </a:pPr>
             <a:r>
-              <a:rPr sz="1250">
+              <a:rPr sz="1450" dirty="0">
                 <a:solidFill>
                   <a:srgbClr val="2563EB"/>
                 </a:solidFill>
@@ -28051,7 +28188,7 @@
               <a:t>–  </a:t>
             </a:r>
             <a:r>
-              <a:rPr sz="1250">
+              <a:rPr sz="1450" dirty="0">
                 <a:solidFill>
                   <a:srgbClr val="0F172A"/>
                 </a:solidFill>
@@ -28074,7 +28211,7 @@
               <a:buNone/>
             </a:pPr>
             <a:r>
-              <a:rPr sz="1250">
+              <a:rPr sz="1450" dirty="0">
                 <a:solidFill>
                   <a:srgbClr val="2563EB"/>
                 </a:solidFill>
@@ -28083,7 +28220,7 @@
               <a:t>–  </a:t>
             </a:r>
             <a:r>
-              <a:rPr sz="1250">
+              <a:rPr sz="1450" dirty="0">
                 <a:solidFill>
                   <a:srgbClr val="0F172A"/>
                 </a:solidFill>
@@ -28106,7 +28243,7 @@
               <a:buNone/>
             </a:pPr>
             <a:r>
-              <a:rPr sz="1250">
+              <a:rPr sz="1450" dirty="0">
                 <a:solidFill>
                   <a:srgbClr val="2563EB"/>
                 </a:solidFill>
@@ -28115,7 +28252,7 @@
               <a:t>–  </a:t>
             </a:r>
             <a:r>
-              <a:rPr sz="1250">
+              <a:rPr sz="1450" dirty="0">
                 <a:solidFill>
                   <a:srgbClr val="0F172A"/>
                 </a:solidFill>
@@ -28138,7 +28275,7 @@
               <a:buNone/>
             </a:pPr>
             <a:r>
-              <a:rPr sz="1250">
+              <a:rPr sz="1450" dirty="0">
                 <a:solidFill>
                   <a:srgbClr val="2563EB"/>
                 </a:solidFill>
@@ -28147,7 +28284,7 @@
               <a:t>–  </a:t>
             </a:r>
             <a:r>
-              <a:rPr sz="1250">
+              <a:rPr sz="1450" dirty="0">
                 <a:solidFill>
                   <a:srgbClr val="0F172A"/>
                 </a:solidFill>
@@ -28155,6 +28292,12 @@
               </a:rPr>
               <a:t>Net-cash position = resilience in a downturn</a:t>
             </a:r>
+            <a:endParaRPr lang="en-US" sz="1450" dirty="0">
+              <a:solidFill>
+                <a:srgbClr val="0F172A"/>
+              </a:solidFill>
+              <a:latin typeface="Arial"/>
+            </a:endParaRPr>
           </a:p>
           <a:p>
             <a:pPr>
@@ -28170,16 +28313,16 @@
               <a:buNone/>
             </a:pPr>
             <a:r>
-              <a:rPr sz="1250">
+              <a:rPr lang="en-US" sz="1450" b="1" dirty="0">
                 <a:solidFill>
                   <a:srgbClr val="2563EB"/>
                 </a:solidFill>
                 <a:latin typeface="Arial"/>
               </a:rPr>
-              <a:t>–  </a:t>
-            </a:r>
-            <a:r>
-              <a:rPr sz="1250">
+              <a:t>  </a:t>
+            </a:r>
+            <a:r>
+              <a:rPr lang="en-US" sz="1450" b="1" dirty="0">
                 <a:solidFill>
                   <a:srgbClr val="0F172A"/>
                 </a:solidFill>
@@ -28336,7 +28479,7 @@
         <p:spPr>
           <a:xfrm>
             <a:off x="8174736" y="2478024"/>
-            <a:ext cx="3264408" cy="2432304"/>
+            <a:ext cx="3264408" cy="2663421"/>
           </a:xfrm>
           <a:prstGeom prst="rect">
             <a:avLst/>
@@ -28362,7 +28505,7 @@
               <a:buNone/>
             </a:pPr>
             <a:r>
-              <a:rPr sz="1250">
+              <a:rPr sz="1450" dirty="0">
                 <a:solidFill>
                   <a:srgbClr val="06B6D4"/>
                 </a:solidFill>
@@ -28371,7 +28514,7 @@
               <a:t>–  </a:t>
             </a:r>
             <a:r>
-              <a:rPr sz="1250">
+              <a:rPr sz="1450" dirty="0">
                 <a:solidFill>
                   <a:srgbClr val="0F172A"/>
                 </a:solidFill>
@@ -28394,7 +28537,7 @@
               <a:buNone/>
             </a:pPr>
             <a:r>
-              <a:rPr sz="1250">
+              <a:rPr sz="1450" dirty="0">
                 <a:solidFill>
                   <a:srgbClr val="06B6D4"/>
                 </a:solidFill>
@@ -28403,7 +28546,7 @@
               <a:t>–  </a:t>
             </a:r>
             <a:r>
-              <a:rPr sz="1250">
+              <a:rPr sz="1450" dirty="0">
                 <a:solidFill>
                   <a:srgbClr val="0F172A"/>
                 </a:solidFill>
@@ -28426,7 +28569,7 @@
               <a:buNone/>
             </a:pPr>
             <a:r>
-              <a:rPr sz="1250">
+              <a:rPr sz="1450" dirty="0">
                 <a:solidFill>
                   <a:srgbClr val="06B6D4"/>
                 </a:solidFill>
@@ -28435,7 +28578,7 @@
               <a:t>–  </a:t>
             </a:r>
             <a:r>
-              <a:rPr sz="1250">
+              <a:rPr sz="1450" dirty="0">
                 <a:solidFill>
                   <a:srgbClr val="0F172A"/>
                 </a:solidFill>
@@ -28458,7 +28601,7 @@
               <a:buNone/>
             </a:pPr>
             <a:r>
-              <a:rPr sz="1250">
+              <a:rPr sz="1450" dirty="0">
                 <a:solidFill>
                   <a:srgbClr val="06B6D4"/>
                 </a:solidFill>
@@ -28467,7 +28610,7 @@
               <a:t>–  </a:t>
             </a:r>
             <a:r>
-              <a:rPr sz="1250">
+              <a:rPr sz="1450" dirty="0">
                 <a:solidFill>
                   <a:srgbClr val="0F172A"/>
                 </a:solidFill>
@@ -28490,16 +28633,16 @@
               <a:buNone/>
             </a:pPr>
             <a:r>
-              <a:rPr sz="1250">
+              <a:rPr sz="1450" b="1" dirty="0">
                 <a:solidFill>
                   <a:srgbClr val="06B6D4"/>
                 </a:solidFill>
                 <a:latin typeface="Arial"/>
               </a:rPr>
-              <a:t>–  </a:t>
-            </a:r>
-            <a:r>
-              <a:rPr sz="1250">
+              <a:t>  </a:t>
+            </a:r>
+            <a:r>
+              <a:rPr sz="1450" b="1" dirty="0">
                 <a:solidFill>
                   <a:srgbClr val="0F172A"/>
                 </a:solidFill>
@@ -28563,8 +28706,8 @@
         </p:nvSpPr>
         <p:spPr>
           <a:xfrm>
-            <a:off x="731520" y="5285232"/>
-            <a:ext cx="10698480" cy="777240"/>
+            <a:off x="731520" y="5439877"/>
+            <a:ext cx="10698480" cy="467949"/>
           </a:xfrm>
           <a:prstGeom prst="rect">
             <a:avLst/>
@@ -28589,7 +28732,7 @@
               </a:spcAft>
             </a:pPr>
             <a:r>
-              <a:rPr sz="1350" b="1" i="0">
+              <a:rPr sz="1500" b="1" i="0" dirty="0">
                 <a:solidFill>
                   <a:srgbClr val="FFFFFF"/>
                 </a:solidFill>
@@ -29400,8 +29543,8 @@
         </p:nvSpPr>
         <p:spPr>
           <a:xfrm>
-            <a:off x="621792" y="2203704"/>
-            <a:ext cx="3145536" cy="512064"/>
+            <a:off x="621792" y="2350090"/>
+            <a:ext cx="3145536" cy="219291"/>
           </a:xfrm>
           <a:prstGeom prst="rect">
             <a:avLst/>
@@ -29426,7 +29569,7 @@
               </a:spcAft>
             </a:pPr>
             <a:r>
-              <a:rPr sz="1300" b="1" i="0">
+              <a:rPr sz="1500" b="1" i="0" dirty="0">
                 <a:solidFill>
                   <a:srgbClr val="0F172A"/>
                 </a:solidFill>
@@ -29492,8 +29635,8 @@
         </p:nvSpPr>
         <p:spPr>
           <a:xfrm>
-            <a:off x="3913632" y="2203704"/>
-            <a:ext cx="2441448" cy="512064"/>
+            <a:off x="3913632" y="2350090"/>
+            <a:ext cx="2441448" cy="219291"/>
           </a:xfrm>
           <a:prstGeom prst="rect">
             <a:avLst/>
@@ -29518,7 +29661,7 @@
               </a:spcAft>
             </a:pPr>
             <a:r>
-              <a:rPr sz="1300" b="0" i="0">
+              <a:rPr sz="1500" b="0" i="0" dirty="0">
                 <a:solidFill>
                   <a:srgbClr val="0F172A"/>
                 </a:solidFill>
@@ -29584,8 +29727,8 @@
         </p:nvSpPr>
         <p:spPr>
           <a:xfrm>
-            <a:off x="6501384" y="2203704"/>
-            <a:ext cx="2441448" cy="512064"/>
+            <a:off x="6501384" y="2350090"/>
+            <a:ext cx="2441448" cy="219291"/>
           </a:xfrm>
           <a:prstGeom prst="rect">
             <a:avLst/>
@@ -29610,7 +29753,7 @@
               </a:spcAft>
             </a:pPr>
             <a:r>
-              <a:rPr sz="1300" b="0" i="0">
+              <a:rPr sz="1500" b="0" i="0">
                 <a:solidFill>
                   <a:srgbClr val="0F172A"/>
                 </a:solidFill>
@@ -29676,8 +29819,8 @@
         </p:nvSpPr>
         <p:spPr>
           <a:xfrm>
-            <a:off x="9089136" y="2203704"/>
-            <a:ext cx="2450592" cy="512064"/>
+            <a:off x="9089136" y="2350090"/>
+            <a:ext cx="2450592" cy="219291"/>
           </a:xfrm>
           <a:prstGeom prst="rect">
             <a:avLst/>
@@ -29702,7 +29845,7 @@
               </a:spcAft>
             </a:pPr>
             <a:r>
-              <a:rPr sz="1300" b="0" i="0">
+              <a:rPr sz="1500" b="0" i="0">
                 <a:solidFill>
                   <a:srgbClr val="0F172A"/>
                 </a:solidFill>
@@ -29768,8 +29911,8 @@
         </p:nvSpPr>
         <p:spPr>
           <a:xfrm>
-            <a:off x="621792" y="2715768"/>
-            <a:ext cx="3145536" cy="512064"/>
+            <a:off x="621792" y="2862154"/>
+            <a:ext cx="3145536" cy="219291"/>
           </a:xfrm>
           <a:prstGeom prst="rect">
             <a:avLst/>
@@ -29794,7 +29937,7 @@
               </a:spcAft>
             </a:pPr>
             <a:r>
-              <a:rPr sz="1300" b="1" i="0">
+              <a:rPr sz="1500" b="1" i="0">
                 <a:solidFill>
                   <a:srgbClr val="0F172A"/>
                 </a:solidFill>
@@ -29860,8 +30003,8 @@
         </p:nvSpPr>
         <p:spPr>
           <a:xfrm>
-            <a:off x="3913632" y="2715768"/>
-            <a:ext cx="2441448" cy="512064"/>
+            <a:off x="3913632" y="2862154"/>
+            <a:ext cx="2441448" cy="219291"/>
           </a:xfrm>
           <a:prstGeom prst="rect">
             <a:avLst/>
@@ -29886,7 +30029,7 @@
               </a:spcAft>
             </a:pPr>
             <a:r>
-              <a:rPr sz="1300" b="0" i="0">
+              <a:rPr sz="1500" b="0" i="0">
                 <a:solidFill>
                   <a:srgbClr val="0F172A"/>
                 </a:solidFill>
@@ -29952,8 +30095,8 @@
         </p:nvSpPr>
         <p:spPr>
           <a:xfrm>
-            <a:off x="6501384" y="2715768"/>
-            <a:ext cx="2441448" cy="512064"/>
+            <a:off x="6501384" y="2862154"/>
+            <a:ext cx="2441448" cy="219291"/>
           </a:xfrm>
           <a:prstGeom prst="rect">
             <a:avLst/>
@@ -29978,7 +30121,7 @@
               </a:spcAft>
             </a:pPr>
             <a:r>
-              <a:rPr sz="1300" b="0" i="0">
+              <a:rPr sz="1500" b="0" i="0">
                 <a:solidFill>
                   <a:srgbClr val="0F172A"/>
                 </a:solidFill>
@@ -30044,8 +30187,8 @@
         </p:nvSpPr>
         <p:spPr>
           <a:xfrm>
-            <a:off x="9089136" y="2715768"/>
-            <a:ext cx="2450592" cy="512064"/>
+            <a:off x="9089136" y="2862154"/>
+            <a:ext cx="2450592" cy="219291"/>
           </a:xfrm>
           <a:prstGeom prst="rect">
             <a:avLst/>
@@ -30070,7 +30213,7 @@
               </a:spcAft>
             </a:pPr>
             <a:r>
-              <a:rPr sz="1300" b="0" i="0">
+              <a:rPr sz="1500" b="0" i="0">
                 <a:solidFill>
                   <a:srgbClr val="0F172A"/>
                 </a:solidFill>
@@ -30136,8 +30279,8 @@
         </p:nvSpPr>
         <p:spPr>
           <a:xfrm>
-            <a:off x="621792" y="3227832"/>
-            <a:ext cx="3145536" cy="512064"/>
+            <a:off x="621792" y="3374218"/>
+            <a:ext cx="3145536" cy="219291"/>
           </a:xfrm>
           <a:prstGeom prst="rect">
             <a:avLst/>
@@ -30162,7 +30305,7 @@
               </a:spcAft>
             </a:pPr>
             <a:r>
-              <a:rPr sz="1300" b="1" i="0">
+              <a:rPr sz="1500" b="1" i="0">
                 <a:solidFill>
                   <a:srgbClr val="0F172A"/>
                 </a:solidFill>
@@ -30228,8 +30371,8 @@
         </p:nvSpPr>
         <p:spPr>
           <a:xfrm>
-            <a:off x="3913632" y="3227832"/>
-            <a:ext cx="2441448" cy="512064"/>
+            <a:off x="3913632" y="3374218"/>
+            <a:ext cx="2441448" cy="219291"/>
           </a:xfrm>
           <a:prstGeom prst="rect">
             <a:avLst/>
@@ -30254,7 +30397,7 @@
               </a:spcAft>
             </a:pPr>
             <a:r>
-              <a:rPr sz="1300" b="0" i="0">
+              <a:rPr sz="1500" b="0" i="0">
                 <a:solidFill>
                   <a:srgbClr val="0F172A"/>
                 </a:solidFill>
@@ -30320,8 +30463,8 @@
         </p:nvSpPr>
         <p:spPr>
           <a:xfrm>
-            <a:off x="6501384" y="3227832"/>
-            <a:ext cx="2441448" cy="512064"/>
+            <a:off x="6501384" y="3374218"/>
+            <a:ext cx="2441448" cy="219291"/>
           </a:xfrm>
           <a:prstGeom prst="rect">
             <a:avLst/>
@@ -30346,7 +30489,7 @@
               </a:spcAft>
             </a:pPr>
             <a:r>
-              <a:rPr sz="1300" b="0" i="0">
+              <a:rPr sz="1500" b="0" i="0">
                 <a:solidFill>
                   <a:srgbClr val="0F172A"/>
                 </a:solidFill>
@@ -30412,8 +30555,8 @@
         </p:nvSpPr>
         <p:spPr>
           <a:xfrm>
-            <a:off x="9089136" y="3227832"/>
-            <a:ext cx="2450592" cy="512064"/>
+            <a:off x="9089136" y="3374218"/>
+            <a:ext cx="2450592" cy="219291"/>
           </a:xfrm>
           <a:prstGeom prst="rect">
             <a:avLst/>
@@ -30438,7 +30581,7 @@
               </a:spcAft>
             </a:pPr>
             <a:r>
-              <a:rPr sz="1300" b="0" i="0">
+              <a:rPr sz="1500" b="0" i="0">
                 <a:solidFill>
                   <a:srgbClr val="0F172A"/>
                 </a:solidFill>
@@ -30504,8 +30647,8 @@
         </p:nvSpPr>
         <p:spPr>
           <a:xfrm>
-            <a:off x="621792" y="3739896"/>
-            <a:ext cx="3145536" cy="512064"/>
+            <a:off x="621792" y="3886282"/>
+            <a:ext cx="3145536" cy="219291"/>
           </a:xfrm>
           <a:prstGeom prst="rect">
             <a:avLst/>
@@ -30530,7 +30673,7 @@
               </a:spcAft>
             </a:pPr>
             <a:r>
-              <a:rPr sz="1300" b="1" i="0">
+              <a:rPr sz="1500" b="1" i="0" dirty="0">
                 <a:solidFill>
                   <a:srgbClr val="0F172A"/>
                 </a:solidFill>
@@ -30596,8 +30739,8 @@
         </p:nvSpPr>
         <p:spPr>
           <a:xfrm>
-            <a:off x="3913632" y="3739896"/>
-            <a:ext cx="2441448" cy="512064"/>
+            <a:off x="3913632" y="3886282"/>
+            <a:ext cx="2441448" cy="219291"/>
           </a:xfrm>
           <a:prstGeom prst="rect">
             <a:avLst/>
@@ -30622,7 +30765,7 @@
               </a:spcAft>
             </a:pPr>
             <a:r>
-              <a:rPr sz="1300" b="0" i="0">
+              <a:rPr sz="1500" b="0" i="0">
                 <a:solidFill>
                   <a:srgbClr val="0F172A"/>
                 </a:solidFill>
@@ -30688,8 +30831,8 @@
         </p:nvSpPr>
         <p:spPr>
           <a:xfrm>
-            <a:off x="6501384" y="3739896"/>
-            <a:ext cx="2441448" cy="512064"/>
+            <a:off x="6501384" y="3886282"/>
+            <a:ext cx="2441448" cy="219291"/>
           </a:xfrm>
           <a:prstGeom prst="rect">
             <a:avLst/>
@@ -30714,7 +30857,7 @@
               </a:spcAft>
             </a:pPr>
             <a:r>
-              <a:rPr sz="1300" b="0" i="0">
+              <a:rPr sz="1500" b="0" i="0">
                 <a:solidFill>
                   <a:srgbClr val="0F172A"/>
                 </a:solidFill>
@@ -30780,8 +30923,8 @@
         </p:nvSpPr>
         <p:spPr>
           <a:xfrm>
-            <a:off x="9089136" y="3739896"/>
-            <a:ext cx="2450592" cy="512064"/>
+            <a:off x="9089136" y="3886282"/>
+            <a:ext cx="2450592" cy="219291"/>
           </a:xfrm>
           <a:prstGeom prst="rect">
             <a:avLst/>
@@ -30806,7 +30949,7 @@
               </a:spcAft>
             </a:pPr>
             <a:r>
-              <a:rPr sz="1300" b="0" i="0">
+              <a:rPr sz="1500" b="0" i="0">
                 <a:solidFill>
                   <a:srgbClr val="0F172A"/>
                 </a:solidFill>
@@ -30872,8 +31015,8 @@
         </p:nvSpPr>
         <p:spPr>
           <a:xfrm>
-            <a:off x="621792" y="4251960"/>
-            <a:ext cx="3145536" cy="512064"/>
+            <a:off x="621792" y="4398346"/>
+            <a:ext cx="3145536" cy="219291"/>
           </a:xfrm>
           <a:prstGeom prst="rect">
             <a:avLst/>
@@ -30898,7 +31041,7 @@
               </a:spcAft>
             </a:pPr>
             <a:r>
-              <a:rPr sz="1300" b="1" i="0">
+              <a:rPr sz="1500" b="1" i="0">
                 <a:solidFill>
                   <a:srgbClr val="0F172A"/>
                 </a:solidFill>
@@ -30964,8 +31107,8 @@
         </p:nvSpPr>
         <p:spPr>
           <a:xfrm>
-            <a:off x="3913632" y="4251960"/>
-            <a:ext cx="2441448" cy="512064"/>
+            <a:off x="3913632" y="4398346"/>
+            <a:ext cx="2441448" cy="219291"/>
           </a:xfrm>
           <a:prstGeom prst="rect">
             <a:avLst/>
@@ -30990,7 +31133,7 @@
               </a:spcAft>
             </a:pPr>
             <a:r>
-              <a:rPr sz="1300" b="0" i="0">
+              <a:rPr sz="1500" b="0" i="0">
                 <a:solidFill>
                   <a:srgbClr val="0F172A"/>
                 </a:solidFill>
@@ -31056,8 +31199,8 @@
         </p:nvSpPr>
         <p:spPr>
           <a:xfrm>
-            <a:off x="6501384" y="4251960"/>
-            <a:ext cx="2441448" cy="512064"/>
+            <a:off x="6501384" y="4398346"/>
+            <a:ext cx="2441448" cy="219291"/>
           </a:xfrm>
           <a:prstGeom prst="rect">
             <a:avLst/>
@@ -31082,7 +31225,7 @@
               </a:spcAft>
             </a:pPr>
             <a:r>
-              <a:rPr sz="1300" b="0" i="0">
+              <a:rPr sz="1500" b="0" i="0">
                 <a:solidFill>
                   <a:srgbClr val="0F172A"/>
                 </a:solidFill>
@@ -31148,8 +31291,8 @@
         </p:nvSpPr>
         <p:spPr>
           <a:xfrm>
-            <a:off x="9089136" y="4251960"/>
-            <a:ext cx="2450592" cy="512064"/>
+            <a:off x="9089136" y="4398346"/>
+            <a:ext cx="2450592" cy="219291"/>
           </a:xfrm>
           <a:prstGeom prst="rect">
             <a:avLst/>
@@ -31174,7 +31317,7 @@
               </a:spcAft>
             </a:pPr>
             <a:r>
-              <a:rPr sz="1300" b="0" i="0">
+              <a:rPr sz="1500" b="0" i="0">
                 <a:solidFill>
                   <a:srgbClr val="0F172A"/>
                 </a:solidFill>
@@ -31240,8 +31383,8 @@
         </p:nvSpPr>
         <p:spPr>
           <a:xfrm>
-            <a:off x="621792" y="4764024"/>
-            <a:ext cx="3145536" cy="512064"/>
+            <a:off x="621792" y="4910410"/>
+            <a:ext cx="3145536" cy="219291"/>
           </a:xfrm>
           <a:prstGeom prst="rect">
             <a:avLst/>
@@ -31266,7 +31409,7 @@
               </a:spcAft>
             </a:pPr>
             <a:r>
-              <a:rPr sz="1300" b="1" i="0">
+              <a:rPr sz="1500" b="1" i="0">
                 <a:solidFill>
                   <a:srgbClr val="0F172A"/>
                 </a:solidFill>
@@ -31332,8 +31475,8 @@
         </p:nvSpPr>
         <p:spPr>
           <a:xfrm>
-            <a:off x="3913632" y="4764024"/>
-            <a:ext cx="2441448" cy="512064"/>
+            <a:off x="3913632" y="4910410"/>
+            <a:ext cx="2441448" cy="219291"/>
           </a:xfrm>
           <a:prstGeom prst="rect">
             <a:avLst/>
@@ -31358,7 +31501,7 @@
               </a:spcAft>
             </a:pPr>
             <a:r>
-              <a:rPr sz="1300" b="0" i="0">
+              <a:rPr sz="1500" b="0" i="0">
                 <a:solidFill>
                   <a:srgbClr val="0F172A"/>
                 </a:solidFill>
@@ -31424,8 +31567,8 @@
         </p:nvSpPr>
         <p:spPr>
           <a:xfrm>
-            <a:off x="6501384" y="4764024"/>
-            <a:ext cx="2441448" cy="512064"/>
+            <a:off x="6501384" y="4910410"/>
+            <a:ext cx="2441448" cy="219291"/>
           </a:xfrm>
           <a:prstGeom prst="rect">
             <a:avLst/>
@@ -31450,7 +31593,7 @@
               </a:spcAft>
             </a:pPr>
             <a:r>
-              <a:rPr sz="1300" b="0" i="0">
+              <a:rPr sz="1500" b="0" i="0">
                 <a:solidFill>
                   <a:srgbClr val="0F172A"/>
                 </a:solidFill>
@@ -31516,8 +31659,8 @@
         </p:nvSpPr>
         <p:spPr>
           <a:xfrm>
-            <a:off x="9089136" y="4764024"/>
-            <a:ext cx="2450592" cy="512064"/>
+            <a:off x="9089136" y="4910410"/>
+            <a:ext cx="2450592" cy="219291"/>
           </a:xfrm>
           <a:prstGeom prst="rect">
             <a:avLst/>
@@ -31542,7 +31685,7 @@
               </a:spcAft>
             </a:pPr>
             <a:r>
-              <a:rPr sz="1300" b="0" i="0">
+              <a:rPr sz="1500" b="0" i="0">
                 <a:solidFill>
                   <a:srgbClr val="0F172A"/>
                 </a:solidFill>
@@ -31608,8 +31751,8 @@
         </p:nvSpPr>
         <p:spPr>
           <a:xfrm>
-            <a:off x="621792" y="5276088"/>
-            <a:ext cx="3145536" cy="512064"/>
+            <a:off x="621792" y="5422474"/>
+            <a:ext cx="3145536" cy="219291"/>
           </a:xfrm>
           <a:prstGeom prst="rect">
             <a:avLst/>
@@ -31634,7 +31777,7 @@
               </a:spcAft>
             </a:pPr>
             <a:r>
-              <a:rPr sz="1300" b="1" i="0">
+              <a:rPr sz="1500" b="1" i="0">
                 <a:solidFill>
                   <a:srgbClr val="0F172A"/>
                 </a:solidFill>
@@ -31700,8 +31843,8 @@
         </p:nvSpPr>
         <p:spPr>
           <a:xfrm>
-            <a:off x="3913632" y="5276088"/>
-            <a:ext cx="2441448" cy="512064"/>
+            <a:off x="3913632" y="5422474"/>
+            <a:ext cx="2441448" cy="219291"/>
           </a:xfrm>
           <a:prstGeom prst="rect">
             <a:avLst/>
@@ -31726,7 +31869,7 @@
               </a:spcAft>
             </a:pPr>
             <a:r>
-              <a:rPr sz="1300" b="0" i="0">
+              <a:rPr sz="1500" b="0" i="0">
                 <a:solidFill>
                   <a:srgbClr val="0F172A"/>
                 </a:solidFill>
@@ -31792,8 +31935,8 @@
         </p:nvSpPr>
         <p:spPr>
           <a:xfrm>
-            <a:off x="6501384" y="5276088"/>
-            <a:ext cx="2441448" cy="512064"/>
+            <a:off x="6501384" y="5422474"/>
+            <a:ext cx="2441448" cy="219291"/>
           </a:xfrm>
           <a:prstGeom prst="rect">
             <a:avLst/>
@@ -31818,7 +31961,7 @@
               </a:spcAft>
             </a:pPr>
             <a:r>
-              <a:rPr sz="1300" b="0" i="0">
+              <a:rPr sz="1500" b="0" i="0">
                 <a:solidFill>
                   <a:srgbClr val="0F172A"/>
                 </a:solidFill>
@@ -31884,8 +32027,8 @@
         </p:nvSpPr>
         <p:spPr>
           <a:xfrm>
-            <a:off x="9089136" y="5276088"/>
-            <a:ext cx="2450592" cy="512064"/>
+            <a:off x="9089136" y="5422474"/>
+            <a:ext cx="2450592" cy="219291"/>
           </a:xfrm>
           <a:prstGeom prst="rect">
             <a:avLst/>
@@ -31910,7 +32053,7 @@
               </a:spcAft>
             </a:pPr>
             <a:r>
-              <a:rPr sz="1300" b="0" i="0">
+              <a:rPr sz="1500" b="0" i="0">
                 <a:solidFill>
                   <a:srgbClr val="0F172A"/>
                 </a:solidFill>
@@ -32199,7 +32342,7 @@
         </p:nvSpPr>
         <p:spPr>
           <a:xfrm>
-            <a:off x="548640" y="5806440"/>
+            <a:off x="548640" y="5867400"/>
             <a:ext cx="11064240" cy="411480"/>
           </a:xfrm>
           <a:prstGeom prst="rect">
@@ -32245,7 +32388,7 @@
         <p:spPr>
           <a:xfrm>
             <a:off x="548640" y="6199632"/>
-            <a:ext cx="11064240" cy="274320"/>
+            <a:ext cx="11064240" cy="169277"/>
           </a:xfrm>
           <a:prstGeom prst="rect">
             <a:avLst/>
@@ -32270,13 +32413,13 @@
               </a:spcAft>
             </a:pPr>
             <a:r>
-              <a:rPr sz="1100" b="0" i="1">
+              <a:rPr sz="1100" b="0" i="1" dirty="0">
                 <a:solidFill>
                   <a:srgbClr val="64748B"/>
                 </a:solidFill>
                 <a:latin typeface="Arial"/>
               </a:rPr>
-              <a:t>Table 1 (paper, §3.4) · Annual Reports SAIC/BYD/Geely 2024 &amp; 2025 · EU Reg. 2024/2754</a:t>
+              <a:t>Annual Reports SAIC/BYD/Geely 2024 &amp; 2025 · EU Reg. 2024/2754</a:t>
             </a:r>
           </a:p>
         </p:txBody>

</xml_diff>

<commit_message>
restore Julia's edits + enlarge fonts + fuller notes
Bake Julia's manual edits into the build script so they persist: slide 5/6/9
source-line trims, slide 13 kicker RESULT, slide 19 Geely-PDF point removed,
slide 20 "Key sources", slide 8 arrow lines without dash. Add global ~1.16x
font scale (body/table now ~15-16 pt). Speaker notes expanded to ~30-35 min.

Co-Authored-By: Claude Opus 4.8 <noreply@anthropic.com>
</commit_message>
<xml_diff>
--- a/research/presentation/China-Strategies-Presentation-FINAL.pptx
+++ b/research/presentation/China-Strategies-Presentation-FINAL.pptx
@@ -521,7 +521,7 @@
           <a:lstStyle/>
           <a:p>
             <a:r>
-              <a:t>Good afternoon, and welcome. Our paper asks one question: which way of building a car company in China creates the most value for shareholders over time? We compare three real firms with three models — SAIC uses joint ventures, BYD builds its own technology, and Geely buys companies abroad. Our main point is simple: governance — who controls the firm — matters more than the technology it starts with. We go through four lenses, give our verdict, draw three lessons, and end with how we used AI. Let us start with why this matters now.</a:t>
+              <a:t>Good afternoon, and welcome. Our paper asks one question: which way of building a car company in China creates the most value for shareholders over time? We compare three real firms with three models — SAIC uses joint ventures, BYD builds its own technology, and Geely buys companies abroad. Our main point is simple: governance — who controls the firm — matters more than the technology it starts with. We test this through four lenses: governance, financing, capability, and long-term viability. Then we give our result, draw three lessons, and end with how we used AI. Each of us will take a part. Let us start with why this question matters now.</a:t>
             </a:r>
           </a:p>
         </p:txBody>
@@ -591,7 +591,7 @@
           <a:lstStyle/>
           <a:p>
             <a:r>
-              <a:t>How a firm learns shapes what it can build. SAIC took technology through joint ventures. It worked — quality rose about eight percent — but the easy money killed its own research, so it had no EV platform when the shift came. BYD built everything itself, from battery cells to software; that deep knowledge is hard to copy. Geely bought Volvo and turned it into real shared engineering, confirmed by patent data. So the lesson is simple: handed-over technology fades when the cycle turns, but built or co-developed knowledge lasts. Next, the trade-off.</a:t>
+              <a:t>How a firm learns shapes what it can build later. SAIC took technology through joint ventures. It worked at first — quality rose about eight percent — but the easy money removed the pressure to invent, so it had no EV platform of its own when the shift came. BYD built everything itself, from battery cells to software, and that deep knowledge is very hard to copy. Geely bought Volvo and turned it into real shared engineering, not one-way copying, and patent data confirm it. So the lesson is simple: handed-over technology fades when the cycle turns, while built or co-developed knowledge lasts. Next, the trade-off behind this.</a:t>
             </a:r>
           </a:p>
         </p:txBody>
@@ -661,7 +661,7 @@
           <a:lstStyle/>
           <a:p>
             <a:r>
-              <a:t>This slide shows the trade-off between speed, depth, and independence. SAIC was fastest to quality but shallow and dependent, with no platform of its own. Geely is the rare strong case — fast and deep — because it co-developed with Volvo. BYD was slowest but deepest, thirty years from cells to software, fully its own. The cost of the shallow path is in the bar at the bottom: SAIC's joint-venture plants run at just 14 to 37 percent of capacity. When the technology shifts, there is no platform to fall back on. Next, the EV transition itself.</a:t>
+              <a:t>This slide shows the trade-off between speed, depth, and independence. SAIC was the fastest to quality, but shallow and dependent, with no platform of its own. Geely is the rare strong case — fast and deep — because it co-developed with Volvo. BYD was the slowest but the deepest, thirty years from cells to software, and fully its own. The cost of the shallow path is in the bar at the bottom: SAIC's joint-venture plants run at just 14 to 37 percent of capacity. When the technology shifts, there is no platform to fall back on, and the factories sit half empty. Next, the EV transition itself.</a:t>
             </a:r>
           </a:p>
         </p:txBody>
@@ -731,7 +731,7 @@
           <a:lstStyle/>
           <a:p>
             <a:r>
-              <a:t>The EV shift tests every earlier choice. SAIC is most exposed — its plants run far below capacity — but to be fair, its own brand grew thirty-three percent, with no direct subsidies, and it launched a brand with Huawei. So its future is a race between falling joint-venture income and a thin own-brand margin, and its slow structure sets the pace. BYD is the strongest: no petrol cars since 2022, world number one for four years, exports up one hundred and forty percent. Geely is in between — strong growth, but partner-dependent with loss-making brands. Same shock, three outcomes — exactly what the earlier choices predicted. Now our answer.</a:t>
+              <a:t>The EV shift tests every earlier choice. SAIC is the most exposed — its plants run far below capacity — but to be fair, its own brand grew thirty-three percent, with no direct subsidies, and it launched a brand with Huawei. So its future is a race between falling joint-venture income and a thin own-brand margin, and its slow structure sets the pace. BYD is the strongest: no petrol cars since 2022, the world's number one for four years, and exports up one hundred and forty percent. Geely is in between — strong growth, but it leans on partners and carries loss-making brands. Same shock, three different results — exactly what the earlier choices predicted. Now our result.</a:t>
             </a:r>
           </a:p>
         </p:txBody>
@@ -801,7 +801,7 @@
           <a:lstStyle/>
           <a:p>
             <a:r>
-              <a:t>Here is our answer. Of the three, BYD is most likely to create long-term value. The evidence is consistent: the highest return on equity, four years as the top EV maker, and a 5.6-billion-dollar raise that sovereign funds joined. But notice the wording in the box. It is not that building everything yourself is magic. BYD wins because it combines two things — commercial founder control and a self-financing balance sheet that stays strong in a downturn. Governance and capital discipline together. And we stay honest: BYD's return fell to thirteen percent in 2025 under the price war. Now three lessons.</a:t>
+              <a:t>Here is our result. Of the three, BYD is the one most likely to create long-term value. The evidence is consistent: the highest return on equity, four years as the top EV maker, and a 5.6-billion-dollar raise that sovereign wealth funds joined. But please notice the wording in the box. It is not that building everything yourself is magic. BYD wins because it combines two things — commercial founder control and a self-financing balance sheet that stays strong in a downturn. That is governance and capital discipline working together. And we stay honest: BYD's own return fell to thirteen percent in 2025 under the price war. Now three lessons that go beyond cars.</a:t>
             </a:r>
           </a:p>
         </p:txBody>
@@ -871,7 +871,7 @@
           <a:lstStyle/>
           <a:p>
             <a:r>
-              <a:t>Three lessons that go beyond cars. One: how you build capability decides how long it lasts. Buying or borrowing technology can hollow out a firm when the technology changes; building or co-developing keeps the strength. Two: governance sets the speed of change. Commercial owners move fast; split control stalls — and when technology moves faster than your decisions, governance is the limit. Three: capital structure decides who survives a downturn — risk-sharing can trap you, self-financing trades speed for safety, debt does the opposite. One theme: structure decides. Now the conclusion.</a:t>
+              <a:t>We draw three lessons for any fast-moving market. One: how you build capability decides how long it lasts. Buying or borrowing technology can hollow out a firm when the technology changes, while building or co-developing keeps the strength. Two: governance sets the speed of change. Commercial owners move fast; split control stalls — and when technology moves faster than your decisions, governance becomes the limit. Three: capital structure decides who survives a downturn. Risk-sharing can trap you, self-financing trades speed for safety, and debt does the opposite. One theme runs through all three: structure decides. Now the conclusion.</a:t>
             </a:r>
           </a:p>
         </p:txBody>
@@ -941,7 +941,7 @@
           <a:lstStyle/>
           <a:p>
             <a:r>
-              <a:t>Here is the core point. Across all four lenses, structure — more than starting technology — decided the outcome. The joint-venture model did not lose to a better battery; it lost to a better way of allocating control and capital. BYD's founder control plus self-financing proved the most adaptive, while SAIC's state model serves goals beyond profit, which shows up as a discount. So our line, in the box: when technology moves faster than firms can decide, governance is no longer a footnote to strategy — it is strategy. Before questions, a word on limits and on how we used AI.</a:t>
+              <a:t>Here is the core point. Across all four lenses, structure — more than starting technology — decided the outcome. The joint-venture model did not lose to a better battery; it lost to a better way of allocating control and capital. BYD's founder control plus self-financing proved the most adaptive, while SAIC's state model serves goals beyond profit, which shows up as a lasting discount. So our line, in the box: when technology moves faster than firms can decide, governance is no longer a footnote to strategy — it is strategy. Before questions, a short word on our limits and on how we used AI.</a:t>
             </a:r>
           </a:p>
         </p:txBody>
@@ -1011,7 +1011,7 @@
           <a:lstStyle/>
           <a:p>
             <a:r>
-              <a:t>A short, honest word on limits. We study three firms in one industry and one country, so this is deep case work, not a statistical law. The EV shift is still young, so the ranking could change. We rely on reported figures, and the reports mix currencies, which we reconciled carefully. We left NIO out — a fourth, capital-market model beyond our scope. Future work could add NIO, follow these firms longer, build a formal governance score, and study how the EU tariffs reshape exports. Now, how we used AI.</a:t>
+              <a:t>A short, honest word on limits. We study three firms in one industry and one country, so this is deep case work, not a statistical law. The EV shift is still young, so the ranking could change. We rely on reported figures, and the reports mix currencies, which we reconciled carefully. We also left NIO out — a fourth, capital-market model that was beyond our scope. Future work could add NIO, follow these firms over a longer cycle, build a formal governance score, and study how the EU tariffs reshape exports. Now, how we used AI.</a:t>
             </a:r>
           </a:p>
         </p:txBody>
@@ -1081,7 +1081,7 @@
           <a:lstStyle/>
           <a:p>
             <a:r>
-              <a:t>We did not use a simple chatbot. We used Claude Code as a layered system — a main model for most work, a stronger one for the hard analysis, and five small agents, each with one job. But the heart of it is the shared repository shown here. We had one folder per case and a shared folder for common data. The rule was simple: pull before each session, push after. Because the tool could read all three case wikis at once, we compared the firms directly, with no manual file-sharing. Next, what this added.</a:t>
+              <a:t>We did not use a simple chatbot. We used Claude Code as a layered system — a main model for most work, a stronger one for the hard analysis, and five small agents, each with one job. But the heart of it is the shared repository you see here. We had one folder for each case and a shared folder for common data, like the EU regulation and the IEA figures. The rule was simple: pull before each session, push after. Because the tool could read all three case wikis at once, we compared the firms directly, with no manual file-sharing. Next, what this actually added.</a:t>
             </a:r>
           </a:p>
         </p:txBody>
@@ -1151,7 +1151,7 @@
           <a:lstStyle/>
           <a:p>
             <a:r>
-              <a:t>Where did AI help most? First, it compressed research time — more than thirty papers and reports, all searchable. Second, it kept us disciplined: every source was rated by quality, and we built arguments only on the strongest. The sharpest habit was to tell it to act like a strict professor and to quote the exact source for each fact. That habit also caught three real data errors before submission — a wrong tariff, a profit figure inflated ten times, and an EPS on the wrong share count — all fixed against the audited reports. Next, the honest limits.</a:t>
+              <a:t>Where did AI help the most? First, it saved a lot of time — more than thirty papers and reports, all ingested and searchable. Second, it kept us disciplined: every source was rated by quality, and we built our arguments only on the strongest ones. The sharpest habit was to tell it to act like a strict professor, and to quote the exact source for each fact. That same habit caught three real data errors before submission — a wrong tariff, a profit figure inflated ten times, and an earnings figure on the wrong share count — and we fixed all three against the audited reports. Next, the honest limits.</a:t>
             </a:r>
           </a:p>
         </p:txBody>
@@ -1221,7 +1221,7 @@
           <a:lstStyle/>
           <a:p>
             <a:r>
-              <a:t>Now the limits, honestly. It cannot download paywalled PDFs — it knows the papers' content, but we still had to read and check the key claims ourselves. Geely's PDFs were not machine-readable, so that case used more web sources. On long sessions we hit memory limits, and the output was often too wordy and needed editing. The lesson: this is not a chat box — it took time to learn, and every output needed a careful read. The cost was small, about twenty-one euros a month each. The line we held: AI was our tool and reviewer, never a ghostwriter. The thinking stayed ours.</a:t>
+              <a:t>Now the limits, honestly. It cannot download paywalled PDFs — it knows the papers' content, but we still had to read and check the key claims ourselves. On long sessions we hit memory limits, and the output was often too wordy and needed editing. The lesson is that this is not a chat box — it took time to learn, and every output needed a careful read. The cost was small, about twenty-one euros a month each. The line we held: AI was our tool and our reviewer, never a ghostwriter. The thinking stayed ours. Finally, our sources.</a:t>
             </a:r>
           </a:p>
         </p:txBody>
@@ -1291,7 +1291,7 @@
           <a:lstStyle/>
           <a:p>
             <a:r>
-              <a:t>The joint-venture era is ending. Electric cars are now more than half of new sales in China, and Chinese firms make about sixty percent of the world's EVs. For thirty years the deal was simple: foreign firms gave technology, and a state firm gave market access. That worked when the engine was the hard part. Now the hard part is batteries and software, and that knowledge sits with the Chinese independents. So the old deal no longer helps. You can see it at SAIC: profit fell eighty-eight percent in one year. And the EU set very different tariffs — high for SAIC, low for BYD — which tracks how state-dependent each firm is. Next, our exact question.</a:t>
+              <a:t>The joint-venture era is ending. Electric cars are now more than half of new sales in China, and Chinese firms make about sixty percent of the world's EVs. For thirty years the deal was simple: foreign firms gave technology, and a state firm gave market access. That worked when the engine and the gearbox were the hard part. Now the hard part is the battery, the power electronics, and the software — and that knowledge sits with the Chinese independents, not the foreign partners. So the old deal no longer helps the joint-venture firms. You can see the stress at SAIC: its profit fell eighty-eight percent in one year. And the EU set very different tariffs — high for SAIC, low for BYD — which tracks how state-dependent each firm is. So the market and the regulator point the same way. Next, our exact question.</a:t>
             </a:r>
           </a:p>
         </p:txBody>
@@ -1361,7 +1361,7 @@
           <a:lstStyle/>
           <a:p>
             <a:r>
-              <a:t>These are our main sources, in APA style. The theory comes from Shleifer and Vishny, Jensen and Meckling, and Teece; the China evidence from Bai, Howell, and Holmes. The figures come from the audited annual reports, the EU regulation, and the IEA. The full list is in the paper. Thank you very much — we are happy to take your questions.</a:t>
+              <a:t>These are our main sources, in APA style. The theory comes from Shleifer and Vishny, Jensen and Meckling, and Teece; the China evidence from Bai, Howell, and Holmes. The figures come from the audited annual reports of all three firms, plus the EU regulation and the IEA outlook. The full list is in the paper. Thank you very much for your attention — we are happy to take your questions.</a:t>
             </a:r>
           </a:p>
         </p:txBody>
@@ -1431,7 +1431,7 @@
           <a:lstStyle/>
           <a:p>
             <a:r>
-              <a:t>Our question is short but hard: which structure builds the most value over time? We study three firms with three paths. SAIC is state-owned, controlled by SASAC. BYD is founder-led, run by Wang Chuanfu. Geely is also founder-led, under Li Shufu, but it grew by buying firms abroad. We look at all three through the same four lenses — governance, financing, capability, and viability — in the same order. So we compare one choice at a time, not three company stories. Our thesis is at the bottom: structure beats starting technology. Now the theory behind these lenses.</a:t>
+              <a:t>Our question is short but hard: which structure builds the most value over time? We study three firms with three paths. SAIC is state-owned, controlled by the asset commission SASAC. BYD is founder-led, run by Wang Chuanfu. Geely is also founder-led, under Li Shufu, but it grew by buying firms abroad, like Volvo. To keep it fair, we look at all three through the same four lenses — governance, financing, capability, and viability — in the same order. So we compare one structural choice at a time, not three separate company stories. Our thesis is at the bottom: structure beats starting technology. Now the theory behind these lenses.</a:t>
             </a:r>
           </a:p>
         </p:txBody>
@@ -1501,7 +1501,7 @@
           <a:lstStyle/>
           <a:p>
             <a:r>
-              <a:t>Six well-known ideas all point the same way. Shleifer and Vishny: in a state firm, control sends money to political goals, not shareholders. Megginson and Netter: private firms beat state firms. Jensen and Meckling: a strong founder-owner removes the conflict between owners and managers. Holmes and Fan: the joint-venture trade has a hidden cost — connected firms lag about eighteen percent. Luo and Tung: emerging-market firms buy abroad to catch up. Teece: deep in-house knowledge is hard to copy. So the prediction is clear before we look at the data: founder control should win. Next, our map.</a:t>
+              <a:t>Six well-known ideas all point the same way. Shleifer and Vishny say that in a state firm, control sends money to political goals, not to shareholders. Megginson and Netter show that private firms beat state firms. Jensen and Meckling explain the good case: a strong founder-owner removes the conflict between owners and managers. Holmes and Fan describe the joint-venture trade and its hidden cost — connected firms lag about eighteen percent after listing. Luo and Tung explain why an emerging-market firm buys abroad: to catch up quickly. And Teece explains why deep in-house knowledge is so hard for rivals to copy. So the prediction is clear before we even look at the data: founder control should adapt faster and create more value. Next, our map.</a:t>
             </a:r>
           </a:p>
         </p:txBody>
@@ -1571,7 +1571,7 @@
           <a:lstStyle/>
           <a:p>
             <a:r>
-              <a:t>This matrix is the map for the talk. The rows are the firms, the columns are the four lenses. Read across for one firm; read down to compare. The key point is that the columns are linked. SAIC is state-led, capital-light, dependent on transferred technology, and weakest in the EV shift — those cells belong together. BYD shows the opposite all the way across, and Geely is in between. Over the next slides we go column by column with the evidence. We start with governance.</a:t>
+              <a:t>This matrix is the map for the whole talk. The rows are the three firms, and the columns are the four lenses. Read across a row for one firm's full profile; read down a column to compare the firms on one topic. The key point is that the columns are linked. SAIC is state-led, capital-light, dependent on transferred technology, and weakest in the EV shift — and those four cells belong together. BYD shows the opposite pattern straight across, and Geely is in between. Over the next slides we go column by column with the evidence behind each cell. We start with governance.</a:t>
             </a:r>
           </a:p>
         </p:txBody>
@@ -1641,7 +1641,7 @@
           <a:lstStyle/>
           <a:p>
             <a:r>
-              <a:t>Governance is two questions: who controls, and what they want. SAIC sits under the state — SASAC owns about seventy-three percent, and the Party role is in the charter, so its goals go beyond profit. The cost is speed: it cannot leave a failing joint venture without approval. BYD is the opposite — the founder and his team hold over a third of the votes, so Wang could end petrol-car production in one year, in 2022, alone. Geely is also founder-led and fast on deals, but it runs many brands, and some lose money. So control runs from political at SAIC to commercial at BYD. Next, the EU put a price on this.</a:t>
+              <a:t>Governance is really two questions: who holds control, and what they want. SAIC sits under the state — SASAC owns about seventy-three percent, and the Party role is written into the charter, so its goals go beyond profit, to things like jobs and policy. The cost is speed: it cannot leave a failing joint venture without state approval. BYD is the opposite — the founder and his team hold over a third of the votes, so Wang could end petrol-car production in one year, in 2022, on his own. Geely is also founder-led and fast on deals, but it runs many brands, and some of them lose money. So control runs on a scale, from political at SAIC to fully commercial at BYD. Next, the EU put a real price on this difference.</a:t>
             </a:r>
           </a:p>
         </p:txBody>
@@ -1711,7 +1711,7 @@
           <a:lstStyle/>
           <a:p>
             <a:r>
-              <a:t>Here is outside proof. The EU studied state support and set tariffs: 35.3 percent for SAIC, 17 for BYD, 18.8 for Geely. That gap is not about car quality — it is about state dependence. For SAIC the Commission even used “facts available,” because the group held back financing data. So a neutral regulator reached our conclusion from the outside: control structure drives competitive position. And for exports, that tariff is a direct cost of the governance model. Now we follow the money.</a:t>
+              <a:t>Here is proof from outside the firms. The EU studied state support and set tariffs: 35.3 percent for SAIC, 17 for BYD, and 18.8 for Geely. That gap is not about car quality — it is about state dependence. For SAIC the Commission even used “facts available,” because the group held back some financing data. So a neutral regulator reached the same conclusion we reach from the inside: control structure drives competitive position. And for a firm that wants to grow through exports, that tariff is a direct, lasting cost of the governance model it chose. Now we follow the money.</a:t>
             </a:r>
           </a:p>
         </p:txBody>
@@ -1781,7 +1781,7 @@
           <a:lstStyle/>
           <a:p>
             <a:r>
-              <a:t>Each firm funds growth differently, and it shows in a downturn. SAIC was capital-light — it shared cost and risk with foreign partners. That felt safe, until SAIC-GM lost half its sales, and SAIC had to absorb the losses without control to fix them. Profit fell eighty-eight percent; the capital-light model became a capital trap. BYD funds itself from its own cash and spends more on R&amp;D than it earns, so it needs no banks; the limit is its own cash. Geely borrows to buy capability fast, but its debt is rising. So the real choice is resilience versus speed. Next, the numbers.</a:t>
+              <a:t>Each firm funds its growth differently, and the difference shows up in a downturn. SAIC was capital-light: it shared cost and risk with its foreign partners. That felt safe — until SAIC-GM lost more than half its sales, and SAIC was still bound to absorb the losses, with no control to fix the business. Profit fell eighty-eight percent; the capital-light model had become a capital trap. BYD funds itself from its own cash, and it spends more on research than it earns in profit, so it needs no banks; the limit is its own cash flow. Geely borrows to buy capability fast — that is how it got Volvo — but its debt is rising. So the real choice is resilience versus speed. Next, the numbers.</a:t>
             </a:r>
           </a:p>
         </p:txBody>
@@ -1851,7 +1851,7 @@
           <a:lstStyle/>
           <a:p>
             <a:r>
-              <a:t>Here are the numbers in one table. Return on equity: BYD and Geely near twenty percent, SAIC below one — that line says it all. Research: BYD spends more on R&amp;D than it earns in profit. Cash flow: BYD generates far more than the others. One honest note: SAIC's profit looks recovered in 2025, but that is mostly because the 2024 write-downs did not repeat, not a real turnaround. The bottom row, the EU tariff, marks the same governance gap. Next, how each firm builds technology.</a:t>
+              <a:t>Here are the numbers in one table. Look at return on equity: BYD and Geely are near twenty percent, while SAIC is below one — that single line tells the story. Research spending: BYD spends more on R&amp;D than it earns in profit. Cash flow: BYD generates far more than the other two. One honest note on SAIC: its profit looks like it recovered in 2025, but that is mostly because the big write-downs of 2024 did not repeat — the business stabilised, it did not really turn around. And the bottom row, the EU tariff, marks the same governance gap once more. Next, how each firm builds its technology.</a:t>
             </a:r>
           </a:p>
         </p:txBody>
@@ -4979,7 +4979,7 @@
               </a:spcAft>
             </a:pPr>
             <a:r>
-              <a:rPr sz="1300" b="1" i="0">
+              <a:rPr sz="1507" b="1" i="0">
                 <a:solidFill>
                   <a:srgbClr val="06B6D4"/>
                 </a:solidFill>
@@ -5180,7 +5180,7 @@
               </a:spcAft>
             </a:pPr>
             <a:r>
-              <a:rPr sz="1250" b="1" i="0">
+              <a:rPr sz="1449" b="1" i="0">
                 <a:solidFill>
                   <a:srgbClr val="FFFFFF"/>
                 </a:solidFill>
@@ -5269,7 +5269,7 @@
               </a:spcAft>
             </a:pPr>
             <a:r>
-              <a:rPr sz="1250" b="1" i="0">
+              <a:rPr sz="1449" b="1" i="0">
                 <a:solidFill>
                   <a:srgbClr val="FFFFFF"/>
                 </a:solidFill>
@@ -5358,7 +5358,7 @@
               </a:spcAft>
             </a:pPr>
             <a:r>
-              <a:rPr sz="1250" b="1" i="0">
+              <a:rPr sz="1449" b="1" i="0">
                 <a:solidFill>
                   <a:srgbClr val="FFFFFF"/>
                 </a:solidFill>
@@ -5403,7 +5403,7 @@
               </a:spcAft>
             </a:pPr>
             <a:r>
-              <a:rPr sz="1500" b="1" i="0">
+              <a:rPr sz="1739" b="1" i="0">
                 <a:solidFill>
                   <a:srgbClr val="FFFFFF"/>
                 </a:solidFill>
@@ -5448,7 +5448,7 @@
               </a:spcAft>
             </a:pPr>
             <a:r>
-              <a:rPr sz="1200" b="0" i="0">
+              <a:rPr sz="1391" b="0" i="0">
                 <a:solidFill>
                   <a:srgbClr val="64748B"/>
                 </a:solidFill>
@@ -5470,7 +5470,7 @@
               </a:spcAft>
             </a:pPr>
             <a:r>
-              <a:rPr sz="1200" b="0" i="0">
+              <a:rPr sz="1391" b="0" i="0">
                 <a:solidFill>
                   <a:srgbClr val="64748B"/>
                 </a:solidFill>
@@ -5577,7 +5577,7 @@
               </a:spcAft>
             </a:pPr>
             <a:r>
-              <a:rPr sz="1400" b="1" i="0">
+              <a:rPr sz="1623" b="1" i="0">
                 <a:solidFill>
                   <a:srgbClr val="06B6D4"/>
                 </a:solidFill>
@@ -5845,7 +5845,7 @@
               </a:spcAft>
             </a:pPr>
             <a:r>
-              <a:rPr sz="1600" b="1" i="0">
+              <a:rPr sz="1855" b="1" i="0">
                 <a:solidFill>
                   <a:srgbClr val="DC2626"/>
                 </a:solidFill>
@@ -5891,7 +5891,7 @@
               <a:buNone/>
             </a:pPr>
             <a:r>
-              <a:rPr sz="1350">
+              <a:rPr sz="1565">
                 <a:solidFill>
                   <a:srgbClr val="DC2626"/>
                 </a:solidFill>
@@ -5900,7 +5900,7 @@
               <a:t>–  </a:t>
             </a:r>
             <a:r>
-              <a:rPr sz="1350">
+              <a:rPr sz="1565">
                 <a:solidFill>
                   <a:srgbClr val="0F172A"/>
                 </a:solidFill>
@@ -5923,7 +5923,7 @@
               <a:buNone/>
             </a:pPr>
             <a:r>
-              <a:rPr sz="1350">
+              <a:rPr sz="1565">
                 <a:solidFill>
                   <a:srgbClr val="DC2626"/>
                 </a:solidFill>
@@ -5932,7 +5932,7 @@
               <a:t>–  </a:t>
             </a:r>
             <a:r>
-              <a:rPr sz="1350">
+              <a:rPr sz="1565">
                 <a:solidFill>
                   <a:srgbClr val="0F172A"/>
                 </a:solidFill>
@@ -5955,7 +5955,7 @@
               <a:buNone/>
             </a:pPr>
             <a:r>
-              <a:rPr sz="1350">
+              <a:rPr sz="1565">
                 <a:solidFill>
                   <a:srgbClr val="DC2626"/>
                 </a:solidFill>
@@ -5964,7 +5964,7 @@
               <a:t>–  </a:t>
             </a:r>
             <a:r>
-              <a:rPr sz="1350">
+              <a:rPr sz="1565">
                 <a:solidFill>
                   <a:srgbClr val="0F172A"/>
                 </a:solidFill>
@@ -6099,7 +6099,7 @@
               </a:spcAft>
             </a:pPr>
             <a:r>
-              <a:rPr sz="1600" b="1" i="0">
+              <a:rPr sz="1855" b="1" i="0">
                 <a:solidFill>
                   <a:srgbClr val="2563EB"/>
                 </a:solidFill>
@@ -6145,7 +6145,7 @@
               <a:buNone/>
             </a:pPr>
             <a:r>
-              <a:rPr sz="1350">
+              <a:rPr sz="1565">
                 <a:solidFill>
                   <a:srgbClr val="2563EB"/>
                 </a:solidFill>
@@ -6154,7 +6154,7 @@
               <a:t>–  </a:t>
             </a:r>
             <a:r>
-              <a:rPr sz="1350">
+              <a:rPr sz="1565">
                 <a:solidFill>
                   <a:srgbClr val="0F172A"/>
                 </a:solidFill>
@@ -6177,7 +6177,7 @@
               <a:buNone/>
             </a:pPr>
             <a:r>
-              <a:rPr sz="1350">
+              <a:rPr sz="1565">
                 <a:solidFill>
                   <a:srgbClr val="2563EB"/>
                 </a:solidFill>
@@ -6186,7 +6186,7 @@
               <a:t>–  </a:t>
             </a:r>
             <a:r>
-              <a:rPr sz="1350">
+              <a:rPr sz="1565">
                 <a:solidFill>
                   <a:srgbClr val="0F172A"/>
                 </a:solidFill>
@@ -6209,7 +6209,7 @@
               <a:buNone/>
             </a:pPr>
             <a:r>
-              <a:rPr sz="1350">
+              <a:rPr sz="1565">
                 <a:solidFill>
                   <a:srgbClr val="2563EB"/>
                 </a:solidFill>
@@ -6218,7 +6218,7 @@
               <a:t>–  </a:t>
             </a:r>
             <a:r>
-              <a:rPr sz="1350">
+              <a:rPr sz="1565">
                 <a:solidFill>
                   <a:srgbClr val="0F172A"/>
                 </a:solidFill>
@@ -6353,7 +6353,7 @@
               </a:spcAft>
             </a:pPr>
             <a:r>
-              <a:rPr sz="1600" b="1" i="0">
+              <a:rPr sz="1855" b="1" i="0">
                 <a:solidFill>
                   <a:srgbClr val="06B6D4"/>
                 </a:solidFill>
@@ -6399,7 +6399,7 @@
               <a:buNone/>
             </a:pPr>
             <a:r>
-              <a:rPr sz="1350">
+              <a:rPr sz="1565">
                 <a:solidFill>
                   <a:srgbClr val="06B6D4"/>
                 </a:solidFill>
@@ -6408,7 +6408,7 @@
               <a:t>–  </a:t>
             </a:r>
             <a:r>
-              <a:rPr sz="1350">
+              <a:rPr sz="1565">
                 <a:solidFill>
                   <a:srgbClr val="0F172A"/>
                 </a:solidFill>
@@ -6431,7 +6431,7 @@
               <a:buNone/>
             </a:pPr>
             <a:r>
-              <a:rPr sz="1350">
+              <a:rPr sz="1565">
                 <a:solidFill>
                   <a:srgbClr val="06B6D4"/>
                 </a:solidFill>
@@ -6440,7 +6440,7 @@
               <a:t>–  </a:t>
             </a:r>
             <a:r>
-              <a:rPr sz="1350">
+              <a:rPr sz="1565">
                 <a:solidFill>
                   <a:srgbClr val="0F172A"/>
                 </a:solidFill>
@@ -6463,7 +6463,7 @@
               <a:buNone/>
             </a:pPr>
             <a:r>
-              <a:rPr sz="1350">
+              <a:rPr sz="1565">
                 <a:solidFill>
                   <a:srgbClr val="06B6D4"/>
                 </a:solidFill>
@@ -6472,7 +6472,7 @@
               <a:t>–  </a:t>
             </a:r>
             <a:r>
-              <a:rPr sz="1350">
+              <a:rPr sz="1565">
                 <a:solidFill>
                   <a:srgbClr val="0F172A"/>
                 </a:solidFill>
@@ -6517,7 +6517,7 @@
               </a:spcAft>
             </a:pPr>
             <a:r>
-              <a:rPr sz="1400" b="1" i="0">
+              <a:rPr sz="1623" b="1" i="0">
                 <a:solidFill>
                   <a:srgbClr val="0F172A"/>
                 </a:solidFill>
@@ -6562,7 +6562,7 @@
               </a:spcAft>
             </a:pPr>
             <a:r>
-              <a:rPr sz="1100" b="0" i="1">
+              <a:rPr sz="1276" b="0" i="1">
                 <a:solidFill>
                   <a:srgbClr val="64748B"/>
                 </a:solidFill>
@@ -6607,7 +6607,7 @@
               </a:spcAft>
             </a:pPr>
             <a:r>
-              <a:rPr sz="1050" b="0" i="0">
+              <a:rPr sz="1218" b="0" i="0">
                 <a:solidFill>
                   <a:srgbClr val="64748B"/>
                 </a:solidFill>
@@ -6652,7 +6652,7 @@
               </a:spcAft>
             </a:pPr>
             <a:r>
-              <a:rPr sz="1050" b="0" i="0">
+              <a:rPr sz="1218" b="0" i="0">
                 <a:solidFill>
                   <a:srgbClr val="64748B"/>
                 </a:solidFill>
@@ -6759,7 +6759,7 @@
               </a:spcAft>
             </a:pPr>
             <a:r>
-              <a:rPr sz="1400" b="1" i="0">
+              <a:rPr sz="1623" b="1" i="0">
                 <a:solidFill>
                   <a:srgbClr val="06B6D4"/>
                 </a:solidFill>
@@ -7027,7 +7027,7 @@
               </a:spcAft>
             </a:pPr>
             <a:r>
-              <a:rPr sz="1600" b="1" i="0">
+              <a:rPr sz="1855" b="1" i="0">
                 <a:solidFill>
                   <a:srgbClr val="FFFFFF"/>
                 </a:solidFill>
@@ -7072,7 +7072,7 @@
               </a:spcAft>
             </a:pPr>
             <a:r>
-              <a:rPr sz="1500" b="1" i="0">
+              <a:rPr sz="1739" b="1" i="0">
                 <a:solidFill>
                   <a:srgbClr val="DC2626"/>
                 </a:solidFill>
@@ -7117,7 +7117,7 @@
               </a:spcAft>
             </a:pPr>
             <a:r>
-              <a:rPr sz="1350" b="0" i="0">
+              <a:rPr sz="1565" b="0" i="0">
                 <a:solidFill>
                   <a:srgbClr val="0F172A"/>
                 </a:solidFill>
@@ -7252,7 +7252,7 @@
               </a:spcAft>
             </a:pPr>
             <a:r>
-              <a:rPr sz="1600" b="1" i="0">
+              <a:rPr sz="1855" b="1" i="0">
                 <a:solidFill>
                   <a:srgbClr val="FFFFFF"/>
                 </a:solidFill>
@@ -7297,7 +7297,7 @@
               </a:spcAft>
             </a:pPr>
             <a:r>
-              <a:rPr sz="1500" b="1" i="0">
+              <a:rPr sz="1739" b="1" i="0">
                 <a:solidFill>
                   <a:srgbClr val="06B6D4"/>
                 </a:solidFill>
@@ -7342,7 +7342,7 @@
               </a:spcAft>
             </a:pPr>
             <a:r>
-              <a:rPr sz="1350" b="0" i="0">
+              <a:rPr sz="1565" b="0" i="0">
                 <a:solidFill>
                   <a:srgbClr val="0F172A"/>
                 </a:solidFill>
@@ -7477,7 +7477,7 @@
               </a:spcAft>
             </a:pPr>
             <a:r>
-              <a:rPr sz="1600" b="1" i="0">
+              <a:rPr sz="1855" b="1" i="0">
                 <a:solidFill>
                   <a:srgbClr val="FFFFFF"/>
                 </a:solidFill>
@@ -7522,7 +7522,7 @@
               </a:spcAft>
             </a:pPr>
             <a:r>
-              <a:rPr sz="1500" b="1" i="0">
+              <a:rPr sz="1739" b="1" i="0">
                 <a:solidFill>
                   <a:srgbClr val="2563EB"/>
                 </a:solidFill>
@@ -7567,7 +7567,7 @@
               </a:spcAft>
             </a:pPr>
             <a:r>
-              <a:rPr sz="1350" b="0" i="0">
+              <a:rPr sz="1565" b="0" i="0">
                 <a:solidFill>
                   <a:srgbClr val="0F172A"/>
                 </a:solidFill>
@@ -7656,7 +7656,7 @@
               </a:spcAft>
             </a:pPr>
             <a:r>
-              <a:rPr sz="1400" b="1" i="0">
+              <a:rPr sz="1623" b="1" i="0">
                 <a:solidFill>
                   <a:srgbClr val="FFFFFF"/>
                 </a:solidFill>
@@ -7701,7 +7701,7 @@
               </a:spcAft>
             </a:pPr>
             <a:r>
-              <a:rPr sz="1100" b="0" i="1">
+              <a:rPr sz="1276" b="0" i="1">
                 <a:solidFill>
                   <a:srgbClr val="64748B"/>
                 </a:solidFill>
@@ -7746,7 +7746,7 @@
               </a:spcAft>
             </a:pPr>
             <a:r>
-              <a:rPr sz="1050" b="0" i="0">
+              <a:rPr sz="1218" b="0" i="0">
                 <a:solidFill>
                   <a:srgbClr val="64748B"/>
                 </a:solidFill>
@@ -7791,7 +7791,7 @@
               </a:spcAft>
             </a:pPr>
             <a:r>
-              <a:rPr sz="1050" b="0" i="0">
+              <a:rPr sz="1218" b="0" i="0">
                 <a:solidFill>
                   <a:srgbClr val="64748B"/>
                 </a:solidFill>
@@ -7898,7 +7898,7 @@
               </a:spcAft>
             </a:pPr>
             <a:r>
-              <a:rPr sz="1400" b="1" i="0">
+              <a:rPr sz="1623" b="1" i="0">
                 <a:solidFill>
                   <a:srgbClr val="06B6D4"/>
                 </a:solidFill>
@@ -8166,7 +8166,7 @@
               </a:spcAft>
             </a:pPr>
             <a:r>
-              <a:rPr sz="1600" b="1" i="0">
+              <a:rPr sz="1855" b="1" i="0">
                 <a:solidFill>
                   <a:srgbClr val="DC2626"/>
                 </a:solidFill>
@@ -8212,7 +8212,7 @@
               <a:buNone/>
             </a:pPr>
             <a:r>
-              <a:rPr sz="1350">
+              <a:rPr sz="1565">
                 <a:solidFill>
                   <a:srgbClr val="DC2626"/>
                 </a:solidFill>
@@ -8221,7 +8221,7 @@
               <a:t>–  </a:t>
             </a:r>
             <a:r>
-              <a:rPr sz="1350">
+              <a:rPr sz="1565">
                 <a:solidFill>
                   <a:srgbClr val="0F172A"/>
                 </a:solidFill>
@@ -8244,7 +8244,7 @@
               <a:buNone/>
             </a:pPr>
             <a:r>
-              <a:rPr sz="1350">
+              <a:rPr sz="1565">
                 <a:solidFill>
                   <a:srgbClr val="DC2626"/>
                 </a:solidFill>
@@ -8253,7 +8253,7 @@
               <a:t>–  </a:t>
             </a:r>
             <a:r>
-              <a:rPr sz="1350">
+              <a:rPr sz="1565">
                 <a:solidFill>
                   <a:srgbClr val="0F172A"/>
                 </a:solidFill>
@@ -8276,7 +8276,7 @@
               <a:buNone/>
             </a:pPr>
             <a:r>
-              <a:rPr sz="1350">
+              <a:rPr sz="1565">
                 <a:solidFill>
                   <a:srgbClr val="DC2626"/>
                 </a:solidFill>
@@ -8285,7 +8285,7 @@
               <a:t>–  </a:t>
             </a:r>
             <a:r>
-              <a:rPr sz="1350">
+              <a:rPr sz="1565">
                 <a:solidFill>
                   <a:srgbClr val="0F172A"/>
                 </a:solidFill>
@@ -8420,7 +8420,7 @@
               </a:spcAft>
             </a:pPr>
             <a:r>
-              <a:rPr sz="1600" b="1" i="0">
+              <a:rPr sz="1855" b="1" i="0">
                 <a:solidFill>
                   <a:srgbClr val="2563EB"/>
                 </a:solidFill>
@@ -8466,7 +8466,7 @@
               <a:buNone/>
             </a:pPr>
             <a:r>
-              <a:rPr sz="1350">
+              <a:rPr sz="1565">
                 <a:solidFill>
                   <a:srgbClr val="2563EB"/>
                 </a:solidFill>
@@ -8475,7 +8475,7 @@
               <a:t>–  </a:t>
             </a:r>
             <a:r>
-              <a:rPr sz="1350">
+              <a:rPr sz="1565">
                 <a:solidFill>
                   <a:srgbClr val="0F172A"/>
                 </a:solidFill>
@@ -8498,7 +8498,7 @@
               <a:buNone/>
             </a:pPr>
             <a:r>
-              <a:rPr sz="1350">
+              <a:rPr sz="1565">
                 <a:solidFill>
                   <a:srgbClr val="2563EB"/>
                 </a:solidFill>
@@ -8507,7 +8507,7 @@
               <a:t>–  </a:t>
             </a:r>
             <a:r>
-              <a:rPr sz="1350">
+              <a:rPr sz="1565">
                 <a:solidFill>
                   <a:srgbClr val="0F172A"/>
                 </a:solidFill>
@@ -8530,7 +8530,7 @@
               <a:buNone/>
             </a:pPr>
             <a:r>
-              <a:rPr sz="1350">
+              <a:rPr sz="1565">
                 <a:solidFill>
                   <a:srgbClr val="2563EB"/>
                 </a:solidFill>
@@ -8539,7 +8539,7 @@
               <a:t>–  </a:t>
             </a:r>
             <a:r>
-              <a:rPr sz="1350">
+              <a:rPr sz="1565">
                 <a:solidFill>
                   <a:srgbClr val="0F172A"/>
                 </a:solidFill>
@@ -8674,7 +8674,7 @@
               </a:spcAft>
             </a:pPr>
             <a:r>
-              <a:rPr sz="1600" b="1" i="0">
+              <a:rPr sz="1855" b="1" i="0">
                 <a:solidFill>
                   <a:srgbClr val="06B6D4"/>
                 </a:solidFill>
@@ -8720,7 +8720,7 @@
               <a:buNone/>
             </a:pPr>
             <a:r>
-              <a:rPr sz="1350">
+              <a:rPr sz="1565">
                 <a:solidFill>
                   <a:srgbClr val="06B6D4"/>
                 </a:solidFill>
@@ -8729,7 +8729,7 @@
               <a:t>–  </a:t>
             </a:r>
             <a:r>
-              <a:rPr sz="1350">
+              <a:rPr sz="1565">
                 <a:solidFill>
                   <a:srgbClr val="0F172A"/>
                 </a:solidFill>
@@ -8752,7 +8752,7 @@
               <a:buNone/>
             </a:pPr>
             <a:r>
-              <a:rPr sz="1350">
+              <a:rPr sz="1565">
                 <a:solidFill>
                   <a:srgbClr val="06B6D4"/>
                 </a:solidFill>
@@ -8761,7 +8761,7 @@
               <a:t>–  </a:t>
             </a:r>
             <a:r>
-              <a:rPr sz="1350">
+              <a:rPr sz="1565">
                 <a:solidFill>
                   <a:srgbClr val="0F172A"/>
                 </a:solidFill>
@@ -8784,7 +8784,7 @@
               <a:buNone/>
             </a:pPr>
             <a:r>
-              <a:rPr sz="1350">
+              <a:rPr sz="1565">
                 <a:solidFill>
                   <a:srgbClr val="06B6D4"/>
                 </a:solidFill>
@@ -8793,7 +8793,7 @@
               <a:t>–  </a:t>
             </a:r>
             <a:r>
-              <a:rPr sz="1350">
+              <a:rPr sz="1565">
                 <a:solidFill>
                   <a:srgbClr val="0F172A"/>
                 </a:solidFill>
@@ -8838,7 +8838,7 @@
               </a:spcAft>
             </a:pPr>
             <a:r>
-              <a:rPr sz="1400" b="1" i="0">
+              <a:rPr sz="1623" b="1" i="0">
                 <a:solidFill>
                   <a:srgbClr val="0F172A"/>
                 </a:solidFill>
@@ -8883,7 +8883,7 @@
               </a:spcAft>
             </a:pPr>
             <a:r>
-              <a:rPr sz="1100" b="0" i="1">
+              <a:rPr sz="1276" b="0" i="1">
                 <a:solidFill>
                   <a:srgbClr val="64748B"/>
                 </a:solidFill>
@@ -8928,7 +8928,7 @@
               </a:spcAft>
             </a:pPr>
             <a:r>
-              <a:rPr sz="1050" b="0" i="0">
+              <a:rPr sz="1218" b="0" i="0">
                 <a:solidFill>
                   <a:srgbClr val="64748B"/>
                 </a:solidFill>
@@ -8973,7 +8973,7 @@
               </a:spcAft>
             </a:pPr>
             <a:r>
-              <a:rPr sz="1050" b="0" i="0">
+              <a:rPr sz="1218" b="0" i="0">
                 <a:solidFill>
                   <a:srgbClr val="64748B"/>
                 </a:solidFill>
@@ -9124,13 +9124,13 @@
               </a:spcAft>
             </a:pPr>
             <a:r>
-              <a:rPr sz="1400" b="1" i="0">
+              <a:rPr sz="1623" b="1" i="0">
                 <a:solidFill>
                   <a:srgbClr val="06B6D4"/>
                 </a:solidFill>
                 <a:latin typeface="Arial"/>
               </a:rPr>
-              <a:t>VERDICT</a:t>
+              <a:t>RESULT</a:t>
             </a:r>
           </a:p>
         </p:txBody>
@@ -9325,7 +9325,7 @@
               </a:spcAft>
             </a:pPr>
             <a:r>
-              <a:rPr sz="1200" b="0" i="0">
+              <a:rPr sz="1391" b="0" i="0">
                 <a:solidFill>
                   <a:srgbClr val="CBD5E1"/>
                 </a:solidFill>
@@ -9347,7 +9347,7 @@
               </a:spcAft>
             </a:pPr>
             <a:r>
-              <a:rPr sz="1200" b="0" i="0">
+              <a:rPr sz="1391" b="0" i="0">
                 <a:solidFill>
                   <a:srgbClr val="CBD5E1"/>
                 </a:solidFill>
@@ -9481,7 +9481,7 @@
               </a:spcAft>
             </a:pPr>
             <a:r>
-              <a:rPr sz="1200" b="0" i="0">
+              <a:rPr sz="1391" b="0" i="0">
                 <a:solidFill>
                   <a:srgbClr val="CBD5E1"/>
                 </a:solidFill>
@@ -9503,7 +9503,7 @@
               </a:spcAft>
             </a:pPr>
             <a:r>
-              <a:rPr sz="1200" b="0" i="0">
+              <a:rPr sz="1391" b="0" i="0">
                 <a:solidFill>
                   <a:srgbClr val="CBD5E1"/>
                 </a:solidFill>
@@ -9637,7 +9637,7 @@
               </a:spcAft>
             </a:pPr>
             <a:r>
-              <a:rPr sz="1200" b="0" i="0">
+              <a:rPr sz="1391" b="0" i="0">
                 <a:solidFill>
                   <a:srgbClr val="CBD5E1"/>
                 </a:solidFill>
@@ -9659,7 +9659,7 @@
               </a:spcAft>
             </a:pPr>
             <a:r>
-              <a:rPr sz="1200" b="0" i="0">
+              <a:rPr sz="1391" b="0" i="0">
                 <a:solidFill>
                   <a:srgbClr val="CBD5E1"/>
                 </a:solidFill>
@@ -9792,7 +9792,7 @@
               </a:spcAft>
             </a:pPr>
             <a:r>
-              <a:rPr sz="1450" b="0" i="0">
+              <a:rPr sz="1682" b="0" i="0">
                 <a:solidFill>
                   <a:srgbClr val="FFFFFF"/>
                 </a:solidFill>
@@ -9837,7 +9837,7 @@
               </a:spcAft>
             </a:pPr>
             <a:r>
-              <a:rPr sz="1100" b="0" i="1">
+              <a:rPr sz="1276" b="0" i="1">
                 <a:solidFill>
                   <a:srgbClr val="64748B"/>
                 </a:solidFill>
@@ -9882,7 +9882,7 @@
               </a:spcAft>
             </a:pPr>
             <a:r>
-              <a:rPr sz="1050" b="0" i="0">
+              <a:rPr sz="1218" b="0" i="0">
                 <a:solidFill>
                   <a:srgbClr val="64748B"/>
                 </a:solidFill>
@@ -9927,7 +9927,7 @@
               </a:spcAft>
             </a:pPr>
             <a:r>
-              <a:rPr sz="1050" b="0" i="0">
+              <a:rPr sz="1218" b="0" i="0">
                 <a:solidFill>
                   <a:srgbClr val="64748B"/>
                 </a:solidFill>
@@ -10034,7 +10034,7 @@
               </a:spcAft>
             </a:pPr>
             <a:r>
-              <a:rPr sz="1400" b="1" i="0">
+              <a:rPr sz="1623" b="1" i="0">
                 <a:solidFill>
                   <a:srgbClr val="06B6D4"/>
                 </a:solidFill>
@@ -10347,7 +10347,7 @@
               </a:spcAft>
             </a:pPr>
             <a:r>
-              <a:rPr sz="1650" b="1" i="0">
+              <a:rPr sz="1913" b="1" i="0">
                 <a:solidFill>
                   <a:srgbClr val="0F172A"/>
                 </a:solidFill>
@@ -10392,7 +10392,7 @@
               </a:spcAft>
             </a:pPr>
             <a:r>
-              <a:rPr sz="1300" b="0" i="0">
+              <a:rPr sz="1507" b="0" i="0">
                 <a:solidFill>
                   <a:srgbClr val="0F172A"/>
                 </a:solidFill>
@@ -10572,7 +10572,7 @@
               </a:spcAft>
             </a:pPr>
             <a:r>
-              <a:rPr sz="1650" b="1" i="0">
+              <a:rPr sz="1913" b="1" i="0">
                 <a:solidFill>
                   <a:srgbClr val="0F172A"/>
                 </a:solidFill>
@@ -10617,7 +10617,7 @@
               </a:spcAft>
             </a:pPr>
             <a:r>
-              <a:rPr sz="1300" b="0" i="0">
+              <a:rPr sz="1507" b="0" i="0">
                 <a:solidFill>
                   <a:srgbClr val="0F172A"/>
                 </a:solidFill>
@@ -10797,7 +10797,7 @@
               </a:spcAft>
             </a:pPr>
             <a:r>
-              <a:rPr sz="1650" b="1" i="0">
+              <a:rPr sz="1913" b="1" i="0">
                 <a:solidFill>
                   <a:srgbClr val="0F172A"/>
                 </a:solidFill>
@@ -10842,7 +10842,7 @@
               </a:spcAft>
             </a:pPr>
             <a:r>
-              <a:rPr sz="1300" b="0" i="0">
+              <a:rPr sz="1507" b="0" i="0">
                 <a:solidFill>
                   <a:srgbClr val="0F172A"/>
                 </a:solidFill>
@@ -10887,7 +10887,7 @@
               </a:spcAft>
             </a:pPr>
             <a:r>
-              <a:rPr sz="1050" b="0" i="0">
+              <a:rPr sz="1218" b="0" i="0">
                 <a:solidFill>
                   <a:srgbClr val="64748B"/>
                 </a:solidFill>
@@ -10932,7 +10932,7 @@
               </a:spcAft>
             </a:pPr>
             <a:r>
-              <a:rPr sz="1050" b="0" i="0">
+              <a:rPr sz="1218" b="0" i="0">
                 <a:solidFill>
                   <a:srgbClr val="64748B"/>
                 </a:solidFill>
@@ -11083,7 +11083,7 @@
               </a:spcAft>
             </a:pPr>
             <a:r>
-              <a:rPr sz="1400" b="1" i="0">
+              <a:rPr sz="1623" b="1" i="0">
                 <a:solidFill>
                   <a:srgbClr val="06B6D4"/>
                 </a:solidFill>
@@ -11351,7 +11351,7 @@
               </a:spcAft>
             </a:pPr>
             <a:r>
-              <a:rPr sz="1400" b="1" i="0">
+              <a:rPr sz="1623" b="1" i="0">
                 <a:solidFill>
                   <a:srgbClr val="06B6D4"/>
                 </a:solidFill>
@@ -11397,7 +11397,7 @@
               <a:buNone/>
             </a:pPr>
             <a:r>
-              <a:rPr sz="1300">
+              <a:rPr sz="1507">
                 <a:solidFill>
                   <a:srgbClr val="06B6D4"/>
                 </a:solidFill>
@@ -11406,7 +11406,7 @@
               <a:t>–  </a:t>
             </a:r>
             <a:r>
-              <a:rPr sz="1300">
+              <a:rPr sz="1507">
                 <a:solidFill>
                   <a:srgbClr val="E2E8F0"/>
                 </a:solidFill>
@@ -11429,7 +11429,7 @@
               <a:buNone/>
             </a:pPr>
             <a:r>
-              <a:rPr sz="1300">
+              <a:rPr sz="1507">
                 <a:solidFill>
                   <a:srgbClr val="06B6D4"/>
                 </a:solidFill>
@@ -11438,7 +11438,7 @@
               <a:t>–  </a:t>
             </a:r>
             <a:r>
-              <a:rPr sz="1300">
+              <a:rPr sz="1507">
                 <a:solidFill>
                   <a:srgbClr val="E2E8F0"/>
                 </a:solidFill>
@@ -11461,7 +11461,7 @@
               <a:buNone/>
             </a:pPr>
             <a:r>
-              <a:rPr sz="1300">
+              <a:rPr sz="1507">
                 <a:solidFill>
                   <a:srgbClr val="06B6D4"/>
                 </a:solidFill>
@@ -11470,7 +11470,7 @@
               <a:t>–  </a:t>
             </a:r>
             <a:r>
-              <a:rPr sz="1300">
+              <a:rPr sz="1507">
                 <a:solidFill>
                   <a:srgbClr val="E2E8F0"/>
                 </a:solidFill>
@@ -11493,7 +11493,7 @@
               <a:buNone/>
             </a:pPr>
             <a:r>
-              <a:rPr sz="1300">
+              <a:rPr sz="1507">
                 <a:solidFill>
                   <a:srgbClr val="06B6D4"/>
                 </a:solidFill>
@@ -11502,7 +11502,7 @@
               <a:t>–  </a:t>
             </a:r>
             <a:r>
-              <a:rPr sz="1300">
+              <a:rPr sz="1507">
                 <a:solidFill>
                   <a:srgbClr val="E2E8F0"/>
                 </a:solidFill>
@@ -11547,7 +11547,7 @@
               </a:spcAft>
             </a:pPr>
             <a:r>
-              <a:rPr sz="1050" b="0" i="0">
+              <a:rPr sz="1218" b="0" i="0">
                 <a:solidFill>
                   <a:srgbClr val="64748B"/>
                 </a:solidFill>
@@ -11592,7 +11592,7 @@
               </a:spcAft>
             </a:pPr>
             <a:r>
-              <a:rPr sz="1050" b="0" i="0">
+              <a:rPr sz="1218" b="0" i="0">
                 <a:solidFill>
                   <a:srgbClr val="64748B"/>
                 </a:solidFill>
@@ -11699,7 +11699,7 @@
               </a:spcAft>
             </a:pPr>
             <a:r>
-              <a:rPr sz="1400" b="1" i="0">
+              <a:rPr sz="1623" b="1" i="0">
                 <a:solidFill>
                   <a:srgbClr val="06B6D4"/>
                 </a:solidFill>
@@ -11967,7 +11967,7 @@
               </a:spcAft>
             </a:pPr>
             <a:r>
-              <a:rPr sz="1600" b="1" i="0">
+              <a:rPr sz="1855" b="1" i="0">
                 <a:solidFill>
                   <a:srgbClr val="D97706"/>
                 </a:solidFill>
@@ -12013,7 +12013,7 @@
               <a:buNone/>
             </a:pPr>
             <a:r>
-              <a:rPr sz="1300">
+              <a:rPr sz="1507">
                 <a:solidFill>
                   <a:srgbClr val="D97706"/>
                 </a:solidFill>
@@ -12022,7 +12022,7 @@
               <a:t>–  </a:t>
             </a:r>
             <a:r>
-              <a:rPr sz="1300">
+              <a:rPr sz="1507">
                 <a:solidFill>
                   <a:srgbClr val="0F172A"/>
                 </a:solidFill>
@@ -12045,7 +12045,7 @@
               <a:buNone/>
             </a:pPr>
             <a:r>
-              <a:rPr sz="1300">
+              <a:rPr sz="1507">
                 <a:solidFill>
                   <a:srgbClr val="D97706"/>
                 </a:solidFill>
@@ -12054,7 +12054,7 @@
               <a:t>–  </a:t>
             </a:r>
             <a:r>
-              <a:rPr sz="1300">
+              <a:rPr sz="1507">
                 <a:solidFill>
                   <a:srgbClr val="0F172A"/>
                 </a:solidFill>
@@ -12077,7 +12077,7 @@
               <a:buNone/>
             </a:pPr>
             <a:r>
-              <a:rPr sz="1300">
+              <a:rPr sz="1507">
                 <a:solidFill>
                   <a:srgbClr val="D97706"/>
                 </a:solidFill>
@@ -12086,7 +12086,7 @@
               <a:t>–  </a:t>
             </a:r>
             <a:r>
-              <a:rPr sz="1300">
+              <a:rPr sz="1507">
                 <a:solidFill>
                   <a:srgbClr val="0F172A"/>
                 </a:solidFill>
@@ -12109,7 +12109,7 @@
               <a:buNone/>
             </a:pPr>
             <a:r>
-              <a:rPr sz="1300">
+              <a:rPr sz="1507">
                 <a:solidFill>
                   <a:srgbClr val="D97706"/>
                 </a:solidFill>
@@ -12118,7 +12118,7 @@
               <a:t>–  </a:t>
             </a:r>
             <a:r>
-              <a:rPr sz="1300">
+              <a:rPr sz="1507">
                 <a:solidFill>
                   <a:srgbClr val="0F172A"/>
                 </a:solidFill>
@@ -12253,7 +12253,7 @@
               </a:spcAft>
             </a:pPr>
             <a:r>
-              <a:rPr sz="1600" b="1" i="0">
+              <a:rPr sz="1855" b="1" i="0">
                 <a:solidFill>
                   <a:srgbClr val="2563EB"/>
                 </a:solidFill>
@@ -12299,7 +12299,7 @@
               <a:buNone/>
             </a:pPr>
             <a:r>
-              <a:rPr sz="1300">
+              <a:rPr sz="1507">
                 <a:solidFill>
                   <a:srgbClr val="2563EB"/>
                 </a:solidFill>
@@ -12308,7 +12308,7 @@
               <a:t>–  </a:t>
             </a:r>
             <a:r>
-              <a:rPr sz="1300">
+              <a:rPr sz="1507">
                 <a:solidFill>
                   <a:srgbClr val="0F172A"/>
                 </a:solidFill>
@@ -12331,7 +12331,7 @@
               <a:buNone/>
             </a:pPr>
             <a:r>
-              <a:rPr sz="1300">
+              <a:rPr sz="1507">
                 <a:solidFill>
                   <a:srgbClr val="2563EB"/>
                 </a:solidFill>
@@ -12340,7 +12340,7 @@
               <a:t>–  </a:t>
             </a:r>
             <a:r>
-              <a:rPr sz="1300">
+              <a:rPr sz="1507">
                 <a:solidFill>
                   <a:srgbClr val="0F172A"/>
                 </a:solidFill>
@@ -12363,7 +12363,7 @@
               <a:buNone/>
             </a:pPr>
             <a:r>
-              <a:rPr sz="1300">
+              <a:rPr sz="1507">
                 <a:solidFill>
                   <a:srgbClr val="2563EB"/>
                 </a:solidFill>
@@ -12372,7 +12372,7 @@
               <a:t>–  </a:t>
             </a:r>
             <a:r>
-              <a:rPr sz="1300">
+              <a:rPr sz="1507">
                 <a:solidFill>
                   <a:srgbClr val="0F172A"/>
                 </a:solidFill>
@@ -12395,7 +12395,7 @@
               <a:buNone/>
             </a:pPr>
             <a:r>
-              <a:rPr sz="1300">
+              <a:rPr sz="1507">
                 <a:solidFill>
                   <a:srgbClr val="2563EB"/>
                 </a:solidFill>
@@ -12404,7 +12404,7 @@
               <a:t>–  </a:t>
             </a:r>
             <a:r>
-              <a:rPr sz="1300">
+              <a:rPr sz="1507">
                 <a:solidFill>
                   <a:srgbClr val="0F172A"/>
                 </a:solidFill>
@@ -12449,7 +12449,7 @@
               </a:spcAft>
             </a:pPr>
             <a:r>
-              <a:rPr sz="1050" b="0" i="0">
+              <a:rPr sz="1218" b="0" i="0">
                 <a:solidFill>
                   <a:srgbClr val="64748B"/>
                 </a:solidFill>
@@ -12494,7 +12494,7 @@
               </a:spcAft>
             </a:pPr>
             <a:r>
-              <a:rPr sz="1050" b="0" i="0">
+              <a:rPr sz="1218" b="0" i="0">
                 <a:solidFill>
                   <a:srgbClr val="64748B"/>
                 </a:solidFill>
@@ -12601,7 +12601,7 @@
               </a:spcAft>
             </a:pPr>
             <a:r>
-              <a:rPr sz="1400" b="1" i="0">
+              <a:rPr sz="1623" b="1" i="0">
                 <a:solidFill>
                   <a:srgbClr val="06B6D4"/>
                 </a:solidFill>
@@ -12779,7 +12779,7 @@
               </a:spcAft>
             </a:pPr>
             <a:r>
-              <a:rPr sz="1200" b="1" i="0">
+              <a:rPr sz="1391" b="1" i="0">
                 <a:solidFill>
                   <a:srgbClr val="64748B"/>
                 </a:solidFill>
@@ -12824,7 +12824,7 @@
               </a:spcAft>
             </a:pPr>
             <a:r>
-              <a:rPr sz="1200" b="1" i="0">
+              <a:rPr sz="1391" b="1" i="0">
                 <a:solidFill>
                   <a:srgbClr val="64748B"/>
                 </a:solidFill>
@@ -12959,7 +12959,7 @@
               </a:spcAft>
             </a:pPr>
             <a:r>
-              <a:rPr sz="1700" b="1" i="0">
+              <a:rPr sz="1972" b="1" i="0">
                 <a:solidFill>
                   <a:srgbClr val="0F172A"/>
                 </a:solidFill>
@@ -13004,7 +13004,7 @@
               </a:spcAft>
             </a:pPr>
             <a:r>
-              <a:rPr sz="1500" b="1" i="0">
+              <a:rPr sz="1739" b="1" i="0">
                 <a:solidFill>
                   <a:srgbClr val="0F172A"/>
                 </a:solidFill>
@@ -13049,7 +13049,7 @@
               </a:spcAft>
             </a:pPr>
             <a:r>
-              <a:rPr sz="1500" b="0" i="0">
+              <a:rPr sz="1739" b="0" i="0">
                 <a:solidFill>
                   <a:srgbClr val="DC2626"/>
                 </a:solidFill>
@@ -13094,7 +13094,7 @@
               </a:spcAft>
             </a:pPr>
             <a:r>
-              <a:rPr sz="1500" b="0" i="0">
+              <a:rPr sz="1739" b="0" i="0">
                 <a:solidFill>
                   <a:srgbClr val="2563EB"/>
                 </a:solidFill>
@@ -13139,7 +13139,7 @@
               </a:spcAft>
             </a:pPr>
             <a:r>
-              <a:rPr sz="1500" b="0" i="0">
+              <a:rPr sz="1739" b="0" i="0">
                 <a:solidFill>
                   <a:srgbClr val="06B6D4"/>
                 </a:solidFill>
@@ -13184,7 +13184,7 @@
               </a:spcAft>
             </a:pPr>
             <a:r>
-              <a:rPr sz="1500" b="0" i="0">
+              <a:rPr sz="1739" b="0" i="0">
                 <a:solidFill>
                   <a:srgbClr val="64748B"/>
                 </a:solidFill>
@@ -13229,7 +13229,7 @@
               </a:spcAft>
             </a:pPr>
             <a:r>
-              <a:rPr sz="1700" b="1" i="0">
+              <a:rPr sz="1972" b="1" i="0">
                 <a:solidFill>
                   <a:srgbClr val="2563EB"/>
                 </a:solidFill>
@@ -13275,7 +13275,7 @@
               <a:buNone/>
             </a:pPr>
             <a:r>
-              <a:rPr sz="1400">
+              <a:rPr sz="1623">
                 <a:solidFill>
                   <a:srgbClr val="2563EB"/>
                 </a:solidFill>
@@ -13284,7 +13284,7 @@
               <a:t>–  </a:t>
             </a:r>
             <a:r>
-              <a:rPr sz="1400">
+              <a:rPr sz="1623">
                 <a:solidFill>
                   <a:srgbClr val="0F172A"/>
                 </a:solidFill>
@@ -13307,7 +13307,7 @@
               <a:buNone/>
             </a:pPr>
             <a:r>
-              <a:rPr sz="1400">
+              <a:rPr sz="1623">
                 <a:solidFill>
                   <a:srgbClr val="2563EB"/>
                 </a:solidFill>
@@ -13316,7 +13316,7 @@
               <a:t>–  </a:t>
             </a:r>
             <a:r>
-              <a:rPr sz="1400">
+              <a:rPr sz="1623">
                 <a:solidFill>
                   <a:srgbClr val="0F172A"/>
                 </a:solidFill>
@@ -13339,7 +13339,7 @@
               <a:buNone/>
             </a:pPr>
             <a:r>
-              <a:rPr sz="1400">
+              <a:rPr sz="1623">
                 <a:solidFill>
                   <a:srgbClr val="2563EB"/>
                 </a:solidFill>
@@ -13348,7 +13348,7 @@
               <a:t>–  </a:t>
             </a:r>
             <a:r>
-              <a:rPr sz="1400">
+              <a:rPr sz="1623">
                 <a:solidFill>
                   <a:srgbClr val="0F172A"/>
                 </a:solidFill>
@@ -13371,7 +13371,7 @@
               <a:buNone/>
             </a:pPr>
             <a:r>
-              <a:rPr sz="1400">
+              <a:rPr sz="1623">
                 <a:solidFill>
                   <a:srgbClr val="2563EB"/>
                 </a:solidFill>
@@ -13380,7 +13380,7 @@
               <a:t>–  </a:t>
             </a:r>
             <a:r>
-              <a:rPr sz="1400">
+              <a:rPr sz="1623">
                 <a:solidFill>
                   <a:srgbClr val="0F172A"/>
                 </a:solidFill>
@@ -13425,7 +13425,7 @@
               </a:spcAft>
             </a:pPr>
             <a:r>
-              <a:rPr sz="1050" b="0" i="0">
+              <a:rPr sz="1218" b="0" i="0">
                 <a:solidFill>
                   <a:srgbClr val="64748B"/>
                 </a:solidFill>
@@ -13470,7 +13470,7 @@
               </a:spcAft>
             </a:pPr>
             <a:r>
-              <a:rPr sz="1050" b="0" i="0">
+              <a:rPr sz="1218" b="0" i="0">
                 <a:solidFill>
                   <a:srgbClr val="64748B"/>
                 </a:solidFill>
@@ -13577,7 +13577,7 @@
               </a:spcAft>
             </a:pPr>
             <a:r>
-              <a:rPr sz="1400" b="1" i="0">
+              <a:rPr sz="1623" b="1" i="0">
                 <a:solidFill>
                   <a:srgbClr val="06B6D4"/>
                 </a:solidFill>
@@ -13755,7 +13755,7 @@
               </a:spcAft>
             </a:pPr>
             <a:r>
-              <a:rPr sz="1300" b="1" i="0">
+              <a:rPr sz="1507" b="1" i="0">
                 <a:solidFill>
                   <a:srgbClr val="2563EB"/>
                 </a:solidFill>
@@ -13801,7 +13801,7 @@
               <a:buNone/>
             </a:pPr>
             <a:r>
-              <a:rPr sz="1400">
+              <a:rPr sz="1623">
                 <a:solidFill>
                   <a:srgbClr val="2563EB"/>
                 </a:solidFill>
@@ -13810,7 +13810,7 @@
               <a:t>–  </a:t>
             </a:r>
             <a:r>
-              <a:rPr sz="1400">
+              <a:rPr sz="1623">
                 <a:solidFill>
                   <a:srgbClr val="0F172A"/>
                 </a:solidFill>
@@ -13833,7 +13833,7 @@
               <a:buNone/>
             </a:pPr>
             <a:r>
-              <a:rPr sz="1400">
+              <a:rPr sz="1623">
                 <a:solidFill>
                   <a:srgbClr val="2563EB"/>
                 </a:solidFill>
@@ -13842,7 +13842,7 @@
               <a:t>–  </a:t>
             </a:r>
             <a:r>
-              <a:rPr sz="1400">
+              <a:rPr sz="1623">
                 <a:solidFill>
                   <a:srgbClr val="0F172A"/>
                 </a:solidFill>
@@ -13865,7 +13865,7 @@
               <a:buNone/>
             </a:pPr>
             <a:r>
-              <a:rPr sz="1400">
+              <a:rPr sz="1623">
                 <a:solidFill>
                   <a:srgbClr val="2563EB"/>
                 </a:solidFill>
@@ -13874,7 +13874,7 @@
               <a:t>–  </a:t>
             </a:r>
             <a:r>
-              <a:rPr sz="1400">
+              <a:rPr sz="1623">
                 <a:solidFill>
                   <a:srgbClr val="0F172A"/>
                 </a:solidFill>
@@ -13897,7 +13897,7 @@
               <a:buNone/>
             </a:pPr>
             <a:r>
-              <a:rPr sz="1400">
+              <a:rPr sz="1623">
                 <a:solidFill>
                   <a:srgbClr val="2563EB"/>
                 </a:solidFill>
@@ -13906,7 +13906,7 @@
               <a:t>–  </a:t>
             </a:r>
             <a:r>
-              <a:rPr sz="1400">
+              <a:rPr sz="1623">
                 <a:solidFill>
                   <a:srgbClr val="0F172A"/>
                 </a:solidFill>
@@ -13951,7 +13951,7 @@
               </a:spcAft>
             </a:pPr>
             <a:r>
-              <a:rPr sz="1200" b="1" i="0">
+              <a:rPr sz="1391" b="1" i="0">
                 <a:solidFill>
                   <a:srgbClr val="16A34A"/>
                 </a:solidFill>
@@ -14086,7 +14086,7 @@
               </a:spcAft>
             </a:pPr>
             <a:r>
-              <a:rPr sz="1300" b="1" i="0">
+              <a:rPr sz="1507" b="1" i="0">
                 <a:solidFill>
                   <a:srgbClr val="16A34A"/>
                 </a:solidFill>
@@ -14131,7 +14131,7 @@
               </a:spcAft>
             </a:pPr>
             <a:r>
-              <a:rPr sz="1200" b="0" i="0">
+              <a:rPr sz="1391" b="0" i="0">
                 <a:solidFill>
                   <a:srgbClr val="0F172A"/>
                 </a:solidFill>
@@ -14266,7 +14266,7 @@
               </a:spcAft>
             </a:pPr>
             <a:r>
-              <a:rPr sz="1300" b="1" i="0">
+              <a:rPr sz="1507" b="1" i="0">
                 <a:solidFill>
                   <a:srgbClr val="16A34A"/>
                 </a:solidFill>
@@ -14311,7 +14311,7 @@
               </a:spcAft>
             </a:pPr>
             <a:r>
-              <a:rPr sz="1200" b="0" i="0">
+              <a:rPr sz="1391" b="0" i="0">
                 <a:solidFill>
                   <a:srgbClr val="0F172A"/>
                 </a:solidFill>
@@ -14446,7 +14446,7 @@
               </a:spcAft>
             </a:pPr>
             <a:r>
-              <a:rPr sz="1300" b="1" i="0">
+              <a:rPr sz="1507" b="1" i="0">
                 <a:solidFill>
                   <a:srgbClr val="16A34A"/>
                 </a:solidFill>
@@ -14491,7 +14491,7 @@
               </a:spcAft>
             </a:pPr>
             <a:r>
-              <a:rPr sz="1200" b="0" i="0">
+              <a:rPr sz="1391" b="0" i="0">
                 <a:solidFill>
                   <a:srgbClr val="0F172A"/>
                 </a:solidFill>
@@ -14536,7 +14536,7 @@
               </a:spcAft>
             </a:pPr>
             <a:r>
-              <a:rPr sz="1100" b="0" i="1">
+              <a:rPr sz="1276" b="0" i="1">
                 <a:solidFill>
                   <a:srgbClr val="64748B"/>
                 </a:solidFill>
@@ -14581,7 +14581,7 @@
               </a:spcAft>
             </a:pPr>
             <a:r>
-              <a:rPr sz="1050" b="0" i="0">
+              <a:rPr sz="1218" b="0" i="0">
                 <a:solidFill>
                   <a:srgbClr val="64748B"/>
                 </a:solidFill>
@@ -14626,7 +14626,7 @@
               </a:spcAft>
             </a:pPr>
             <a:r>
-              <a:rPr sz="1050" b="0" i="0">
+              <a:rPr sz="1218" b="0" i="0">
                 <a:solidFill>
                   <a:srgbClr val="64748B"/>
                 </a:solidFill>
@@ -14733,7 +14733,7 @@
               </a:spcAft>
             </a:pPr>
             <a:r>
-              <a:rPr sz="1400" b="1" i="0">
+              <a:rPr sz="1623" b="1" i="0">
                 <a:solidFill>
                   <a:srgbClr val="06B6D4"/>
                 </a:solidFill>
@@ -15001,7 +15001,7 @@
               </a:spcAft>
             </a:pPr>
             <a:r>
-              <a:rPr sz="1600" b="1" i="0">
+              <a:rPr sz="1855" b="1" i="0">
                 <a:solidFill>
                   <a:srgbClr val="D97706"/>
                 </a:solidFill>
@@ -15047,7 +15047,7 @@
               <a:buNone/>
             </a:pPr>
             <a:r>
-              <a:rPr sz="1250">
+              <a:rPr sz="1449">
                 <a:solidFill>
                   <a:srgbClr val="D97706"/>
                 </a:solidFill>
@@ -15056,7 +15056,7 @@
               <a:t>–  </a:t>
             </a:r>
             <a:r>
-              <a:rPr sz="1250">
+              <a:rPr sz="1449">
                 <a:solidFill>
                   <a:srgbClr val="0F172A"/>
                 </a:solidFill>
@@ -15079,7 +15079,7 @@
               <a:buNone/>
             </a:pPr>
             <a:r>
-              <a:rPr sz="1250">
+              <a:rPr sz="1449">
                 <a:solidFill>
                   <a:srgbClr val="D97706"/>
                 </a:solidFill>
@@ -15088,13 +15088,13 @@
               <a:t>–  </a:t>
             </a:r>
             <a:r>
-              <a:rPr sz="1250">
+              <a:rPr sz="1449">
                 <a:solidFill>
                   <a:srgbClr val="0F172A"/>
                 </a:solidFill>
                 <a:latin typeface="Arial"/>
               </a:rPr>
-              <a:t>Geely PDFs were not machine-readable → more manual web research.</a:t>
+              <a:t>Token / context limits hit quickly on the stronger model in long sessions.</a:t>
             </a:r>
           </a:p>
           <a:p>
@@ -15111,7 +15111,7 @@
               <a:buNone/>
             </a:pPr>
             <a:r>
-              <a:rPr sz="1250">
+              <a:rPr sz="1449">
                 <a:solidFill>
                   <a:srgbClr val="D97706"/>
                 </a:solidFill>
@@ -15120,39 +15120,7 @@
               <a:t>–  </a:t>
             </a:r>
             <a:r>
-              <a:rPr sz="1250">
-                <a:solidFill>
-                  <a:srgbClr val="0F172A"/>
-                </a:solidFill>
-                <a:latin typeface="Arial"/>
-              </a:rPr>
-              <a:t>Token / context limits hit quickly on the stronger model in long sessions.</a:t>
-            </a:r>
-          </a:p>
-          <a:p>
-            <a:pPr>
-              <a:lnSpc>
-                <a:spcPct val="105000"/>
-              </a:lnSpc>
-              <a:spcBef>
-                <a:spcPts val="0"/>
-              </a:spcBef>
-              <a:spcAft>
-                <a:spcPts val="800"/>
-              </a:spcAft>
-              <a:buNone/>
-            </a:pPr>
-            <a:r>
-              <a:rPr sz="1250">
-                <a:solidFill>
-                  <a:srgbClr val="D97706"/>
-                </a:solidFill>
-                <a:latin typeface="Arial"/>
-              </a:rPr>
-              <a:t>–  </a:t>
-            </a:r>
-            <a:r>
-              <a:rPr sz="1250">
+              <a:rPr sz="1449">
                 <a:solidFill>
                   <a:srgbClr val="0F172A"/>
                 </a:solidFill>
@@ -15287,7 +15255,7 @@
               </a:spcAft>
             </a:pPr>
             <a:r>
-              <a:rPr sz="1600" b="1" i="0">
+              <a:rPr sz="1855" b="1" i="0">
                 <a:solidFill>
                   <a:srgbClr val="2563EB"/>
                 </a:solidFill>
@@ -15333,7 +15301,7 @@
               <a:buNone/>
             </a:pPr>
             <a:r>
-              <a:rPr sz="1250">
+              <a:rPr sz="1449">
                 <a:solidFill>
                   <a:srgbClr val="2563EB"/>
                 </a:solidFill>
@@ -15342,7 +15310,7 @@
               <a:t>–  </a:t>
             </a:r>
             <a:r>
-              <a:rPr sz="1250">
+              <a:rPr sz="1449">
                 <a:solidFill>
                   <a:srgbClr val="0F172A"/>
                 </a:solidFill>
@@ -15365,7 +15333,7 @@
               <a:buNone/>
             </a:pPr>
             <a:r>
-              <a:rPr sz="1250">
+              <a:rPr sz="1449">
                 <a:solidFill>
                   <a:srgbClr val="2563EB"/>
                 </a:solidFill>
@@ -15374,7 +15342,7 @@
               <a:t>–  </a:t>
             </a:r>
             <a:r>
-              <a:rPr sz="1250">
+              <a:rPr sz="1449">
                 <a:solidFill>
                   <a:srgbClr val="0F172A"/>
                 </a:solidFill>
@@ -15397,7 +15365,7 @@
               <a:buNone/>
             </a:pPr>
             <a:r>
-              <a:rPr sz="1250">
+              <a:rPr sz="1449">
                 <a:solidFill>
                   <a:srgbClr val="2563EB"/>
                 </a:solidFill>
@@ -15406,7 +15374,7 @@
               <a:t>–  </a:t>
             </a:r>
             <a:r>
-              <a:rPr sz="1250">
+              <a:rPr sz="1449">
                 <a:solidFill>
                   <a:srgbClr val="0F172A"/>
                 </a:solidFill>
@@ -15429,7 +15397,7 @@
               <a:buNone/>
             </a:pPr>
             <a:r>
-              <a:rPr sz="1250">
+              <a:rPr sz="1449">
                 <a:solidFill>
                   <a:srgbClr val="2563EB"/>
                 </a:solidFill>
@@ -15438,7 +15406,7 @@
               <a:t>–  </a:t>
             </a:r>
             <a:r>
-              <a:rPr sz="1250">
+              <a:rPr sz="1449">
                 <a:solidFill>
                   <a:srgbClr val="0F172A"/>
                 </a:solidFill>
@@ -15527,7 +15495,7 @@
               </a:spcAft>
             </a:pPr>
             <a:r>
-              <a:rPr sz="1350" b="1" i="0">
+              <a:rPr sz="1565" b="1" i="0">
                 <a:solidFill>
                   <a:srgbClr val="FFFFFF"/>
                 </a:solidFill>
@@ -15572,7 +15540,7 @@
               </a:spcAft>
             </a:pPr>
             <a:r>
-              <a:rPr sz="1050" b="0" i="0">
+              <a:rPr sz="1218" b="0" i="0">
                 <a:solidFill>
                   <a:srgbClr val="64748B"/>
                 </a:solidFill>
@@ -15617,7 +15585,7 @@
               </a:spcAft>
             </a:pPr>
             <a:r>
-              <a:rPr sz="1050" b="0" i="0">
+              <a:rPr sz="1218" b="0" i="0">
                 <a:solidFill>
                   <a:srgbClr val="64748B"/>
                 </a:solidFill>
@@ -15724,7 +15692,7 @@
               </a:spcAft>
             </a:pPr>
             <a:r>
-              <a:rPr sz="1400" b="1" i="0">
+              <a:rPr sz="1623" b="1" i="0">
                 <a:solidFill>
                   <a:srgbClr val="06B6D4"/>
                 </a:solidFill>
@@ -16037,7 +16005,7 @@
               </a:spcAft>
             </a:pPr>
             <a:r>
-              <a:rPr sz="1200" b="0" i="0">
+              <a:rPr sz="1391" b="0" i="0">
                 <a:solidFill>
                   <a:srgbClr val="0F172A"/>
                 </a:solidFill>
@@ -16059,7 +16027,7 @@
               </a:spcAft>
             </a:pPr>
             <a:r>
-              <a:rPr sz="1200" b="0" i="0">
+              <a:rPr sz="1391" b="0" i="0">
                 <a:solidFill>
                   <a:srgbClr val="0F172A"/>
                 </a:solidFill>
@@ -16239,7 +16207,7 @@
               </a:spcAft>
             </a:pPr>
             <a:r>
-              <a:rPr sz="1200" b="0" i="0">
+              <a:rPr sz="1391" b="0" i="0">
                 <a:solidFill>
                   <a:srgbClr val="0F172A"/>
                 </a:solidFill>
@@ -16261,7 +16229,7 @@
               </a:spcAft>
             </a:pPr>
             <a:r>
-              <a:rPr sz="1200" b="0" i="0">
+              <a:rPr sz="1391" b="0" i="0">
                 <a:solidFill>
                   <a:srgbClr val="0F172A"/>
                 </a:solidFill>
@@ -16441,7 +16409,7 @@
               </a:spcAft>
             </a:pPr>
             <a:r>
-              <a:rPr sz="1200" b="0" i="0">
+              <a:rPr sz="1391" b="0" i="0">
                 <a:solidFill>
                   <a:srgbClr val="0F172A"/>
                 </a:solidFill>
@@ -16463,7 +16431,7 @@
               </a:spcAft>
             </a:pPr>
             <a:r>
-              <a:rPr sz="1200" b="0" i="0">
+              <a:rPr sz="1391" b="0" i="0">
                 <a:solidFill>
                   <a:srgbClr val="0F172A"/>
                 </a:solidFill>
@@ -16643,7 +16611,7 @@
               </a:spcAft>
             </a:pPr>
             <a:r>
-              <a:rPr sz="1200" b="0" i="0">
+              <a:rPr sz="1391" b="0" i="0">
                 <a:solidFill>
                   <a:srgbClr val="0F172A"/>
                 </a:solidFill>
@@ -16665,7 +16633,7 @@
               </a:spcAft>
             </a:pPr>
             <a:r>
-              <a:rPr sz="1200" b="0" i="0">
+              <a:rPr sz="1391" b="0" i="0">
                 <a:solidFill>
                   <a:srgbClr val="0F172A"/>
                 </a:solidFill>
@@ -16711,7 +16679,7 @@
               <a:buNone/>
             </a:pPr>
             <a:r>
-              <a:rPr sz="1500">
+              <a:rPr sz="1739">
                 <a:solidFill>
                   <a:srgbClr val="2563EB"/>
                 </a:solidFill>
@@ -16720,7 +16688,7 @@
               <a:t>–  </a:t>
             </a:r>
             <a:r>
-              <a:rPr sz="1500">
+              <a:rPr sz="1739">
                 <a:solidFill>
                   <a:srgbClr val="0F172A"/>
                 </a:solidFill>
@@ -16743,7 +16711,7 @@
               <a:buNone/>
             </a:pPr>
             <a:r>
-              <a:rPr sz="1500">
+              <a:rPr sz="1739">
                 <a:solidFill>
                   <a:srgbClr val="2563EB"/>
                 </a:solidFill>
@@ -16752,7 +16720,7 @@
               <a:t>–  </a:t>
             </a:r>
             <a:r>
-              <a:rPr sz="1500">
+              <a:rPr sz="1739">
                 <a:solidFill>
                   <a:srgbClr val="0F172A"/>
                 </a:solidFill>
@@ -16775,7 +16743,7 @@
               <a:buNone/>
             </a:pPr>
             <a:r>
-              <a:rPr sz="1500">
+              <a:rPr sz="1739">
                 <a:solidFill>
                   <a:srgbClr val="2563EB"/>
                 </a:solidFill>
@@ -16784,7 +16752,7 @@
               <a:t>–  </a:t>
             </a:r>
             <a:r>
-              <a:rPr sz="1500">
+              <a:rPr sz="1739">
                 <a:solidFill>
                   <a:srgbClr val="0F172A"/>
                 </a:solidFill>
@@ -16829,7 +16797,7 @@
               </a:spcAft>
             </a:pPr>
             <a:r>
-              <a:rPr sz="1100" b="0" i="1">
+              <a:rPr sz="1276" b="0" i="1">
                 <a:solidFill>
                   <a:srgbClr val="64748B"/>
                 </a:solidFill>
@@ -16874,7 +16842,7 @@
               </a:spcAft>
             </a:pPr>
             <a:r>
-              <a:rPr sz="1050" b="0" i="0">
+              <a:rPr sz="1218" b="0" i="0">
                 <a:solidFill>
                   <a:srgbClr val="64748B"/>
                 </a:solidFill>
@@ -16919,7 +16887,7 @@
               </a:spcAft>
             </a:pPr>
             <a:r>
-              <a:rPr sz="1050" b="0" i="0">
+              <a:rPr sz="1218" b="0" i="0">
                 <a:solidFill>
                   <a:srgbClr val="64748B"/>
                 </a:solidFill>
@@ -17026,7 +16994,7 @@
               </a:spcAft>
             </a:pPr>
             <a:r>
-              <a:rPr sz="1400" b="1" i="0">
+              <a:rPr sz="1623" b="1" i="0">
                 <a:solidFill>
                   <a:srgbClr val="06B6D4"/>
                 </a:solidFill>
@@ -17077,7 +17045,7 @@
                 </a:solidFill>
                 <a:latin typeface="Arial"/>
               </a:rPr>
-              <a:t>Key sources (APA 7)</a:t>
+              <a:t>Key sources</a:t>
             </a:r>
           </a:p>
         </p:txBody>
@@ -17205,7 +17173,7 @@
               <a:buNone/>
             </a:pPr>
             <a:r>
-              <a:rPr sz="1050">
+              <a:rPr sz="1218">
                 <a:solidFill>
                   <a:srgbClr val="0F172A"/>
                 </a:solidFill>
@@ -17228,7 +17196,7 @@
               <a:buNone/>
             </a:pPr>
             <a:r>
-              <a:rPr sz="1050">
+              <a:rPr sz="1218">
                 <a:solidFill>
                   <a:srgbClr val="0F172A"/>
                 </a:solidFill>
@@ -17251,7 +17219,7 @@
               <a:buNone/>
             </a:pPr>
             <a:r>
-              <a:rPr sz="1050">
+              <a:rPr sz="1218">
                 <a:solidFill>
                   <a:srgbClr val="0F172A"/>
                 </a:solidFill>
@@ -17274,7 +17242,7 @@
               <a:buNone/>
             </a:pPr>
             <a:r>
-              <a:rPr sz="1050">
+              <a:rPr sz="1218">
                 <a:solidFill>
                   <a:srgbClr val="0F172A"/>
                 </a:solidFill>
@@ -17297,7 +17265,7 @@
               <a:buNone/>
             </a:pPr>
             <a:r>
-              <a:rPr sz="1050">
+              <a:rPr sz="1218">
                 <a:solidFill>
                   <a:srgbClr val="0F172A"/>
                 </a:solidFill>
@@ -17320,7 +17288,7 @@
               <a:buNone/>
             </a:pPr>
             <a:r>
-              <a:rPr sz="1050">
+              <a:rPr sz="1218">
                 <a:solidFill>
                   <a:srgbClr val="0F172A"/>
                 </a:solidFill>
@@ -17343,7 +17311,7 @@
               <a:buNone/>
             </a:pPr>
             <a:r>
-              <a:rPr sz="1050">
+              <a:rPr sz="1218">
                 <a:solidFill>
                   <a:srgbClr val="0F172A"/>
                 </a:solidFill>
@@ -17366,7 +17334,7 @@
               <a:buNone/>
             </a:pPr>
             <a:r>
-              <a:rPr sz="1050">
+              <a:rPr sz="1218">
                 <a:solidFill>
                   <a:srgbClr val="0F172A"/>
                 </a:solidFill>
@@ -17389,7 +17357,7 @@
               <a:buNone/>
             </a:pPr>
             <a:r>
-              <a:rPr sz="1050">
+              <a:rPr sz="1218">
                 <a:solidFill>
                   <a:srgbClr val="0F172A"/>
                 </a:solidFill>
@@ -17435,7 +17403,7 @@
               <a:buNone/>
             </a:pPr>
             <a:r>
-              <a:rPr sz="1050">
+              <a:rPr sz="1218">
                 <a:solidFill>
                   <a:srgbClr val="0F172A"/>
                 </a:solidFill>
@@ -17458,7 +17426,7 @@
               <a:buNone/>
             </a:pPr>
             <a:r>
-              <a:rPr sz="1050">
+              <a:rPr sz="1218">
                 <a:solidFill>
                   <a:srgbClr val="0F172A"/>
                 </a:solidFill>
@@ -17481,7 +17449,7 @@
               <a:buNone/>
             </a:pPr>
             <a:r>
-              <a:rPr sz="1050">
+              <a:rPr sz="1218">
                 <a:solidFill>
                   <a:srgbClr val="0F172A"/>
                 </a:solidFill>
@@ -17504,7 +17472,7 @@
               <a:buNone/>
             </a:pPr>
             <a:r>
-              <a:rPr sz="1050">
+              <a:rPr sz="1218">
                 <a:solidFill>
                   <a:srgbClr val="0F172A"/>
                 </a:solidFill>
@@ -17527,7 +17495,7 @@
               <a:buNone/>
             </a:pPr>
             <a:r>
-              <a:rPr sz="1050">
+              <a:rPr sz="1218">
                 <a:solidFill>
                   <a:srgbClr val="0F172A"/>
                 </a:solidFill>
@@ -17550,7 +17518,7 @@
               <a:buNone/>
             </a:pPr>
             <a:r>
-              <a:rPr sz="1050">
+              <a:rPr sz="1218">
                 <a:solidFill>
                   <a:srgbClr val="0F172A"/>
                 </a:solidFill>
@@ -17573,7 +17541,7 @@
               <a:buNone/>
             </a:pPr>
             <a:r>
-              <a:rPr sz="1050">
+              <a:rPr sz="1218">
                 <a:solidFill>
                   <a:srgbClr val="0F172A"/>
                 </a:solidFill>
@@ -17596,7 +17564,7 @@
               <a:buNone/>
             </a:pPr>
             <a:r>
-              <a:rPr sz="1050">
+              <a:rPr sz="1218">
                 <a:solidFill>
                   <a:srgbClr val="0F172A"/>
                 </a:solidFill>
@@ -17619,7 +17587,7 @@
               <a:buNone/>
             </a:pPr>
             <a:r>
-              <a:rPr sz="1050">
+              <a:rPr sz="1218">
                 <a:solidFill>
                   <a:srgbClr val="0F172A"/>
                 </a:solidFill>
@@ -17664,7 +17632,7 @@
               </a:spcAft>
             </a:pPr>
             <a:r>
-              <a:rPr sz="1050" b="0" i="0">
+              <a:rPr sz="1218" b="0" i="0">
                 <a:solidFill>
                   <a:srgbClr val="64748B"/>
                 </a:solidFill>
@@ -17709,7 +17677,7 @@
               </a:spcAft>
             </a:pPr>
             <a:r>
-              <a:rPr sz="1050" b="0" i="0">
+              <a:rPr sz="1218" b="0" i="0">
                 <a:solidFill>
                   <a:srgbClr val="64748B"/>
                 </a:solidFill>
@@ -17816,7 +17784,7 @@
               </a:spcAft>
             </a:pPr>
             <a:r>
-              <a:rPr sz="1400" b="1" i="0">
+              <a:rPr sz="1623" b="1" i="0">
                 <a:solidFill>
                   <a:srgbClr val="06B6D4"/>
                 </a:solidFill>
@@ -18038,7 +18006,7 @@
               </a:spcAft>
             </a:pPr>
             <a:r>
-              <a:rPr sz="1600" b="1" i="1">
+              <a:rPr sz="1855" b="1" i="1">
                 <a:solidFill>
                   <a:srgbClr val="FFFFFF"/>
                 </a:solidFill>
@@ -18173,7 +18141,7 @@
               </a:spcAft>
             </a:pPr>
             <a:r>
-              <a:rPr sz="1600" b="1" i="0">
+              <a:rPr sz="1855" b="1" i="0">
                 <a:solidFill>
                   <a:srgbClr val="DC2626"/>
                 </a:solidFill>
@@ -18218,7 +18186,7 @@
               </a:spcAft>
             </a:pPr>
             <a:r>
-              <a:rPr sz="1300" b="0" i="0">
+              <a:rPr sz="1507" b="0" i="0">
                 <a:solidFill>
                   <a:srgbClr val="0F172A"/>
                 </a:solidFill>
@@ -18240,7 +18208,7 @@
               </a:spcAft>
             </a:pPr>
             <a:r>
-              <a:rPr sz="1300" b="0" i="0">
+              <a:rPr sz="1507" b="0" i="0">
                 <a:solidFill>
                   <a:srgbClr val="0F172A"/>
                 </a:solidFill>
@@ -18375,7 +18343,7 @@
               </a:spcAft>
             </a:pPr>
             <a:r>
-              <a:rPr sz="1600" b="1" i="0">
+              <a:rPr sz="1855" b="1" i="0">
                 <a:solidFill>
                   <a:srgbClr val="2563EB"/>
                 </a:solidFill>
@@ -18420,7 +18388,7 @@
               </a:spcAft>
             </a:pPr>
             <a:r>
-              <a:rPr sz="1300" b="0" i="0">
+              <a:rPr sz="1507" b="0" i="0">
                 <a:solidFill>
                   <a:srgbClr val="0F172A"/>
                 </a:solidFill>
@@ -18442,7 +18410,7 @@
               </a:spcAft>
             </a:pPr>
             <a:r>
-              <a:rPr sz="1300" b="0" i="0">
+              <a:rPr sz="1507" b="0" i="0">
                 <a:solidFill>
                   <a:srgbClr val="0F172A"/>
                 </a:solidFill>
@@ -18577,7 +18545,7 @@
               </a:spcAft>
             </a:pPr>
             <a:r>
-              <a:rPr sz="1600" b="1" i="0">
+              <a:rPr sz="1855" b="1" i="0">
                 <a:solidFill>
                   <a:srgbClr val="06B6D4"/>
                 </a:solidFill>
@@ -18622,7 +18590,7 @@
               </a:spcAft>
             </a:pPr>
             <a:r>
-              <a:rPr sz="1300" b="0" i="0">
+              <a:rPr sz="1507" b="0" i="0">
                 <a:solidFill>
                   <a:srgbClr val="0F172A"/>
                 </a:solidFill>
@@ -18644,7 +18612,7 @@
               </a:spcAft>
             </a:pPr>
             <a:r>
-              <a:rPr sz="1300" b="0" i="0">
+              <a:rPr sz="1507" b="0" i="0">
                 <a:solidFill>
                   <a:srgbClr val="0F172A"/>
                 </a:solidFill>
@@ -18689,7 +18657,7 @@
               </a:spcAft>
             </a:pPr>
             <a:r>
-              <a:rPr sz="1250" b="1" i="0">
+              <a:rPr sz="1449" b="1" i="0">
                 <a:solidFill>
                   <a:srgbClr val="2563EB"/>
                 </a:solidFill>
@@ -18778,7 +18746,7 @@
               </a:spcAft>
             </a:pPr>
             <a:r>
-              <a:rPr sz="1350" b="1" i="0">
+              <a:rPr sz="1565" b="1" i="0">
                 <a:solidFill>
                   <a:srgbClr val="FFFFFF"/>
                 </a:solidFill>
@@ -18912,7 +18880,7 @@
               </a:spcAft>
             </a:pPr>
             <a:r>
-              <a:rPr sz="1350" b="1" i="0">
+              <a:rPr sz="1565" b="1" i="0">
                 <a:solidFill>
                   <a:srgbClr val="FFFFFF"/>
                 </a:solidFill>
@@ -19046,7 +19014,7 @@
               </a:spcAft>
             </a:pPr>
             <a:r>
-              <a:rPr sz="1350" b="1" i="0">
+              <a:rPr sz="1565" b="1" i="0">
                 <a:solidFill>
                   <a:srgbClr val="FFFFFF"/>
                 </a:solidFill>
@@ -19180,7 +19148,7 @@
               </a:spcAft>
             </a:pPr>
             <a:r>
-              <a:rPr sz="1350" b="1" i="0">
+              <a:rPr sz="1565" b="1" i="0">
                 <a:solidFill>
                   <a:srgbClr val="FFFFFF"/>
                 </a:solidFill>
@@ -19225,7 +19193,7 @@
               </a:spcAft>
             </a:pPr>
             <a:r>
-              <a:rPr sz="1400" b="1" i="0">
+              <a:rPr sz="1623" b="1" i="0">
                 <a:solidFill>
                   <a:srgbClr val="0F172A"/>
                 </a:solidFill>
@@ -19270,7 +19238,7 @@
               </a:spcAft>
             </a:pPr>
             <a:r>
-              <a:rPr sz="1050" b="0" i="0">
+              <a:rPr sz="1218" b="0" i="0">
                 <a:solidFill>
                   <a:srgbClr val="64748B"/>
                 </a:solidFill>
@@ -19315,7 +19283,7 @@
               </a:spcAft>
             </a:pPr>
             <a:r>
-              <a:rPr sz="1050" b="0" i="0">
+              <a:rPr sz="1218" b="0" i="0">
                 <a:solidFill>
                   <a:srgbClr val="64748B"/>
                 </a:solidFill>
@@ -19422,7 +19390,7 @@
               </a:spcAft>
             </a:pPr>
             <a:r>
-              <a:rPr sz="1400" b="1" i="0">
+              <a:rPr sz="1623" b="1" i="0">
                 <a:solidFill>
                   <a:srgbClr val="06B6D4"/>
                 </a:solidFill>
@@ -19690,7 +19658,7 @@
               </a:spcAft>
             </a:pPr>
             <a:r>
-              <a:rPr sz="1450" b="1" i="0">
+              <a:rPr sz="1682" b="1" i="0">
                 <a:solidFill>
                   <a:srgbClr val="0F172A"/>
                 </a:solidFill>
@@ -19735,7 +19703,7 @@
               </a:spcAft>
             </a:pPr>
             <a:r>
-              <a:rPr sz="1150" b="1" i="1">
+              <a:rPr sz="1334" b="1" i="1">
                 <a:solidFill>
                   <a:srgbClr val="DC2626"/>
                 </a:solidFill>
@@ -19780,7 +19748,7 @@
               </a:spcAft>
             </a:pPr>
             <a:r>
-              <a:rPr sz="1250" b="0" i="0">
+              <a:rPr sz="1449" b="0" i="0">
                 <a:solidFill>
                   <a:srgbClr val="0F172A"/>
                 </a:solidFill>
@@ -19915,7 +19883,7 @@
               </a:spcAft>
             </a:pPr>
             <a:r>
-              <a:rPr sz="1450" b="1" i="0">
+              <a:rPr sz="1682" b="1" i="0">
                 <a:solidFill>
                   <a:srgbClr val="0F172A"/>
                 </a:solidFill>
@@ -19960,7 +19928,7 @@
               </a:spcAft>
             </a:pPr>
             <a:r>
-              <a:rPr sz="1150" b="1" i="1">
+              <a:rPr sz="1334" b="1" i="1">
                 <a:solidFill>
                   <a:srgbClr val="DC2626"/>
                 </a:solidFill>
@@ -20005,7 +19973,7 @@
               </a:spcAft>
             </a:pPr>
             <a:r>
-              <a:rPr sz="1250" b="0" i="0">
+              <a:rPr sz="1449" b="0" i="0">
                 <a:solidFill>
                   <a:srgbClr val="0F172A"/>
                 </a:solidFill>
@@ -20140,7 +20108,7 @@
               </a:spcAft>
             </a:pPr>
             <a:r>
-              <a:rPr sz="1450" b="1" i="0">
+              <a:rPr sz="1682" b="1" i="0">
                 <a:solidFill>
                   <a:srgbClr val="0F172A"/>
                 </a:solidFill>
@@ -20185,7 +20153,7 @@
               </a:spcAft>
             </a:pPr>
             <a:r>
-              <a:rPr sz="1150" b="1" i="1">
+              <a:rPr sz="1334" b="1" i="1">
                 <a:solidFill>
                   <a:srgbClr val="2563EB"/>
                 </a:solidFill>
@@ -20230,7 +20198,7 @@
               </a:spcAft>
             </a:pPr>
             <a:r>
-              <a:rPr sz="1250" b="0" i="0">
+              <a:rPr sz="1449" b="0" i="0">
                 <a:solidFill>
                   <a:srgbClr val="0F172A"/>
                 </a:solidFill>
@@ -20365,7 +20333,7 @@
               </a:spcAft>
             </a:pPr>
             <a:r>
-              <a:rPr sz="1450" b="1" i="0">
+              <a:rPr sz="1682" b="1" i="0">
                 <a:solidFill>
                   <a:srgbClr val="0F172A"/>
                 </a:solidFill>
@@ -20410,7 +20378,7 @@
               </a:spcAft>
             </a:pPr>
             <a:r>
-              <a:rPr sz="1150" b="1" i="1">
+              <a:rPr sz="1334" b="1" i="1">
                 <a:solidFill>
                   <a:srgbClr val="DC2626"/>
                 </a:solidFill>
@@ -20455,7 +20423,7 @@
               </a:spcAft>
             </a:pPr>
             <a:r>
-              <a:rPr sz="1250" b="0" i="0">
+              <a:rPr sz="1449" b="0" i="0">
                 <a:solidFill>
                   <a:srgbClr val="0F172A"/>
                 </a:solidFill>
@@ -20590,7 +20558,7 @@
               </a:spcAft>
             </a:pPr>
             <a:r>
-              <a:rPr sz="1450" b="1" i="0">
+              <a:rPr sz="1682" b="1" i="0">
                 <a:solidFill>
                   <a:srgbClr val="0F172A"/>
                 </a:solidFill>
@@ -20635,7 +20603,7 @@
               </a:spcAft>
             </a:pPr>
             <a:r>
-              <a:rPr sz="1150" b="1" i="1">
+              <a:rPr sz="1334" b="1" i="1">
                 <a:solidFill>
                   <a:srgbClr val="06B6D4"/>
                 </a:solidFill>
@@ -20680,7 +20648,7 @@
               </a:spcAft>
             </a:pPr>
             <a:r>
-              <a:rPr sz="1250" b="0" i="0">
+              <a:rPr sz="1449" b="0" i="0">
                 <a:solidFill>
                   <a:srgbClr val="0F172A"/>
                 </a:solidFill>
@@ -20815,7 +20783,7 @@
               </a:spcAft>
             </a:pPr>
             <a:r>
-              <a:rPr sz="1450" b="1" i="0">
+              <a:rPr sz="1682" b="1" i="0">
                 <a:solidFill>
                   <a:srgbClr val="0F172A"/>
                 </a:solidFill>
@@ -20860,7 +20828,7 @@
               </a:spcAft>
             </a:pPr>
             <a:r>
-              <a:rPr sz="1150" b="1" i="1">
+              <a:rPr sz="1334" b="1" i="1">
                 <a:solidFill>
                   <a:srgbClr val="2563EB"/>
                 </a:solidFill>
@@ -20905,7 +20873,7 @@
               </a:spcAft>
             </a:pPr>
             <a:r>
-              <a:rPr sz="1250" b="0" i="0">
+              <a:rPr sz="1449" b="0" i="0">
                 <a:solidFill>
                   <a:srgbClr val="0F172A"/>
                 </a:solidFill>
@@ -20950,7 +20918,7 @@
               </a:spcAft>
             </a:pPr>
             <a:r>
-              <a:rPr sz="1050" b="0" i="0">
+              <a:rPr sz="1218" b="0" i="0">
                 <a:solidFill>
                   <a:srgbClr val="64748B"/>
                 </a:solidFill>
@@ -20995,7 +20963,7 @@
               </a:spcAft>
             </a:pPr>
             <a:r>
-              <a:rPr sz="1050" b="0" i="0">
+              <a:rPr sz="1218" b="0" i="0">
                 <a:solidFill>
                   <a:srgbClr val="64748B"/>
                 </a:solidFill>
@@ -21102,7 +21070,7 @@
               </a:spcAft>
             </a:pPr>
             <a:r>
-              <a:rPr sz="1400" b="1" i="0">
+              <a:rPr sz="1623" b="1" i="0">
                 <a:solidFill>
                   <a:srgbClr val="06B6D4"/>
                 </a:solidFill>
@@ -21324,7 +21292,7 @@
               </a:spcAft>
             </a:pPr>
             <a:r>
-              <a:rPr sz="1350" b="1" i="0">
+              <a:rPr sz="1565" b="1" i="0">
                 <a:solidFill>
                   <a:srgbClr val="FFFFFF"/>
                 </a:solidFill>
@@ -21413,7 +21381,7 @@
               </a:spcAft>
             </a:pPr>
             <a:r>
-              <a:rPr sz="1350" b="1" i="0">
+              <a:rPr sz="1565" b="1" i="0">
                 <a:solidFill>
                   <a:srgbClr val="FFFFFF"/>
                 </a:solidFill>
@@ -21502,7 +21470,7 @@
               </a:spcAft>
             </a:pPr>
             <a:r>
-              <a:rPr sz="1350" b="1" i="0">
+              <a:rPr sz="1565" b="1" i="0">
                 <a:solidFill>
                   <a:srgbClr val="FFFFFF"/>
                 </a:solidFill>
@@ -21591,7 +21559,7 @@
               </a:spcAft>
             </a:pPr>
             <a:r>
-              <a:rPr sz="1350" b="1" i="0">
+              <a:rPr sz="1565" b="1" i="0">
                 <a:solidFill>
                   <a:srgbClr val="FFFFFF"/>
                 </a:solidFill>
@@ -21680,7 +21648,7 @@
               </a:spcAft>
             </a:pPr>
             <a:r>
-              <a:rPr sz="1350" b="1" i="0">
+              <a:rPr sz="1565" b="1" i="0">
                 <a:solidFill>
                   <a:srgbClr val="FFFFFF"/>
                 </a:solidFill>
@@ -21771,7 +21739,7 @@
               </a:spcAft>
             </a:pPr>
             <a:r>
-              <a:rPr sz="1350" b="1" i="0">
+              <a:rPr sz="1565" b="1" i="0">
                 <a:solidFill>
                   <a:srgbClr val="FFFFFF"/>
                 </a:solidFill>
@@ -21862,7 +21830,7 @@
               </a:spcAft>
             </a:pPr>
             <a:r>
-              <a:rPr sz="1350" b="0" i="0">
+              <a:rPr sz="1565" b="0" i="0">
                 <a:solidFill>
                   <a:srgbClr val="0F172A"/>
                 </a:solidFill>
@@ -21953,7 +21921,7 @@
               </a:spcAft>
             </a:pPr>
             <a:r>
-              <a:rPr sz="1350" b="0" i="0">
+              <a:rPr sz="1565" b="0" i="0">
                 <a:solidFill>
                   <a:srgbClr val="0F172A"/>
                 </a:solidFill>
@@ -21975,7 +21943,7 @@
               </a:spcAft>
             </a:pPr>
             <a:r>
-              <a:rPr sz="1350" b="0" i="0">
+              <a:rPr sz="1565" b="0" i="0">
                 <a:solidFill>
                   <a:srgbClr val="0F172A"/>
                 </a:solidFill>
@@ -22066,7 +22034,7 @@
               </a:spcAft>
             </a:pPr>
             <a:r>
-              <a:rPr sz="1350" b="0" i="0">
+              <a:rPr sz="1565" b="0" i="0">
                 <a:solidFill>
                   <a:srgbClr val="0F172A"/>
                 </a:solidFill>
@@ -22157,7 +22125,7 @@
               </a:spcAft>
             </a:pPr>
             <a:r>
-              <a:rPr sz="1350" b="0" i="0">
+              <a:rPr sz="1565" b="0" i="0">
                 <a:solidFill>
                   <a:srgbClr val="0F172A"/>
                 </a:solidFill>
@@ -22248,7 +22216,7 @@
               </a:spcAft>
             </a:pPr>
             <a:r>
-              <a:rPr sz="1350" b="1" i="0">
+              <a:rPr sz="1565" b="1" i="0">
                 <a:solidFill>
                   <a:srgbClr val="FFFFFF"/>
                 </a:solidFill>
@@ -22339,7 +22307,7 @@
               </a:spcAft>
             </a:pPr>
             <a:r>
-              <a:rPr sz="1350" b="0" i="0">
+              <a:rPr sz="1565" b="0" i="0">
                 <a:solidFill>
                   <a:srgbClr val="0F172A"/>
                 </a:solidFill>
@@ -22361,7 +22329,7 @@
               </a:spcAft>
             </a:pPr>
             <a:r>
-              <a:rPr sz="1350" b="0" i="0">
+              <a:rPr sz="1565" b="0" i="0">
                 <a:solidFill>
                   <a:srgbClr val="0F172A"/>
                 </a:solidFill>
@@ -22452,7 +22420,7 @@
               </a:spcAft>
             </a:pPr>
             <a:r>
-              <a:rPr sz="1350" b="0" i="0">
+              <a:rPr sz="1565" b="0" i="0">
                 <a:solidFill>
                   <a:srgbClr val="0F172A"/>
                 </a:solidFill>
@@ -22474,7 +22442,7 @@
               </a:spcAft>
             </a:pPr>
             <a:r>
-              <a:rPr sz="1350" b="0" i="0">
+              <a:rPr sz="1565" b="0" i="0">
                 <a:solidFill>
                   <a:srgbClr val="0F172A"/>
                 </a:solidFill>
@@ -22565,7 +22533,7 @@
               </a:spcAft>
             </a:pPr>
             <a:r>
-              <a:rPr sz="1350" b="0" i="0">
+              <a:rPr sz="1565" b="0" i="0">
                 <a:solidFill>
                   <a:srgbClr val="0F172A"/>
                 </a:solidFill>
@@ -22656,7 +22624,7 @@
               </a:spcAft>
             </a:pPr>
             <a:r>
-              <a:rPr sz="1350" b="0" i="0">
+              <a:rPr sz="1565" b="0" i="0">
                 <a:solidFill>
                   <a:srgbClr val="0F172A"/>
                 </a:solidFill>
@@ -22747,7 +22715,7 @@
               </a:spcAft>
             </a:pPr>
             <a:r>
-              <a:rPr sz="1350" b="1" i="0">
+              <a:rPr sz="1565" b="1" i="0">
                 <a:solidFill>
                   <a:srgbClr val="FFFFFF"/>
                 </a:solidFill>
@@ -22838,7 +22806,7 @@
               </a:spcAft>
             </a:pPr>
             <a:r>
-              <a:rPr sz="1350" b="0" i="0">
+              <a:rPr sz="1565" b="0" i="0">
                 <a:solidFill>
                   <a:srgbClr val="0F172A"/>
                 </a:solidFill>
@@ -22860,7 +22828,7 @@
               </a:spcAft>
             </a:pPr>
             <a:r>
-              <a:rPr sz="1350" b="0" i="0">
+              <a:rPr sz="1565" b="0" i="0">
                 <a:solidFill>
                   <a:srgbClr val="0F172A"/>
                 </a:solidFill>
@@ -22951,7 +22919,7 @@
               </a:spcAft>
             </a:pPr>
             <a:r>
-              <a:rPr sz="1350" b="0" i="0">
+              <a:rPr sz="1565" b="0" i="0">
                 <a:solidFill>
                   <a:srgbClr val="0F172A"/>
                 </a:solidFill>
@@ -23042,7 +23010,7 @@
               </a:spcAft>
             </a:pPr>
             <a:r>
-              <a:rPr sz="1350" b="0" i="0">
+              <a:rPr sz="1565" b="0" i="0">
                 <a:solidFill>
                   <a:srgbClr val="0F172A"/>
                 </a:solidFill>
@@ -23133,7 +23101,7 @@
               </a:spcAft>
             </a:pPr>
             <a:r>
-              <a:rPr sz="1350" b="0" i="0">
+              <a:rPr sz="1565" b="0" i="0">
                 <a:solidFill>
                   <a:srgbClr val="0F172A"/>
                 </a:solidFill>
@@ -23178,7 +23146,7 @@
               </a:spcAft>
             </a:pPr>
             <a:r>
-              <a:rPr sz="1400" b="1" i="0">
+              <a:rPr sz="1623" b="1" i="0">
                 <a:solidFill>
                   <a:srgbClr val="FFFFFF"/>
                 </a:solidFill>
@@ -23223,7 +23191,7 @@
               </a:spcAft>
             </a:pPr>
             <a:r>
-              <a:rPr sz="1400" b="1" i="0">
+              <a:rPr sz="1623" b="1" i="0">
                 <a:solidFill>
                   <a:srgbClr val="FFFFFF"/>
                 </a:solidFill>
@@ -23268,7 +23236,7 @@
               </a:spcAft>
             </a:pPr>
             <a:r>
-              <a:rPr sz="1400" b="1" i="0">
+              <a:rPr sz="1623" b="1" i="0">
                 <a:solidFill>
                   <a:srgbClr val="FFFFFF"/>
                 </a:solidFill>
@@ -23313,13 +23281,13 @@
               </a:spcAft>
             </a:pPr>
             <a:r>
-              <a:rPr sz="1400" b="1" i="0">
+              <a:rPr sz="1623" b="1" i="0">
                 <a:solidFill>
                   <a:srgbClr val="0F172A"/>
                 </a:solidFill>
                 <a:latin typeface="Arial"/>
               </a:rPr>
-              <a:t>Reading the matrix: the firm that is least adaptable in governance is also the most exposed in viability — the columns are linked, not independent.</a:t>
+              <a:t>Reading the matrix: the firm that is least adaptable in governance is also the most exposed in viability</a:t>
             </a:r>
           </a:p>
         </p:txBody>
@@ -23358,13 +23326,13 @@
               </a:spcAft>
             </a:pPr>
             <a:r>
-              <a:rPr sz="1100" b="0" i="1">
+              <a:rPr sz="1276" b="0" i="1">
                 <a:solidFill>
                   <a:srgbClr val="64748B"/>
                 </a:solidFill>
                 <a:latin typeface="Arial"/>
               </a:rPr>
-              <a:t>Anchors: Shleifer &amp; Vishny (1994) · Megginson &amp; Netter (2001) · Teece et al. (1997) · Luo &amp; Tung (2007) · Fan et al. (2007)</a:t>
+              <a:t>Shleifer &amp; Vishny (1994) · Megginson &amp; Netter (2001) · Teece et al. (1997) · Luo &amp; Tung (2007) · Fan et al. (2007)</a:t>
             </a:r>
           </a:p>
         </p:txBody>
@@ -23403,7 +23371,7 @@
               </a:spcAft>
             </a:pPr>
             <a:r>
-              <a:rPr sz="1050" b="0" i="0">
+              <a:rPr sz="1218" b="0" i="0">
                 <a:solidFill>
                   <a:srgbClr val="64748B"/>
                 </a:solidFill>
@@ -23448,7 +23416,7 @@
               </a:spcAft>
             </a:pPr>
             <a:r>
-              <a:rPr sz="1050" b="0" i="0">
+              <a:rPr sz="1218" b="0" i="0">
                 <a:solidFill>
                   <a:srgbClr val="64748B"/>
                 </a:solidFill>
@@ -23555,7 +23523,7 @@
               </a:spcAft>
             </a:pPr>
             <a:r>
-              <a:rPr sz="1400" b="1" i="0">
+              <a:rPr sz="1623" b="1" i="0">
                 <a:solidFill>
                   <a:srgbClr val="06B6D4"/>
                 </a:solidFill>
@@ -23823,7 +23791,7 @@
               </a:spcAft>
             </a:pPr>
             <a:r>
-              <a:rPr sz="1600" b="1" i="0">
+              <a:rPr sz="1855" b="1" i="0">
                 <a:solidFill>
                   <a:srgbClr val="DC2626"/>
                 </a:solidFill>
@@ -23869,7 +23837,7 @@
               <a:buNone/>
             </a:pPr>
             <a:r>
-              <a:rPr sz="1250">
+              <a:rPr sz="1449">
                 <a:solidFill>
                   <a:srgbClr val="DC2626"/>
                 </a:solidFill>
@@ -23878,7 +23846,7 @@
               <a:t>–  </a:t>
             </a:r>
             <a:r>
-              <a:rPr sz="1250">
+              <a:rPr sz="1449">
                 <a:solidFill>
                   <a:srgbClr val="0F172A"/>
                 </a:solidFill>
@@ -23901,7 +23869,7 @@
               <a:buNone/>
             </a:pPr>
             <a:r>
-              <a:rPr sz="1250">
+              <a:rPr sz="1449">
                 <a:solidFill>
                   <a:srgbClr val="DC2626"/>
                 </a:solidFill>
@@ -23910,7 +23878,7 @@
               <a:t>–  </a:t>
             </a:r>
             <a:r>
-              <a:rPr sz="1250">
+              <a:rPr sz="1449">
                 <a:solidFill>
                   <a:srgbClr val="0F172A"/>
                 </a:solidFill>
@@ -23933,7 +23901,7 @@
               <a:buNone/>
             </a:pPr>
             <a:r>
-              <a:rPr sz="1250">
+              <a:rPr sz="1449">
                 <a:solidFill>
                   <a:srgbClr val="DC2626"/>
                 </a:solidFill>
@@ -23942,7 +23910,7 @@
               <a:t>–  </a:t>
             </a:r>
             <a:r>
-              <a:rPr sz="1250">
+              <a:rPr sz="1449">
                 <a:solidFill>
                   <a:srgbClr val="0F172A"/>
                 </a:solidFill>
@@ -23965,7 +23933,7 @@
               <a:buNone/>
             </a:pPr>
             <a:r>
-              <a:rPr sz="1250">
+              <a:rPr sz="1449">
                 <a:solidFill>
                   <a:srgbClr val="DC2626"/>
                 </a:solidFill>
@@ -23974,7 +23942,7 @@
               <a:t>–  </a:t>
             </a:r>
             <a:r>
-              <a:rPr sz="1250">
+              <a:rPr sz="1449">
                 <a:solidFill>
                   <a:srgbClr val="0F172A"/>
                 </a:solidFill>
@@ -23997,7 +23965,7 @@
               <a:buNone/>
             </a:pPr>
             <a:r>
-              <a:rPr sz="1250">
+              <a:rPr sz="1449">
                 <a:solidFill>
                   <a:srgbClr val="DC2626"/>
                 </a:solidFill>
@@ -24006,7 +23974,7 @@
               <a:t>–  </a:t>
             </a:r>
             <a:r>
-              <a:rPr sz="1250">
+              <a:rPr sz="1449">
                 <a:solidFill>
                   <a:srgbClr val="0F172A"/>
                 </a:solidFill>
@@ -24141,7 +24109,7 @@
               </a:spcAft>
             </a:pPr>
             <a:r>
-              <a:rPr sz="1600" b="1" i="0">
+              <a:rPr sz="1855" b="1" i="0">
                 <a:solidFill>
                   <a:srgbClr val="2563EB"/>
                 </a:solidFill>
@@ -24187,7 +24155,7 @@
               <a:buNone/>
             </a:pPr>
             <a:r>
-              <a:rPr sz="1250">
+              <a:rPr sz="1449">
                 <a:solidFill>
                   <a:srgbClr val="2563EB"/>
                 </a:solidFill>
@@ -24196,7 +24164,7 @@
               <a:t>–  </a:t>
             </a:r>
             <a:r>
-              <a:rPr sz="1250">
+              <a:rPr sz="1449">
                 <a:solidFill>
                   <a:srgbClr val="0F172A"/>
                 </a:solidFill>
@@ -24219,7 +24187,7 @@
               <a:buNone/>
             </a:pPr>
             <a:r>
-              <a:rPr sz="1250">
+              <a:rPr sz="1449">
                 <a:solidFill>
                   <a:srgbClr val="2563EB"/>
                 </a:solidFill>
@@ -24228,7 +24196,7 @@
               <a:t>–  </a:t>
             </a:r>
             <a:r>
-              <a:rPr sz="1250">
+              <a:rPr sz="1449">
                 <a:solidFill>
                   <a:srgbClr val="0F172A"/>
                 </a:solidFill>
@@ -24251,7 +24219,7 @@
               <a:buNone/>
             </a:pPr>
             <a:r>
-              <a:rPr sz="1250">
+              <a:rPr sz="1449">
                 <a:solidFill>
                   <a:srgbClr val="2563EB"/>
                 </a:solidFill>
@@ -24260,7 +24228,7 @@
               <a:t>–  </a:t>
             </a:r>
             <a:r>
-              <a:rPr sz="1250">
+              <a:rPr sz="1449">
                 <a:solidFill>
                   <a:srgbClr val="0F172A"/>
                 </a:solidFill>
@@ -24283,7 +24251,7 @@
               <a:buNone/>
             </a:pPr>
             <a:r>
-              <a:rPr sz="1250">
+              <a:rPr sz="1449">
                 <a:solidFill>
                   <a:srgbClr val="2563EB"/>
                 </a:solidFill>
@@ -24292,7 +24260,7 @@
               <a:t>–  </a:t>
             </a:r>
             <a:r>
-              <a:rPr sz="1250">
+              <a:rPr sz="1449">
                 <a:solidFill>
                   <a:srgbClr val="0F172A"/>
                 </a:solidFill>
@@ -24315,7 +24283,7 @@
               <a:buNone/>
             </a:pPr>
             <a:r>
-              <a:rPr sz="1250">
+              <a:rPr sz="1449">
                 <a:solidFill>
                   <a:srgbClr val="2563EB"/>
                 </a:solidFill>
@@ -24324,7 +24292,7 @@
               <a:t>–  </a:t>
             </a:r>
             <a:r>
-              <a:rPr sz="1250">
+              <a:rPr sz="1449">
                 <a:solidFill>
                   <a:srgbClr val="0F172A"/>
                 </a:solidFill>
@@ -24459,7 +24427,7 @@
               </a:spcAft>
             </a:pPr>
             <a:r>
-              <a:rPr sz="1600" b="1" i="0">
+              <a:rPr sz="1855" b="1" i="0">
                 <a:solidFill>
                   <a:srgbClr val="06B6D4"/>
                 </a:solidFill>
@@ -24505,7 +24473,7 @@
               <a:buNone/>
             </a:pPr>
             <a:r>
-              <a:rPr sz="1250">
+              <a:rPr sz="1449">
                 <a:solidFill>
                   <a:srgbClr val="06B6D4"/>
                 </a:solidFill>
@@ -24514,7 +24482,7 @@
               <a:t>–  </a:t>
             </a:r>
             <a:r>
-              <a:rPr sz="1250">
+              <a:rPr sz="1449">
                 <a:solidFill>
                   <a:srgbClr val="0F172A"/>
                 </a:solidFill>
@@ -24537,7 +24505,7 @@
               <a:buNone/>
             </a:pPr>
             <a:r>
-              <a:rPr sz="1250">
+              <a:rPr sz="1449">
                 <a:solidFill>
                   <a:srgbClr val="06B6D4"/>
                 </a:solidFill>
@@ -24546,7 +24514,7 @@
               <a:t>–  </a:t>
             </a:r>
             <a:r>
-              <a:rPr sz="1250">
+              <a:rPr sz="1449">
                 <a:solidFill>
                   <a:srgbClr val="0F172A"/>
                 </a:solidFill>
@@ -24569,7 +24537,7 @@
               <a:buNone/>
             </a:pPr>
             <a:r>
-              <a:rPr sz="1250">
+              <a:rPr sz="1449">
                 <a:solidFill>
                   <a:srgbClr val="06B6D4"/>
                 </a:solidFill>
@@ -24578,7 +24546,7 @@
               <a:t>–  </a:t>
             </a:r>
             <a:r>
-              <a:rPr sz="1250">
+              <a:rPr sz="1449">
                 <a:solidFill>
                   <a:srgbClr val="0F172A"/>
                 </a:solidFill>
@@ -24601,7 +24569,7 @@
               <a:buNone/>
             </a:pPr>
             <a:r>
-              <a:rPr sz="1250">
+              <a:rPr sz="1449">
                 <a:solidFill>
                   <a:srgbClr val="06B6D4"/>
                 </a:solidFill>
@@ -24610,7 +24578,7 @@
               <a:t>–  </a:t>
             </a:r>
             <a:r>
-              <a:rPr sz="1250">
+              <a:rPr sz="1449">
                 <a:solidFill>
                   <a:srgbClr val="0F172A"/>
                 </a:solidFill>
@@ -24633,7 +24601,7 @@
               <a:buNone/>
             </a:pPr>
             <a:r>
-              <a:rPr sz="1250">
+              <a:rPr sz="1449">
                 <a:solidFill>
                   <a:srgbClr val="06B6D4"/>
                 </a:solidFill>
@@ -24642,7 +24610,7 @@
               <a:t>–  </a:t>
             </a:r>
             <a:r>
-              <a:rPr sz="1250">
+              <a:rPr sz="1449">
                 <a:solidFill>
                   <a:srgbClr val="0F172A"/>
                 </a:solidFill>
@@ -24687,13 +24655,13 @@
               </a:spcAft>
             </a:pPr>
             <a:r>
-              <a:rPr sz="1100" b="0" i="1">
+              <a:rPr sz="1276" b="0" i="1">
                 <a:solidFill>
                   <a:srgbClr val="64748B"/>
                 </a:solidFill>
                 <a:latin typeface="Arial"/>
               </a:rPr>
-              <a:t>Theory: Shleifer &amp; Vishny (1994) · Fan et al. (2007) · Jensen &amp; Meckling (1976) · Megginson &amp; Netter (2001)</a:t>
+              <a:t>Shleifer &amp; Vishny (1994) · Fan et al. (2007) · Jensen &amp; Meckling (1976) · Megginson &amp; Netter (2001)</a:t>
             </a:r>
           </a:p>
         </p:txBody>
@@ -24732,7 +24700,7 @@
               </a:spcAft>
             </a:pPr>
             <a:r>
-              <a:rPr sz="1050" b="0" i="0">
+              <a:rPr sz="1218" b="0" i="0">
                 <a:solidFill>
                   <a:srgbClr val="64748B"/>
                 </a:solidFill>
@@ -24777,7 +24745,7 @@
               </a:spcAft>
             </a:pPr>
             <a:r>
-              <a:rPr sz="1050" b="0" i="0">
+              <a:rPr sz="1218" b="0" i="0">
                 <a:solidFill>
                   <a:srgbClr val="64748B"/>
                 </a:solidFill>
@@ -24884,7 +24852,7 @@
               </a:spcAft>
             </a:pPr>
             <a:r>
-              <a:rPr sz="1400" b="1" i="0">
+              <a:rPr sz="1623" b="1" i="0">
                 <a:solidFill>
                   <a:srgbClr val="06B6D4"/>
                 </a:solidFill>
@@ -25197,7 +25165,7 @@
               </a:spcAft>
             </a:pPr>
             <a:r>
-              <a:rPr sz="1600" b="1" i="0">
+              <a:rPr sz="1855" b="1" i="0">
                 <a:solidFill>
                   <a:srgbClr val="0F172A"/>
                 </a:solidFill>
@@ -25242,7 +25210,7 @@
               </a:spcAft>
             </a:pPr>
             <a:r>
-              <a:rPr sz="1200" b="0" i="1">
+              <a:rPr sz="1391" b="0" i="1">
                 <a:solidFill>
                   <a:srgbClr val="64748B"/>
                 </a:solidFill>
@@ -25264,7 +25232,7 @@
               </a:spcAft>
             </a:pPr>
             <a:r>
-              <a:rPr sz="1200" b="0" i="1">
+              <a:rPr sz="1391" b="0" i="1">
                 <a:solidFill>
                   <a:srgbClr val="64748B"/>
                 </a:solidFill>
@@ -25444,7 +25412,7 @@
               </a:spcAft>
             </a:pPr>
             <a:r>
-              <a:rPr sz="1600" b="1" i="0">
+              <a:rPr sz="1855" b="1" i="0">
                 <a:solidFill>
                   <a:srgbClr val="0F172A"/>
                 </a:solidFill>
@@ -25489,7 +25457,7 @@
               </a:spcAft>
             </a:pPr>
             <a:r>
-              <a:rPr sz="1200" b="0" i="1">
+              <a:rPr sz="1391" b="0" i="1">
                 <a:solidFill>
                   <a:srgbClr val="64748B"/>
                 </a:solidFill>
@@ -25511,7 +25479,7 @@
               </a:spcAft>
             </a:pPr>
             <a:r>
-              <a:rPr sz="1200" b="0" i="1">
+              <a:rPr sz="1391" b="0" i="1">
                 <a:solidFill>
                   <a:srgbClr val="64748B"/>
                 </a:solidFill>
@@ -25691,7 +25659,7 @@
               </a:spcAft>
             </a:pPr>
             <a:r>
-              <a:rPr sz="1600" b="1" i="0">
+              <a:rPr sz="1855" b="1" i="0">
                 <a:solidFill>
                   <a:srgbClr val="0F172A"/>
                 </a:solidFill>
@@ -25736,7 +25704,7 @@
               </a:spcAft>
             </a:pPr>
             <a:r>
-              <a:rPr sz="1200" b="0" i="1">
+              <a:rPr sz="1391" b="0" i="1">
                 <a:solidFill>
                   <a:srgbClr val="64748B"/>
                 </a:solidFill>
@@ -25758,7 +25726,7 @@
               </a:spcAft>
             </a:pPr>
             <a:r>
-              <a:rPr sz="1200" b="0" i="1">
+              <a:rPr sz="1391" b="0" i="1">
                 <a:solidFill>
                   <a:srgbClr val="64748B"/>
                 </a:solidFill>
@@ -25804,7 +25772,7 @@
               <a:buNone/>
             </a:pPr>
             <a:r>
-              <a:rPr sz="1500">
+              <a:rPr sz="1739">
                 <a:solidFill>
                   <a:srgbClr val="2563EB"/>
                 </a:solidFill>
@@ -25813,7 +25781,7 @@
               <a:t>–  </a:t>
             </a:r>
             <a:r>
-              <a:rPr sz="1500">
+              <a:rPr sz="1739">
                 <a:solidFill>
                   <a:srgbClr val="0F172A"/>
                 </a:solidFill>
@@ -25836,7 +25804,7 @@
               <a:buNone/>
             </a:pPr>
             <a:r>
-              <a:rPr sz="1500">
+              <a:rPr sz="1739">
                 <a:solidFill>
                   <a:srgbClr val="2563EB"/>
                 </a:solidFill>
@@ -25845,7 +25813,7 @@
               <a:t>–  </a:t>
             </a:r>
             <a:r>
-              <a:rPr sz="1500">
+              <a:rPr sz="1739">
                 <a:solidFill>
                   <a:srgbClr val="0F172A"/>
                 </a:solidFill>
@@ -25868,7 +25836,7 @@
               <a:buNone/>
             </a:pPr>
             <a:r>
-              <a:rPr sz="1500">
+              <a:rPr sz="1739">
                 <a:solidFill>
                   <a:srgbClr val="2563EB"/>
                 </a:solidFill>
@@ -25877,7 +25845,7 @@
               <a:t>–  </a:t>
             </a:r>
             <a:r>
-              <a:rPr sz="1500">
+              <a:rPr sz="1739">
                 <a:solidFill>
                   <a:srgbClr val="0F172A"/>
                 </a:solidFill>
@@ -25922,7 +25890,7 @@
               </a:spcAft>
             </a:pPr>
             <a:r>
-              <a:rPr sz="1100" b="0" i="1">
+              <a:rPr sz="1276" b="0" i="1">
                 <a:solidFill>
                   <a:srgbClr val="64748B"/>
                 </a:solidFill>
@@ -25967,7 +25935,7 @@
               </a:spcAft>
             </a:pPr>
             <a:r>
-              <a:rPr sz="1050" b="0" i="0">
+              <a:rPr sz="1218" b="0" i="0">
                 <a:solidFill>
                   <a:srgbClr val="64748B"/>
                 </a:solidFill>
@@ -26012,7 +25980,7 @@
               </a:spcAft>
             </a:pPr>
             <a:r>
-              <a:rPr sz="1050" b="0" i="0">
+              <a:rPr sz="1218" b="0" i="0">
                 <a:solidFill>
                   <a:srgbClr val="64748B"/>
                 </a:solidFill>
@@ -26119,7 +26087,7 @@
               </a:spcAft>
             </a:pPr>
             <a:r>
-              <a:rPr sz="1400" b="1" i="0">
+              <a:rPr sz="1623" b="1" i="0">
                 <a:solidFill>
                   <a:srgbClr val="06B6D4"/>
                 </a:solidFill>
@@ -26387,7 +26355,7 @@
               </a:spcAft>
             </a:pPr>
             <a:r>
-              <a:rPr sz="1600" b="1" i="0">
+              <a:rPr sz="1855" b="1" i="0">
                 <a:solidFill>
                   <a:srgbClr val="DC2626"/>
                 </a:solidFill>
@@ -26433,7 +26401,7 @@
               <a:buNone/>
             </a:pPr>
             <a:r>
-              <a:rPr sz="1250">
+              <a:rPr sz="1449">
                 <a:solidFill>
                   <a:srgbClr val="DC2626"/>
                 </a:solidFill>
@@ -26442,7 +26410,7 @@
               <a:t>–  </a:t>
             </a:r>
             <a:r>
-              <a:rPr sz="1250">
+              <a:rPr sz="1449">
                 <a:solidFill>
                   <a:srgbClr val="0F172A"/>
                 </a:solidFill>
@@ -26465,7 +26433,7 @@
               <a:buNone/>
             </a:pPr>
             <a:r>
-              <a:rPr sz="1250">
+              <a:rPr sz="1449">
                 <a:solidFill>
                   <a:srgbClr val="DC2626"/>
                 </a:solidFill>
@@ -26474,7 +26442,7 @@
               <a:t>–  </a:t>
             </a:r>
             <a:r>
-              <a:rPr sz="1250">
+              <a:rPr sz="1449">
                 <a:solidFill>
                   <a:srgbClr val="0F172A"/>
                 </a:solidFill>
@@ -26497,7 +26465,7 @@
               <a:buNone/>
             </a:pPr>
             <a:r>
-              <a:rPr sz="1250">
+              <a:rPr sz="1449">
                 <a:solidFill>
                   <a:srgbClr val="DC2626"/>
                 </a:solidFill>
@@ -26506,7 +26474,7 @@
               <a:t>–  </a:t>
             </a:r>
             <a:r>
-              <a:rPr sz="1250">
+              <a:rPr sz="1449">
                 <a:solidFill>
                   <a:srgbClr val="0F172A"/>
                 </a:solidFill>
@@ -26529,7 +26497,7 @@
               <a:buNone/>
             </a:pPr>
             <a:r>
-              <a:rPr sz="1250">
+              <a:rPr sz="1449">
                 <a:solidFill>
                   <a:srgbClr val="DC2626"/>
                 </a:solidFill>
@@ -26538,7 +26506,7 @@
               <a:t>–  </a:t>
             </a:r>
             <a:r>
-              <a:rPr sz="1250">
+              <a:rPr sz="1449">
                 <a:solidFill>
                   <a:srgbClr val="0F172A"/>
                 </a:solidFill>
@@ -26561,16 +26529,7 @@
               <a:buNone/>
             </a:pPr>
             <a:r>
-              <a:rPr sz="1250">
-                <a:solidFill>
-                  <a:srgbClr val="DC2626"/>
-                </a:solidFill>
-                <a:latin typeface="Arial"/>
-              </a:rPr>
-              <a:t>–  </a:t>
-            </a:r>
-            <a:r>
-              <a:rPr sz="1250">
+              <a:rPr sz="1449">
                 <a:solidFill>
                   <a:srgbClr val="0F172A"/>
                 </a:solidFill>
@@ -26705,7 +26664,7 @@
               </a:spcAft>
             </a:pPr>
             <a:r>
-              <a:rPr sz="1600" b="1" i="0">
+              <a:rPr sz="1855" b="1" i="0">
                 <a:solidFill>
                   <a:srgbClr val="2563EB"/>
                 </a:solidFill>
@@ -26751,7 +26710,7 @@
               <a:buNone/>
             </a:pPr>
             <a:r>
-              <a:rPr sz="1250">
+              <a:rPr sz="1449">
                 <a:solidFill>
                   <a:srgbClr val="2563EB"/>
                 </a:solidFill>
@@ -26760,7 +26719,7 @@
               <a:t>–  </a:t>
             </a:r>
             <a:r>
-              <a:rPr sz="1250">
+              <a:rPr sz="1449">
                 <a:solidFill>
                   <a:srgbClr val="0F172A"/>
                 </a:solidFill>
@@ -26783,7 +26742,7 @@
               <a:buNone/>
             </a:pPr>
             <a:r>
-              <a:rPr sz="1250">
+              <a:rPr sz="1449">
                 <a:solidFill>
                   <a:srgbClr val="2563EB"/>
                 </a:solidFill>
@@ -26792,7 +26751,7 @@
               <a:t>–  </a:t>
             </a:r>
             <a:r>
-              <a:rPr sz="1250">
+              <a:rPr sz="1449">
                 <a:solidFill>
                   <a:srgbClr val="0F172A"/>
                 </a:solidFill>
@@ -26815,7 +26774,7 @@
               <a:buNone/>
             </a:pPr>
             <a:r>
-              <a:rPr sz="1250">
+              <a:rPr sz="1449">
                 <a:solidFill>
                   <a:srgbClr val="2563EB"/>
                 </a:solidFill>
@@ -26824,7 +26783,7 @@
               <a:t>–  </a:t>
             </a:r>
             <a:r>
-              <a:rPr sz="1250">
+              <a:rPr sz="1449">
                 <a:solidFill>
                   <a:srgbClr val="0F172A"/>
                 </a:solidFill>
@@ -26847,7 +26806,7 @@
               <a:buNone/>
             </a:pPr>
             <a:r>
-              <a:rPr sz="1250">
+              <a:rPr sz="1449">
                 <a:solidFill>
                   <a:srgbClr val="2563EB"/>
                 </a:solidFill>
@@ -26856,7 +26815,7 @@
               <a:t>–  </a:t>
             </a:r>
             <a:r>
-              <a:rPr sz="1250">
+              <a:rPr sz="1449">
                 <a:solidFill>
                   <a:srgbClr val="0F172A"/>
                 </a:solidFill>
@@ -26879,16 +26838,7 @@
               <a:buNone/>
             </a:pPr>
             <a:r>
-              <a:rPr sz="1250">
-                <a:solidFill>
-                  <a:srgbClr val="2563EB"/>
-                </a:solidFill>
-                <a:latin typeface="Arial"/>
-              </a:rPr>
-              <a:t>–  </a:t>
-            </a:r>
-            <a:r>
-              <a:rPr sz="1250">
+              <a:rPr sz="1449">
                 <a:solidFill>
                   <a:srgbClr val="0F172A"/>
                 </a:solidFill>
@@ -27023,7 +26973,7 @@
               </a:spcAft>
             </a:pPr>
             <a:r>
-              <a:rPr sz="1600" b="1" i="0">
+              <a:rPr sz="1855" b="1" i="0">
                 <a:solidFill>
                   <a:srgbClr val="06B6D4"/>
                 </a:solidFill>
@@ -27069,7 +27019,7 @@
               <a:buNone/>
             </a:pPr>
             <a:r>
-              <a:rPr sz="1250">
+              <a:rPr sz="1449">
                 <a:solidFill>
                   <a:srgbClr val="06B6D4"/>
                 </a:solidFill>
@@ -27078,7 +27028,7 @@
               <a:t>–  </a:t>
             </a:r>
             <a:r>
-              <a:rPr sz="1250">
+              <a:rPr sz="1449">
                 <a:solidFill>
                   <a:srgbClr val="0F172A"/>
                 </a:solidFill>
@@ -27101,7 +27051,7 @@
               <a:buNone/>
             </a:pPr>
             <a:r>
-              <a:rPr sz="1250">
+              <a:rPr sz="1449">
                 <a:solidFill>
                   <a:srgbClr val="06B6D4"/>
                 </a:solidFill>
@@ -27110,7 +27060,7 @@
               <a:t>–  </a:t>
             </a:r>
             <a:r>
-              <a:rPr sz="1250">
+              <a:rPr sz="1449">
                 <a:solidFill>
                   <a:srgbClr val="0F172A"/>
                 </a:solidFill>
@@ -27133,7 +27083,7 @@
               <a:buNone/>
             </a:pPr>
             <a:r>
-              <a:rPr sz="1250">
+              <a:rPr sz="1449">
                 <a:solidFill>
                   <a:srgbClr val="06B6D4"/>
                 </a:solidFill>
@@ -27142,7 +27092,7 @@
               <a:t>–  </a:t>
             </a:r>
             <a:r>
-              <a:rPr sz="1250">
+              <a:rPr sz="1449">
                 <a:solidFill>
                   <a:srgbClr val="0F172A"/>
                 </a:solidFill>
@@ -27165,7 +27115,7 @@
               <a:buNone/>
             </a:pPr>
             <a:r>
-              <a:rPr sz="1250">
+              <a:rPr sz="1449">
                 <a:solidFill>
                   <a:srgbClr val="06B6D4"/>
                 </a:solidFill>
@@ -27174,7 +27124,7 @@
               <a:t>–  </a:t>
             </a:r>
             <a:r>
-              <a:rPr sz="1250">
+              <a:rPr sz="1449">
                 <a:solidFill>
                   <a:srgbClr val="0F172A"/>
                 </a:solidFill>
@@ -27197,16 +27147,7 @@
               <a:buNone/>
             </a:pPr>
             <a:r>
-              <a:rPr sz="1250">
-                <a:solidFill>
-                  <a:srgbClr val="06B6D4"/>
-                </a:solidFill>
-                <a:latin typeface="Arial"/>
-              </a:rPr>
-              <a:t>–  </a:t>
-            </a:r>
-            <a:r>
-              <a:rPr sz="1250">
+              <a:rPr sz="1449">
                 <a:solidFill>
                   <a:srgbClr val="0F172A"/>
                 </a:solidFill>
@@ -27295,7 +27236,7 @@
               </a:spcAft>
             </a:pPr>
             <a:r>
-              <a:rPr sz="1350" b="1" i="0">
+              <a:rPr sz="1565" b="1" i="0">
                 <a:solidFill>
                   <a:srgbClr val="FFFFFF"/>
                 </a:solidFill>
@@ -27340,7 +27281,7 @@
               </a:spcAft>
             </a:pPr>
             <a:r>
-              <a:rPr sz="1100" b="0" i="1">
+              <a:rPr sz="1276" b="0" i="1">
                 <a:solidFill>
                   <a:srgbClr val="64748B"/>
                 </a:solidFill>
@@ -27385,7 +27326,7 @@
               </a:spcAft>
             </a:pPr>
             <a:r>
-              <a:rPr sz="1050" b="0" i="0">
+              <a:rPr sz="1218" b="0" i="0">
                 <a:solidFill>
                   <a:srgbClr val="64748B"/>
                 </a:solidFill>
@@ -27430,7 +27371,7 @@
               </a:spcAft>
             </a:pPr>
             <a:r>
-              <a:rPr sz="1050" b="0" i="0">
+              <a:rPr sz="1218" b="0" i="0">
                 <a:solidFill>
                   <a:srgbClr val="64748B"/>
                 </a:solidFill>
@@ -27537,7 +27478,7 @@
               </a:spcAft>
             </a:pPr>
             <a:r>
-              <a:rPr sz="1400" b="1" i="0">
+              <a:rPr sz="1623" b="1" i="0">
                 <a:solidFill>
                   <a:srgbClr val="06B6D4"/>
                 </a:solidFill>
@@ -27759,7 +27700,7 @@
               </a:spcAft>
             </a:pPr>
             <a:r>
-              <a:rPr sz="1350" b="1" i="0">
+              <a:rPr sz="1565" b="1" i="0">
                 <a:solidFill>
                   <a:srgbClr val="FFFFFF"/>
                 </a:solidFill>
@@ -27848,7 +27789,7 @@
               </a:spcAft>
             </a:pPr>
             <a:r>
-              <a:rPr sz="1350" b="1" i="0">
+              <a:rPr sz="1565" b="1" i="0">
                 <a:solidFill>
                   <a:srgbClr val="FFFFFF"/>
                 </a:solidFill>
@@ -27937,7 +27878,7 @@
               </a:spcAft>
             </a:pPr>
             <a:r>
-              <a:rPr sz="1350" b="1" i="0">
+              <a:rPr sz="1565" b="1" i="0">
                 <a:solidFill>
                   <a:srgbClr val="FFFFFF"/>
                 </a:solidFill>
@@ -28026,7 +27967,7 @@
               </a:spcAft>
             </a:pPr>
             <a:r>
-              <a:rPr sz="1350" b="1" i="0">
+              <a:rPr sz="1565" b="1" i="0">
                 <a:solidFill>
                   <a:srgbClr val="FFFFFF"/>
                 </a:solidFill>
@@ -28117,7 +28058,7 @@
               </a:spcAft>
             </a:pPr>
             <a:r>
-              <a:rPr sz="1300" b="1" i="0">
+              <a:rPr sz="1507" b="1" i="0">
                 <a:solidFill>
                   <a:srgbClr val="0F172A"/>
                 </a:solidFill>
@@ -28208,7 +28149,7 @@
               </a:spcAft>
             </a:pPr>
             <a:r>
-              <a:rPr sz="1300" b="0" i="0">
+              <a:rPr sz="1507" b="0" i="0">
                 <a:solidFill>
                   <a:srgbClr val="0F172A"/>
                 </a:solidFill>
@@ -28299,7 +28240,7 @@
               </a:spcAft>
             </a:pPr>
             <a:r>
-              <a:rPr sz="1300" b="0" i="0">
+              <a:rPr sz="1507" b="0" i="0">
                 <a:solidFill>
                   <a:srgbClr val="0F172A"/>
                 </a:solidFill>
@@ -28390,7 +28331,7 @@
               </a:spcAft>
             </a:pPr>
             <a:r>
-              <a:rPr sz="1300" b="0" i="0">
+              <a:rPr sz="1507" b="0" i="0">
                 <a:solidFill>
                   <a:srgbClr val="0F172A"/>
                 </a:solidFill>
@@ -28481,7 +28422,7 @@
               </a:spcAft>
             </a:pPr>
             <a:r>
-              <a:rPr sz="1300" b="1" i="0">
+              <a:rPr sz="1507" b="1" i="0">
                 <a:solidFill>
                   <a:srgbClr val="0F172A"/>
                 </a:solidFill>
@@ -28572,7 +28513,7 @@
               </a:spcAft>
             </a:pPr>
             <a:r>
-              <a:rPr sz="1300" b="0" i="0">
+              <a:rPr sz="1507" b="0" i="0">
                 <a:solidFill>
                   <a:srgbClr val="0F172A"/>
                 </a:solidFill>
@@ -28663,7 +28604,7 @@
               </a:spcAft>
             </a:pPr>
             <a:r>
-              <a:rPr sz="1300" b="0" i="0">
+              <a:rPr sz="1507" b="0" i="0">
                 <a:solidFill>
                   <a:srgbClr val="0F172A"/>
                 </a:solidFill>
@@ -28754,7 +28695,7 @@
               </a:spcAft>
             </a:pPr>
             <a:r>
-              <a:rPr sz="1300" b="0" i="0">
+              <a:rPr sz="1507" b="0" i="0">
                 <a:solidFill>
                   <a:srgbClr val="0F172A"/>
                 </a:solidFill>
@@ -28845,7 +28786,7 @@
               </a:spcAft>
             </a:pPr>
             <a:r>
-              <a:rPr sz="1300" b="1" i="0">
+              <a:rPr sz="1507" b="1" i="0">
                 <a:solidFill>
                   <a:srgbClr val="0F172A"/>
                 </a:solidFill>
@@ -28936,7 +28877,7 @@
               </a:spcAft>
             </a:pPr>
             <a:r>
-              <a:rPr sz="1300" b="0" i="0">
+              <a:rPr sz="1507" b="0" i="0">
                 <a:solidFill>
                   <a:srgbClr val="0F172A"/>
                 </a:solidFill>
@@ -29027,7 +28968,7 @@
               </a:spcAft>
             </a:pPr>
             <a:r>
-              <a:rPr sz="1300" b="0" i="0">
+              <a:rPr sz="1507" b="0" i="0">
                 <a:solidFill>
                   <a:srgbClr val="0F172A"/>
                 </a:solidFill>
@@ -29118,7 +29059,7 @@
               </a:spcAft>
             </a:pPr>
             <a:r>
-              <a:rPr sz="1300" b="0" i="0">
+              <a:rPr sz="1507" b="0" i="0">
                 <a:solidFill>
                   <a:srgbClr val="0F172A"/>
                 </a:solidFill>
@@ -29209,7 +29150,7 @@
               </a:spcAft>
             </a:pPr>
             <a:r>
-              <a:rPr sz="1300" b="1" i="0">
+              <a:rPr sz="1507" b="1" i="0">
                 <a:solidFill>
                   <a:srgbClr val="0F172A"/>
                 </a:solidFill>
@@ -29300,7 +29241,7 @@
               </a:spcAft>
             </a:pPr>
             <a:r>
-              <a:rPr sz="1300" b="0" i="0">
+              <a:rPr sz="1507" b="0" i="0">
                 <a:solidFill>
                   <a:srgbClr val="0F172A"/>
                 </a:solidFill>
@@ -29391,7 +29332,7 @@
               </a:spcAft>
             </a:pPr>
             <a:r>
-              <a:rPr sz="1300" b="0" i="0">
+              <a:rPr sz="1507" b="0" i="0">
                 <a:solidFill>
                   <a:srgbClr val="0F172A"/>
                 </a:solidFill>
@@ -29482,7 +29423,7 @@
               </a:spcAft>
             </a:pPr>
             <a:r>
-              <a:rPr sz="1300" b="0" i="0">
+              <a:rPr sz="1507" b="0" i="0">
                 <a:solidFill>
                   <a:srgbClr val="0F172A"/>
                 </a:solidFill>
@@ -29573,7 +29514,7 @@
               </a:spcAft>
             </a:pPr>
             <a:r>
-              <a:rPr sz="1300" b="1" i="0">
+              <a:rPr sz="1507" b="1" i="0">
                 <a:solidFill>
                   <a:srgbClr val="0F172A"/>
                 </a:solidFill>
@@ -29664,7 +29605,7 @@
               </a:spcAft>
             </a:pPr>
             <a:r>
-              <a:rPr sz="1300" b="0" i="0">
+              <a:rPr sz="1507" b="0" i="0">
                 <a:solidFill>
                   <a:srgbClr val="0F172A"/>
                 </a:solidFill>
@@ -29755,7 +29696,7 @@
               </a:spcAft>
             </a:pPr>
             <a:r>
-              <a:rPr sz="1300" b="0" i="0">
+              <a:rPr sz="1507" b="0" i="0">
                 <a:solidFill>
                   <a:srgbClr val="0F172A"/>
                 </a:solidFill>
@@ -29846,7 +29787,7 @@
               </a:spcAft>
             </a:pPr>
             <a:r>
-              <a:rPr sz="1300" b="0" i="0">
+              <a:rPr sz="1507" b="0" i="0">
                 <a:solidFill>
                   <a:srgbClr val="0F172A"/>
                 </a:solidFill>
@@ -29937,7 +29878,7 @@
               </a:spcAft>
             </a:pPr>
             <a:r>
-              <a:rPr sz="1300" b="1" i="0">
+              <a:rPr sz="1507" b="1" i="0">
                 <a:solidFill>
                   <a:srgbClr val="0F172A"/>
                 </a:solidFill>
@@ -30028,7 +29969,7 @@
               </a:spcAft>
             </a:pPr>
             <a:r>
-              <a:rPr sz="1300" b="0" i="0">
+              <a:rPr sz="1507" b="0" i="0">
                 <a:solidFill>
                   <a:srgbClr val="0F172A"/>
                 </a:solidFill>
@@ -30119,7 +30060,7 @@
               </a:spcAft>
             </a:pPr>
             <a:r>
-              <a:rPr sz="1300" b="0" i="0">
+              <a:rPr sz="1507" b="0" i="0">
                 <a:solidFill>
                   <a:srgbClr val="0F172A"/>
                 </a:solidFill>
@@ -30210,7 +30151,7 @@
               </a:spcAft>
             </a:pPr>
             <a:r>
-              <a:rPr sz="1300" b="0" i="0">
+              <a:rPr sz="1507" b="0" i="0">
                 <a:solidFill>
                   <a:srgbClr val="0F172A"/>
                 </a:solidFill>
@@ -30301,7 +30242,7 @@
               </a:spcAft>
             </a:pPr>
             <a:r>
-              <a:rPr sz="1300" b="1" i="0">
+              <a:rPr sz="1507" b="1" i="0">
                 <a:solidFill>
                   <a:srgbClr val="0F172A"/>
                 </a:solidFill>
@@ -30392,7 +30333,7 @@
               </a:spcAft>
             </a:pPr>
             <a:r>
-              <a:rPr sz="1300" b="0" i="0">
+              <a:rPr sz="1507" b="0" i="0">
                 <a:solidFill>
                   <a:srgbClr val="0F172A"/>
                 </a:solidFill>
@@ -30483,7 +30424,7 @@
               </a:spcAft>
             </a:pPr>
             <a:r>
-              <a:rPr sz="1300" b="0" i="0">
+              <a:rPr sz="1507" b="0" i="0">
                 <a:solidFill>
                   <a:srgbClr val="0F172A"/>
                 </a:solidFill>
@@ -30574,7 +30515,7 @@
               </a:spcAft>
             </a:pPr>
             <a:r>
-              <a:rPr sz="1300" b="0" i="0">
+              <a:rPr sz="1507" b="0" i="0">
                 <a:solidFill>
                   <a:srgbClr val="0F172A"/>
                 </a:solidFill>
@@ -30663,7 +30604,7 @@
               </a:spcAft>
             </a:pPr>
             <a:r>
-              <a:rPr sz="1350" b="1" i="0">
+              <a:rPr sz="1565" b="1" i="0">
                 <a:solidFill>
                   <a:srgbClr val="FFFFFF"/>
                 </a:solidFill>
@@ -30752,7 +30693,7 @@
               </a:spcAft>
             </a:pPr>
             <a:r>
-              <a:rPr sz="1350" b="1" i="0">
+              <a:rPr sz="1565" b="1" i="0">
                 <a:solidFill>
                   <a:srgbClr val="FFFFFF"/>
                 </a:solidFill>
@@ -30841,7 +30782,7 @@
               </a:spcAft>
             </a:pPr>
             <a:r>
-              <a:rPr sz="1350" b="1" i="0">
+              <a:rPr sz="1565" b="1" i="0">
                 <a:solidFill>
                   <a:srgbClr val="FFFFFF"/>
                 </a:solidFill>
@@ -30886,7 +30827,7 @@
               </a:spcAft>
             </a:pPr>
             <a:r>
-              <a:rPr sz="1300" b="1" i="0">
+              <a:rPr sz="1507" b="1" i="0">
                 <a:solidFill>
                   <a:srgbClr val="0F172A"/>
                 </a:solidFill>
@@ -30931,13 +30872,13 @@
               </a:spcAft>
             </a:pPr>
             <a:r>
-              <a:rPr sz="1100" b="0" i="1">
+              <a:rPr sz="1276" b="0" i="1">
                 <a:solidFill>
                   <a:srgbClr val="64748B"/>
                 </a:solidFill>
                 <a:latin typeface="Arial"/>
               </a:rPr>
-              <a:t>Table 1 (paper, §3.4) · Annual Reports SAIC/BYD/Geely 2024 &amp; 2025 · EU Reg. 2024/2754</a:t>
+              <a:t>Annual Reports SAIC/BYD/Geely 2024 &amp; 2025 · EU Reg. 2024/2754</a:t>
             </a:r>
           </a:p>
         </p:txBody>
@@ -30976,7 +30917,7 @@
               </a:spcAft>
             </a:pPr>
             <a:r>
-              <a:rPr sz="1050" b="0" i="0">
+              <a:rPr sz="1218" b="0" i="0">
                 <a:solidFill>
                   <a:srgbClr val="64748B"/>
                 </a:solidFill>
@@ -31021,7 +30962,7 @@
               </a:spcAft>
             </a:pPr>
             <a:r>
-              <a:rPr sz="1050" b="0" i="0">
+              <a:rPr sz="1218" b="0" i="0">
                 <a:solidFill>
                   <a:srgbClr val="64748B"/>
                 </a:solidFill>

</xml_diff>

<commit_message>
add presentation speech script + cue cards, refine debate argument, sync final deck
- add research/wiki/saic-motor/Doc/praesentation-sprechtext-julia.md(.docx):
  slide-by-slide English delivery script + German/English cue cards for
  Julia's portion of the team presentation (slides 6-16), timed and
  rebalanced across shared vs. solo slides to hit the ~13 min/person target
- replace ZF Friedrichshafen example in the debate CON speech with a
  standalone-value framing and reframe the Opel/PSA argument as a
  fire-sale discount (Shleifer & Vishny 1992; Andrade et al. 2001),
  moving the "alternatives exist" argument to the DaimlerChrysler teammate
- add Aylin's BMW-Rover opposition brief for cross-referencing team arguments
- sync final presentation deck with manual edits
</commit_message>
<xml_diff>
--- a/research/presentation/China-Strategies-Presentation-FINAL.pptx
+++ b/research/presentation/China-Strategies-Presentation-FINAL.pptx
@@ -2,32 +2,32 @@
 <file path=ppt/presentation.xml><?xml version="1.0" encoding="utf-8"?>
 <p:presentation xmlns:a="http://schemas.openxmlformats.org/drawingml/2006/main" xmlns:r="http://schemas.openxmlformats.org/officeDocument/2006/relationships" xmlns:p="http://schemas.openxmlformats.org/presentationml/2006/main" saveSubsetFonts="1" autoCompressPictures="0">
   <p:sldMasterIdLst>
-    <p:sldMasterId id="2147483648" r:id="rId1"/>
+    <p:sldMasterId id="2147483648" r:id="rId4"/>
   </p:sldMasterIdLst>
   <p:notesMasterIdLst>
-    <p:notesMasterId r:id="rId22"/>
+    <p:notesMasterId r:id="rId25"/>
   </p:notesMasterIdLst>
   <p:sldIdLst>
-    <p:sldId id="256" r:id="rId2"/>
-    <p:sldId id="257" r:id="rId3"/>
-    <p:sldId id="258" r:id="rId4"/>
-    <p:sldId id="259" r:id="rId5"/>
-    <p:sldId id="260" r:id="rId6"/>
-    <p:sldId id="261" r:id="rId7"/>
-    <p:sldId id="262" r:id="rId8"/>
-    <p:sldId id="263" r:id="rId9"/>
-    <p:sldId id="264" r:id="rId10"/>
-    <p:sldId id="265" r:id="rId11"/>
-    <p:sldId id="266" r:id="rId12"/>
-    <p:sldId id="267" r:id="rId13"/>
-    <p:sldId id="268" r:id="rId14"/>
-    <p:sldId id="269" r:id="rId15"/>
-    <p:sldId id="270" r:id="rId16"/>
-    <p:sldId id="271" r:id="rId17"/>
-    <p:sldId id="272" r:id="rId18"/>
-    <p:sldId id="273" r:id="rId19"/>
-    <p:sldId id="274" r:id="rId20"/>
-    <p:sldId id="275" r:id="rId21"/>
+    <p:sldId id="256" r:id="rId5"/>
+    <p:sldId id="257" r:id="rId6"/>
+    <p:sldId id="258" r:id="rId7"/>
+    <p:sldId id="259" r:id="rId8"/>
+    <p:sldId id="260" r:id="rId9"/>
+    <p:sldId id="261" r:id="rId10"/>
+    <p:sldId id="262" r:id="rId11"/>
+    <p:sldId id="263" r:id="rId12"/>
+    <p:sldId id="264" r:id="rId13"/>
+    <p:sldId id="265" r:id="rId14"/>
+    <p:sldId id="266" r:id="rId15"/>
+    <p:sldId id="267" r:id="rId16"/>
+    <p:sldId id="268" r:id="rId17"/>
+    <p:sldId id="269" r:id="rId18"/>
+    <p:sldId id="270" r:id="rId19"/>
+    <p:sldId id="271" r:id="rId20"/>
+    <p:sldId id="272" r:id="rId21"/>
+    <p:sldId id="273" r:id="rId22"/>
+    <p:sldId id="274" r:id="rId23"/>
+    <p:sldId id="275" r:id="rId24"/>
   </p:sldIdLst>
   <p:sldSz cx="12192000" cy="6858000"/>
   <p:notesSz cx="6858000" cy="9144000"/>
@@ -143,6 +143,14 @@
     </p:ext>
   </p:extLst>
 </p:presentation>
+</file>
+
+<file path=ppt/revisionInfo.xml><?xml version="1.0" encoding="utf-8"?>
+<p1510:revInfo xmlns:a="http://schemas.openxmlformats.org/drawingml/2006/main" xmlns:r="http://schemas.openxmlformats.org/officeDocument/2006/relationships" xmlns:p1510="http://schemas.microsoft.com/office/powerpoint/2015/10/main">
+  <p1510:revLst>
+    <p1510:client id="{849355AE-A6F9-2B7B-0C1A-B901C31CA72A}" v="124" dt="2026-07-02T11:13:27.150"/>
+  </p1510:revLst>
+</p1510:revInfo>
 </file>
 
 <file path=ppt/notesMasters/notesMaster1.xml><?xml version="1.0" encoding="utf-8"?>
@@ -315,7 +323,11 @@
           <a:lstStyle/>
           <a:p>
             <a:r>
-              <a:t>Good afternoon, and welcome. Our paper asks one question: which way of building a car company in China creates the most value for shareholders over time? We compare three real firms with three models — SAIC uses joint ventures, BYD builds its own technology, and Geely buys companies abroad. Our main point is simple: governance — who controls the firm — matters more than the technology it starts with. We test this through four lenses: governance, financing, capability, and long-term viability. Then we give our result, draw three lessons, and end with how we used AI. Each of us will take a part. Let us start with why this question matters now.</a:t>
+              <a:rPr lang="en-US"/>
+              <a:t>Chiara: Good</a:t>
+            </a:r>
+            <a:r>
+              <a:t> afternoon, and welcome. Our paper asks one question: which way of building a car company in China creates the most value for shareholders over time? We compare three real firms with three models — SAIC uses joint ventures, BYD builds its own technology, and Geely buys companies abroad. Our main point is simple: governance — who controls the firm — matters more than the technology it starts with. We test this through four lenses: governance, financing, capability, and long-term viability. Then we give our result, draw three lessons, and end with how we used AI. Each of us will take a part. Let us start with why this question matters now.</a:t>
             </a:r>
           </a:p>
         </p:txBody>
@@ -385,7 +397,35 @@
           <a:lstStyle/>
           <a:p>
             <a:r>
-              <a:t>How a firm learns shapes what it can build later. SAIC took technology through joint ventures. It worked at first — quality rose about eight percent — but the easy money removed the pressure to invent, so it had no EV platform of its own when the shift came. BYD built everything itself, from battery cells to software, and that deep knowledge is very hard to copy. Geely bought Volvo and turned it into real shared engineering, not one-way copying, and patent data confirm it. So the lesson is simple: handed-over technology fades when the cycle turns, while built or co-developed knowledge lasts. Next, the trade-off behind this.</a:t>
+              <a:rPr lang="en-US"/>
+              <a:t>Gemeinsam, Julia </a:t>
+            </a:r>
+            <a:r>
+              <a:rPr lang="en-US" err="1"/>
+              <a:t>startet</a:t>
+            </a:r>
+            <a:r>
+              <a:rPr lang="en-US"/>
+              <a:t>, Chiara </a:t>
+            </a:r>
+            <a:r>
+              <a:rPr lang="en-US" err="1"/>
+              <a:t>endet</a:t>
+            </a:r>
+            <a:r>
+              <a:rPr lang="en-US"/>
+              <a:t> </a:t>
+            </a:r>
+            <a:r>
+              <a:rPr lang="en-US" err="1"/>
+              <a:t>mit</a:t>
+            </a:r>
+            <a:r>
+              <a:rPr lang="en-US"/>
+              <a:t> Fazit: How</a:t>
+            </a:r>
+            <a:r>
+              <a:t> a firm learns shapes what it can build later. SAIC took technology through joint ventures. It worked at first — quality rose about eight percent — but the easy money removed the pressure to invent, so it had no EV platform of its own when the shift came. BYD built everything itself, from battery cells to software, and that deep knowledge is very hard to copy. Geely bought Volvo and turned it into real shared engineering, not one-way copying, and patent data confirm it. So the lesson is simple: handed-over technology fades when the cycle turns, while built or co-developed knowledge lasts. Next, the trade-off behind this.</a:t>
             </a:r>
           </a:p>
         </p:txBody>
@@ -455,7 +495,39 @@
           <a:lstStyle/>
           <a:p>
             <a:r>
-              <a:t>This slide shows the trade-off between speed, depth, and independence. SAIC was the fastest to quality, but shallow and dependent, with no platform of its own. Geely is the rare strong case — fast and deep — because it co-developed with Volvo. BYD was the slowest but the deepest, thirty years from cells to software, and fully its own. The cost of the shallow path is in the bar at the bottom: SAIC's joint-venture plants run at just 14 to 37 percent of capacity. When the technology shifts, there is no platform to fall back on, and the factories sit half empty. Next, the EV transition itself.</a:t>
+              <a:rPr lang="en-US" err="1"/>
+              <a:t>Gemeinsam</a:t>
+            </a:r>
+            <a:r>
+              <a:rPr lang="en-US"/>
+              <a:t>, Julia </a:t>
+            </a:r>
+            <a:r>
+              <a:rPr lang="en-US" err="1"/>
+              <a:t>startet</a:t>
+            </a:r>
+            <a:r>
+              <a:rPr lang="en-US"/>
+              <a:t>, Julia </a:t>
+            </a:r>
+            <a:r>
+              <a:rPr lang="en-US" err="1"/>
+              <a:t>endet</a:t>
+            </a:r>
+            <a:r>
+              <a:rPr lang="en-US"/>
+              <a:t> </a:t>
+            </a:r>
+            <a:r>
+              <a:rPr lang="en-US" err="1"/>
+              <a:t>mit</a:t>
+            </a:r>
+            <a:r>
+              <a:rPr lang="en-US"/>
+              <a:t> Fazit: This</a:t>
+            </a:r>
+            <a:r>
+              <a:t> slide shows the trade-off between speed, depth, and independence. SAIC was the fastest to quality, but shallow and dependent, with no platform of its own. Geely is the rare strong case — fast and deep — because it co-developed with Volvo. BYD was the slowest but the deepest, thirty years from cells to software, and fully its own. The cost of the shallow path is in the bar at the bottom: SAIC's joint-venture plants run at just 14 to 37 percent of capacity. When the technology shifts, there is no platform to fall back on, and the factories sit half empty. Next, the EV transition itself.</a:t>
             </a:r>
           </a:p>
         </p:txBody>
@@ -525,7 +597,35 @@
           <a:lstStyle/>
           <a:p>
             <a:r>
-              <a:t>The EV shift tests every earlier choice. SAIC is the most exposed — its plants run far below capacity — but to be fair, its own brand grew thirty-three percent, with no direct subsidies, and it launched a brand with Huawei. So its future is a race between falling joint-venture income and a thin own-brand margin, and its slow structure sets the pace. BYD is the strongest: no petrol cars since 2022, the world's number one for four years, and exports up one hundred and forty percent. Geely is in between — strong growth, but it leans on partners and carries loss-making brands. Same shock, three different results — exactly what the earlier choices predicted. Now our result.</a:t>
+              <a:rPr lang="en-US"/>
+              <a:t>Gemeinsam, Julia </a:t>
+            </a:r>
+            <a:r>
+              <a:rPr lang="en-US" err="1"/>
+              <a:t>startet</a:t>
+            </a:r>
+            <a:r>
+              <a:rPr lang="en-US"/>
+              <a:t>, Chiara </a:t>
+            </a:r>
+            <a:r>
+              <a:rPr lang="en-US" err="1"/>
+              <a:t>endet</a:t>
+            </a:r>
+            <a:r>
+              <a:rPr lang="en-US"/>
+              <a:t> </a:t>
+            </a:r>
+            <a:r>
+              <a:rPr lang="en-US" err="1"/>
+              <a:t>mit</a:t>
+            </a:r>
+            <a:r>
+              <a:rPr lang="en-US"/>
+              <a:t> Fazit: The</a:t>
+            </a:r>
+            <a:r>
+              <a:t> EV shift tests every earlier choice. SAIC is the most exposed — its plants run far below capacity — but to be fair, its own brand grew thirty-three percent, with no direct subsidies, and it launched a brand with Huawei. So its future is a race between falling joint-venture income and a thin own-brand margin, and its slow structure sets the pace. BYD is the strongest: no petrol cars since 2022, the world's number one for four years, and exports up one hundred and forty percent. Geely is in between — strong growth, but it leans on partners and carries loss-making brands. Same shock, three different results — exactly what the earlier choices predicted. Now our result.</a:t>
             </a:r>
           </a:p>
         </p:txBody>
@@ -595,7 +695,11 @@
           <a:lstStyle/>
           <a:p>
             <a:r>
-              <a:t>Here is our result. Of the three, BYD is the one most likely to create long-term value. The evidence is consistent: the highest return on equity, four years as the top EV maker, and a 5.6-billion-dollar raise that sovereign wealth funds joined. But please notice the wording in the box. It is not that building everything yourself is magic. BYD wins because it combines two things — commercial founder control and a self-financing balance sheet that stays strong in a downturn. That is governance and capital discipline working together. And we stay honest: BYD's own return fell to thirteen percent in 2025 under the price war. Now three lessons that go beyond cars.</a:t>
+              <a:rPr lang="en-US"/>
+              <a:t>Julia: Here</a:t>
+            </a:r>
+            <a:r>
+              <a:t> is our result. Of the three, BYD is the one most likely to create long-term value. The evidence is consistent: the highest return on equity, four years as the top EV maker, and a 5.6-billion-dollar raise that sovereign wealth funds joined. But please notice the wording in the box. It is not that building everything yourself is magic. BYD wins because it combines two things — commercial founder control and a self-financing balance sheet that stays strong in a downturn. That is governance and capital discipline working together. And we stay honest: BYD's own return fell to thirteen percent in 2025 under the price war. Now three lessons that go beyond cars.</a:t>
             </a:r>
           </a:p>
         </p:txBody>
@@ -665,7 +769,11 @@
           <a:lstStyle/>
           <a:p>
             <a:r>
-              <a:t>We draw three lessons for any fast-moving market. One: how you build capability decides how long it lasts. Buying or borrowing technology can hollow out a firm when the technology changes, while building or co-developing keeps the strength. Two: governance sets the speed of change. Commercial owners move fast; split control stalls — and when technology moves faster than your decisions, governance becomes the limit. Three: capital structure decides who survives a downturn. Risk-sharing can trap you, self-financing trades speed for safety, and debt does the opposite. One theme runs through all three: structure decides. Now the conclusion.</a:t>
+              <a:rPr lang="en-US"/>
+              <a:t>Julia: We</a:t>
+            </a:r>
+            <a:r>
+              <a:t> draw three lessons for any fast-moving market. One: how you build capability decides how long it lasts. Buying or borrowing technology can hollow out a firm when the technology changes, while building or co-developing keeps the strength. Two: governance sets the speed of change. Commercial owners move fast; split control stalls — and when technology moves faster than your decisions, governance becomes the limit. Three: capital structure decides who survives a downturn. Risk-sharing can trap you, self-financing trades speed for safety, and debt does the opposite. One theme runs through all three: structure decides. Now the conclusion.</a:t>
             </a:r>
           </a:p>
         </p:txBody>
@@ -735,7 +843,11 @@
           <a:lstStyle/>
           <a:p>
             <a:r>
-              <a:t>Here is the core point. Across all four lenses, structure — more than starting technology — decided the outcome. The joint-venture model did not lose to a better battery; it lost to a better way of allocating control and capital. BYD's founder control plus self-financing proved the most adaptive, while SAIC's state model serves goals beyond profit, which shows up as a lasting discount. So our line, in the box: when technology moves faster than firms can decide, governance is no longer a footnote to strategy — it is strategy. Before questions, a short word on our limits and on how we used AI.</a:t>
+              <a:rPr lang="en-US"/>
+              <a:t>Julia: Here</a:t>
+            </a:r>
+            <a:r>
+              <a:t> is the core point. Across all four lenses, structure — more than starting technology — decided the outcome. The joint-venture model did not lose to a better battery; it lost to a better way of allocating control and capital. BYD's founder control plus self-financing proved the most adaptive, while SAIC's state model serves goals beyond profit, which shows up as a lasting discount. So our line, in the box: when technology moves faster than firms can decide, governance is no longer a footnote to strategy — it is strategy. Before questions, a short word on our limits and on how we used AI.</a:t>
             </a:r>
           </a:p>
         </p:txBody>
@@ -805,7 +917,11 @@
           <a:lstStyle/>
           <a:p>
             <a:r>
-              <a:t>A short, honest word on limits. We study three firms in one industry and one country, so this is deep case work, not a statistical law. The EV shift is still young, so the ranking could change. We rely on reported figures, and the reports mix currencies, which we reconciled carefully. We also left NIO out — a fourth, capital-market model that was beyond our scope. Future work could add NIO, follow these firms over a longer cycle, build a formal governance score, and study how the EU tariffs reshape exports. Now, how we used AI.</a:t>
+              <a:rPr lang="en-US"/>
+              <a:t>Julia: A</a:t>
+            </a:r>
+            <a:r>
+              <a:t> short, honest word on limits. We study three firms in one industry and one country, so this is deep case work, not a statistical law. The EV shift is still young, so the ranking could change. We rely on reported figures, and the reports mix currencies, which we reconciled carefully. We also left NIO out — a fourth, capital-market model that was beyond our scope. Future work could add NIO, follow these firms over a longer cycle, build a formal governance score, and study how the EU tariffs reshape exports. Now, how we used AI.</a:t>
             </a:r>
           </a:p>
         </p:txBody>
@@ -875,7 +991,11 @@
           <a:lstStyle/>
           <a:p>
             <a:r>
-              <a:t>We did not use a simple chatbot. We used Claude Code as a layered system — a main model for most work, a stronger one for the hard analysis, and five small agents, each with one job. But the heart of it is the shared repository you see here. We had one folder for each case and a shared folder for common data, like the EU regulation and the IEA figures. The rule was simple: pull before each session, push after. Because the tool could read all three case wikis at once, we compared the firms directly, with no manual file-sharing. Next, what this actually added.</a:t>
+              <a:rPr lang="en-US"/>
+              <a:t>Batu: We</a:t>
+            </a:r>
+            <a:r>
+              <a:t> did not use a simple chatbot. We used Claude Code as a layered system — a main model for most work, a stronger one for the hard analysis, and five small agents, each with one job. But the heart of it is the shared repository you see here. We had one folder for each case and a shared folder for common data, like the EU regulation and the IEA figures. The rule was simple: pull before each session, push after. Because the tool could read all three case wikis at once, we compared the firms directly, with no manual file-sharing. Next, what this actually added.</a:t>
             </a:r>
           </a:p>
         </p:txBody>
@@ -945,6 +1065,10 @@
           <a:lstStyle/>
           <a:p>
             <a:r>
+              <a:rPr lang="en-US"/>
+              <a:t>Batu: </a:t>
+            </a:r>
+            <a:r>
               <a:t>Where did AI help the most? First, it saved a lot of time — more than thirty papers and reports, all ingested and searchable. Second, it kept us disciplined: every source was rated by quality, and we built our arguments only on the strongest ones. The sharpest habit was to tell it to act like a strict professor, and to quote the exact source for each fact. That same habit caught three real data errors before submission — a wrong tariff, a profit figure inflated ten times, and an earnings figure on the wrong share count — and we fixed all three against the audited reports. Next, the honest limits.</a:t>
             </a:r>
           </a:p>
@@ -1015,7 +1139,11 @@
           <a:lstStyle/>
           <a:p>
             <a:r>
-              <a:t>Now the limits, honestly. It cannot download paywalled PDFs — it knows the papers' content, but we still had to read and check the key claims ourselves. On long sessions we hit memory limits, and the output was often too wordy and needed editing. The lesson is that this is not a chat box — it took time to learn, and every output needed a careful read. The cost was small, about twenty-one euros a month each. The line we held: AI was our tool and our reviewer, never a ghostwriter. The thinking stayed ours. Finally, our sources.</a:t>
+              <a:rPr lang="en-US"/>
+              <a:t>Batu: Now</a:t>
+            </a:r>
+            <a:r>
+              <a:t> the limits, honestly. It cannot download paywalled PDFs — it knows the papers' content, but we still had to read and check the key claims ourselves. On long sessions we hit memory limits, and the output was often too wordy and needed editing. The lesson is that this is not a chat box — it took time to learn, and every output needed a careful read. The cost was small, about twenty-one euros a month each. The line we held: AI was our tool and our reviewer, never a ghostwriter. The thinking stayed ours. Finally, our sources.</a:t>
             </a:r>
           </a:p>
         </p:txBody>
@@ -1085,7 +1213,11 @@
           <a:lstStyle/>
           <a:p>
             <a:r>
-              <a:t>The joint-venture era is ending. Electric cars are now more than half of new sales in China, and Chinese firms make about sixty percent of the world's EVs. For thirty years the deal was simple: foreign firms gave technology, and a state firm gave market access. That worked when the engine and the gearbox were the hard part. Now the hard part is the battery, the power electronics, and the software — and that knowledge sits with the Chinese independents, not the foreign partners. So the old deal no longer helps the joint-venture firms. You can see the stress at SAIC: its profit fell eighty-eight percent in one year. And the EU set very different tariffs — high for SAIC, low for BYD — which tracks how state-dependent each firm is. So the market and the regulator point the same way. Next, our exact question.</a:t>
+              <a:rPr lang="en-US"/>
+              <a:t>Chiara: The</a:t>
+            </a:r>
+            <a:r>
+              <a:t> joint-venture era is ending. Electric cars are now more than half of new sales in China, and Chinese firms make about sixty percent of the world's EVs. For thirty years the deal was simple: foreign firms gave technology, and a state firm gave market access. That worked when the engine and the gearbox were the hard part. Now the hard part is the battery, the power electronics, and the software — and that knowledge sits with the Chinese independents, not the foreign partners. So the old deal no longer helps the joint-venture firms. You can see the stress at SAIC: its profit fell eighty-eight percent in one year. And the EU set very different tariffs — high for SAIC, low for BYD — which tracks how state-dependent each firm is. So the market and the regulator point the same way. Next, our exact question.</a:t>
             </a:r>
           </a:p>
         </p:txBody>
@@ -1155,7 +1287,25 @@
           <a:lstStyle/>
           <a:p>
             <a:r>
-              <a:t>These are our main sources, in APA style. The theory comes from Shleifer and Vishny, Jensen and Meckling, and Teece; the China evidence from Bai, Howell, and Holmes. The figures come from the audited annual reports of all three firms, plus the EU regulation and the IEA outlook. The full list is in the paper. Thank you very much for your attention — we are happy to take your questions.</a:t>
+              <a:rPr lang="en-US"/>
+              <a:t>Batu: These</a:t>
+            </a:r>
+            <a:r>
+              <a:t> are our main sources</a:t>
+            </a:r>
+            <a:r>
+              <a:rPr lang="en-US"/>
+              <a:t>.</a:t>
+            </a:r>
+            <a:r>
+              <a:t> The theory comes from Shleifer and </a:t>
+            </a:r>
+            <a:r>
+              <a:rPr err="1"/>
+              <a:t>Vishny</a:t>
+            </a:r>
+            <a:r>
+              <a:t>, Jensen and Meckling, and Teece; the China evidence from Bai, Howell, and Holmes. The figures come from the audited annual reports of all three firms, plus the EU regulation and the IEA outlook. Thank you very much for your attention — we are happy to take your questions.</a:t>
             </a:r>
           </a:p>
         </p:txBody>
@@ -1225,7 +1375,11 @@
           <a:lstStyle/>
           <a:p>
             <a:r>
-              <a:t>Our question is short but hard: which structure builds the most value over time? We study three firms with three paths. SAIC is state-owned, controlled by the asset commission SASAC. BYD is founder-led, run by Wang Chuanfu. Geely is also founder-led, under Li Shufu, but it grew by buying firms abroad, like Volvo. To keep it fair, we look at all three through the same four lenses — governance, financing, capability, and viability — in the same order. So we compare one structural choice at a time, not three separate company stories. Our thesis is at the bottom: structure beats starting technology. Now the theory behind these lenses.</a:t>
+              <a:rPr lang="en-US"/>
+              <a:t>Chiara: Our</a:t>
+            </a:r>
+            <a:r>
+              <a:t> question is short but hard: which structure builds the most value over time? We study three firms with three paths. SAIC is state-owned, controlled by the asset commission SASAC. BYD is founder-led, run by Wang Chuanfu. Geely is also founder-led, under Li Shufu, but it grew by buying firms abroad, like Volvo. To keep it fair, we look at all three through the same four lenses — governance, financing, capability, and viability — in the same order. So we compare one structural choice at a time, not three separate company stories. Our thesis is at the bottom: structure beats starting technology. Now the theory behind these lenses.</a:t>
             </a:r>
           </a:p>
         </p:txBody>
@@ -1295,7 +1449,11 @@
           <a:lstStyle/>
           <a:p>
             <a:r>
-              <a:t>Six well-known ideas all point the same way. Shleifer and Vishny say that in a state firm, control sends money to political goals, not to shareholders. Megginson and Netter show that private firms beat state firms. Jensen and Meckling explain the good case: a strong founder-owner removes the conflict between owners and managers. Holmes and Fan describe the joint-venture trade and its hidden cost — connected firms lag about eighteen percent after listing. Luo and Tung explain why an emerging-market firm buys abroad: to catch up quickly. And Teece explains why deep in-house knowledge is so hard for rivals to copy. So the prediction is clear before we even look at the data: founder control should adapt faster and create more value. Next, our map.</a:t>
+              <a:rPr lang="en-US"/>
+              <a:t>Chiara: Six</a:t>
+            </a:r>
+            <a:r>
+              <a:t> well-known ideas all point the same way. Shleifer and Vishny say that in a state firm, control sends money to political goals, not to shareholders. Megginson and Netter show that private firms beat state firms. Jensen and Meckling explain the good case: a strong founder-owner removes the conflict between owners and managers. Holmes and Fan describe the joint-venture trade and its hidden cost — connected firms lag about eighteen percent after listing. Luo and Tung explain why an emerging-market firm buys abroad: to catch up quickly. And Teece explains why deep in-house knowledge is so hard for rivals to copy. So the prediction is clear before we even look at the data: founder control should adapt faster and create more value. Next, our map.</a:t>
             </a:r>
           </a:p>
         </p:txBody>
@@ -1365,7 +1523,11 @@
           <a:lstStyle/>
           <a:p>
             <a:r>
-              <a:t>This matrix is the map for the whole talk. The rows are the three firms, and the columns are the four lenses. Read across a row for one firm's full profile; read down a column to compare the firms on one topic. The key point is that the columns are linked. SAIC is state-led, capital-light, dependent on transferred technology, and weakest in the EV shift — and those four cells belong together. BYD shows the opposite pattern straight across, and Geely is in between. Over the next slides we go column by column with the evidence behind each cell. We start with governance.</a:t>
+              <a:rPr lang="en-US"/>
+              <a:t>Chiara: This</a:t>
+            </a:r>
+            <a:r>
+              <a:t> matrix is the map for the whole talk. The rows are the three firms, and the columns are the four lenses. Read across a row for one firm's full profile; read down a column to compare the firms on one topic. The key point is that the columns are linked. SAIC is state-led, capital-light, dependent on transferred technology, and weakest in the EV shift — and those four cells belong together. BYD shows the opposite pattern straight across, and Geely is in between. Over the next slides we go column by column with the evidence behind each cell. We start with governance.</a:t>
             </a:r>
           </a:p>
         </p:txBody>
@@ -1435,7 +1597,32 @@
           <a:lstStyle/>
           <a:p>
             <a:r>
-              <a:t>Governance is really two questions: who holds control, and what they want. SAIC sits under the state — SASAC owns about seventy-three percent, and the Party role is written into the charter, so its goals go beyond profit, to things like jobs and policy. The cost is speed: it cannot leave a failing joint venture without state approval. BYD is the opposite — the founder and his team hold over a third of the votes, so Wang could end petrol-car production in one year, in 2022, on his own. Geely is also founder-led and fast on deals, but it runs many brands, and some of them lose money. So control runs on a scale, from political at SAIC to fully commercial at BYD. Next, the EU put a real price on this difference.</a:t>
+              <a:rPr lang="en-US" dirty="0" err="1"/>
+              <a:t>Gemeinsam</a:t>
+            </a:r>
+            <a:r>
+              <a:rPr lang="en-US" dirty="0"/>
+              <a:t>, Julia </a:t>
+            </a:r>
+            <a:r>
+              <a:rPr lang="en-US" dirty="0" err="1"/>
+              <a:t>startet</a:t>
+            </a:r>
+            <a:r>
+              <a:rPr lang="en-US" dirty="0"/>
+              <a:t>, Chiara </a:t>
+            </a:r>
+            <a:r>
+              <a:rPr lang="en-US"/>
+              <a:t>endet: </a:t>
+            </a:r>
+            <a:r>
+              <a:rPr lang="en-US" dirty="0"/>
+              <a:t>Governance</a:t>
+            </a:r>
+            <a:r>
+              <a:rPr dirty="0"/>
+              <a:t> is really two questions: who holds control, and what they want. SAIC sits under the state — SASAC owns about seventy-three percent, and the Party role is written into the charter, so its goals go beyond profit, to things like jobs and policy. The cost is speed: it cannot leave a failing joint venture without state approval. BYD is the opposite — the founder and his team hold over a third of the votes, so Wang could end petrol-car production in one year, in 2022, on his own. Geely is also founder-led and fast on deals, but it runs many brands, and some of them lose money. So control runs on a scale, from political at SAIC to fully commercial at BYD. Next, the EU put a real price on this difference.</a:t>
             </a:r>
           </a:p>
         </p:txBody>
@@ -1505,7 +1692,11 @@
           <a:lstStyle/>
           <a:p>
             <a:r>
-              <a:t>Here is proof from outside the firms. The EU studied state support and set tariffs: 35.3 percent for SAIC, 17 for BYD, and 18.8 for Geely. That gap is not about car quality — it is about state dependence. For SAIC the Commission even used “facts available,” because the group held back some financing data. So a neutral regulator reached the same conclusion we reach from the inside: control structure drives competitive position. And for a firm that wants to grow through exports, that tariff is a direct, lasting cost of the governance model it chose. Now we follow the money.</a:t>
+              <a:rPr lang="en-US"/>
+              <a:t>Julia: Here</a:t>
+            </a:r>
+            <a:r>
+              <a:t> is proof from outside the firms. The EU studied state support and set tariffs: 35.3 percent for SAIC, 17 for BYD, and 18.8 for Geely. That gap is not about car quality — it is about state dependence. For SAIC the Commission even used “facts available,” because the group held back some financing data. So a neutral regulator reached the same conclusion we reach from the inside: control structure drives competitive position. And for a firm that wants to grow through exports, that tariff is a direct, lasting cost of the governance model it chose. Now we follow the money.</a:t>
             </a:r>
           </a:p>
         </p:txBody>
@@ -1575,7 +1766,55 @@
           <a:lstStyle/>
           <a:p>
             <a:r>
-              <a:t>Each firm funds its growth differently, and the difference shows up in a downturn. SAIC was capital-light: it shared cost and risk with its foreign partners. That felt safe — until SAIC-GM lost more than half its sales, and SAIC was still bound to absorb the losses, with no control to fix the business. Profit fell eighty-eight percent; the capital-light model had become a capital trap. BYD funds itself from its own cash, and it spends more on research than it earns in profit, so it needs no banks; the limit is its own cash flow. Geely borrows to buy capability fast — that is how it got Volvo — but its debt is rising. So the real choice is resilience versus speed. Next, the numbers.</a:t>
+              <a:rPr lang="en-US" err="1"/>
+              <a:t>Gemeinsam</a:t>
+            </a:r>
+            <a:r>
+              <a:rPr lang="en-US"/>
+              <a:t>, Julia </a:t>
+            </a:r>
+            <a:r>
+              <a:rPr lang="en-US" err="1"/>
+              <a:t>startet</a:t>
+            </a:r>
+            <a:r>
+              <a:rPr lang="en-US"/>
+              <a:t>, Chiara </a:t>
+            </a:r>
+            <a:r>
+              <a:rPr lang="en-US" err="1"/>
+              <a:t>endet</a:t>
+            </a:r>
+            <a:r>
+              <a:rPr lang="en-US"/>
+              <a:t> </a:t>
+            </a:r>
+            <a:r>
+              <a:rPr lang="en-US" err="1"/>
+              <a:t>mit</a:t>
+            </a:r>
+            <a:r>
+              <a:rPr lang="en-US"/>
+              <a:t> </a:t>
+            </a:r>
+            <a:r>
+              <a:rPr lang="en-US" err="1"/>
+              <a:t>unterem</a:t>
+            </a:r>
+            <a:r>
+              <a:rPr lang="en-US"/>
+              <a:t> </a:t>
+            </a:r>
+            <a:r>
+              <a:rPr lang="en-US" err="1"/>
+              <a:t>Fazit</a:t>
+            </a:r>
+            <a:r>
+              <a:rPr lang="en-US"/>
+              <a:t>: Each</a:t>
+            </a:r>
+            <a:r>
+              <a:t> firm funds its growth differently, and the difference shows up in a downturn. SAIC was capital-light: it shared cost and risk with its foreign partners. That felt safe — until SAIC-GM lost more than half its sales, and SAIC was still bound to absorb the losses, with no control to fix the business. Profit fell eighty-eight percent; the capital-light model had become a capital trap. BYD funds itself from its own cash, and it spends more on research than it earns in profit, so it needs no banks; the limit is its own cash flow. Geely borrows to buy capability fast — that is how it got Volvo — but its debt is rising. So the real choice is resilience versus speed. Next, the numbers.</a:t>
             </a:r>
           </a:p>
         </p:txBody>
@@ -1645,7 +1884,18 @@
           <a:lstStyle/>
           <a:p>
             <a:r>
-              <a:t>Here are the numbers in one table. Look at return on equity: BYD and Geely are near twenty percent, while SAIC is below one — that single line tells the story. Research spending: BYD spends more on R&amp;D than it earns in profit. Cash flow: BYD generates far more than the other two. One honest note on SAIC: its profit looks like it recovered in 2025, but that is mostly because the big write-downs of 2024 did not repeat — the business stabilised, it did not really turn around. And the bottom row, the EU tariff, marks the same governance gap once more. Next, how each firm builds its technology.</a:t>
+              <a:rPr lang="en-US"/>
+              <a:t>Batu: Here</a:t>
+            </a:r>
+            <a:r>
+              <a:t> are the numbers in one table. Look at return on equity: BYD and Geely are near twenty percent, while SAIC is below one — that single line tells the story. Research spending: BYD spends more on R&amp;D than it earns in profit. Cash flow: BYD generates far more than the other two. One honest note on SAIC: its profit looks like it recovered in 2025, but that is mostly because the big write-downs of 2024 did not repeat — the business </a:t>
+            </a:r>
+            <a:r>
+              <a:rPr err="1"/>
+              <a:t>stabilised</a:t>
+            </a:r>
+            <a:r>
+              <a:t>, it did not really turn around. And the bottom row, the EU tariff, marks the same governance gap once more. Next, how each firm builds its technology.</a:t>
             </a:r>
           </a:p>
         </p:txBody>
@@ -1849,7 +2099,7 @@
           <a:p>
             <a:fld id="{5BCAD085-E8A6-8845-BD4E-CB4CCA059FC4}" type="datetimeFigureOut">
               <a:rPr lang="en-US" smtClean="0"/>
-              <a:t>6/29/2026</a:t>
+              <a:t>7/3/2026</a:t>
             </a:fld>
             <a:endParaRPr lang="en-US"/>
           </a:p>
@@ -2017,7 +2267,7 @@
           <a:p>
             <a:fld id="{5BCAD085-E8A6-8845-BD4E-CB4CCA059FC4}" type="datetimeFigureOut">
               <a:rPr lang="en-US" smtClean="0"/>
-              <a:t>6/29/2026</a:t>
+              <a:t>7/3/2026</a:t>
             </a:fld>
             <a:endParaRPr lang="en-US"/>
           </a:p>
@@ -2195,7 +2445,7 @@
           <a:p>
             <a:fld id="{5BCAD085-E8A6-8845-BD4E-CB4CCA059FC4}" type="datetimeFigureOut">
               <a:rPr lang="en-US" smtClean="0"/>
-              <a:t>6/29/2026</a:t>
+              <a:t>7/3/2026</a:t>
             </a:fld>
             <a:endParaRPr lang="en-US"/>
           </a:p>
@@ -2363,7 +2613,7 @@
           <a:p>
             <a:fld id="{5BCAD085-E8A6-8845-BD4E-CB4CCA059FC4}" type="datetimeFigureOut">
               <a:rPr lang="en-US" smtClean="0"/>
-              <a:t>6/29/2026</a:t>
+              <a:t>7/3/2026</a:t>
             </a:fld>
             <a:endParaRPr lang="en-US"/>
           </a:p>
@@ -2608,7 +2858,7 @@
           <a:p>
             <a:fld id="{5BCAD085-E8A6-8845-BD4E-CB4CCA059FC4}" type="datetimeFigureOut">
               <a:rPr lang="en-US" smtClean="0"/>
-              <a:t>6/29/2026</a:t>
+              <a:t>7/3/2026</a:t>
             </a:fld>
             <a:endParaRPr lang="en-US"/>
           </a:p>
@@ -2893,7 +3143,7 @@
           <a:p>
             <a:fld id="{5BCAD085-E8A6-8845-BD4E-CB4CCA059FC4}" type="datetimeFigureOut">
               <a:rPr lang="en-US" smtClean="0"/>
-              <a:t>6/29/2026</a:t>
+              <a:t>7/3/2026</a:t>
             </a:fld>
             <a:endParaRPr lang="en-US"/>
           </a:p>
@@ -3312,7 +3562,7 @@
           <a:p>
             <a:fld id="{5BCAD085-E8A6-8845-BD4E-CB4CCA059FC4}" type="datetimeFigureOut">
               <a:rPr lang="en-US" smtClean="0"/>
-              <a:t>6/29/2026</a:t>
+              <a:t>7/3/2026</a:t>
             </a:fld>
             <a:endParaRPr lang="en-US"/>
           </a:p>
@@ -3429,7 +3679,7 @@
           <a:p>
             <a:fld id="{5BCAD085-E8A6-8845-BD4E-CB4CCA059FC4}" type="datetimeFigureOut">
               <a:rPr lang="en-US" smtClean="0"/>
-              <a:t>6/29/2026</a:t>
+              <a:t>7/3/2026</a:t>
             </a:fld>
             <a:endParaRPr lang="en-US"/>
           </a:p>
@@ -3524,7 +3774,7 @@
           <a:p>
             <a:fld id="{5BCAD085-E8A6-8845-BD4E-CB4CCA059FC4}" type="datetimeFigureOut">
               <a:rPr lang="en-US" smtClean="0"/>
-              <a:t>6/29/2026</a:t>
+              <a:t>7/3/2026</a:t>
             </a:fld>
             <a:endParaRPr lang="en-US"/>
           </a:p>
@@ -3799,7 +4049,7 @@
           <a:p>
             <a:fld id="{5BCAD085-E8A6-8845-BD4E-CB4CCA059FC4}" type="datetimeFigureOut">
               <a:rPr lang="en-US" smtClean="0"/>
-              <a:t>6/29/2026</a:t>
+              <a:t>7/3/2026</a:t>
             </a:fld>
             <a:endParaRPr lang="en-US"/>
           </a:p>
@@ -4051,7 +4301,7 @@
           <a:p>
             <a:fld id="{5BCAD085-E8A6-8845-BD4E-CB4CCA059FC4}" type="datetimeFigureOut">
               <a:rPr lang="en-US" smtClean="0"/>
-              <a:t>6/29/2026</a:t>
+              <a:t>7/3/2026</a:t>
             </a:fld>
             <a:endParaRPr lang="en-US"/>
           </a:p>
@@ -4262,7 +4512,7 @@
           <a:p>
             <a:fld id="{5BCAD085-E8A6-8845-BD4E-CB4CCA059FC4}" type="datetimeFigureOut">
               <a:rPr lang="en-US" smtClean="0"/>
-              <a:t>6/29/2026</a:t>
+              <a:t>7/3/2026</a:t>
             </a:fld>
             <a:endParaRPr lang="en-US"/>
           </a:p>
@@ -5617,7 +5867,7 @@
         <p:spPr>
           <a:xfrm>
             <a:off x="713232" y="2167128"/>
-            <a:ext cx="3264408" cy="548640"/>
+            <a:ext cx="3264408" cy="278987"/>
           </a:xfrm>
           <a:prstGeom prst="rect">
             <a:avLst/>
@@ -5630,25 +5880,40 @@
           </a:bodyPr>
           <a:lstStyle/>
           <a:p>
-            <a:pPr algn="l">
+            <a:pPr>
               <a:lnSpc>
                 <a:spcPct val="98000"/>
               </a:lnSpc>
-              <a:spcBef>
-                <a:spcPts val="0"/>
-              </a:spcBef>
               <a:spcAft>
                 <a:spcPts val="200"/>
               </a:spcAft>
             </a:pPr>
             <a:r>
-              <a:rPr sz="1855" b="1" i="0" dirty="0">
+              <a:rPr sz="1850" b="1" i="0">
                 <a:solidFill>
                   <a:srgbClr val="DC2626"/>
                 </a:solidFill>
                 <a:latin typeface="Arial"/>
               </a:rPr>
-              <a:t>SAIC — mandatory transfer</a:t>
+              <a:t>SAIC </a:t>
+            </a:r>
+            <a:r>
+              <a:rPr lang="en-US" sz="1850" b="1">
+                <a:solidFill>
+                  <a:srgbClr val="DC2626"/>
+                </a:solidFill>
+                <a:latin typeface="Arial"/>
+              </a:rPr>
+              <a:t>- </a:t>
+            </a:r>
+            <a:r>
+              <a:rPr sz="1850" b="1" i="0">
+                <a:solidFill>
+                  <a:srgbClr val="DC2626"/>
+                </a:solidFill>
+                <a:latin typeface="Arial"/>
+              </a:rPr>
+              <a:t>mandatory transfer</a:t>
             </a:r>
           </a:p>
         </p:txBody>
@@ -5688,7 +5953,7 @@
               <a:buNone/>
             </a:pPr>
             <a:r>
-              <a:rPr sz="1565" dirty="0">
+              <a:rPr sz="1565">
                 <a:solidFill>
                   <a:srgbClr val="DC2626"/>
                 </a:solidFill>
@@ -5697,7 +5962,7 @@
               <a:t>–  </a:t>
             </a:r>
             <a:r>
-              <a:rPr sz="1565" dirty="0">
+              <a:rPr sz="1565">
                 <a:solidFill>
                   <a:srgbClr val="0F172A"/>
                 </a:solidFill>
@@ -5720,7 +5985,7 @@
               <a:buNone/>
             </a:pPr>
             <a:r>
-              <a:rPr sz="1565" dirty="0">
+              <a:rPr sz="1565">
                 <a:solidFill>
                   <a:srgbClr val="DC2626"/>
                 </a:solidFill>
@@ -5729,7 +5994,7 @@
               <a:t>–  </a:t>
             </a:r>
             <a:r>
-              <a:rPr sz="1565" dirty="0">
+              <a:rPr sz="1565">
                 <a:solidFill>
                   <a:srgbClr val="0F172A"/>
                 </a:solidFill>
@@ -5752,7 +6017,7 @@
               <a:buNone/>
             </a:pPr>
             <a:r>
-              <a:rPr sz="1565" dirty="0">
+              <a:rPr sz="1565">
                 <a:solidFill>
                   <a:srgbClr val="DC2626"/>
                 </a:solidFill>
@@ -5761,7 +6026,7 @@
               <a:t>–  </a:t>
             </a:r>
             <a:r>
-              <a:rPr sz="1565" dirty="0">
+              <a:rPr sz="1565">
                 <a:solidFill>
                   <a:srgbClr val="0F172A"/>
                 </a:solidFill>
@@ -5873,7 +6138,7 @@
         <p:spPr>
           <a:xfrm>
             <a:off x="4443984" y="2167128"/>
-            <a:ext cx="3264408" cy="548640"/>
+            <a:ext cx="3264408" cy="278987"/>
           </a:xfrm>
           <a:prstGeom prst="rect">
             <a:avLst/>
@@ -5886,25 +6151,40 @@
           </a:bodyPr>
           <a:lstStyle/>
           <a:p>
-            <a:pPr algn="l">
+            <a:pPr>
               <a:lnSpc>
                 <a:spcPct val="98000"/>
               </a:lnSpc>
-              <a:spcBef>
-                <a:spcPts val="0"/>
-              </a:spcBef>
               <a:spcAft>
                 <a:spcPts val="200"/>
               </a:spcAft>
             </a:pPr>
             <a:r>
-              <a:rPr sz="1855" b="1" i="0" dirty="0">
+              <a:rPr sz="1850" b="1" i="0">
                 <a:solidFill>
                   <a:srgbClr val="2563EB"/>
                 </a:solidFill>
                 <a:latin typeface="Arial"/>
               </a:rPr>
-              <a:t>BYD — organic build</a:t>
+              <a:t>BYD </a:t>
+            </a:r>
+            <a:r>
+              <a:rPr lang="en-US" sz="1850" b="1">
+                <a:solidFill>
+                  <a:srgbClr val="2563EB"/>
+                </a:solidFill>
+                <a:latin typeface="Arial"/>
+              </a:rPr>
+              <a:t>- </a:t>
+            </a:r>
+            <a:r>
+              <a:rPr sz="1850" b="1" i="0">
+                <a:solidFill>
+                  <a:srgbClr val="2563EB"/>
+                </a:solidFill>
+                <a:latin typeface="Arial"/>
+              </a:rPr>
+              <a:t>organic build</a:t>
             </a:r>
           </a:p>
         </p:txBody>
@@ -5944,7 +6224,7 @@
               <a:buNone/>
             </a:pPr>
             <a:r>
-              <a:rPr sz="1565" dirty="0">
+              <a:rPr sz="1565">
                 <a:solidFill>
                   <a:srgbClr val="2563EB"/>
                 </a:solidFill>
@@ -5953,7 +6233,7 @@
               <a:t>–  </a:t>
             </a:r>
             <a:r>
-              <a:rPr sz="1565" dirty="0">
+              <a:rPr sz="1565">
                 <a:solidFill>
                   <a:srgbClr val="0F172A"/>
                 </a:solidFill>
@@ -5976,7 +6256,7 @@
               <a:buNone/>
             </a:pPr>
             <a:r>
-              <a:rPr sz="1565" dirty="0">
+              <a:rPr sz="1565">
                 <a:solidFill>
                   <a:srgbClr val="2563EB"/>
                 </a:solidFill>
@@ -5985,7 +6265,7 @@
               <a:t>–  </a:t>
             </a:r>
             <a:r>
-              <a:rPr sz="1565" dirty="0">
+              <a:rPr sz="1565">
                 <a:solidFill>
                   <a:srgbClr val="0F172A"/>
                 </a:solidFill>
@@ -6008,7 +6288,7 @@
               <a:buNone/>
             </a:pPr>
             <a:r>
-              <a:rPr sz="1565" dirty="0">
+              <a:rPr sz="1565">
                 <a:solidFill>
                   <a:srgbClr val="2563EB"/>
                 </a:solidFill>
@@ -6017,7 +6297,7 @@
               <a:t>–  </a:t>
             </a:r>
             <a:r>
-              <a:rPr sz="1565" dirty="0">
+              <a:rPr sz="1565">
                 <a:solidFill>
                   <a:srgbClr val="0F172A"/>
                 </a:solidFill>
@@ -6142,36 +6422,51 @@
           </a:bodyPr>
           <a:lstStyle/>
           <a:p>
-            <a:pPr algn="l">
+            <a:pPr>
               <a:lnSpc>
                 <a:spcPct val="98000"/>
               </a:lnSpc>
-              <a:spcBef>
-                <a:spcPts val="0"/>
-              </a:spcBef>
               <a:spcAft>
                 <a:spcPts val="200"/>
               </a:spcAft>
             </a:pPr>
             <a:r>
-              <a:rPr sz="1855" b="1" i="0" dirty="0">
+              <a:rPr sz="1850" b="1" i="0">
                 <a:solidFill>
                   <a:srgbClr val="06B6D4"/>
                 </a:solidFill>
                 <a:latin typeface="Arial"/>
               </a:rPr>
-              <a:t>Geely — acquisition + co-dev</a:t>
-            </a:r>
-            <a:r>
-              <a:rPr lang="de-DE" sz="1855" b="1" i="0" dirty="0" err="1">
+              <a:t>Geely </a:t>
+            </a:r>
+            <a:r>
+              <a:rPr lang="en-US" sz="1850" b="1">
                 <a:solidFill>
                   <a:srgbClr val="06B6D4"/>
                 </a:solidFill>
                 <a:latin typeface="Arial"/>
               </a:rPr>
+              <a:t>- </a:t>
+            </a:r>
+            <a:r>
+              <a:rPr sz="1850" b="1" i="0">
+                <a:solidFill>
+                  <a:srgbClr val="06B6D4"/>
+                </a:solidFill>
+                <a:latin typeface="Arial"/>
+              </a:rPr>
+              <a:t>acquisition + co-dev</a:t>
+            </a:r>
+            <a:r>
+              <a:rPr lang="de-DE" sz="1850" b="1" i="0" err="1">
+                <a:solidFill>
+                  <a:srgbClr val="06B6D4"/>
+                </a:solidFill>
+                <a:latin typeface="Arial"/>
+              </a:rPr>
               <a:t>elopment</a:t>
             </a:r>
-            <a:endParaRPr sz="1855" b="1" i="0" dirty="0">
+            <a:endParaRPr sz="1850" b="1" i="0">
               <a:solidFill>
                 <a:srgbClr val="06B6D4"/>
               </a:solidFill>
@@ -6215,7 +6510,7 @@
               <a:buNone/>
             </a:pPr>
             <a:r>
-              <a:rPr sz="1565" dirty="0">
+              <a:rPr sz="1565">
                 <a:solidFill>
                   <a:srgbClr val="06B6D4"/>
                 </a:solidFill>
@@ -6224,7 +6519,7 @@
               <a:t>–  </a:t>
             </a:r>
             <a:r>
-              <a:rPr sz="1565" dirty="0">
+              <a:rPr sz="1565">
                 <a:solidFill>
                   <a:srgbClr val="0F172A"/>
                 </a:solidFill>
@@ -6247,7 +6542,7 @@
               <a:buNone/>
             </a:pPr>
             <a:r>
-              <a:rPr sz="1565" dirty="0">
+              <a:rPr sz="1565">
                 <a:solidFill>
                   <a:srgbClr val="06B6D4"/>
                 </a:solidFill>
@@ -6256,7 +6551,7 @@
               <a:t>–  </a:t>
             </a:r>
             <a:r>
-              <a:rPr sz="1565" dirty="0">
+              <a:rPr sz="1565">
                 <a:solidFill>
                   <a:srgbClr val="0F172A"/>
                 </a:solidFill>
@@ -6279,7 +6574,7 @@
               <a:buNone/>
             </a:pPr>
             <a:r>
-              <a:rPr sz="1565" dirty="0">
+              <a:rPr sz="1565">
                 <a:solidFill>
                   <a:srgbClr val="06B6D4"/>
                 </a:solidFill>
@@ -6288,7 +6583,7 @@
               <a:t>–  </a:t>
             </a:r>
             <a:r>
-              <a:rPr sz="1565" dirty="0">
+              <a:rPr sz="1565">
                 <a:solidFill>
                   <a:srgbClr val="0F172A"/>
                 </a:solidFill>
@@ -6333,7 +6628,7 @@
               </a:spcAft>
             </a:pPr>
             <a:r>
-              <a:rPr sz="1623" b="1" i="0" dirty="0">
+              <a:rPr sz="1623" b="1" i="0">
                 <a:solidFill>
                   <a:srgbClr val="0F172A"/>
                 </a:solidFill>
@@ -6378,7 +6673,7 @@
               </a:spcAft>
             </a:pPr>
             <a:r>
-              <a:rPr sz="1276" b="0" i="1" dirty="0">
+              <a:rPr sz="1276" b="0" i="1">
                 <a:solidFill>
                   <a:srgbClr val="64748B"/>
                 </a:solidFill>
@@ -6945,7 +7240,7 @@
               </a:spcAft>
             </a:pPr>
             <a:r>
-              <a:rPr sz="1565" b="0" i="0" dirty="0">
+              <a:rPr sz="1565" b="0" i="0">
                 <a:solidFill>
                   <a:srgbClr val="0F172A"/>
                 </a:solidFill>
@@ -6954,7 +7249,7 @@
               <a:t>Fastest to quality (+8.3%)</a:t>
             </a:r>
             <a:r>
-              <a:rPr lang="de-DE" sz="1565" b="0" i="0" dirty="0">
+              <a:rPr lang="de-DE" sz="1565" b="0" i="0">
                 <a:solidFill>
                   <a:srgbClr val="0F172A"/>
                 </a:solidFill>
@@ -6963,7 +7258,7 @@
               <a:t>, </a:t>
             </a:r>
             <a:r>
-              <a:rPr sz="1565" b="0" i="0" dirty="0">
+              <a:rPr sz="1565" b="0" i="0">
                 <a:solidFill>
                   <a:srgbClr val="0F172A"/>
                 </a:solidFill>
@@ -7417,7 +7712,7 @@
               </a:spcAft>
             </a:pPr>
             <a:r>
-              <a:rPr sz="1565" b="0" i="0" dirty="0">
+              <a:rPr sz="1565" b="0" i="0">
                 <a:solidFill>
                   <a:srgbClr val="0F172A"/>
                 </a:solidFill>
@@ -7426,7 +7721,7 @@
               <a:t>30 years from cells to software</a:t>
             </a:r>
             <a:r>
-              <a:rPr lang="de-DE" sz="1565" b="0" i="0" dirty="0">
+              <a:rPr lang="de-DE" sz="1565" b="0" i="0">
                 <a:solidFill>
                   <a:srgbClr val="0F172A"/>
                 </a:solidFill>
@@ -7435,7 +7730,7 @@
               <a:t>;</a:t>
             </a:r>
             <a:r>
-              <a:rPr sz="1565" b="0" i="0" dirty="0">
+              <a:rPr sz="1565" b="0" i="0">
                 <a:solidFill>
                   <a:srgbClr val="0F172A"/>
                 </a:solidFill>
@@ -7480,7 +7775,7 @@
               </a:spcAft>
             </a:pPr>
             <a:r>
-              <a:rPr sz="1623" b="1" dirty="0">
+              <a:rPr sz="1623" b="1">
                 <a:solidFill>
                   <a:srgbClr val="0F172A"/>
                 </a:solidFill>
@@ -7489,7 +7784,7 @@
               <a:t>The proof: SAIC-GM plants run at just 37% capacity and VW's MEB plant at 14% (2025)</a:t>
             </a:r>
             <a:r>
-              <a:rPr lang="de-DE" sz="1623" b="1" dirty="0">
+              <a:rPr lang="de-DE" sz="1623" b="1">
                 <a:solidFill>
                   <a:srgbClr val="0F172A"/>
                 </a:solidFill>
@@ -7498,7 +7793,7 @@
               <a:t>; </a:t>
             </a:r>
             <a:r>
-              <a:rPr sz="1623" b="1" dirty="0">
+              <a:rPr sz="1623" b="1">
                 <a:solidFill>
                   <a:srgbClr val="0F172A"/>
                 </a:solidFill>
@@ -7995,7 +8290,7 @@
         <p:spPr>
           <a:xfrm>
             <a:off x="713232" y="2167128"/>
-            <a:ext cx="3264408" cy="548640"/>
+            <a:ext cx="3264408" cy="278987"/>
           </a:xfrm>
           <a:prstGeom prst="rect">
             <a:avLst/>
@@ -8020,13 +8315,31 @@
               </a:spcAft>
             </a:pPr>
             <a:r>
-              <a:rPr sz="1855" b="1" i="0">
+              <a:rPr sz="1850" b="1" i="0">
                 <a:solidFill>
                   <a:srgbClr val="DC2626"/>
                 </a:solidFill>
                 <a:latin typeface="Arial"/>
               </a:rPr>
-              <a:t>SAIC — most exposed</a:t>
+              <a:t>SAIC </a:t>
+            </a:r>
+            <a:r>
+              <a:rPr lang="en-US" sz="1850" b="1">
+                <a:solidFill>
+                  <a:srgbClr val="DC2626"/>
+                </a:solidFill>
+                <a:latin typeface="Arial"/>
+              </a:rPr>
+              <a:t>-</a:t>
+            </a:r>
+            <a:r>
+              <a:rPr sz="1850" b="1" i="0">
+                <a:solidFill>
+                  <a:srgbClr val="DC2626"/>
+                </a:solidFill>
+                <a:latin typeface="Arial"/>
+              </a:rPr>
+              <a:t> most exposed</a:t>
             </a:r>
           </a:p>
         </p:txBody>
@@ -8251,7 +8564,7 @@
         <p:spPr>
           <a:xfrm>
             <a:off x="4443984" y="2167128"/>
-            <a:ext cx="3264408" cy="548640"/>
+            <a:ext cx="3264408" cy="278987"/>
           </a:xfrm>
           <a:prstGeom prst="rect">
             <a:avLst/>
@@ -8264,25 +8577,40 @@
           </a:bodyPr>
           <a:lstStyle/>
           <a:p>
-            <a:pPr algn="l">
+            <a:pPr>
               <a:lnSpc>
                 <a:spcPct val="98000"/>
               </a:lnSpc>
-              <a:spcBef>
-                <a:spcPts val="0"/>
-              </a:spcBef>
               <a:spcAft>
                 <a:spcPts val="200"/>
               </a:spcAft>
             </a:pPr>
             <a:r>
-              <a:rPr sz="1855" b="1" i="0">
+              <a:rPr sz="1850" b="1" i="0">
                 <a:solidFill>
                   <a:srgbClr val="2563EB"/>
                 </a:solidFill>
                 <a:latin typeface="Arial"/>
               </a:rPr>
-              <a:t>BYD — strongest position</a:t>
+              <a:t>BYD </a:t>
+            </a:r>
+            <a:r>
+              <a:rPr lang="en-US" sz="1850" b="1">
+                <a:solidFill>
+                  <a:srgbClr val="2563EB"/>
+                </a:solidFill>
+                <a:latin typeface="Arial"/>
+              </a:rPr>
+              <a:t>- </a:t>
+            </a:r>
+            <a:r>
+              <a:rPr sz="1850" b="1" i="0">
+                <a:solidFill>
+                  <a:srgbClr val="2563EB"/>
+                </a:solidFill>
+                <a:latin typeface="Arial"/>
+              </a:rPr>
+              <a:t>strongest position</a:t>
             </a:r>
           </a:p>
         </p:txBody>
@@ -8507,7 +8835,7 @@
         <p:spPr>
           <a:xfrm>
             <a:off x="8174736" y="2167128"/>
-            <a:ext cx="3264408" cy="548640"/>
+            <a:ext cx="3264408" cy="278987"/>
           </a:xfrm>
           <a:prstGeom prst="rect">
             <a:avLst/>
@@ -8532,13 +8860,31 @@
               </a:spcAft>
             </a:pPr>
             <a:r>
-              <a:rPr sz="1855" b="1" i="0">
+              <a:rPr sz="1850" b="1" i="0">
                 <a:solidFill>
                   <a:srgbClr val="06B6D4"/>
                 </a:solidFill>
                 <a:latin typeface="Arial"/>
               </a:rPr>
-              <a:t>Geely — most asymmetric</a:t>
+              <a:t>Geely </a:t>
+            </a:r>
+            <a:r>
+              <a:rPr lang="en-US" sz="1850" b="1">
+                <a:solidFill>
+                  <a:srgbClr val="06B6D4"/>
+                </a:solidFill>
+                <a:latin typeface="Arial"/>
+              </a:rPr>
+              <a:t>-</a:t>
+            </a:r>
+            <a:r>
+              <a:rPr sz="1850" b="1" i="0">
+                <a:solidFill>
+                  <a:srgbClr val="06B6D4"/>
+                </a:solidFill>
+                <a:latin typeface="Arial"/>
+              </a:rPr>
+              <a:t> most asymmetric</a:t>
             </a:r>
           </a:p>
         </p:txBody>
@@ -8696,7 +9042,7 @@
               </a:spcAft>
             </a:pPr>
             <a:r>
-              <a:rPr sz="1623" b="1" i="0" dirty="0">
+              <a:rPr sz="1623" b="1" i="0">
                 <a:solidFill>
                   <a:srgbClr val="0F172A"/>
                 </a:solidFill>
@@ -8705,7 +9051,7 @@
               <a:t>Same technology shock, three very different outcomes</a:t>
             </a:r>
             <a:r>
-              <a:rPr lang="de-DE" sz="1623" b="1" i="0" dirty="0">
+              <a:rPr lang="de-DE" sz="1623" b="1" i="0">
                 <a:solidFill>
                   <a:srgbClr val="0F172A"/>
                 </a:solidFill>
@@ -8714,7 +9060,7 @@
               <a:t>;</a:t>
             </a:r>
             <a:r>
-              <a:rPr sz="1623" b="1" i="0" dirty="0">
+              <a:rPr sz="1623" b="1" i="0">
                 <a:solidFill>
                   <a:srgbClr val="0F172A"/>
                 </a:solidFill>
@@ -9682,7 +10028,7 @@
               </a:spcAft>
             </a:pPr>
             <a:r>
-              <a:rPr sz="1682" b="0" i="0" dirty="0">
+              <a:rPr sz="1682" b="0" i="0">
                 <a:solidFill>
                   <a:srgbClr val="FFFFFF"/>
                 </a:solidFill>
@@ -9691,7 +10037,7 @@
               <a:t>Why BYD and why not simply “vertical integration is best”: the model wins because it aligns concentrated, commercially-oriented control with a self-financing structure that stays resilient when markets contract</a:t>
             </a:r>
             <a:r>
-              <a:rPr lang="de-DE" sz="1682" b="0" i="0" dirty="0">
+              <a:rPr lang="de-DE" sz="1682" b="0" i="0">
                 <a:solidFill>
                   <a:srgbClr val="FFFFFF"/>
                 </a:solidFill>
@@ -9700,7 +10046,7 @@
               <a:t>, </a:t>
             </a:r>
             <a:r>
-              <a:rPr sz="1682" b="0" i="0" dirty="0">
+              <a:rPr sz="1682" b="0" i="0">
                 <a:solidFill>
                   <a:srgbClr val="FFFFFF"/>
                 </a:solidFill>
@@ -11216,7 +11562,7 @@
         <p:spPr>
           <a:xfrm>
             <a:off x="822960" y="2697480"/>
-            <a:ext cx="6126480" cy="2560320"/>
+            <a:ext cx="6126480" cy="1107034"/>
           </a:xfrm>
           <a:prstGeom prst="rect">
             <a:avLst/>
@@ -11229,13 +11575,10 @@
           </a:bodyPr>
           <a:lstStyle/>
           <a:p>
-            <a:pPr algn="l">
+            <a:pPr>
               <a:lnSpc>
                 <a:spcPct val="112000"/>
               </a:lnSpc>
-              <a:spcBef>
-                <a:spcPts val="0"/>
-              </a:spcBef>
               <a:spcAft>
                 <a:spcPts val="200"/>
               </a:spcAft>
@@ -11247,7 +11590,25 @@
                 </a:solidFill>
                 <a:latin typeface="Arial"/>
               </a:rPr>
-              <a:t>When technology moves faster than firms can decide, governance is no longer a footnote to strategy — it is strategy.</a:t>
+              <a:t>When technology moves faster than firms can decide, governance is no longer a footnote to </a:t>
+            </a:r>
+            <a:r>
+              <a:rPr lang="en-US" sz="2200" b="1" i="1">
+                <a:solidFill>
+                  <a:srgbClr val="FFFFFF"/>
+                </a:solidFill>
+                <a:latin typeface="Arial"/>
+              </a:rPr>
+              <a:t>strategy, it</a:t>
+            </a:r>
+            <a:r>
+              <a:rPr sz="2200" b="1" i="1">
+                <a:solidFill>
+                  <a:srgbClr val="FFFFFF"/>
+                </a:solidFill>
+                <a:latin typeface="Arial"/>
+              </a:rPr>
+              <a:t> is strategy.</a:t>
             </a:r>
           </a:p>
         </p:txBody>
@@ -11332,7 +11693,7 @@
               <a:buNone/>
             </a:pPr>
             <a:r>
-              <a:rPr sz="1507" dirty="0">
+              <a:rPr sz="1507">
                 <a:solidFill>
                   <a:srgbClr val="06B6D4"/>
                 </a:solidFill>
@@ -11341,7 +11702,7 @@
               <a:t>–  </a:t>
             </a:r>
             <a:r>
-              <a:rPr sz="1507" dirty="0">
+              <a:rPr sz="1507">
                 <a:solidFill>
                   <a:srgbClr val="E2E8F0"/>
                 </a:solidFill>
@@ -11364,7 +11725,7 @@
               <a:buNone/>
             </a:pPr>
             <a:r>
-              <a:rPr sz="1507" dirty="0">
+              <a:rPr sz="1507">
                 <a:solidFill>
                   <a:srgbClr val="06B6D4"/>
                 </a:solidFill>
@@ -11373,7 +11734,7 @@
               <a:t>–  </a:t>
             </a:r>
             <a:r>
-              <a:rPr sz="1507" dirty="0">
+              <a:rPr sz="1507">
                 <a:solidFill>
                   <a:srgbClr val="E2E8F0"/>
                 </a:solidFill>
@@ -11382,7 +11743,7 @@
               <a:t>BYD</a:t>
             </a:r>
             <a:r>
-              <a:rPr lang="de-DE" sz="1507" dirty="0">
+              <a:rPr lang="de-DE" sz="1507">
                 <a:solidFill>
                   <a:srgbClr val="E2E8F0"/>
                 </a:solidFill>
@@ -11391,7 +11752,7 @@
               <a:t>‘s</a:t>
             </a:r>
             <a:r>
-              <a:rPr sz="1507" dirty="0">
+              <a:rPr sz="1507">
                 <a:solidFill>
                   <a:srgbClr val="E2E8F0"/>
                 </a:solidFill>
@@ -11414,7 +11775,7 @@
               <a:buNone/>
             </a:pPr>
             <a:r>
-              <a:rPr sz="1507" dirty="0">
+              <a:rPr sz="1507">
                 <a:solidFill>
                   <a:srgbClr val="06B6D4"/>
                 </a:solidFill>
@@ -11423,7 +11784,7 @@
               <a:t>–  </a:t>
             </a:r>
             <a:r>
-              <a:rPr sz="1507" dirty="0">
+              <a:rPr sz="1507">
                 <a:solidFill>
                   <a:srgbClr val="E2E8F0"/>
                 </a:solidFill>
@@ -11432,7 +11793,7 @@
               <a:t>SAIC's state model </a:t>
             </a:r>
             <a:r>
-              <a:rPr sz="1507" dirty="0" err="1">
+              <a:rPr sz="1507" err="1">
                 <a:solidFill>
                   <a:srgbClr val="E2E8F0"/>
                 </a:solidFill>
@@ -11441,7 +11802,7 @@
               <a:t>optimises</a:t>
             </a:r>
             <a:r>
-              <a:rPr sz="1507" dirty="0">
+              <a:rPr sz="1507">
                 <a:solidFill>
                   <a:srgbClr val="E2E8F0"/>
                 </a:solidFill>
@@ -11464,7 +11825,7 @@
               <a:buNone/>
             </a:pPr>
             <a:r>
-              <a:rPr sz="1507" dirty="0">
+              <a:rPr sz="1507">
                 <a:solidFill>
                   <a:srgbClr val="06B6D4"/>
                 </a:solidFill>
@@ -11473,7 +11834,7 @@
               <a:t>–  </a:t>
             </a:r>
             <a:r>
-              <a:rPr sz="1507" dirty="0">
+              <a:rPr sz="1507">
                 <a:solidFill>
                   <a:srgbClr val="E2E8F0"/>
                 </a:solidFill>
@@ -11978,7 +12339,7 @@
           <a:noFill/>
         </p:spPr>
         <p:txBody>
-          <a:bodyPr wrap="square" lIns="0" tIns="0" rIns="0" bIns="0">
+          <a:bodyPr wrap="square" lIns="0" tIns="0" rIns="0" bIns="0" anchor="t">
             <a:spAutoFit/>
           </a:bodyPr>
           <a:lstStyle/>
@@ -11987,16 +12348,80 @@
               <a:lnSpc>
                 <a:spcPct val="105000"/>
               </a:lnSpc>
-              <a:spcBef>
-                <a:spcPts val="0"/>
-              </a:spcBef>
               <a:spcAft>
                 <a:spcPts val="900"/>
               </a:spcAft>
+            </a:pPr>
+            <a:r>
+              <a:rPr sz="1500">
+                <a:solidFill>
+                  <a:srgbClr val="D97706"/>
+                </a:solidFill>
+                <a:latin typeface="Arial"/>
+              </a:rPr>
+              <a:t>–  </a:t>
+            </a:r>
+            <a:r>
+              <a:rPr sz="1500">
+                <a:solidFill>
+                  <a:srgbClr val="0F172A"/>
+                </a:solidFill>
+                <a:latin typeface="Arial"/>
+              </a:rPr>
+              <a:t>Three firms, one industry, one country</a:t>
+            </a:r>
+            <a:r>
+              <a:rPr lang="en-US" sz="1500">
+                <a:solidFill>
+                  <a:srgbClr val="0F172A"/>
+                </a:solidFill>
+                <a:latin typeface="Arial"/>
+              </a:rPr>
+              <a:t>: </a:t>
+            </a:r>
+            <a:r>
+              <a:rPr sz="1500">
+                <a:solidFill>
+                  <a:srgbClr val="0F172A"/>
+                </a:solidFill>
+                <a:latin typeface="Arial"/>
+              </a:rPr>
+              <a:t>limited statistical </a:t>
+            </a:r>
+            <a:r>
+              <a:rPr sz="1500" err="1">
+                <a:solidFill>
+                  <a:srgbClr val="0F172A"/>
+                </a:solidFill>
+                <a:latin typeface="Arial"/>
+              </a:rPr>
+              <a:t>generalisability</a:t>
+            </a:r>
+            <a:r>
+              <a:rPr sz="1500">
+                <a:solidFill>
+                  <a:srgbClr val="0F172A"/>
+                </a:solidFill>
+                <a:latin typeface="Arial"/>
+              </a:rPr>
+              <a:t>.</a:t>
+            </a:r>
+          </a:p>
+          <a:p>
+            <a:pPr>
+              <a:lnSpc>
+                <a:spcPct val="105000"/>
+              </a:lnSpc>
+              <a:spcBef>
+                <a:spcPts val="0"/>
+              </a:spcBef>
+              <a:spcAft>
+                <a:spcPts val="900"/>
+              </a:spcAft>
               <a:buNone/>
             </a:pPr>
             <a:r>
-              <a:rPr sz="1507" dirty="0">
+              <a:rPr sz="1507">
                 <a:solidFill>
                   <a:srgbClr val="D97706"/>
                 </a:solidFill>
@@ -12005,57 +12430,7 @@
               <a:t>–  </a:t>
             </a:r>
             <a:r>
-              <a:rPr sz="1507" dirty="0">
-                <a:solidFill>
-                  <a:srgbClr val="0F172A"/>
-                </a:solidFill>
-                <a:latin typeface="Arial"/>
-              </a:rPr>
-              <a:t>Three firms, one industry, one country — limited statistical </a:t>
-            </a:r>
-            <a:r>
-              <a:rPr sz="1507" dirty="0" err="1">
-                <a:solidFill>
-                  <a:srgbClr val="0F172A"/>
-                </a:solidFill>
-                <a:latin typeface="Arial"/>
-              </a:rPr>
-              <a:t>generalisability</a:t>
-            </a:r>
-            <a:r>
-              <a:rPr sz="1507" dirty="0">
-                <a:solidFill>
-                  <a:srgbClr val="0F172A"/>
-                </a:solidFill>
-                <a:latin typeface="Arial"/>
-              </a:rPr>
-              <a:t>.</a:t>
-            </a:r>
-          </a:p>
-          <a:p>
-            <a:pPr>
-              <a:lnSpc>
-                <a:spcPct val="105000"/>
-              </a:lnSpc>
-              <a:spcBef>
-                <a:spcPts val="0"/>
-              </a:spcBef>
-              <a:spcAft>
-                <a:spcPts val="900"/>
-              </a:spcAft>
-              <a:buNone/>
-            </a:pPr>
-            <a:r>
-              <a:rPr sz="1507" dirty="0">
-                <a:solidFill>
-                  <a:srgbClr val="D97706"/>
-                </a:solidFill>
-                <a:latin typeface="Arial"/>
-              </a:rPr>
-              <a:t>–  </a:t>
-            </a:r>
-            <a:r>
-              <a:rPr sz="1507" dirty="0">
+              <a:rPr sz="1507">
                 <a:solidFill>
                   <a:srgbClr val="0F172A"/>
                 </a:solidFill>
@@ -12238,7 +12613,7 @@
               <a:buNone/>
             </a:pPr>
             <a:r>
-              <a:rPr sz="1507" dirty="0">
+              <a:rPr sz="1507">
                 <a:solidFill>
                   <a:srgbClr val="2563EB"/>
                 </a:solidFill>
@@ -12247,7 +12622,7 @@
               <a:t>–  </a:t>
             </a:r>
             <a:r>
-              <a:rPr sz="1507" dirty="0">
+              <a:rPr sz="1507">
                 <a:solidFill>
                   <a:srgbClr val="0F172A"/>
                 </a:solidFill>
@@ -12270,7 +12645,7 @@
               <a:buNone/>
             </a:pPr>
             <a:r>
-              <a:rPr sz="1507" dirty="0">
+              <a:rPr sz="1507">
                 <a:solidFill>
                   <a:srgbClr val="2563EB"/>
                 </a:solidFill>
@@ -12279,7 +12654,7 @@
               <a:t>–  </a:t>
             </a:r>
             <a:r>
-              <a:rPr sz="1507" dirty="0">
+              <a:rPr sz="1507">
                 <a:solidFill>
                   <a:srgbClr val="0F172A"/>
                 </a:solidFill>
@@ -12302,7 +12677,7 @@
               <a:buNone/>
             </a:pPr>
             <a:r>
-              <a:rPr sz="1507" dirty="0">
+              <a:rPr sz="1507">
                 <a:solidFill>
                   <a:srgbClr val="2563EB"/>
                 </a:solidFill>
@@ -12311,7 +12686,7 @@
               <a:t>–  </a:t>
             </a:r>
             <a:r>
-              <a:rPr sz="1507" dirty="0">
+              <a:rPr sz="1507">
                 <a:solidFill>
                   <a:srgbClr val="0F172A"/>
                 </a:solidFill>
@@ -12536,7 +12911,7 @@
         <p:spPr>
           <a:xfrm>
             <a:off x="548640" y="658368"/>
-            <a:ext cx="11064240" cy="914400"/>
+            <a:ext cx="11064240" cy="323165"/>
           </a:xfrm>
           <a:prstGeom prst="rect">
             <a:avLst/>
@@ -12549,13 +12924,7 @@
           </a:bodyPr>
           <a:lstStyle/>
           <a:p>
-            <a:pPr algn="l">
-              <a:lnSpc>
-                <a:spcPct val="100000"/>
-              </a:lnSpc>
-              <a:spcBef>
-                <a:spcPts val="0"/>
-              </a:spcBef>
+            <a:pPr>
               <a:spcAft>
                 <a:spcPts val="200"/>
               </a:spcAft>
@@ -12567,7 +12936,25 @@
                 </a:solidFill>
                 <a:latin typeface="Arial"/>
               </a:rPr>
-              <a:t>AI as research infrastructure — a layered agent system, not a chatbot</a:t>
+              <a:t>AI as research infrastructure</a:t>
+            </a:r>
+            <a:r>
+              <a:rPr lang="en-US" sz="2100" b="1">
+                <a:solidFill>
+                  <a:srgbClr val="0F172A"/>
+                </a:solidFill>
+                <a:latin typeface="Arial"/>
+              </a:rPr>
+              <a:t>: Layered</a:t>
+            </a:r>
+            <a:r>
+              <a:rPr sz="2100" b="1" i="0">
+                <a:solidFill>
+                  <a:srgbClr val="0F172A"/>
+                </a:solidFill>
+                <a:latin typeface="Arial"/>
+              </a:rPr>
+              <a:t> agent system, not a chatbot</a:t>
             </a:r>
           </a:p>
         </p:txBody>
@@ -12696,7 +13083,7 @@
               </a:spcAft>
             </a:pPr>
             <a:r>
-              <a:rPr sz="1391" b="1" i="0" dirty="0">
+              <a:rPr sz="1391" b="1" i="0">
                 <a:solidFill>
                   <a:srgbClr val="64748B"/>
                 </a:solidFill>
@@ -12705,7 +13092,7 @@
               <a:t>Platform: Claude Code (Anthropic) —</a:t>
             </a:r>
             <a:r>
-              <a:rPr lang="de-DE" sz="1391" b="1" i="0" dirty="0">
+              <a:rPr lang="de-DE" sz="1391" b="1" i="0">
                 <a:solidFill>
                   <a:srgbClr val="64748B"/>
                 </a:solidFill>
@@ -12714,7 +13101,7 @@
               <a:t>&gt; </a:t>
             </a:r>
             <a:r>
-              <a:rPr sz="1391" b="1" i="0" dirty="0">
+              <a:rPr sz="1391" b="1" i="0">
                 <a:solidFill>
                   <a:srgbClr val="64748B"/>
                 </a:solidFill>
@@ -12734,7 +13121,7 @@
         <p:spPr>
           <a:xfrm>
             <a:off x="548640" y="1993392"/>
-            <a:ext cx="11064240" cy="274320"/>
+            <a:ext cx="11064240" cy="215444"/>
           </a:xfrm>
           <a:prstGeom prst="rect">
             <a:avLst/>
@@ -12747,26 +13134,53 @@
           </a:bodyPr>
           <a:lstStyle/>
           <a:p>
-            <a:pPr algn="l">
-              <a:lnSpc>
-                <a:spcPct val="100000"/>
-              </a:lnSpc>
-              <a:spcBef>
-                <a:spcPts val="0"/>
-              </a:spcBef>
+            <a:pPr>
               <a:spcAft>
                 <a:spcPts val="200"/>
               </a:spcAft>
             </a:pPr>
             <a:r>
-              <a:rPr sz="1391" b="1" i="0">
+              <a:rPr lang="en-US" sz="1350" b="1">
                 <a:solidFill>
                   <a:srgbClr val="64748B"/>
                 </a:solidFill>
                 <a:latin typeface="Arial"/>
               </a:rPr>
-              <a:t>5 agents: wiki-ingest · wiki-query · wiki-lint · verify-claims · find-references</a:t>
-            </a:r>
+              <a:t>6 Agents</a:t>
+            </a:r>
+            <a:r>
+              <a:rPr sz="1350" b="1" i="0">
+                <a:solidFill>
+                  <a:srgbClr val="64748B"/>
+                </a:solidFill>
+                <a:latin typeface="Arial"/>
+              </a:rPr>
+              <a:t>: wiki-ingest · wiki-query · wiki-lint · verify-claims · find-references</a:t>
+            </a:r>
+            <a:r>
+              <a:rPr lang="en-US" sz="1350" b="1">
+                <a:solidFill>
+                  <a:srgbClr val="64748B"/>
+                </a:solidFill>
+                <a:latin typeface="Arial"/>
+              </a:rPr>
+              <a:t> </a:t>
+            </a:r>
+            <a:r>
+              <a:rPr lang="en-US" sz="1400" b="1">
+                <a:solidFill>
+                  <a:srgbClr val="64748B"/>
+                </a:solidFill>
+                <a:latin typeface="Arial"/>
+              </a:rPr>
+              <a:t>· academic.pptx (phyton-pptx)</a:t>
+            </a:r>
+            <a:endParaRPr sz="1391" b="1" i="0">
+              <a:solidFill>
+                <a:srgbClr val="64748B"/>
+              </a:solidFill>
+              <a:latin typeface="Arial"/>
+            </a:endParaRPr>
           </a:p>
         </p:txBody>
       </p:sp>
@@ -13186,7 +13600,7 @@
         <p:spPr>
           <a:xfrm>
             <a:off x="6858000" y="3200400"/>
-            <a:ext cx="4937760" cy="2560320"/>
+            <a:ext cx="4937760" cy="1674305"/>
           </a:xfrm>
           <a:prstGeom prst="rect">
             <a:avLst/>
@@ -13194,7 +13608,7 @@
           <a:noFill/>
         </p:spPr>
         <p:txBody>
-          <a:bodyPr wrap="square" lIns="0" tIns="0" rIns="0" bIns="0">
+          <a:bodyPr wrap="square" lIns="0" tIns="0" rIns="0" bIns="0" anchor="t">
             <a:spAutoFit/>
           </a:bodyPr>
           <a:lstStyle/>
@@ -13299,16 +13713,12 @@
               <a:lnSpc>
                 <a:spcPct val="105000"/>
               </a:lnSpc>
-              <a:spcBef>
-                <a:spcPts val="0"/>
-              </a:spcBef>
               <a:spcAft>
                 <a:spcPts val="1000"/>
               </a:spcAft>
-              <a:buNone/>
-            </a:pPr>
-            <a:r>
-              <a:rPr sz="1623">
+            </a:pPr>
+            <a:r>
+              <a:rPr sz="1600">
                 <a:solidFill>
                   <a:srgbClr val="2563EB"/>
                 </a:solidFill>
@@ -13317,14 +13727,39 @@
               <a:t>–  </a:t>
             </a:r>
             <a:r>
-              <a:rPr sz="1623">
+              <a:rPr sz="1600">
                 <a:solidFill>
                   <a:srgbClr val="0F172A"/>
                 </a:solidFill>
                 <a:latin typeface="Arial"/>
               </a:rPr>
-              <a:t>Direct cross-case comparison — no manual hand-offs</a:t>
-            </a:r>
+              <a:t>Direct cross-case </a:t>
+            </a:r>
+            <a:r>
+              <a:rPr lang="en-US" sz="1600">
+                <a:solidFill>
+                  <a:srgbClr val="0F172A"/>
+                </a:solidFill>
+                <a:latin typeface="Arial"/>
+              </a:rPr>
+              <a:t>comparison: no</a:t>
+            </a:r>
+            <a:r>
+              <a:rPr sz="1600">
+                <a:solidFill>
+                  <a:srgbClr val="0F172A"/>
+                </a:solidFill>
+                <a:latin typeface="Arial"/>
+              </a:rPr>
+              <a:t> manual hand-offs</a:t>
+            </a:r>
+            <a:endParaRPr lang="en-US" sz="1600">
+              <a:solidFill>
+                <a:srgbClr val="0F172A"/>
+              </a:solidFill>
+              <a:latin typeface="Arial"/>
+              <a:cs typeface="Arial"/>
+            </a:endParaRPr>
           </a:p>
         </p:txBody>
       </p:sp>
@@ -14714,7 +15149,7 @@
         <p:spPr>
           <a:xfrm>
             <a:off x="548640" y="658368"/>
-            <a:ext cx="11064240" cy="914400"/>
+            <a:ext cx="11064240" cy="323165"/>
           </a:xfrm>
           <a:prstGeom prst="rect">
             <a:avLst/>
@@ -14745,7 +15180,7 @@
                 </a:solidFill>
                 <a:latin typeface="Arial"/>
               </a:rPr>
-              <a:t>Useful but bounded — and the thinking stayed human</a:t>
+              <a:t>Useful but bounded and the thinking stayed human</a:t>
             </a:r>
           </a:p>
         </p:txBody>
@@ -14986,7 +15421,7 @@
         <p:spPr>
           <a:xfrm>
             <a:off x="731520" y="2423160"/>
-            <a:ext cx="5074920" cy="2468880"/>
+            <a:ext cx="5074920" cy="2372894"/>
           </a:xfrm>
           <a:prstGeom prst="rect">
             <a:avLst/>
@@ -14994,7 +15429,7 @@
           <a:noFill/>
         </p:spPr>
         <p:txBody>
-          <a:bodyPr wrap="square" lIns="0" tIns="0" rIns="0" bIns="0">
+          <a:bodyPr wrap="square" lIns="0" tIns="0" rIns="0" bIns="0" anchor="t">
             <a:spAutoFit/>
           </a:bodyPr>
           <a:lstStyle/>
@@ -15003,12 +15438,58 @@
               <a:lnSpc>
                 <a:spcPct val="105000"/>
               </a:lnSpc>
-              <a:spcBef>
-                <a:spcPts val="0"/>
-              </a:spcBef>
               <a:spcAft>
                 <a:spcPts val="800"/>
               </a:spcAft>
+            </a:pPr>
+            <a:r>
+              <a:rPr sz="1400">
+                <a:solidFill>
+                  <a:srgbClr val="D97706"/>
+                </a:solidFill>
+                <a:latin typeface="Arial"/>
+              </a:rPr>
+              <a:t>–  </a:t>
+            </a:r>
+            <a:r>
+              <a:rPr sz="1400">
+                <a:solidFill>
+                  <a:srgbClr val="0F172A"/>
+                </a:solidFill>
+                <a:latin typeface="Arial"/>
+              </a:rPr>
+              <a:t>Cannot download paywalled PDFs</a:t>
+            </a:r>
+            <a:r>
+              <a:rPr lang="en-US" sz="1400">
+                <a:solidFill>
+                  <a:srgbClr val="0F172A"/>
+                </a:solidFill>
+                <a:latin typeface="Arial"/>
+              </a:rPr>
+              <a:t>; </a:t>
+            </a:r>
+            <a:r>
+              <a:rPr sz="1400">
+                <a:solidFill>
+                  <a:srgbClr val="0F172A"/>
+                </a:solidFill>
+                <a:latin typeface="Arial"/>
+              </a:rPr>
+              <a:t>it knows the papers' content, but key claims still needed manual reading and checking.</a:t>
+            </a:r>
+          </a:p>
+          <a:p>
+            <a:pPr>
+              <a:lnSpc>
+                <a:spcPct val="105000"/>
+              </a:lnSpc>
+              <a:spcBef>
+                <a:spcPts val="0"/>
+              </a:spcBef>
+              <a:spcAft>
+                <a:spcPts val="800"/>
+              </a:spcAft>
               <a:buNone/>
             </a:pPr>
             <a:r>
@@ -15027,7 +15508,7 @@
                 </a:solidFill>
                 <a:latin typeface="Arial"/>
               </a:rPr>
-              <a:t>Cannot download paywalled PDFs — it knows the papers' content, but key claims still needed manual reading and checking.</a:t>
+              <a:t>Token / context limits hit quickly on the stronger model in long sessions.</a:t>
             </a:r>
           </a:p>
           <a:p>
@@ -15035,16 +15516,12 @@
               <a:lnSpc>
                 <a:spcPct val="105000"/>
               </a:lnSpc>
-              <a:spcBef>
-                <a:spcPts val="0"/>
-              </a:spcBef>
               <a:spcAft>
                 <a:spcPts val="800"/>
               </a:spcAft>
-              <a:buNone/>
-            </a:pPr>
-            <a:r>
-              <a:rPr sz="1449">
+            </a:pPr>
+            <a:r>
+              <a:rPr sz="1400">
                 <a:solidFill>
                   <a:srgbClr val="D97706"/>
                 </a:solidFill>
@@ -15053,46 +15530,52 @@
               <a:t>–  </a:t>
             </a:r>
             <a:r>
-              <a:rPr sz="1449">
+              <a:rPr sz="1400">
                 <a:solidFill>
                   <a:srgbClr val="0F172A"/>
                 </a:solidFill>
                 <a:latin typeface="Arial"/>
               </a:rPr>
-              <a:t>Token / context limits hit quickly on the stronger model in long sessions.</a:t>
-            </a:r>
+              <a:t>Output was often verbose and needed active editing; some DOIs were wrong.</a:t>
+            </a:r>
+            <a:endParaRPr lang="en-US" sz="1400">
+              <a:solidFill>
+                <a:srgbClr val="0F172A"/>
+              </a:solidFill>
+              <a:latin typeface="Arial"/>
+            </a:endParaRPr>
           </a:p>
           <a:p>
             <a:pPr>
               <a:lnSpc>
                 <a:spcPct val="105000"/>
               </a:lnSpc>
-              <a:spcBef>
-                <a:spcPts val="0"/>
-              </a:spcBef>
               <a:spcAft>
                 <a:spcPts val="800"/>
               </a:spcAft>
-              <a:buNone/>
-            </a:pPr>
-            <a:r>
-              <a:rPr sz="1449">
+            </a:pPr>
+            <a:r>
+              <a:rPr lang="en-US" sz="1400">
                 <a:solidFill>
                   <a:srgbClr val="D97706"/>
                 </a:solidFill>
                 <a:latin typeface="Arial"/>
               </a:rPr>
-              <a:t>–  </a:t>
-            </a:r>
-            <a:r>
-              <a:rPr sz="1449">
+              <a:t>– </a:t>
+            </a:r>
+            <a:r>
+              <a:rPr lang="en-US" sz="1400">
                 <a:solidFill>
                   <a:srgbClr val="0F172A"/>
                 </a:solidFill>
                 <a:latin typeface="Arial"/>
               </a:rPr>
-              <a:t>Output was often verbose and needed active editing; some DOIs were wrong.</a:t>
-            </a:r>
+              <a:t>Consistency issues: slight variations in accuracy when referring to the same Data multiple times.</a:t>
+            </a:r>
+            <a:endParaRPr lang="en-US">
+              <a:ea typeface="Calibri"/>
+              <a:cs typeface="Calibri"/>
+            </a:endParaRPr>
           </a:p>
         </p:txBody>
       </p:sp>
@@ -15268,7 +15751,7 @@
               <a:buNone/>
             </a:pPr>
             <a:r>
-              <a:rPr sz="1449" dirty="0">
+              <a:rPr sz="1449">
                 <a:solidFill>
                   <a:srgbClr val="2563EB"/>
                 </a:solidFill>
@@ -15277,7 +15760,7 @@
               <a:t>–  </a:t>
             </a:r>
             <a:r>
-              <a:rPr sz="1449" dirty="0">
+              <a:rPr sz="1449">
                 <a:solidFill>
                   <a:srgbClr val="0F172A"/>
                 </a:solidFill>
@@ -15300,7 +15783,7 @@
               <a:buNone/>
             </a:pPr>
             <a:r>
-              <a:rPr sz="1449" dirty="0">
+              <a:rPr sz="1449">
                 <a:solidFill>
                   <a:srgbClr val="2563EB"/>
                 </a:solidFill>
@@ -15309,7 +15792,7 @@
               <a:t>–  </a:t>
             </a:r>
             <a:r>
-              <a:rPr sz="1449" dirty="0">
+              <a:rPr sz="1449">
                 <a:solidFill>
                   <a:srgbClr val="0F172A"/>
                 </a:solidFill>
@@ -15318,7 +15801,7 @@
               <a:t>AI output always needs critical review</a:t>
             </a:r>
             <a:r>
-              <a:rPr lang="de-DE" sz="1449" dirty="0">
+              <a:rPr lang="de-DE" sz="1449">
                 <a:solidFill>
                   <a:srgbClr val="0F172A"/>
                 </a:solidFill>
@@ -15327,7 +15810,7 @@
               <a:t>,</a:t>
             </a:r>
             <a:r>
-              <a:rPr sz="1449" dirty="0">
+              <a:rPr sz="1449">
                 <a:solidFill>
                   <a:srgbClr val="0F172A"/>
                 </a:solidFill>
@@ -15350,7 +15833,7 @@
               <a:buNone/>
             </a:pPr>
             <a:r>
-              <a:rPr sz="1449" dirty="0">
+              <a:rPr sz="1449">
                 <a:solidFill>
                   <a:srgbClr val="2563EB"/>
                 </a:solidFill>
@@ -15359,7 +15842,7 @@
               <a:t>–  </a:t>
             </a:r>
             <a:r>
-              <a:rPr sz="1449" dirty="0">
+              <a:rPr sz="1449">
                 <a:solidFill>
                   <a:srgbClr val="0F172A"/>
                 </a:solidFill>
@@ -15382,7 +15865,7 @@
               <a:buNone/>
             </a:pPr>
             <a:r>
-              <a:rPr sz="1449" dirty="0">
+              <a:rPr sz="1449">
                 <a:solidFill>
                   <a:srgbClr val="2563EB"/>
                 </a:solidFill>
@@ -15391,7 +15874,7 @@
               <a:t>–  </a:t>
             </a:r>
             <a:r>
-              <a:rPr sz="1449" dirty="0">
+              <a:rPr sz="1449">
                 <a:solidFill>
                   <a:srgbClr val="0F172A"/>
                 </a:solidFill>
@@ -15399,51 +15882,6 @@
               </a:rPr>
               <a:t>Framing that worked: a source-quality enforcer and critical reviewer, not a writer.</a:t>
             </a:r>
-          </a:p>
-        </p:txBody>
-      </p:sp>
-      <p:sp>
-        <p:nvSpPr>
-          <p:cNvPr id="15" name="Rectangle 14"/>
-          <p:cNvSpPr/>
-          <p:nvPr/>
-        </p:nvSpPr>
-        <p:spPr>
-          <a:xfrm>
-            <a:off x="548640" y="5257800"/>
-            <a:ext cx="11064240" cy="640080"/>
-          </a:xfrm>
-          <a:prstGeom prst="rect">
-            <a:avLst/>
-          </a:prstGeom>
-          <a:solidFill>
-            <a:srgbClr val="0F172A"/>
-          </a:solidFill>
-          <a:ln>
-            <a:noFill/>
-          </a:ln>
-          <a:effectLst/>
-        </p:spPr>
-        <p:style>
-          <a:lnRef idx="1">
-            <a:schemeClr val="accent1"/>
-          </a:lnRef>
-          <a:fillRef idx="3">
-            <a:schemeClr val="accent1"/>
-          </a:fillRef>
-          <a:effectRef idx="2">
-            <a:schemeClr val="accent1"/>
-          </a:effectRef>
-          <a:fontRef idx="minor">
-            <a:schemeClr val="lt1"/>
-          </a:fontRef>
-        </p:style>
-        <p:txBody>
-          <a:bodyPr rtlCol="0" anchor="ctr"/>
-          <a:lstStyle/>
-          <a:p>
-            <a:pPr algn="ctr"/>
-            <a:endParaRPr/>
           </a:p>
         </p:txBody>
       </p:sp>
@@ -15455,8 +15893,8 @@
         </p:nvSpPr>
         <p:spPr>
           <a:xfrm>
-            <a:off x="731520" y="5257800"/>
-            <a:ext cx="10698480" cy="640080"/>
+            <a:off x="731520" y="5331619"/>
+            <a:ext cx="10698480" cy="492443"/>
           </a:xfrm>
           <a:prstGeom prst="rect">
             <a:avLst/>
@@ -15469,26 +15907,44 @@
           </a:bodyPr>
           <a:lstStyle/>
           <a:p>
-            <a:pPr algn="l">
-              <a:lnSpc>
-                <a:spcPct val="100000"/>
-              </a:lnSpc>
-              <a:spcBef>
-                <a:spcPts val="0"/>
-              </a:spcBef>
+            <a:pPr>
               <a:spcAft>
                 <a:spcPts val="200"/>
               </a:spcAft>
             </a:pPr>
             <a:r>
-              <a:rPr sz="1565" b="1" i="0">
-                <a:solidFill>
-                  <a:srgbClr val="FFFFFF"/>
-                </a:solidFill>
-                <a:latin typeface="Arial"/>
-              </a:rPr>
-              <a:t>Bottom line: AI compressed research time and caught errors — but every judgment, argument and conclusion remained the authors' own.</a:t>
-            </a:r>
+              <a:rPr sz="1600" b="1">
+                <a:solidFill>
+                  <a:srgbClr val="0F172A"/>
+                </a:solidFill>
+                <a:latin typeface="Arial"/>
+              </a:rPr>
+              <a:t>Bottom line: AI compressed research time and caught errors</a:t>
+            </a:r>
+            <a:r>
+              <a:rPr lang="en-US" sz="1600" b="1">
+                <a:solidFill>
+                  <a:srgbClr val="0F172A"/>
+                </a:solidFill>
+                <a:latin typeface="Arial"/>
+              </a:rPr>
+              <a:t>, </a:t>
+            </a:r>
+            <a:r>
+              <a:rPr sz="1600" b="1">
+                <a:solidFill>
+                  <a:srgbClr val="0F172A"/>
+                </a:solidFill>
+                <a:latin typeface="Arial"/>
+              </a:rPr>
+              <a:t>but every judgment, argument and conclusion remained the authors' own.</a:t>
+            </a:r>
+            <a:endParaRPr lang="en-US" sz="1600" b="1">
+              <a:solidFill>
+                <a:srgbClr val="0F172A"/>
+              </a:solidFill>
+              <a:latin typeface="Arial"/>
+            </a:endParaRPr>
           </a:p>
         </p:txBody>
       </p:sp>
@@ -16683,7 +17139,7 @@
               <a:buNone/>
             </a:pPr>
             <a:r>
-              <a:rPr sz="1739" dirty="0">
+              <a:rPr sz="1739">
                 <a:solidFill>
                   <a:srgbClr val="2563EB"/>
                 </a:solidFill>
@@ -16692,7 +17148,7 @@
               <a:t>–  </a:t>
             </a:r>
             <a:r>
-              <a:rPr sz="1739" dirty="0">
+              <a:rPr sz="1739">
                 <a:solidFill>
                   <a:srgbClr val="0F172A"/>
                 </a:solidFill>
@@ -16701,7 +17157,7 @@
               <a:t>For three decades foreign technology was traded for market access, with a state-owned partner in the middle (Holmes et al., 2015)</a:t>
             </a:r>
             <a:r>
-              <a:rPr lang="de-DE" sz="1739" dirty="0">
+              <a:rPr lang="de-DE" sz="1739">
                 <a:solidFill>
                   <a:srgbClr val="0F172A"/>
                 </a:solidFill>
@@ -16710,7 +17166,7 @@
               <a:t>, </a:t>
             </a:r>
             <a:r>
-              <a:rPr sz="1739" dirty="0">
+              <a:rPr sz="1739">
                 <a:solidFill>
                   <a:srgbClr val="0F172A"/>
                 </a:solidFill>
@@ -16733,7 +17189,7 @@
               <a:buNone/>
             </a:pPr>
             <a:r>
-              <a:rPr sz="1739" dirty="0">
+              <a:rPr sz="1739">
                 <a:solidFill>
                   <a:srgbClr val="2563EB"/>
                 </a:solidFill>
@@ -16742,7 +17198,7 @@
               <a:t>–  </a:t>
             </a:r>
             <a:r>
-              <a:rPr sz="1739" dirty="0">
+              <a:rPr sz="1739">
                 <a:solidFill>
                   <a:srgbClr val="0F172A"/>
                 </a:solidFill>
@@ -16765,7 +17221,7 @@
               <a:buNone/>
             </a:pPr>
             <a:r>
-              <a:rPr sz="1739" dirty="0">
+              <a:rPr sz="1739">
                 <a:solidFill>
                   <a:srgbClr val="2563EB"/>
                 </a:solidFill>
@@ -16774,7 +17230,7 @@
               <a:t>–  </a:t>
             </a:r>
             <a:r>
-              <a:rPr sz="1739" dirty="0">
+              <a:rPr sz="1739">
                 <a:solidFill>
                   <a:srgbClr val="0F172A"/>
                 </a:solidFill>
@@ -19246,7 +19702,7 @@
               </a:spcAft>
             </a:pPr>
             <a:r>
-              <a:rPr sz="1623" b="1" i="0" dirty="0">
+              <a:rPr sz="1623" b="1" i="0">
                 <a:solidFill>
                   <a:srgbClr val="0F172A"/>
                 </a:solidFill>
@@ -21173,7 +21629,7 @@
         <p:spPr>
           <a:xfrm>
             <a:off x="548640" y="658368"/>
-            <a:ext cx="11064240" cy="914400"/>
+            <a:ext cx="11064240" cy="323165"/>
           </a:xfrm>
           <a:prstGeom prst="rect">
             <a:avLst/>
@@ -21186,13 +21642,7 @@
           </a:bodyPr>
           <a:lstStyle/>
           <a:p>
-            <a:pPr algn="l">
-              <a:lnSpc>
-                <a:spcPct val="100000"/>
-              </a:lnSpc>
-              <a:spcBef>
-                <a:spcPts val="0"/>
-              </a:spcBef>
+            <a:pPr>
               <a:spcAft>
                 <a:spcPts val="200"/>
               </a:spcAft>
@@ -21204,7 +21654,25 @@
                 </a:solidFill>
                 <a:latin typeface="Arial"/>
               </a:rPr>
-              <a:t>Three models tested against four dimensions — a 3 × 4 matrix</a:t>
+              <a:t>Three models tested against four </a:t>
+            </a:r>
+            <a:r>
+              <a:rPr lang="en-US" sz="2100" b="1">
+                <a:solidFill>
+                  <a:srgbClr val="0F172A"/>
+                </a:solidFill>
+                <a:latin typeface="Arial"/>
+              </a:rPr>
+              <a:t>dimensions: a</a:t>
+            </a:r>
+            <a:r>
+              <a:rPr sz="2100" b="1" i="0">
+                <a:solidFill>
+                  <a:srgbClr val="0F172A"/>
+                </a:solidFill>
+                <a:latin typeface="Arial"/>
+              </a:rPr>
+              <a:t> 3 × 4 matrix</a:t>
             </a:r>
           </a:p>
         </p:txBody>
@@ -23354,7 +23822,7 @@
               </a:spcAft>
             </a:pPr>
             <a:r>
-              <a:rPr sz="1623" b="1" dirty="0">
+              <a:rPr sz="1623" b="1">
                 <a:solidFill>
                   <a:srgbClr val="0F172A"/>
                 </a:solidFill>
@@ -23363,7 +23831,7 @@
               <a:t>Reading</a:t>
             </a:r>
             <a:r>
-              <a:rPr sz="1623" b="1" i="0" dirty="0">
+              <a:rPr sz="1623" b="1" i="0">
                 <a:solidFill>
                   <a:srgbClr val="0F172A"/>
                 </a:solidFill>
@@ -23633,7 +24101,7 @@
         <p:spPr>
           <a:xfrm>
             <a:off x="548640" y="658368"/>
-            <a:ext cx="11064240" cy="914400"/>
+            <a:ext cx="11064240" cy="323165"/>
           </a:xfrm>
           <a:prstGeom prst="rect">
             <a:avLst/>
@@ -23646,13 +24114,7 @@
           </a:bodyPr>
           <a:lstStyle/>
           <a:p>
-            <a:pPr algn="l">
-              <a:lnSpc>
-                <a:spcPct val="100000"/>
-              </a:lnSpc>
-              <a:spcBef>
-                <a:spcPts val="0"/>
-              </a:spcBef>
+            <a:pPr>
               <a:spcAft>
                 <a:spcPts val="200"/>
               </a:spcAft>
@@ -23664,7 +24126,43 @@
                 </a:solidFill>
                 <a:latin typeface="Arial"/>
               </a:rPr>
-              <a:t>Who controls the firm — and what they optimise — diverges sharply</a:t>
+              <a:t>Who controls the </a:t>
+            </a:r>
+            <a:r>
+              <a:rPr lang="en-US" sz="2100" b="1">
+                <a:solidFill>
+                  <a:srgbClr val="0F172A"/>
+                </a:solidFill>
+                <a:latin typeface="Arial"/>
+              </a:rPr>
+              <a:t>firm and</a:t>
+            </a:r>
+            <a:r>
+              <a:rPr sz="2100" b="1" i="0">
+                <a:solidFill>
+                  <a:srgbClr val="0F172A"/>
+                </a:solidFill>
+                <a:latin typeface="Arial"/>
+              </a:rPr>
+              <a:t> what they </a:t>
+            </a:r>
+            <a:r>
+              <a:rPr lang="en-US" sz="2100" b="1">
+                <a:solidFill>
+                  <a:srgbClr val="0F172A"/>
+                </a:solidFill>
+                <a:latin typeface="Arial"/>
+              </a:rPr>
+              <a:t>optimise diverges</a:t>
+            </a:r>
+            <a:r>
+              <a:rPr sz="2100" b="1" i="0">
+                <a:solidFill>
+                  <a:srgbClr val="0F172A"/>
+                </a:solidFill>
+                <a:latin typeface="Arial"/>
+              </a:rPr>
+              <a:t> sharply</a:t>
             </a:r>
           </a:p>
         </p:txBody>
@@ -23860,7 +24358,7 @@
         <p:spPr>
           <a:xfrm>
             <a:off x="713232" y="1892808"/>
-            <a:ext cx="3264408" cy="548640"/>
+            <a:ext cx="3264408" cy="278987"/>
           </a:xfrm>
           <a:prstGeom prst="rect">
             <a:avLst/>
@@ -23885,13 +24383,31 @@
               </a:spcAft>
             </a:pPr>
             <a:r>
-              <a:rPr sz="1855" b="1" i="0">
+              <a:rPr sz="1850" b="1" i="0">
                 <a:solidFill>
                   <a:srgbClr val="DC2626"/>
                 </a:solidFill>
                 <a:latin typeface="Arial"/>
               </a:rPr>
-              <a:t>SAIC — dual state principal</a:t>
+              <a:t>SAIC </a:t>
+            </a:r>
+            <a:r>
+              <a:rPr lang="en-US" sz="1850" b="1">
+                <a:solidFill>
+                  <a:srgbClr val="DC2626"/>
+                </a:solidFill>
+                <a:latin typeface="Arial"/>
+              </a:rPr>
+              <a:t>-</a:t>
+            </a:r>
+            <a:r>
+              <a:rPr sz="1850" b="1" i="0">
+                <a:solidFill>
+                  <a:srgbClr val="DC2626"/>
+                </a:solidFill>
+                <a:latin typeface="Arial"/>
+              </a:rPr>
+              <a:t> dual state principal</a:t>
             </a:r>
           </a:p>
         </p:txBody>
@@ -23905,7 +24421,7 @@
         <p:spPr>
           <a:xfrm>
             <a:off x="713232" y="2478024"/>
-            <a:ext cx="3264408" cy="2646045"/>
+            <a:ext cx="3264408" cy="2635786"/>
           </a:xfrm>
           <a:prstGeom prst="rect">
             <a:avLst/>
@@ -23913,7 +24429,7 @@
           <a:noFill/>
         </p:spPr>
         <p:txBody>
-          <a:bodyPr wrap="square" lIns="0" tIns="0" rIns="0" bIns="0">
+          <a:bodyPr wrap="square" lIns="0" tIns="0" rIns="0" bIns="0" anchor="t">
             <a:spAutoFit/>
           </a:bodyPr>
           <a:lstStyle/>
@@ -23931,7 +24447,7 @@
               <a:buNone/>
             </a:pPr>
             <a:r>
-              <a:rPr sz="1449" dirty="0">
+              <a:rPr sz="1400">
                 <a:solidFill>
                   <a:srgbClr val="DC2626"/>
                 </a:solidFill>
@@ -23940,7 +24456,7 @@
               <a:t>–  </a:t>
             </a:r>
             <a:r>
-              <a:rPr sz="1449" dirty="0">
+              <a:rPr sz="1400">
                 <a:solidFill>
                   <a:srgbClr val="0F172A"/>
                 </a:solidFill>
@@ -23949,7 +24465,7 @@
               <a:t>S</a:t>
             </a:r>
             <a:r>
-              <a:rPr lang="de-DE" sz="1449" dirty="0" err="1">
+              <a:rPr lang="de-DE" sz="1400" err="1">
                 <a:solidFill>
                   <a:srgbClr val="0F172A"/>
                 </a:solidFill>
@@ -23958,7 +24474,7 @@
               <a:t>tate</a:t>
             </a:r>
             <a:r>
-              <a:rPr sz="1449" dirty="0">
+              <a:rPr sz="1400">
                 <a:solidFill>
                   <a:srgbClr val="0F172A"/>
                 </a:solidFill>
@@ -23981,7 +24497,7 @@
               <a:buNone/>
             </a:pPr>
             <a:r>
-              <a:rPr sz="1449" dirty="0">
+              <a:rPr sz="1400">
                 <a:solidFill>
                   <a:srgbClr val="DC2626"/>
                 </a:solidFill>
@@ -23990,7 +24506,7 @@
               <a:t>–  </a:t>
             </a:r>
             <a:r>
-              <a:rPr sz="1449" dirty="0" err="1">
+              <a:rPr sz="1400" err="1">
                 <a:solidFill>
                   <a:srgbClr val="0F172A"/>
                 </a:solidFill>
@@ -23999,15 +24515,60 @@
               <a:t>Optimises</a:t>
             </a:r>
             <a:r>
-              <a:rPr sz="1449" dirty="0">
+              <a:rPr sz="1400">
                 <a:solidFill>
                   <a:srgbClr val="0F172A"/>
                 </a:solidFill>
                 <a:latin typeface="Arial"/>
               </a:rPr>
-              <a:t> beyond shareholder value</a:t>
-            </a:r>
-            <a:endParaRPr lang="de-DE" sz="1449" dirty="0">
+              <a:t> </a:t>
+            </a:r>
+            <a:r>
+              <a:rPr sz="1400" err="1">
+                <a:solidFill>
+                  <a:srgbClr val="0F172A"/>
+                </a:solidFill>
+                <a:latin typeface="Arial"/>
+              </a:rPr>
+              <a:t>beyond</a:t>
+            </a:r>
+            <a:r>
+              <a:rPr sz="1400">
+                <a:solidFill>
+                  <a:srgbClr val="0F172A"/>
+                </a:solidFill>
+                <a:latin typeface="Arial"/>
+              </a:rPr>
+              <a:t> </a:t>
+            </a:r>
+            <a:r>
+              <a:rPr sz="1400" err="1">
+                <a:solidFill>
+                  <a:srgbClr val="0F172A"/>
+                </a:solidFill>
+                <a:latin typeface="Arial"/>
+              </a:rPr>
+              <a:t>shareholder</a:t>
+            </a:r>
+            <a:r>
+              <a:rPr sz="1400">
+                <a:solidFill>
+                  <a:srgbClr val="0F172A"/>
+                </a:solidFill>
+                <a:latin typeface="Arial"/>
+              </a:rPr>
+              <a:t> </a:t>
+            </a:r>
+            <a:r>
+              <a:rPr sz="1400" err="1">
+                <a:solidFill>
+                  <a:srgbClr val="0F172A"/>
+                </a:solidFill>
+                <a:latin typeface="Arial"/>
+              </a:rPr>
+              <a:t>value</a:t>
+            </a:r>
+            <a:endParaRPr lang="de-DE" sz="1400" err="1">
               <a:solidFill>
                 <a:srgbClr val="0F172A"/>
               </a:solidFill>
@@ -24028,7 +24589,7 @@
               <a:buNone/>
             </a:pPr>
             <a:r>
-              <a:rPr sz="1449" dirty="0">
+              <a:rPr sz="1449">
                 <a:solidFill>
                   <a:srgbClr val="DC2626"/>
                 </a:solidFill>
@@ -24037,7 +24598,7 @@
               <a:t>–  </a:t>
             </a:r>
             <a:r>
-              <a:rPr sz="1449" dirty="0">
+              <a:rPr sz="1449">
                 <a:solidFill>
                   <a:srgbClr val="0F172A"/>
                 </a:solidFill>
@@ -24060,7 +24621,7 @@
               <a:buNone/>
             </a:pPr>
             <a:r>
-              <a:rPr sz="1449" dirty="0">
+              <a:rPr sz="1400">
                 <a:solidFill>
                   <a:srgbClr val="DC2626"/>
                 </a:solidFill>
@@ -24069,15 +24630,96 @@
               <a:t>–  </a:t>
             </a:r>
             <a:r>
-              <a:rPr sz="1449" dirty="0">
+              <a:rPr sz="1400" err="1">
                 <a:solidFill>
                   <a:srgbClr val="0F172A"/>
                 </a:solidFill>
                 <a:latin typeface="Arial"/>
               </a:rPr>
-              <a:t>Cannot exit unprofitable JVs without state sign-off</a:t>
-            </a:r>
-            <a:endParaRPr lang="de-DE" sz="1449" dirty="0">
+              <a:t>Cannot</a:t>
+            </a:r>
+            <a:r>
+              <a:rPr sz="1400">
+                <a:solidFill>
+                  <a:srgbClr val="0F172A"/>
+                </a:solidFill>
+                <a:latin typeface="Arial"/>
+              </a:rPr>
+              <a:t> </a:t>
+            </a:r>
+            <a:r>
+              <a:rPr sz="1400" err="1">
+                <a:solidFill>
+                  <a:srgbClr val="0F172A"/>
+                </a:solidFill>
+                <a:latin typeface="Arial"/>
+              </a:rPr>
+              <a:t>exit</a:t>
+            </a:r>
+            <a:r>
+              <a:rPr sz="1400">
+                <a:solidFill>
+                  <a:srgbClr val="0F172A"/>
+                </a:solidFill>
+                <a:latin typeface="Arial"/>
+              </a:rPr>
+              <a:t> unprofitable JVs </a:t>
+            </a:r>
+            <a:r>
+              <a:rPr sz="1400" err="1">
+                <a:solidFill>
+                  <a:srgbClr val="0F172A"/>
+                </a:solidFill>
+                <a:latin typeface="Arial"/>
+              </a:rPr>
+              <a:t>without</a:t>
+            </a:r>
+            <a:r>
+              <a:rPr sz="1400">
+                <a:solidFill>
+                  <a:srgbClr val="0F172A"/>
+                </a:solidFill>
+                <a:latin typeface="Arial"/>
+              </a:rPr>
+              <a:t> </a:t>
+            </a:r>
+            <a:r>
+              <a:rPr sz="1400" err="1">
+                <a:solidFill>
+                  <a:srgbClr val="0F172A"/>
+                </a:solidFill>
+                <a:latin typeface="Arial"/>
+              </a:rPr>
+              <a:t>state</a:t>
+            </a:r>
+            <a:r>
+              <a:rPr sz="1400">
+                <a:solidFill>
+                  <a:srgbClr val="0F172A"/>
+                </a:solidFill>
+                <a:latin typeface="Arial"/>
+              </a:rPr>
+              <a:t> </a:t>
+            </a:r>
+            <a:r>
+              <a:rPr sz="1400" err="1">
+                <a:solidFill>
+                  <a:srgbClr val="0F172A"/>
+                </a:solidFill>
+                <a:latin typeface="Arial"/>
+              </a:rPr>
+              <a:t>sign</a:t>
+            </a:r>
+            <a:r>
+              <a:rPr sz="1400">
+                <a:solidFill>
+                  <a:srgbClr val="0F172A"/>
+                </a:solidFill>
+                <a:latin typeface="Arial"/>
+              </a:rPr>
+              <a:t>-off</a:t>
+            </a:r>
+            <a:endParaRPr lang="de-DE" sz="1400">
               <a:solidFill>
                 <a:srgbClr val="0F172A"/>
               </a:solidFill>
@@ -24097,7 +24739,7 @@
               </a:spcAft>
               <a:buNone/>
             </a:pPr>
-            <a:endParaRPr sz="1449" dirty="0">
+            <a:endParaRPr sz="1449">
               <a:solidFill>
                 <a:srgbClr val="0F172A"/>
               </a:solidFill>
@@ -24118,14 +24760,32 @@
               <a:buNone/>
             </a:pPr>
             <a:r>
-              <a:rPr sz="1449" b="1" dirty="0">
+              <a:rPr sz="1400" b="1">
                 <a:solidFill>
                   <a:srgbClr val="0F172A"/>
                 </a:solidFill>
                 <a:latin typeface="Arial"/>
               </a:rPr>
-              <a:t>Slow capital reallocation → strategic rigidity</a:t>
-            </a:r>
+              <a:t>Slow capital reallocation → strategic </a:t>
+            </a:r>
+            <a:r>
+              <a:rPr lang="en-US" sz="1400" b="1">
+                <a:solidFill>
+                  <a:srgbClr val="0F172A"/>
+                </a:solidFill>
+                <a:latin typeface="Arial"/>
+                <a:ea typeface="+mn-lt"/>
+                <a:cs typeface="Arial"/>
+              </a:rPr>
+              <a:t>inflexibility</a:t>
+            </a:r>
+            <a:endParaRPr sz="1400" b="1">
+              <a:solidFill>
+                <a:srgbClr val="0F172A"/>
+              </a:solidFill>
+              <a:latin typeface="Arial"/>
+              <a:cs typeface="Arial"/>
+            </a:endParaRPr>
           </a:p>
         </p:txBody>
       </p:sp>
@@ -24230,7 +24890,7 @@
         <p:spPr>
           <a:xfrm>
             <a:off x="4443984" y="1892808"/>
-            <a:ext cx="3264408" cy="548640"/>
+            <a:ext cx="3264408" cy="278987"/>
           </a:xfrm>
           <a:prstGeom prst="rect">
             <a:avLst/>
@@ -24255,13 +24915,31 @@
               </a:spcAft>
             </a:pPr>
             <a:r>
-              <a:rPr sz="1855" b="1" i="0">
+              <a:rPr sz="1850" b="1" i="0">
                 <a:solidFill>
                   <a:srgbClr val="2563EB"/>
                 </a:solidFill>
                 <a:latin typeface="Arial"/>
               </a:rPr>
-              <a:t>BYD — founder control</a:t>
+              <a:t>BYD </a:t>
+            </a:r>
+            <a:r>
+              <a:rPr lang="en-US" sz="1850" b="1">
+                <a:solidFill>
+                  <a:srgbClr val="2563EB"/>
+                </a:solidFill>
+                <a:latin typeface="Arial"/>
+              </a:rPr>
+              <a:t>-</a:t>
+            </a:r>
+            <a:r>
+              <a:rPr sz="1850" b="1" i="0">
+                <a:solidFill>
+                  <a:srgbClr val="2563EB"/>
+                </a:solidFill>
+                <a:latin typeface="Arial"/>
+              </a:rPr>
+              <a:t> founder control</a:t>
             </a:r>
           </a:p>
         </p:txBody>
@@ -24301,7 +24979,7 @@
               <a:buNone/>
             </a:pPr>
             <a:r>
-              <a:rPr sz="1449" dirty="0">
+              <a:rPr sz="1449">
                 <a:solidFill>
                   <a:srgbClr val="2563EB"/>
                 </a:solidFill>
@@ -24310,7 +24988,7 @@
               <a:t>–  </a:t>
             </a:r>
             <a:r>
-              <a:rPr sz="1449" dirty="0">
+              <a:rPr sz="1449">
                 <a:solidFill>
                   <a:srgbClr val="0F172A"/>
                 </a:solidFill>
@@ -24319,7 +24997,7 @@
               <a:t>Wang </a:t>
             </a:r>
             <a:r>
-              <a:rPr sz="1449" dirty="0" err="1">
+              <a:rPr sz="1449" err="1">
                 <a:solidFill>
                   <a:srgbClr val="0F172A"/>
                 </a:solidFill>
@@ -24328,7 +25006,7 @@
               <a:t>Chuanfu</a:t>
             </a:r>
             <a:r>
-              <a:rPr sz="1449" dirty="0">
+              <a:rPr sz="1449">
                 <a:solidFill>
                   <a:srgbClr val="0F172A"/>
                 </a:solidFill>
@@ -24351,7 +25029,7 @@
               <a:buNone/>
             </a:pPr>
             <a:r>
-              <a:rPr sz="1449" dirty="0">
+              <a:rPr sz="1449">
                 <a:solidFill>
                   <a:srgbClr val="2563EB"/>
                 </a:solidFill>
@@ -24360,7 +25038,7 @@
               <a:t>–  </a:t>
             </a:r>
             <a:r>
-              <a:rPr sz="1449" dirty="0">
+              <a:rPr sz="1449">
                 <a:solidFill>
                   <a:srgbClr val="0F172A"/>
                 </a:solidFill>
@@ -24383,7 +25061,7 @@
               <a:buNone/>
             </a:pPr>
             <a:r>
-              <a:rPr sz="1449" dirty="0">
+              <a:rPr sz="1449">
                 <a:solidFill>
                   <a:srgbClr val="2563EB"/>
                 </a:solidFill>
@@ -24392,7 +25070,7 @@
               <a:t>–  </a:t>
             </a:r>
             <a:r>
-              <a:rPr sz="1449" dirty="0">
+              <a:rPr sz="1449">
                 <a:solidFill>
                   <a:srgbClr val="0F172A"/>
                 </a:solidFill>
@@ -24415,7 +25093,7 @@
               <a:buNone/>
             </a:pPr>
             <a:r>
-              <a:rPr sz="1449" dirty="0">
+              <a:rPr sz="1449">
                 <a:solidFill>
                   <a:srgbClr val="2563EB"/>
                 </a:solidFill>
@@ -24424,7 +25102,7 @@
               <a:t>–  </a:t>
             </a:r>
             <a:r>
-              <a:rPr sz="1449" dirty="0">
+              <a:rPr sz="1449">
                 <a:solidFill>
                   <a:srgbClr val="0F172A"/>
                 </a:solidFill>
@@ -24433,7 +25111,7 @@
               <a:t>Exited combustion engines in 2022</a:t>
             </a:r>
             <a:r>
-              <a:rPr lang="de-DE" sz="1449" dirty="0">
+              <a:rPr lang="de-DE" sz="1449">
                 <a:solidFill>
                   <a:srgbClr val="0F172A"/>
                 </a:solidFill>
@@ -24442,7 +25120,7 @@
               <a:t>, </a:t>
             </a:r>
             <a:r>
-              <a:rPr sz="1449" dirty="0">
+              <a:rPr sz="1449">
                 <a:solidFill>
                   <a:srgbClr val="0F172A"/>
                 </a:solidFill>
@@ -24450,7 +25128,7 @@
               </a:rPr>
               <a:t>decided alone</a:t>
             </a:r>
-            <a:endParaRPr lang="de-DE" sz="1449" dirty="0">
+            <a:endParaRPr lang="de-DE" sz="1449">
               <a:solidFill>
                 <a:srgbClr val="0F172A"/>
               </a:solidFill>
@@ -24470,7 +25148,7 @@
               </a:spcAft>
               <a:buNone/>
             </a:pPr>
-            <a:endParaRPr sz="1449" dirty="0">
+            <a:endParaRPr sz="1449">
               <a:solidFill>
                 <a:srgbClr val="0F172A"/>
               </a:solidFill>
@@ -24491,7 +25169,7 @@
               <a:buNone/>
             </a:pPr>
             <a:r>
-              <a:rPr sz="1449" b="1" dirty="0">
+              <a:rPr sz="1449" b="1">
                 <a:solidFill>
                   <a:srgbClr val="0F172A"/>
                 </a:solidFill>
@@ -24603,7 +25281,7 @@
         <p:spPr>
           <a:xfrm>
             <a:off x="8174736" y="1892808"/>
-            <a:ext cx="3264408" cy="548640"/>
+            <a:ext cx="3264408" cy="278987"/>
           </a:xfrm>
           <a:prstGeom prst="rect">
             <a:avLst/>
@@ -24628,13 +25306,31 @@
               </a:spcAft>
             </a:pPr>
             <a:r>
-              <a:rPr sz="1855" b="1" i="0">
+              <a:rPr sz="1850" b="1" i="0">
                 <a:solidFill>
                   <a:srgbClr val="06B6D4"/>
                 </a:solidFill>
                 <a:latin typeface="Arial"/>
               </a:rPr>
-              <a:t>Geely — founder apex</a:t>
+              <a:t>Geely </a:t>
+            </a:r>
+            <a:r>
+              <a:rPr lang="en-US" sz="1850" b="1">
+                <a:solidFill>
+                  <a:srgbClr val="06B6D4"/>
+                </a:solidFill>
+                <a:latin typeface="Arial"/>
+              </a:rPr>
+              <a:t>-</a:t>
+            </a:r>
+            <a:r>
+              <a:rPr sz="1850" b="1" i="0">
+                <a:solidFill>
+                  <a:srgbClr val="06B6D4"/>
+                </a:solidFill>
+                <a:latin typeface="Arial"/>
+              </a:rPr>
+              <a:t> founder apex</a:t>
             </a:r>
           </a:p>
         </p:txBody>
@@ -24674,7 +25370,7 @@
               <a:buNone/>
             </a:pPr>
             <a:r>
-              <a:rPr sz="1449" dirty="0">
+              <a:rPr sz="1449">
                 <a:solidFill>
                   <a:srgbClr val="06B6D4"/>
                 </a:solidFill>
@@ -24683,7 +25379,7 @@
               <a:t>–  </a:t>
             </a:r>
             <a:r>
-              <a:rPr sz="1449" dirty="0">
+              <a:rPr sz="1449">
                 <a:solidFill>
                   <a:srgbClr val="0F172A"/>
                 </a:solidFill>
@@ -24706,7 +25402,7 @@
               <a:buNone/>
             </a:pPr>
             <a:r>
-              <a:rPr sz="1449" dirty="0">
+              <a:rPr sz="1449">
                 <a:solidFill>
                   <a:srgbClr val="06B6D4"/>
                 </a:solidFill>
@@ -24715,7 +25411,7 @@
               <a:t>–  </a:t>
             </a:r>
             <a:r>
-              <a:rPr sz="1449" dirty="0">
+              <a:rPr sz="1449">
                 <a:solidFill>
                   <a:srgbClr val="0F172A"/>
                 </a:solidFill>
@@ -24738,7 +25434,7 @@
               <a:buNone/>
             </a:pPr>
             <a:r>
-              <a:rPr sz="1449" dirty="0">
+              <a:rPr sz="1449">
                 <a:solidFill>
                   <a:srgbClr val="06B6D4"/>
                 </a:solidFill>
@@ -24747,7 +25443,7 @@
               <a:t>–  </a:t>
             </a:r>
             <a:r>
-              <a:rPr sz="1449" dirty="0">
+              <a:rPr sz="1449">
                 <a:solidFill>
                   <a:srgbClr val="0F172A"/>
                 </a:solidFill>
@@ -24770,7 +25466,7 @@
               <a:buNone/>
             </a:pPr>
             <a:r>
-              <a:rPr sz="1449" dirty="0">
+              <a:rPr sz="1449">
                 <a:solidFill>
                   <a:srgbClr val="06B6D4"/>
                 </a:solidFill>
@@ -24779,7 +25475,7 @@
               <a:t>–  </a:t>
             </a:r>
             <a:r>
-              <a:rPr sz="1449" dirty="0">
+              <a:rPr sz="1449">
                 <a:solidFill>
                   <a:srgbClr val="0F172A"/>
                 </a:solidFill>
@@ -24787,7 +25483,7 @@
               </a:rPr>
               <a:t>Volvo / Polestar / Lotus add portfolio complexity</a:t>
             </a:r>
-            <a:endParaRPr lang="de-DE" sz="1449" dirty="0">
+            <a:endParaRPr lang="de-DE" sz="1449">
               <a:solidFill>
                 <a:srgbClr val="0F172A"/>
               </a:solidFill>
@@ -24807,7 +25503,7 @@
               </a:spcAft>
               <a:buNone/>
             </a:pPr>
-            <a:endParaRPr sz="1449" dirty="0">
+            <a:endParaRPr sz="1449">
               <a:solidFill>
                 <a:srgbClr val="0F172A"/>
               </a:solidFill>
@@ -24828,7 +25524,7 @@
               <a:buNone/>
             </a:pPr>
             <a:r>
-              <a:rPr sz="1449" b="1" dirty="0">
+              <a:rPr sz="1449" b="1">
                 <a:solidFill>
                   <a:srgbClr val="0F172A"/>
                 </a:solidFill>
@@ -25098,7 +25794,7 @@
         <p:spPr>
           <a:xfrm>
             <a:off x="548640" y="658368"/>
-            <a:ext cx="11064240" cy="914400"/>
+            <a:ext cx="11064240" cy="323165"/>
           </a:xfrm>
           <a:prstGeom prst="rect">
             <a:avLst/>
@@ -25111,13 +25807,7 @@
           </a:bodyPr>
           <a:lstStyle/>
           <a:p>
-            <a:pPr algn="l">
-              <a:lnSpc>
-                <a:spcPct val="100000"/>
-              </a:lnSpc>
-              <a:spcBef>
-                <a:spcPts val="0"/>
-              </a:spcBef>
+            <a:pPr>
               <a:spcAft>
                 <a:spcPts val="200"/>
               </a:spcAft>
@@ -25129,8 +25819,24 @@
                 </a:solidFill>
                 <a:latin typeface="Arial"/>
               </a:rPr>
-              <a:t>The EU tariff gap prices governance risk — an outside validation</a:t>
-            </a:r>
+              <a:t>The EU tariff gap prices governance </a:t>
+            </a:r>
+            <a:r>
+              <a:rPr lang="en-US" sz="2100" b="1">
+                <a:solidFill>
+                  <a:srgbClr val="0F172A"/>
+                </a:solidFill>
+                <a:latin typeface="Arial"/>
+              </a:rPr>
+              <a:t>risk</a:t>
+            </a:r>
+            <a:endParaRPr lang="en-US" sz="2100" b="1" i="0">
+              <a:solidFill>
+                <a:srgbClr val="0F172A"/>
+              </a:solidFill>
+              <a:latin typeface="Arial"/>
+              <a:cs typeface="Arial"/>
+            </a:endParaRPr>
           </a:p>
         </p:txBody>
       </p:sp>
@@ -25980,7 +26686,7 @@
         <p:spPr>
           <a:xfrm>
             <a:off x="548640" y="4069080"/>
-            <a:ext cx="11064240" cy="1732013"/>
+            <a:ext cx="11064240" cy="1310552"/>
           </a:xfrm>
           <a:prstGeom prst="rect">
             <a:avLst/>
@@ -25988,7 +26694,7 @@
           <a:noFill/>
         </p:spPr>
         <p:txBody>
-          <a:bodyPr wrap="square" lIns="0" tIns="0" rIns="0" bIns="0">
+          <a:bodyPr wrap="square" lIns="0" tIns="0" rIns="0" bIns="0" anchor="t">
             <a:spAutoFit/>
           </a:bodyPr>
           <a:lstStyle/>
@@ -26006,7 +26712,7 @@
               <a:buNone/>
             </a:pPr>
             <a:r>
-              <a:rPr sz="1739" dirty="0">
+              <a:rPr sz="1700">
                 <a:solidFill>
                   <a:srgbClr val="2563EB"/>
                 </a:solidFill>
@@ -26015,7 +26721,7 @@
               <a:t>–  </a:t>
             </a:r>
             <a:r>
-              <a:rPr sz="1739" dirty="0">
+              <a:rPr sz="1700">
                 <a:solidFill>
                   <a:srgbClr val="0F172A"/>
                 </a:solidFill>
@@ -26024,7 +26730,7 @@
               <a:t>An independent regulator </a:t>
             </a:r>
             <a:r>
-              <a:rPr lang="de-DE" sz="1739" dirty="0">
+              <a:rPr lang="de-DE" sz="1700">
                 <a:solidFill>
                   <a:srgbClr val="0F172A"/>
                 </a:solidFill>
@@ -26033,7 +26739,7 @@
               <a:t>(</a:t>
             </a:r>
             <a:r>
-              <a:rPr sz="1739" dirty="0">
+              <a:rPr sz="1700">
                 <a:solidFill>
                   <a:srgbClr val="0F172A"/>
                 </a:solidFill>
@@ -26042,7 +26748,7 @@
               <a:t>European Commission</a:t>
             </a:r>
             <a:r>
-              <a:rPr lang="de-DE" sz="1739" dirty="0">
+              <a:rPr lang="de-DE" sz="1700">
                 <a:solidFill>
                   <a:srgbClr val="0F172A"/>
                 </a:solidFill>
@@ -26051,7 +26757,7 @@
               <a:t>)</a:t>
             </a:r>
             <a:r>
-              <a:rPr sz="1739" dirty="0">
+              <a:rPr sz="1700">
                 <a:solidFill>
                   <a:srgbClr val="0F172A"/>
                 </a:solidFill>
@@ -26060,7 +26766,7 @@
               <a:t> priced SAIC's state dependence at</a:t>
             </a:r>
             <a:r>
-              <a:rPr lang="de-DE" sz="1739" dirty="0">
+              <a:rPr lang="de-DE" sz="1700">
                 <a:solidFill>
                   <a:srgbClr val="0F172A"/>
                 </a:solidFill>
@@ -26069,7 +26775,7 @@
               <a:t> </a:t>
             </a:r>
             <a:r>
-              <a:rPr sz="1739" dirty="0">
+              <a:rPr sz="1700">
                 <a:solidFill>
                   <a:srgbClr val="0F172A"/>
                 </a:solidFill>
@@ -26078,7 +26784,7 @@
               <a:t>18.3-point </a:t>
             </a:r>
             <a:r>
-              <a:rPr lang="de-DE" sz="1739" dirty="0" err="1">
+              <a:rPr lang="de-DE" sz="1700" err="1">
                 <a:solidFill>
                   <a:srgbClr val="0F172A"/>
                 </a:solidFill>
@@ -26087,7 +26793,7 @@
               <a:t>percent</a:t>
             </a:r>
             <a:r>
-              <a:rPr sz="1739" dirty="0">
+              <a:rPr sz="1700">
                 <a:solidFill>
                   <a:srgbClr val="0F172A"/>
                 </a:solidFill>
@@ -26110,7 +26816,7 @@
               <a:buNone/>
             </a:pPr>
             <a:r>
-              <a:rPr sz="1739" dirty="0">
+              <a:rPr sz="1700">
                 <a:solidFill>
                   <a:srgbClr val="2563EB"/>
                 </a:solidFill>
@@ -26119,15 +26825,204 @@
               <a:t>–  </a:t>
             </a:r>
             <a:r>
-              <a:rPr sz="1739" dirty="0">
+              <a:rPr sz="1700" err="1">
                 <a:solidFill>
                   <a:srgbClr val="0F172A"/>
                 </a:solidFill>
                 <a:latin typeface="Arial"/>
               </a:rPr>
-              <a:t>Adaptability rises as control concentrates: JV boards (bilateral consent) → state oversight → founder control.</a:t>
-            </a:r>
-            <a:endParaRPr lang="de-DE" sz="1739" dirty="0">
+              <a:t>Adaptability</a:t>
+            </a:r>
+            <a:r>
+              <a:rPr sz="1700">
+                <a:solidFill>
+                  <a:srgbClr val="0F172A"/>
+                </a:solidFill>
+                <a:latin typeface="Arial"/>
+              </a:rPr>
+              <a:t> </a:t>
+            </a:r>
+            <a:r>
+              <a:rPr sz="1700" err="1">
+                <a:solidFill>
+                  <a:srgbClr val="0F172A"/>
+                </a:solidFill>
+                <a:latin typeface="Arial"/>
+              </a:rPr>
+              <a:t>rises</a:t>
+            </a:r>
+            <a:r>
+              <a:rPr sz="1700">
+                <a:solidFill>
+                  <a:srgbClr val="0F172A"/>
+                </a:solidFill>
+                <a:latin typeface="Arial"/>
+              </a:rPr>
+              <a:t> </a:t>
+            </a:r>
+            <a:r>
+              <a:rPr sz="1700" err="1">
+                <a:solidFill>
+                  <a:srgbClr val="0F172A"/>
+                </a:solidFill>
+                <a:latin typeface="Arial"/>
+              </a:rPr>
+              <a:t>as</a:t>
+            </a:r>
+            <a:r>
+              <a:rPr sz="1700">
+                <a:solidFill>
+                  <a:srgbClr val="0F172A"/>
+                </a:solidFill>
+                <a:latin typeface="Arial"/>
+              </a:rPr>
+              <a:t> </a:t>
+            </a:r>
+            <a:r>
+              <a:rPr sz="1700" err="1">
+                <a:solidFill>
+                  <a:srgbClr val="0F172A"/>
+                </a:solidFill>
+                <a:latin typeface="Arial"/>
+              </a:rPr>
+              <a:t>control</a:t>
+            </a:r>
+            <a:r>
+              <a:rPr sz="1700">
+                <a:solidFill>
+                  <a:srgbClr val="0F172A"/>
+                </a:solidFill>
+                <a:latin typeface="Arial"/>
+              </a:rPr>
+              <a:t> </a:t>
+            </a:r>
+            <a:r>
+              <a:rPr sz="1700" err="1">
+                <a:solidFill>
+                  <a:srgbClr val="0F172A"/>
+                </a:solidFill>
+                <a:latin typeface="Arial"/>
+              </a:rPr>
+              <a:t>concentrates</a:t>
+            </a:r>
+            <a:r>
+              <a:rPr sz="1700">
+                <a:solidFill>
+                  <a:srgbClr val="0F172A"/>
+                </a:solidFill>
+                <a:latin typeface="Arial"/>
+              </a:rPr>
+              <a:t>: JV </a:t>
+            </a:r>
+            <a:r>
+              <a:rPr sz="1700" err="1">
+                <a:solidFill>
+                  <a:srgbClr val="0F172A"/>
+                </a:solidFill>
+                <a:latin typeface="Arial"/>
+              </a:rPr>
+              <a:t>boards</a:t>
+            </a:r>
+            <a:r>
+              <a:rPr sz="1700">
+                <a:solidFill>
+                  <a:srgbClr val="0F172A"/>
+                </a:solidFill>
+                <a:latin typeface="Arial"/>
+              </a:rPr>
+              <a:t> (bilateral </a:t>
+            </a:r>
+            <a:r>
+              <a:rPr sz="1700" err="1">
+                <a:solidFill>
+                  <a:srgbClr val="0F172A"/>
+                </a:solidFill>
+                <a:latin typeface="Arial"/>
+              </a:rPr>
+              <a:t>consent</a:t>
+            </a:r>
+            <a:r>
+              <a:rPr sz="1700">
+                <a:solidFill>
+                  <a:srgbClr val="0F172A"/>
+                </a:solidFill>
+                <a:latin typeface="Arial"/>
+              </a:rPr>
+              <a:t>) → </a:t>
+            </a:r>
+            <a:r>
+              <a:rPr sz="1700" err="1">
+                <a:solidFill>
+                  <a:srgbClr val="0F172A"/>
+                </a:solidFill>
+                <a:latin typeface="Arial"/>
+              </a:rPr>
+              <a:t>state</a:t>
+            </a:r>
+            <a:r>
+              <a:rPr sz="1700">
+                <a:solidFill>
+                  <a:srgbClr val="0F172A"/>
+                </a:solidFill>
+                <a:latin typeface="Arial"/>
+              </a:rPr>
+              <a:t> </a:t>
+            </a:r>
+            <a:r>
+              <a:rPr sz="1700" err="1">
+                <a:solidFill>
+                  <a:srgbClr val="0F172A"/>
+                </a:solidFill>
+                <a:latin typeface="Arial"/>
+              </a:rPr>
+              <a:t>oversight</a:t>
+            </a:r>
+            <a:r>
+              <a:rPr sz="1700">
+                <a:solidFill>
+                  <a:srgbClr val="0F172A"/>
+                </a:solidFill>
+                <a:latin typeface="Arial"/>
+              </a:rPr>
+              <a:t> → </a:t>
+            </a:r>
+            <a:r>
+              <a:rPr sz="1700" err="1">
+                <a:solidFill>
+                  <a:srgbClr val="0F172A"/>
+                </a:solidFill>
+                <a:latin typeface="Arial"/>
+              </a:rPr>
+              <a:t>founder</a:t>
+            </a:r>
+            <a:r>
+              <a:rPr sz="1700">
+                <a:solidFill>
+                  <a:srgbClr val="0F172A"/>
+                </a:solidFill>
+                <a:latin typeface="Arial"/>
+              </a:rPr>
+              <a:t> </a:t>
+            </a:r>
+            <a:r>
+              <a:rPr sz="1700" err="1">
+                <a:solidFill>
+                  <a:srgbClr val="0F172A"/>
+                </a:solidFill>
+                <a:latin typeface="Arial"/>
+              </a:rPr>
+              <a:t>control</a:t>
+            </a:r>
+            <a:r>
+              <a:rPr sz="1700">
+                <a:solidFill>
+                  <a:srgbClr val="0F172A"/>
+                </a:solidFill>
+                <a:latin typeface="Arial"/>
+              </a:rPr>
+              <a:t>.</a:t>
+            </a:r>
+            <a:endParaRPr lang="de-DE" sz="1700">
               <a:solidFill>
                 <a:srgbClr val="0F172A"/>
               </a:solidFill>
@@ -26148,7 +27043,7 @@
               <a:buNone/>
             </a:pPr>
             <a:r>
-              <a:rPr lang="de-DE" sz="1739" b="1" dirty="0">
+              <a:rPr lang="de-DE" sz="1700" b="1">
                 <a:solidFill>
                   <a:srgbClr val="0F172A"/>
                 </a:solidFill>
@@ -26156,56 +27051,13 @@
               </a:rPr>
               <a:t>  </a:t>
             </a:r>
-          </a:p>
-          <a:p>
-            <a:pPr algn="ctr">
-              <a:lnSpc>
-                <a:spcPct val="105000"/>
-              </a:lnSpc>
-              <a:spcBef>
-                <a:spcPts val="0"/>
-              </a:spcBef>
-              <a:spcAft>
-                <a:spcPts val="900"/>
-              </a:spcAft>
-              <a:buNone/>
-            </a:pPr>
-            <a:r>
-              <a:rPr lang="de-DE" sz="1739" b="1" dirty="0">
-                <a:solidFill>
-                  <a:srgbClr val="0F172A"/>
-                </a:solidFill>
-                <a:latin typeface="Arial"/>
-              </a:rPr>
-              <a:t>    </a:t>
-            </a:r>
-            <a:r>
-              <a:rPr lang="de-DE" sz="1600" b="1" dirty="0">
-                <a:solidFill>
-                  <a:srgbClr val="0F172A"/>
-                </a:solidFill>
-                <a:latin typeface="Arial"/>
-              </a:rPr>
-              <a:t> G</a:t>
-            </a:r>
-            <a:r>
-              <a:rPr sz="1600" b="1" dirty="0" err="1">
-                <a:solidFill>
-                  <a:srgbClr val="0F172A"/>
-                </a:solidFill>
-                <a:latin typeface="Arial"/>
-              </a:rPr>
-              <a:t>overnance</a:t>
-            </a:r>
-            <a:r>
-              <a:rPr sz="1600" b="1" dirty="0">
-                <a:solidFill>
-                  <a:srgbClr val="0F172A"/>
-                </a:solidFill>
-                <a:latin typeface="Arial"/>
-              </a:rPr>
-              <a:t> is a first-order determinant of competitive position, not an administrative footnote.</a:t>
-            </a:r>
+            <a:endParaRPr sz="1600" b="1">
+              <a:solidFill>
+                <a:srgbClr val="0F172A"/>
+              </a:solidFill>
+              <a:latin typeface="Arial"/>
+              <a:cs typeface="Arial"/>
+            </a:endParaRPr>
           </a:p>
         </p:txBody>
       </p:sp>
@@ -26341,6 +27193,118 @@
               </a:rPr>
               <a:t>7</a:t>
             </a:r>
+          </a:p>
+        </p:txBody>
+      </p:sp>
+      <p:sp>
+        <p:nvSpPr>
+          <p:cNvPr id="27" name="TextBox 26">
+            <a:extLst>
+              <a:ext uri="{FF2B5EF4-FFF2-40B4-BE49-F238E27FC236}">
+                <a16:creationId xmlns:a16="http://schemas.microsoft.com/office/drawing/2014/main" id="{0356F55B-2DFE-6626-E0C6-A11E575BBE64}"/>
+              </a:ext>
+            </a:extLst>
+          </p:cNvPr>
+          <p:cNvSpPr txBox="1"/>
+          <p:nvPr/>
+        </p:nvSpPr>
+        <p:spPr>
+          <a:xfrm>
+            <a:off x="548640" y="5378268"/>
+            <a:ext cx="11064240" cy="486800"/>
+          </a:xfrm>
+          <a:prstGeom prst="rect">
+            <a:avLst/>
+          </a:prstGeom>
+          <a:noFill/>
+        </p:spPr>
+        <p:txBody>
+          <a:bodyPr wrap="square" lIns="0" tIns="0" rIns="0" bIns="0" anchor="ctr">
+            <a:spAutoFit/>
+          </a:bodyPr>
+          <a:lstStyle/>
+          <a:p>
+            <a:r>
+              <a:rPr lang="de-DE" sz="1600" b="1">
+                <a:solidFill>
+                  <a:srgbClr val="0F172A"/>
+                </a:solidFill>
+                <a:latin typeface="Arial"/>
+              </a:rPr>
+              <a:t>G</a:t>
+            </a:r>
+            <a:r>
+              <a:rPr lang="en-US" sz="1600" b="1" err="1">
+                <a:solidFill>
+                  <a:srgbClr val="0F172A"/>
+                </a:solidFill>
+                <a:latin typeface="Arial"/>
+              </a:rPr>
+              <a:t>overnance</a:t>
+            </a:r>
+            <a:r>
+              <a:rPr lang="en-US" sz="1600" b="1">
+                <a:solidFill>
+                  <a:srgbClr val="0F172A"/>
+                </a:solidFill>
+                <a:latin typeface="Arial"/>
+              </a:rPr>
+              <a:t> is a first-order determinant of competitive position</a:t>
+            </a:r>
+            <a:r>
+              <a:rPr lang="en-US" sz="1600" b="1" i="0">
+                <a:solidFill>
+                  <a:srgbClr val="0F172A"/>
+                </a:solidFill>
+                <a:latin typeface="Arial"/>
+              </a:rPr>
+              <a:t>, </a:t>
+            </a:r>
+            <a:r>
+              <a:rPr lang="en-US" sz="1600" b="1">
+                <a:solidFill>
+                  <a:srgbClr val="0F172A"/>
+                </a:solidFill>
+                <a:latin typeface="Arial"/>
+              </a:rPr>
+              <a:t>not an administrative footnote</a:t>
+            </a:r>
+            <a:r>
+              <a:rPr lang="en-US" sz="1600" b="1" i="0">
+                <a:solidFill>
+                  <a:srgbClr val="0F172A"/>
+                </a:solidFill>
+                <a:latin typeface="Arial"/>
+              </a:rPr>
+              <a:t>.</a:t>
+            </a:r>
+            <a:endParaRPr lang="en-US" sz="1600">
+              <a:solidFill>
+                <a:srgbClr val="000000"/>
+              </a:solidFill>
+              <a:latin typeface="Arial"/>
+              <a:cs typeface="Arial"/>
+            </a:endParaRPr>
+          </a:p>
+          <a:p>
+            <a:pPr algn="l">
+              <a:lnSpc>
+                <a:spcPct val="105000"/>
+              </a:lnSpc>
+              <a:spcBef>
+                <a:spcPts val="0"/>
+              </a:spcBef>
+              <a:spcAft>
+                <a:spcPts val="200"/>
+              </a:spcAft>
+            </a:pPr>
+            <a:endParaRPr sz="1600" b="1" i="0">
+              <a:solidFill>
+                <a:srgbClr val="0F172A"/>
+              </a:solidFill>
+              <a:latin typeface="Arial"/>
+              <a:cs typeface="Arial"/>
+            </a:endParaRPr>
           </a:p>
         </p:txBody>
       </p:sp>
@@ -26493,7 +27457,7 @@
               </a:spcAft>
             </a:pPr>
             <a:r>
-              <a:rPr sz="2100" b="1" i="0" dirty="0">
+              <a:rPr sz="2100" b="1" i="0">
                 <a:solidFill>
                   <a:srgbClr val="0F172A"/>
                 </a:solidFill>
@@ -26695,7 +27659,7 @@
         <p:spPr>
           <a:xfrm>
             <a:off x="713232" y="1892808"/>
-            <a:ext cx="3264408" cy="548640"/>
+            <a:ext cx="3264408" cy="278987"/>
           </a:xfrm>
           <a:prstGeom prst="rect">
             <a:avLst/>
@@ -26708,26 +27672,39 @@
           </a:bodyPr>
           <a:lstStyle/>
           <a:p>
-            <a:pPr algn="l">
+            <a:pPr>
               <a:lnSpc>
                 <a:spcPct val="98000"/>
               </a:lnSpc>
-              <a:spcBef>
-                <a:spcPts val="0"/>
-              </a:spcBef>
               <a:spcAft>
                 <a:spcPts val="200"/>
               </a:spcAft>
             </a:pPr>
             <a:r>
-              <a:rPr sz="1855" b="1" i="0">
+              <a:rPr lang="en-US" sz="1850" b="1">
                 <a:solidFill>
                   <a:srgbClr val="DC2626"/>
                 </a:solidFill>
                 <a:latin typeface="Arial"/>
               </a:rPr>
-              <a:t>Capital-light JV</a:t>
-            </a:r>
+              <a:t>SAIC - Capital-light</a:t>
+            </a:r>
+            <a:r>
+              <a:rPr sz="1850" b="1" i="0">
+                <a:solidFill>
+                  <a:srgbClr val="DC2626"/>
+                </a:solidFill>
+                <a:latin typeface="Arial"/>
+              </a:rPr>
+              <a:t> JV</a:t>
+            </a:r>
+            <a:endParaRPr lang="en-US" sz="1850" b="1" i="0">
+              <a:solidFill>
+                <a:srgbClr val="DC2626"/>
+              </a:solidFill>
+              <a:latin typeface="Arial"/>
+              <a:cs typeface="Arial"/>
+            </a:endParaRPr>
           </a:p>
         </p:txBody>
       </p:sp>
@@ -27006,7 +27983,7 @@
         <p:spPr>
           <a:xfrm>
             <a:off x="4443984" y="1892808"/>
-            <a:ext cx="3264408" cy="548640"/>
+            <a:ext cx="3264408" cy="278987"/>
           </a:xfrm>
           <a:prstGeom prst="rect">
             <a:avLst/>
@@ -27019,26 +27996,30 @@
           </a:bodyPr>
           <a:lstStyle/>
           <a:p>
-            <a:pPr algn="l">
+            <a:pPr>
               <a:lnSpc>
                 <a:spcPct val="98000"/>
               </a:lnSpc>
-              <a:spcBef>
-                <a:spcPts val="0"/>
-              </a:spcBef>
               <a:spcAft>
                 <a:spcPts val="200"/>
               </a:spcAft>
             </a:pPr>
             <a:r>
-              <a:rPr sz="1855" b="1" i="0">
+              <a:rPr lang="en-US" sz="1850" b="1">
                 <a:solidFill>
                   <a:srgbClr val="2563EB"/>
                 </a:solidFill>
                 <a:latin typeface="Arial"/>
               </a:rPr>
-              <a:t>Self-financing</a:t>
-            </a:r>
+              <a:t>BYD - Self-financing</a:t>
+            </a:r>
+            <a:endParaRPr lang="en-US" sz="1850" b="1" i="0">
+              <a:solidFill>
+                <a:srgbClr val="2563EB"/>
+              </a:solidFill>
+              <a:latin typeface="Arial"/>
+              <a:cs typeface="Arial"/>
+            </a:endParaRPr>
           </a:p>
         </p:txBody>
       </p:sp>
@@ -27051,7 +28032,7 @@
         <p:spPr>
           <a:xfrm>
             <a:off x="4443984" y="2478024"/>
-            <a:ext cx="3264408" cy="2432304"/>
+            <a:ext cx="3264408" cy="2581925"/>
           </a:xfrm>
           <a:prstGeom prst="rect">
             <a:avLst/>
@@ -27059,7 +28040,7 @@
           <a:noFill/>
         </p:spPr>
         <p:txBody>
-          <a:bodyPr wrap="square" lIns="0" tIns="0" rIns="0" bIns="0">
+          <a:bodyPr wrap="square" lIns="0" tIns="0" rIns="0" bIns="0" anchor="t">
             <a:spAutoFit/>
           </a:bodyPr>
           <a:lstStyle/>
@@ -27316,8 +28297,8 @@
         </p:nvSpPr>
         <p:spPr>
           <a:xfrm>
-            <a:off x="8174736" y="1892808"/>
-            <a:ext cx="3264408" cy="548640"/>
+            <a:off x="8145708" y="1892808"/>
+            <a:ext cx="3264408" cy="278987"/>
           </a:xfrm>
           <a:prstGeom prst="rect">
             <a:avLst/>
@@ -27330,25 +28311,31 @@
           </a:bodyPr>
           <a:lstStyle/>
           <a:p>
-            <a:pPr algn="l">
+            <a:pPr>
               <a:lnSpc>
                 <a:spcPct val="98000"/>
               </a:lnSpc>
-              <a:spcBef>
-                <a:spcPts val="0"/>
-              </a:spcBef>
               <a:spcAft>
                 <a:spcPts val="200"/>
               </a:spcAft>
             </a:pPr>
             <a:r>
-              <a:rPr sz="1855" b="1" i="0">
+              <a:rPr lang="en-US" sz="1850" b="1">
                 <a:solidFill>
                   <a:srgbClr val="06B6D4"/>
                 </a:solidFill>
                 <a:latin typeface="Arial"/>
               </a:rPr>
-              <a:t>Leveraged M&amp;A</a:t>
+              <a:t>Geely - Leveraged</a:t>
+            </a:r>
+            <a:r>
+              <a:rPr sz="1850" b="1" i="0">
+                <a:solidFill>
+                  <a:srgbClr val="06B6D4"/>
+                </a:solidFill>
+                <a:latin typeface="Arial"/>
+              </a:rPr>
+              <a:t> M&amp;A</a:t>
             </a:r>
           </a:p>
         </p:txBody>
@@ -27561,7 +28548,7 @@
               </a:spcAft>
             </a:pPr>
             <a:r>
-              <a:rPr sz="1600" b="1" dirty="0">
+              <a:rPr sz="1600" b="1">
                 <a:solidFill>
                   <a:srgbClr val="0F172A"/>
                 </a:solidFill>
@@ -27811,7 +28798,7 @@
               </a:spcAft>
             </a:pPr>
             <a:r>
-              <a:rPr sz="1623" b="1" i="0" dirty="0">
+              <a:rPr sz="1623" b="1" i="0">
                 <a:solidFill>
                   <a:srgbClr val="06B6D4"/>
                 </a:solidFill>
@@ -27820,7 +28807,7 @@
               <a:t>DIMENSION 2 · FINANCIAL </a:t>
             </a:r>
             <a:r>
-              <a:rPr lang="de-DE" sz="1623" b="1" i="0" dirty="0">
+              <a:rPr lang="de-DE" sz="1623" b="1" i="0">
                 <a:solidFill>
                   <a:srgbClr val="06B6D4"/>
                 </a:solidFill>
@@ -27828,7 +28815,7 @@
               </a:rPr>
               <a:t>FIGURES</a:t>
             </a:r>
-            <a:endParaRPr sz="1623" b="1" i="0" dirty="0">
+            <a:endParaRPr sz="1623" b="1" i="0">
               <a:solidFill>
                 <a:srgbClr val="06B6D4"/>
               </a:solidFill>
@@ -29767,8 +30754,8 @@
         </p:nvSpPr>
         <p:spPr>
           <a:xfrm>
-            <a:off x="9089136" y="3739896"/>
-            <a:ext cx="2450592" cy="512064"/>
+            <a:off x="9089136" y="3886282"/>
+            <a:ext cx="2450592" cy="219291"/>
           </a:xfrm>
           <a:prstGeom prst="rect">
             <a:avLst/>
@@ -29793,13 +30780,22 @@
               </a:spcAft>
             </a:pPr>
             <a:r>
-              <a:rPr sz="1507" b="0" i="0">
+              <a:rPr lang="de-DE" sz="1500">
                 <a:solidFill>
                   <a:srgbClr val="0F172A"/>
                 </a:solidFill>
                 <a:latin typeface="Arial"/>
               </a:rPr>
-              <a:t>19.2% / 18.2%</a:t>
+              <a:t>19.4%</a:t>
+            </a:r>
+            <a:r>
+              <a:rPr sz="1500" b="0" i="0">
+                <a:solidFill>
+                  <a:srgbClr val="0F172A"/>
+                </a:solidFill>
+                <a:latin typeface="Arial"/>
+              </a:rPr>
+              <a:t> / 18.2%</a:t>
             </a:r>
           </a:p>
         </p:txBody>
@@ -31212,7 +32208,7 @@
               </a:spcAft>
             </a:pPr>
             <a:r>
-              <a:rPr sz="1200" b="1" i="0" dirty="0">
+              <a:rPr sz="1200" b="1" i="0">
                 <a:solidFill>
                   <a:srgbClr val="0F172A"/>
                 </a:solidFill>
@@ -31999,4 +32995,213 @@
     </a:ext>
   </a:extLst>
 </a:theme>
+</file>
+
+<file path=customXml/item1.xml><?xml version="1.0" encoding="utf-8"?>
+<ct:contentTypeSchema xmlns:ct="http://schemas.microsoft.com/office/2006/metadata/contentType" xmlns:ma="http://schemas.microsoft.com/office/2006/metadata/properties/metaAttributes" ct:_="" ma:_="" ma:contentTypeName="Dokument" ma:contentTypeID="0x010100780DE282C029A0409239520E35F5D949" ma:contentTypeVersion="5" ma:contentTypeDescription="Ein neues Dokument erstellen." ma:contentTypeScope="" ma:versionID="45cb571ff01d4402b8da3c2311b2b4fc">
+  <xsd:schema xmlns:xsd="http://www.w3.org/2001/XMLSchema" xmlns:xs="http://www.w3.org/2001/XMLSchema" xmlns:p="http://schemas.microsoft.com/office/2006/metadata/properties" xmlns:ns3="a85d53a5-b7cb-4d0e-8a72-c954c6b7d638" targetNamespace="http://schemas.microsoft.com/office/2006/metadata/properties" ma:root="true" ma:fieldsID="1677660c848e8da1fd7e15fedf9b5fee" ns3:_="">
+    <xsd:import namespace="a85d53a5-b7cb-4d0e-8a72-c954c6b7d638"/>
+    <xsd:element name="properties">
+      <xsd:complexType>
+        <xsd:sequence>
+          <xsd:element name="documentManagement">
+            <xsd:complexType>
+              <xsd:all>
+                <xsd:element ref="ns3:MediaServiceDateTaken" minOccurs="0"/>
+                <xsd:element ref="ns3:MediaServiceMetadata" minOccurs="0"/>
+                <xsd:element ref="ns3:MediaServiceFastMetadata" minOccurs="0"/>
+                <xsd:element ref="ns3:MediaServiceSearchProperties" minOccurs="0"/>
+                <xsd:element ref="ns3:_activity" minOccurs="0"/>
+              </xsd:all>
+            </xsd:complexType>
+          </xsd:element>
+        </xsd:sequence>
+      </xsd:complexType>
+    </xsd:element>
+  </xsd:schema>
+  <xsd:schema xmlns:xsd="http://www.w3.org/2001/XMLSchema" xmlns:xs="http://www.w3.org/2001/XMLSchema" xmlns:dms="http://schemas.microsoft.com/office/2006/documentManagement/types" xmlns:pc="http://schemas.microsoft.com/office/infopath/2007/PartnerControls" targetNamespace="a85d53a5-b7cb-4d0e-8a72-c954c6b7d638" elementFormDefault="qualified">
+    <xsd:import namespace="http://schemas.microsoft.com/office/2006/documentManagement/types"/>
+    <xsd:import namespace="http://schemas.microsoft.com/office/infopath/2007/PartnerControls"/>
+    <xsd:element name="MediaServiceDateTaken" ma:index="8" nillable="true" ma:displayName="MediaServiceDateTaken" ma:hidden="true" ma:indexed="true" ma:internalName="MediaServiceDateTaken" ma:readOnly="true">
+      <xsd:simpleType>
+        <xsd:restriction base="dms:Text"/>
+      </xsd:simpleType>
+    </xsd:element>
+    <xsd:element name="MediaServiceMetadata" ma:index="9" nillable="true" ma:displayName="MediaServiceMetadata" ma:hidden="true" ma:internalName="MediaServiceMetadata" ma:readOnly="true">
+      <xsd:simpleType>
+        <xsd:restriction base="dms:Note"/>
+      </xsd:simpleType>
+    </xsd:element>
+    <xsd:element name="MediaServiceFastMetadata" ma:index="10" nillable="true" ma:displayName="MediaServiceFastMetadata" ma:hidden="true" ma:internalName="MediaServiceFastMetadata" ma:readOnly="true">
+      <xsd:simpleType>
+        <xsd:restriction base="dms:Note"/>
+      </xsd:simpleType>
+    </xsd:element>
+    <xsd:element name="MediaServiceSearchProperties" ma:index="11" nillable="true" ma:displayName="MediaServiceSearchProperties" ma:hidden="true" ma:internalName="MediaServiceSearchProperties" ma:readOnly="true">
+      <xsd:simpleType>
+        <xsd:restriction base="dms:Note"/>
+      </xsd:simpleType>
+    </xsd:element>
+    <xsd:element name="_activity" ma:index="12" nillable="true" ma:displayName="_activity" ma:hidden="true" ma:internalName="_activity">
+      <xsd:simpleType>
+        <xsd:restriction base="dms:Note"/>
+      </xsd:simpleType>
+    </xsd:element>
+  </xsd:schema>
+  <xsd:schema xmlns="http://schemas.openxmlformats.org/package/2006/metadata/core-properties" xmlns:xsd="http://www.w3.org/2001/XMLSchema" xmlns:xsi="http://www.w3.org/2001/XMLSchema-instance" xmlns:dc="http://purl.org/dc/elements/1.1/" xmlns:dcterms="http://purl.org/dc/terms/" xmlns:odoc="http://schemas.microsoft.com/internal/obd" targetNamespace="http://schemas.openxmlformats.org/package/2006/metadata/core-properties" elementFormDefault="qualified" attributeFormDefault="unqualified" blockDefault="#all">
+    <xsd:import namespace="http://purl.org/dc/elements/1.1/" schemaLocation="http://dublincore.org/schemas/xmls/qdc/2003/04/02/dc.xsd"/>
+    <xsd:import namespace="http://purl.org/dc/terms/" schemaLocation="http://dublincore.org/schemas/xmls/qdc/2003/04/02/dcterms.xsd"/>
+    <xsd:element name="coreProperties" type="CT_coreProperties"/>
+    <xsd:complexType name="CT_coreProperties">
+      <xsd:all>
+        <xsd:element ref="dc:creator" minOccurs="0" maxOccurs="1"/>
+        <xsd:element ref="dcterms:created" minOccurs="0" maxOccurs="1"/>
+        <xsd:element ref="dc:identifier" minOccurs="0" maxOccurs="1"/>
+        <xsd:element name="contentType" minOccurs="0" maxOccurs="1" type="xsd:string" ma:index="0" ma:displayName="Inhaltstyp"/>
+        <xsd:element ref="dc:title" minOccurs="0" maxOccurs="1" ma:index="4" ma:displayName="Titel"/>
+        <xsd:element ref="dc:subject" minOccurs="0" maxOccurs="1"/>
+        <xsd:element ref="dc:description" minOccurs="0" maxOccurs="1"/>
+        <xsd:element name="keywords" minOccurs="0" maxOccurs="1" type="xsd:string"/>
+        <xsd:element ref="dc:language" minOccurs="0" maxOccurs="1"/>
+        <xsd:element name="category" minOccurs="0" maxOccurs="1" type="xsd:string"/>
+        <xsd:element name="version" minOccurs="0" maxOccurs="1" type="xsd:string"/>
+        <xsd:element name="revision" minOccurs="0" maxOccurs="1" type="xsd:string">
+          <xsd:annotation>
+            <xsd:documentation>
+                        This value indicates the number of saves or revisions. The application is responsible for updating this value after each revision.
+                    </xsd:documentation>
+          </xsd:annotation>
+        </xsd:element>
+        <xsd:element name="lastModifiedBy" minOccurs="0" maxOccurs="1" type="xsd:string"/>
+        <xsd:element ref="dcterms:modified" minOccurs="0" maxOccurs="1"/>
+        <xsd:element name="contentStatus" minOccurs="0" maxOccurs="1" type="xsd:string"/>
+      </xsd:all>
+    </xsd:complexType>
+  </xsd:schema>
+  <xs:schema xmlns:pc="http://schemas.microsoft.com/office/infopath/2007/PartnerControls" xmlns:xs="http://www.w3.org/2001/XMLSchema" targetNamespace="http://schemas.microsoft.com/office/infopath/2007/PartnerControls" elementFormDefault="qualified" attributeFormDefault="unqualified">
+    <xs:element name="Person">
+      <xs:complexType>
+        <xs:sequence>
+          <xs:element ref="pc:DisplayName" minOccurs="0"/>
+          <xs:element ref="pc:AccountId" minOccurs="0"/>
+          <xs:element ref="pc:AccountType" minOccurs="0"/>
+        </xs:sequence>
+      </xs:complexType>
+    </xs:element>
+    <xs:element name="DisplayName" type="xs:string"/>
+    <xs:element name="AccountId" type="xs:string"/>
+    <xs:element name="AccountType" type="xs:string"/>
+    <xs:element name="BDCAssociatedEntity">
+      <xs:complexType>
+        <xs:sequence>
+          <xs:element ref="pc:BDCEntity" minOccurs="0" maxOccurs="unbounded"/>
+        </xs:sequence>
+        <xs:attribute ref="pc:EntityNamespace"/>
+        <xs:attribute ref="pc:EntityName"/>
+        <xs:attribute ref="pc:SystemInstanceName"/>
+        <xs:attribute ref="pc:AssociationName"/>
+      </xs:complexType>
+    </xs:element>
+    <xs:attribute name="EntityNamespace" type="xs:string"/>
+    <xs:attribute name="EntityName" type="xs:string"/>
+    <xs:attribute name="SystemInstanceName" type="xs:string"/>
+    <xs:attribute name="AssociationName" type="xs:string"/>
+    <xs:element name="BDCEntity">
+      <xs:complexType>
+        <xs:sequence>
+          <xs:element ref="pc:EntityDisplayName" minOccurs="0"/>
+          <xs:element ref="pc:EntityInstanceReference" minOccurs="0"/>
+          <xs:element ref="pc:EntityId1" minOccurs="0"/>
+          <xs:element ref="pc:EntityId2" minOccurs="0"/>
+          <xs:element ref="pc:EntityId3" minOccurs="0"/>
+          <xs:element ref="pc:EntityId4" minOccurs="0"/>
+          <xs:element ref="pc:EntityId5" minOccurs="0"/>
+        </xs:sequence>
+      </xs:complexType>
+    </xs:element>
+    <xs:element name="EntityDisplayName" type="xs:string"/>
+    <xs:element name="EntityInstanceReference" type="xs:string"/>
+    <xs:element name="EntityId1" type="xs:string"/>
+    <xs:element name="EntityId2" type="xs:string"/>
+    <xs:element name="EntityId3" type="xs:string"/>
+    <xs:element name="EntityId4" type="xs:string"/>
+    <xs:element name="EntityId5" type="xs:string"/>
+    <xs:element name="Terms">
+      <xs:complexType>
+        <xs:sequence>
+          <xs:element ref="pc:TermInfo" minOccurs="0" maxOccurs="unbounded"/>
+        </xs:sequence>
+      </xs:complexType>
+    </xs:element>
+    <xs:element name="TermInfo">
+      <xs:complexType>
+        <xs:sequence>
+          <xs:element ref="pc:TermName" minOccurs="0"/>
+          <xs:element ref="pc:TermId" minOccurs="0"/>
+        </xs:sequence>
+      </xs:complexType>
+    </xs:element>
+    <xs:element name="TermName" type="xs:string"/>
+    <xs:element name="TermId" type="xs:string"/>
+  </xs:schema>
+</ct:contentTypeSchema>
+</file>
+
+<file path=customXml/item2.xml><?xml version="1.0" encoding="utf-8"?>
+<?mso-contentType ?>
+<FormTemplates xmlns="http://schemas.microsoft.com/sharepoint/v3/contenttype/forms">
+  <Display>DocumentLibraryForm</Display>
+  <Edit>DocumentLibraryForm</Edit>
+  <New>DocumentLibraryForm</New>
+</FormTemplates>
+</file>
+
+<file path=customXml/item3.xml><?xml version="1.0" encoding="utf-8"?>
+<p:properties xmlns:p="http://schemas.microsoft.com/office/2006/metadata/properties" xmlns:xsi="http://www.w3.org/2001/XMLSchema-instance" xmlns:pc="http://schemas.microsoft.com/office/infopath/2007/PartnerControls">
+  <documentManagement>
+    <_activity xmlns="a85d53a5-b7cb-4d0e-8a72-c954c6b7d638" xsi:nil="true"/>
+  </documentManagement>
+</p:properties>
+</file>
+
+<file path=customXml/itemProps1.xml><?xml version="1.0" encoding="utf-8"?>
+<ds:datastoreItem xmlns:ds="http://schemas.openxmlformats.org/officeDocument/2006/customXml" ds:itemID="{93A23043-C3CB-461E-B558-FAF50B5A40F6}">
+  <ds:schemaRefs>
+    <ds:schemaRef ds:uri="a85d53a5-b7cb-4d0e-8a72-c954c6b7d638"/>
+    <ds:schemaRef ds:uri="http://purl.org/dc/elements/1.1/"/>
+    <ds:schemaRef ds:uri="http://purl.org/dc/terms/"/>
+    <ds:schemaRef ds:uri="http://schemas.microsoft.com/internal/obd"/>
+    <ds:schemaRef ds:uri="http://schemas.microsoft.com/office/2006/documentManagement/types"/>
+    <ds:schemaRef ds:uri="http://schemas.microsoft.com/office/2006/metadata/contentType"/>
+    <ds:schemaRef ds:uri="http://schemas.microsoft.com/office/2006/metadata/properties"/>
+    <ds:schemaRef ds:uri="http://schemas.microsoft.com/office/2006/metadata/properties/metaAttributes"/>
+    <ds:schemaRef ds:uri="http://schemas.microsoft.com/office/infopath/2007/PartnerControls"/>
+    <ds:schemaRef ds:uri="http://schemas.openxmlformats.org/package/2006/metadata/core-properties"/>
+    <ds:schemaRef ds:uri="http://www.w3.org/2001/XMLSchema"/>
+  </ds:schemaRefs>
+</ds:datastoreItem>
+</file>
+
+<file path=customXml/itemProps2.xml><?xml version="1.0" encoding="utf-8"?>
+<ds:datastoreItem xmlns:ds="http://schemas.openxmlformats.org/officeDocument/2006/customXml" ds:itemID="{5BF969B0-535F-4B0B-BF12-E51D28E7CF9A}">
+  <ds:schemaRefs>
+    <ds:schemaRef ds:uri="http://schemas.microsoft.com/sharepoint/v3/contenttype/forms"/>
+  </ds:schemaRefs>
+</ds:datastoreItem>
+</file>
+
+<file path=customXml/itemProps3.xml><?xml version="1.0" encoding="utf-8"?>
+<ds:datastoreItem xmlns:ds="http://schemas.openxmlformats.org/officeDocument/2006/customXml" ds:itemID="{D556C9EE-C7A0-4652-A76E-1D02A56C5D7B}">
+  <ds:schemaRefs>
+    <ds:schemaRef ds:uri="a85d53a5-b7cb-4d0e-8a72-c954c6b7d638"/>
+    <ds:schemaRef ds:uri="http://purl.org/dc/dcmitype/"/>
+    <ds:schemaRef ds:uri="http://purl.org/dc/elements/1.1/"/>
+    <ds:schemaRef ds:uri="http://purl.org/dc/terms/"/>
+    <ds:schemaRef ds:uri="http://schemas.microsoft.com/office/2006/documentManagement/types"/>
+    <ds:schemaRef ds:uri="http://schemas.microsoft.com/office/2006/metadata/properties"/>
+    <ds:schemaRef ds:uri="http://schemas.microsoft.com/office/infopath/2007/PartnerControls"/>
+    <ds:schemaRef ds:uri="http://schemas.openxmlformats.org/package/2006/metadata/core-properties"/>
+    <ds:schemaRef ds:uri="http://www.w3.org/XML/1998/namespace"/>
+  </ds:schemaRefs>
+</ds:datastoreItem>
 </file>
</xml_diff>